<commit_message>
Sunumu kılavuzdaki akışın içerik beklentilerine göre tamamla
Co-Authored-By: Claude Opus 5.5 <noreply@anthropic.com>
Claude-Session: https://claude.ai/code/session_01DTiHxbPkixs9Jadunw7PB9
</commit_message>
<xml_diff>
--- a/presentation/Mercek_AI_Overflow_Sunum.pptx
+++ b/presentation/Mercek_AI_Overflow_Sunum.pptx
@@ -117,27 +117,27 @@
   <p:extLst>
     <p:ext uri="{521415D9-36F7-43E2-AB2F-B90AF26B5E84}">
       <p14:sectionLst xmlns:p14="http://schemas.microsoft.com/office/powerpoint/2010/main">
-        <p14:section name="Açılış" id="{433dbd12-23f5-d66a-d93b-c48266c416f4}">
+        <p14:section name="Açılış" id="{9d50512d-5699-2619-95c3-f5084f850c70}">
           <p14:sldIdLst>
             <p14:sldId id="256"/>
             <p14:sldId id="257"/>
           </p14:sldIdLst>
         </p14:section>
-        <p14:section name="Problem ve çözüm" id="{e0e5c574-f160-4f3c-0e6e-a831205c90d3}">
+        <p14:section name="Problem ve çözüm" id="{b11fcce0-9103-b751-8e80-fd09ee168271}">
           <p14:sldIdLst>
             <p14:sldId id="258"/>
             <p14:sldId id="259"/>
             <p14:sldId id="260"/>
           </p14:sldIdLst>
         </p14:section>
-        <p14:section name="Ürün" id="{f086654d-ff51-15b9-ae41-85e6e3a4c0fd}">
+        <p14:section name="Ürün" id="{5b887ed5-ae0d-4539-a403-e42e14df49e9}">
           <p14:sldIdLst>
             <p14:sldId id="261"/>
             <p14:sldId id="262"/>
             <p14:sldId id="263"/>
           </p14:sldIdLst>
         </p14:section>
-        <p14:section name="Değer ve kapanış" id="{c70501e5-7a30-a597-e148-4904d69cd674}">
+        <p14:section name="Değer ve kapanış" id="{4423d3af-e1dd-4230-0a6a-095b88b1adc6}">
           <p14:sldIdLst>
             <p14:sldId id="264"/>
             <p14:sldId id="265"/>
@@ -5209,8 +5209,8 @@
         </p:nvSpPr>
         <p:spPr>
           <a:xfrm>
-            <a:off x="4069080" y="3291840"/>
-            <a:ext cx="7498080" cy="365760"/>
+            <a:off x="4069080" y="3273552"/>
+            <a:ext cx="7498080" cy="548640"/>
           </a:xfrm>
           <a:prstGeom prst="rect">
             <a:avLst/>
@@ -5219,21 +5219,32 @@
           <a:ln/>
         </p:spPr>
         <p:txBody>
-          <a:bodyPr wrap="square" lIns="0" tIns="0" rIns="0" bIns="0" rtlCol="0" anchor="ctr"/>
+          <a:bodyPr wrap="square" lIns="0" tIns="0" rIns="0" bIns="0" rtlCol="0" anchor="t"/>
           <a:lstStyle/>
           <a:p>
             <a:pPr indent="0" marL="0">
               <a:buNone/>
             </a:pPr>
             <a:r>
-              <a:rPr lang="en-US" sz="1600" b="1" dirty="0">
+              <a:rPr lang="en-US" sz="1400" b="1" dirty="0">
                 <a:solidFill>
                   <a:schemeClr val="accent3"/>
                 </a:solidFill>
               </a:rPr>
-              <a:t>Toplam: saatler — bu sürede müşteri ödemesini yapamıyor</a:t>
-            </a:r>
-            <a:endParaRPr lang="en-US" sz="1600" dirty="0"/>
+              <a:t>Bedeli: </a:t>
+            </a:r>
+            <a:pPr indent="0" marL="0">
+              <a:buNone/>
+            </a:pPr>
+            <a:r>
+              <a:rPr lang="en-US" sz="1400" dirty="0">
+                <a:solidFill>
+                  <a:schemeClr val="accent3"/>
+                </a:solidFill>
+              </a:rPr>
+              <a:t>saatlerce işlem yapamayan müşteri · her çağrıda çağrı merkezi, L1 ve L2 eforu · daha önce çözülmüş sorunun yeniden çözülmesi</a:t>
+            </a:r>
+            <a:endParaRPr lang="en-US" sz="1400" dirty="0"/>
           </a:p>
         </p:txBody>
       </p:sp>
@@ -6639,18 +6650,54 @@
       </p:sp>
       <p:sp>
         <p:nvSpPr>
-          <p:cNvPr id="3" name="diff-card-1"/>
+          <p:cNvPr id="3" name="Text 1"/>
+          <p:cNvSpPr txBox="1"/>
+          <p:nvPr/>
+        </p:nvSpPr>
+        <p:spPr>
+          <a:xfrm>
+            <a:off x="548640" y="1188720"/>
+            <a:ext cx="11064240" cy="411480"/>
+          </a:xfrm>
+          <a:prstGeom prst="rect">
+            <a:avLst/>
+          </a:prstGeom>
+          <a:noFill/>
+          <a:ln/>
+        </p:spPr>
+        <p:txBody>
+          <a:bodyPr wrap="square" lIns="0" tIns="0" rIns="0" bIns="0" rtlCol="0" anchor="ctr"/>
+          <a:lstStyle/>
+          <a:p>
+            <a:pPr indent="0" marL="0">
+              <a:buNone/>
+            </a:pPr>
+            <a:r>
+              <a:rPr lang="en-US" sz="1800" dirty="0">
+                <a:solidFill>
+                  <a:schemeClr val="tx2"/>
+                </a:solidFill>
+              </a:rPr>
+              <a:t>Bugünkü çağrı araçları sorunu kaydeder; Mercek sorunu bulur, çözümü önerir ve yeni talebin planına bağlar.</a:t>
+            </a:r>
+            <a:endParaRPr lang="en-US" sz="1800" dirty="0"/>
+          </a:p>
+        </p:txBody>
+      </p:sp>
+      <p:sp>
+        <p:nvSpPr>
+          <p:cNvPr id="4" name="diff-card-1"/>
           <p:cNvSpPr/>
           <p:nvPr/>
         </p:nvSpPr>
         <p:spPr>
           <a:xfrm>
-            <a:off x="548640" y="1463040"/>
-            <a:ext cx="5349240" cy="2103120"/>
+            <a:off x="548640" y="1783080"/>
+            <a:ext cx="5349240" cy="2011680"/>
           </a:xfrm>
           <a:prstGeom prst="roundRect">
             <a:avLst>
-              <a:gd name="adj" fmla="val 5217"/>
+              <a:gd name="adj" fmla="val 5455"/>
             </a:avLst>
           </a:prstGeom>
           <a:solidFill>
@@ -6666,13 +6713,13 @@
       </p:sp>
       <p:sp>
         <p:nvSpPr>
-          <p:cNvPr id="4" name="diff-1-circle"/>
+          <p:cNvPr id="5" name="diff-1-circle"/>
           <p:cNvSpPr/>
           <p:nvPr/>
         </p:nvSpPr>
         <p:spPr>
           <a:xfrm>
-            <a:off x="868680" y="1828800"/>
+            <a:off x="868680" y="2148840"/>
             <a:ext cx="777240" cy="777240"/>
           </a:xfrm>
           <a:prstGeom prst="ellipse">
@@ -6691,7 +6738,7 @@
       </p:sp>
       <p:pic>
         <p:nvPicPr>
-          <p:cNvPr id="5" name="diff-1-icon" descr="preencoded.png">    </p:cNvPr>
+          <p:cNvPr id="6" name="diff-1-icon" descr="preencoded.png">    </p:cNvPr>
           <p:cNvPicPr>
             <a:picLocks noChangeAspect="1"/>
           </p:cNvPicPr>
@@ -6705,7 +6752,7 @@
         </p:blipFill>
         <p:spPr>
           <a:xfrm>
-            <a:off x="1070762" y="2030882"/>
+            <a:off x="1070762" y="2350922"/>
             <a:ext cx="373075" cy="373075"/>
           </a:xfrm>
           <a:prstGeom prst="rect">
@@ -6715,14 +6762,14 @@
       </p:pic>
       <p:sp>
         <p:nvSpPr>
-          <p:cNvPr id="6" name="Text 3"/>
+          <p:cNvPr id="7" name="Text 4"/>
           <p:cNvSpPr txBox="1"/>
           <p:nvPr/>
         </p:nvSpPr>
         <p:spPr>
           <a:xfrm>
-            <a:off x="1920240" y="1783080"/>
-            <a:ext cx="3703320" cy="1554480"/>
+            <a:off x="1920240" y="2103120"/>
+            <a:ext cx="3703320" cy="1463040"/>
           </a:xfrm>
           <a:prstGeom prst="rect">
             <a:avLst/>
@@ -6771,18 +6818,18 @@
       </p:sp>
       <p:sp>
         <p:nvSpPr>
-          <p:cNvPr id="7" name="diff-card-2"/>
+          <p:cNvPr id="8" name="diff-card-2"/>
           <p:cNvSpPr/>
           <p:nvPr/>
         </p:nvSpPr>
         <p:spPr>
           <a:xfrm>
-            <a:off x="6263640" y="1463040"/>
-            <a:ext cx="5349240" cy="2103120"/>
+            <a:off x="6263640" y="1783080"/>
+            <a:ext cx="5349240" cy="2011680"/>
           </a:xfrm>
           <a:prstGeom prst="roundRect">
             <a:avLst>
-              <a:gd name="adj" fmla="val 5217"/>
+              <a:gd name="adj" fmla="val 5455"/>
             </a:avLst>
           </a:prstGeom>
           <a:solidFill>
@@ -6798,13 +6845,13 @@
       </p:sp>
       <p:sp>
         <p:nvSpPr>
-          <p:cNvPr id="8" name="diff-2-circle"/>
+          <p:cNvPr id="9" name="diff-2-circle"/>
           <p:cNvSpPr/>
           <p:nvPr/>
         </p:nvSpPr>
         <p:spPr>
           <a:xfrm>
-            <a:off x="6583680" y="1828800"/>
+            <a:off x="6583680" y="2148840"/>
             <a:ext cx="777240" cy="777240"/>
           </a:xfrm>
           <a:prstGeom prst="ellipse">
@@ -6823,7 +6870,7 @@
       </p:sp>
       <p:pic>
         <p:nvPicPr>
-          <p:cNvPr id="9" name="diff-2-icon" descr="preencoded.png">    </p:cNvPr>
+          <p:cNvPr id="10" name="diff-2-icon" descr="preencoded.png">    </p:cNvPr>
           <p:cNvPicPr>
             <a:picLocks noChangeAspect="1"/>
           </p:cNvPicPr>
@@ -6837,7 +6884,7 @@
         </p:blipFill>
         <p:spPr>
           <a:xfrm>
-            <a:off x="6785762" y="2030882"/>
+            <a:off x="6785762" y="2350922"/>
             <a:ext cx="373075" cy="373075"/>
           </a:xfrm>
           <a:prstGeom prst="rect">
@@ -6847,14 +6894,14 @@
       </p:pic>
       <p:sp>
         <p:nvSpPr>
-          <p:cNvPr id="10" name="Text 6"/>
+          <p:cNvPr id="11" name="Text 7"/>
           <p:cNvSpPr txBox="1"/>
           <p:nvPr/>
         </p:nvSpPr>
         <p:spPr>
           <a:xfrm>
-            <a:off x="7635240" y="1783080"/>
-            <a:ext cx="3703320" cy="1554480"/>
+            <a:off x="7635240" y="2103120"/>
+            <a:ext cx="3703320" cy="1463040"/>
           </a:xfrm>
           <a:prstGeom prst="rect">
             <a:avLst/>
@@ -6903,18 +6950,18 @@
       </p:sp>
       <p:sp>
         <p:nvSpPr>
-          <p:cNvPr id="11" name="diff-card-3"/>
+          <p:cNvPr id="12" name="diff-card-3"/>
           <p:cNvSpPr/>
           <p:nvPr/>
         </p:nvSpPr>
         <p:spPr>
           <a:xfrm>
-            <a:off x="548640" y="3840480"/>
-            <a:ext cx="5349240" cy="2103120"/>
+            <a:off x="548640" y="4023360"/>
+            <a:ext cx="5349240" cy="2011680"/>
           </a:xfrm>
           <a:prstGeom prst="roundRect">
             <a:avLst>
-              <a:gd name="adj" fmla="val 5217"/>
+              <a:gd name="adj" fmla="val 5455"/>
             </a:avLst>
           </a:prstGeom>
           <a:solidFill>
@@ -6930,13 +6977,13 @@
       </p:sp>
       <p:sp>
         <p:nvSpPr>
-          <p:cNvPr id="12" name="diff-3-circle"/>
+          <p:cNvPr id="13" name="diff-3-circle"/>
           <p:cNvSpPr/>
           <p:nvPr/>
         </p:nvSpPr>
         <p:spPr>
           <a:xfrm>
-            <a:off x="868680" y="4206240"/>
+            <a:off x="868680" y="4389120"/>
             <a:ext cx="777240" cy="777240"/>
           </a:xfrm>
           <a:prstGeom prst="ellipse">
@@ -6955,7 +7002,7 @@
       </p:sp>
       <p:pic>
         <p:nvPicPr>
-          <p:cNvPr id="13" name="diff-3-icon" descr="preencoded.png">    </p:cNvPr>
+          <p:cNvPr id="14" name="diff-3-icon" descr="preencoded.png">    </p:cNvPr>
           <p:cNvPicPr>
             <a:picLocks noChangeAspect="1"/>
           </p:cNvPicPr>
@@ -6969,7 +7016,7 @@
         </p:blipFill>
         <p:spPr>
           <a:xfrm>
-            <a:off x="1070762" y="4408322"/>
+            <a:off x="1070762" y="4591202"/>
             <a:ext cx="373075" cy="373075"/>
           </a:xfrm>
           <a:prstGeom prst="rect">
@@ -6979,14 +7026,14 @@
       </p:pic>
       <p:sp>
         <p:nvSpPr>
-          <p:cNvPr id="14" name="Text 9"/>
+          <p:cNvPr id="15" name="Text 10"/>
           <p:cNvSpPr txBox="1"/>
           <p:nvPr/>
         </p:nvSpPr>
         <p:spPr>
           <a:xfrm>
-            <a:off x="1920240" y="4160520"/>
-            <a:ext cx="3703320" cy="1554480"/>
+            <a:off x="1920240" y="4343400"/>
+            <a:ext cx="3703320" cy="1463040"/>
           </a:xfrm>
           <a:prstGeom prst="rect">
             <a:avLst/>
@@ -7035,18 +7082,18 @@
       </p:sp>
       <p:sp>
         <p:nvSpPr>
-          <p:cNvPr id="15" name="diff-card-4"/>
+          <p:cNvPr id="16" name="diff-card-4"/>
           <p:cNvSpPr/>
           <p:nvPr/>
         </p:nvSpPr>
         <p:spPr>
           <a:xfrm>
-            <a:off x="6263640" y="3840480"/>
-            <a:ext cx="5349240" cy="2103120"/>
+            <a:off x="6263640" y="4023360"/>
+            <a:ext cx="5349240" cy="2011680"/>
           </a:xfrm>
           <a:prstGeom prst="roundRect">
             <a:avLst>
-              <a:gd name="adj" fmla="val 5217"/>
+              <a:gd name="adj" fmla="val 5455"/>
             </a:avLst>
           </a:prstGeom>
           <a:solidFill>
@@ -7062,13 +7109,13 @@
       </p:sp>
       <p:sp>
         <p:nvSpPr>
-          <p:cNvPr id="16" name="diff-4-circle"/>
+          <p:cNvPr id="17" name="diff-4-circle"/>
           <p:cNvSpPr/>
           <p:nvPr/>
         </p:nvSpPr>
         <p:spPr>
           <a:xfrm>
-            <a:off x="6583680" y="4206240"/>
+            <a:off x="6583680" y="4389120"/>
             <a:ext cx="777240" cy="777240"/>
           </a:xfrm>
           <a:prstGeom prst="ellipse">
@@ -7087,7 +7134,7 @@
       </p:sp>
       <p:pic>
         <p:nvPicPr>
-          <p:cNvPr id="17" name="diff-4-icon" descr="preencoded.png">    </p:cNvPr>
+          <p:cNvPr id="18" name="diff-4-icon" descr="preencoded.png">    </p:cNvPr>
           <p:cNvPicPr>
             <a:picLocks noChangeAspect="1"/>
           </p:cNvPicPr>
@@ -7101,7 +7148,7 @@
         </p:blipFill>
         <p:spPr>
           <a:xfrm>
-            <a:off x="6785762" y="4408322"/>
+            <a:off x="6785762" y="4591202"/>
             <a:ext cx="373075" cy="373075"/>
           </a:xfrm>
           <a:prstGeom prst="rect">
@@ -7111,14 +7158,14 @@
       </p:pic>
       <p:sp>
         <p:nvSpPr>
-          <p:cNvPr id="18" name="Text 12"/>
+          <p:cNvPr id="19" name="Text 13"/>
           <p:cNvSpPr txBox="1"/>
           <p:nvPr/>
         </p:nvSpPr>
         <p:spPr>
           <a:xfrm>
-            <a:off x="7635240" y="4160520"/>
-            <a:ext cx="3703320" cy="1554480"/>
+            <a:off x="7635240" y="4343400"/>
+            <a:ext cx="3703320" cy="1463040"/>
           </a:xfrm>
           <a:prstGeom prst="rect">
             <a:avLst/>
@@ -7339,7 +7386,7 @@
               <a:buNone/>
             </a:pPr>
             <a:r>
-              <a:rPr lang="en-US" sz="1300" dirty="0">
+              <a:rPr lang="en-US" sz="1200" dirty="0">
                 <a:solidFill>
                   <a:schemeClr val="tx1"/>
                 </a:solidFill>
@@ -7353,7 +7400,7 @@
               <a:buNone/>
             </a:pPr>
             <a:r>
-              <a:rPr lang="en-US" sz="1300" dirty="0">
+              <a:rPr lang="en-US" sz="1200" dirty="0">
                 <a:solidFill>
                   <a:schemeClr val="tx1"/>
                 </a:solidFill>
@@ -7367,7 +7414,7 @@
               <a:buNone/>
             </a:pPr>
             <a:r>
-              <a:rPr lang="en-US" sz="1300" dirty="0">
+              <a:rPr lang="en-US" sz="1200" dirty="0">
                 <a:solidFill>
                   <a:schemeClr val="tx1"/>
                 </a:solidFill>
@@ -7444,12 +7491,12 @@
               <a:buNone/>
             </a:pPr>
             <a:r>
-              <a:rPr lang="en-US" sz="1300" dirty="0">
+              <a:rPr lang="en-US" sz="1200" dirty="0">
                 <a:solidFill>
                   <a:schemeClr val="bg1"/>
                 </a:solidFill>
               </a:rPr>
-              <a:t>React arayüz</a:t>
+              <a:t>React + FastAPI</a:t>
             </a:r>
             <a:endParaRPr lang="en-US" sz="1600" dirty="0"/>
           </a:p>
@@ -7458,12 +7505,12 @@
               <a:buNone/>
             </a:pPr>
             <a:r>
-              <a:rPr lang="en-US" sz="1300" dirty="0">
+              <a:rPr lang="en-US" sz="1200" dirty="0">
                 <a:solidFill>
                   <a:schemeClr val="bg1"/>
                 </a:solidFill>
               </a:rPr>
-              <a:t>+ FastAPI</a:t>
+              <a:t>Tek dağıtım,</a:t>
             </a:r>
             <a:endParaRPr lang="en-US" sz="1600" dirty="0"/>
           </a:p>
@@ -7472,12 +7519,12 @@
               <a:buNone/>
             </a:pPr>
             <a:r>
-              <a:rPr lang="en-US" sz="1300" dirty="0">
+              <a:rPr lang="en-US" sz="1200" dirty="0">
                 <a:solidFill>
                   <a:schemeClr val="bg1"/>
                 </a:solidFill>
               </a:rPr>
-              <a:t>/health</a:t>
+              <a:t>sağlık kontrolü</a:t>
             </a:r>
             <a:endParaRPr lang="en-US" sz="1600" dirty="0"/>
           </a:p>
@@ -7491,12 +7538,12 @@
         </p:nvSpPr>
         <p:spPr>
           <a:xfrm>
-            <a:off x="5577840" y="1371600"/>
-            <a:ext cx="2377440" cy="1143000"/>
+            <a:off x="5486400" y="1325880"/>
+            <a:ext cx="2514600" cy="1234440"/>
           </a:xfrm>
           <a:prstGeom prst="roundRect">
             <a:avLst>
-              <a:gd name="adj" fmla="val 9600"/>
+              <a:gd name="adj" fmla="val 8889"/>
             </a:avLst>
           </a:prstGeom>
           <a:solidFill>
@@ -7518,8 +7565,8 @@
         </p:nvSpPr>
         <p:spPr>
           <a:xfrm>
-            <a:off x="5715000" y="1463040"/>
-            <a:ext cx="2103120" cy="960120"/>
+            <a:off x="5623560" y="1417320"/>
+            <a:ext cx="2240280" cy="1051560"/>
           </a:xfrm>
           <a:prstGeom prst="rect">
             <a:avLst/>
@@ -7549,12 +7596,26 @@
               <a:buNone/>
             </a:pPr>
             <a:r>
-              <a:rPr lang="en-US" sz="1300" dirty="0">
+              <a:rPr lang="en-US" sz="1200" dirty="0">
                 <a:solidFill>
                   <a:schemeClr val="tx1"/>
                 </a:solidFill>
               </a:rPr>
               <a:t>chat + embedding modeli</a:t>
+            </a:r>
+            <a:endParaRPr lang="en-US" sz="1600" dirty="0"/>
+          </a:p>
+          <a:p>
+            <a:pPr algn="ctr" indent="0" marL="0">
+              <a:buNone/>
+            </a:pPr>
+            <a:r>
+              <a:rPr lang="en-US" sz="1200" dirty="0">
+                <a:solidFill>
+                  <a:schemeClr val="tx1"/>
+                </a:solidFill>
+              </a:rPr>
+              <a:t>Yönetilen, kurumsal model erişimi</a:t>
             </a:r>
             <a:endParaRPr lang="en-US" sz="1600" dirty="0"/>
           </a:p>
@@ -7568,12 +7629,12 @@
         </p:nvSpPr>
         <p:spPr>
           <a:xfrm>
-            <a:off x="5577840" y="2743200"/>
-            <a:ext cx="2377440" cy="1143000"/>
+            <a:off x="5486400" y="2715768"/>
+            <a:ext cx="2514600" cy="1234440"/>
           </a:xfrm>
           <a:prstGeom prst="roundRect">
             <a:avLst>
-              <a:gd name="adj" fmla="val 9600"/>
+              <a:gd name="adj" fmla="val 8889"/>
             </a:avLst>
           </a:prstGeom>
           <a:solidFill>
@@ -7595,8 +7656,8 @@
         </p:nvSpPr>
         <p:spPr>
           <a:xfrm>
-            <a:off x="5715000" y="2834640"/>
-            <a:ext cx="2103120" cy="960120"/>
+            <a:off x="5623560" y="2807208"/>
+            <a:ext cx="2240280" cy="1051560"/>
           </a:xfrm>
           <a:prstGeom prst="rect">
             <a:avLst/>
@@ -7626,12 +7687,26 @@
               <a:buNone/>
             </a:pPr>
             <a:r>
-              <a:rPr lang="en-US" sz="1300" dirty="0">
+              <a:rPr lang="en-US" sz="1200" dirty="0">
                 <a:solidFill>
                   <a:schemeClr val="tx1"/>
                 </a:solidFill>
               </a:rPr>
-              <a:t>ekran, log, çağrı, talep, takvim</a:t>
+              <a:t>Log, çağrı, talep, takvim</a:t>
+            </a:r>
+            <a:endParaRPr lang="en-US" sz="1600" dirty="0"/>
+          </a:p>
+          <a:p>
+            <a:pPr algn="ctr" indent="0" marL="0">
+              <a:buNone/>
+            </a:pPr>
+            <a:r>
+              <a:rPr lang="en-US" sz="1200" dirty="0">
+                <a:solidFill>
+                  <a:schemeClr val="tx1"/>
+                </a:solidFill>
+              </a:rPr>
+              <a:t>İlişkisel sorgu ve istatistik</a:t>
             </a:r>
             <a:endParaRPr lang="en-US" sz="1600" dirty="0"/>
           </a:p>
@@ -7645,12 +7720,12 @@
         </p:nvSpPr>
         <p:spPr>
           <a:xfrm>
-            <a:off x="5577840" y="4114800"/>
-            <a:ext cx="2377440" cy="1143000"/>
+            <a:off x="5486400" y="4105656"/>
+            <a:ext cx="2514600" cy="1234440"/>
           </a:xfrm>
           <a:prstGeom prst="roundRect">
             <a:avLst>
-              <a:gd name="adj" fmla="val 9600"/>
+              <a:gd name="adj" fmla="val 8889"/>
             </a:avLst>
           </a:prstGeom>
           <a:solidFill>
@@ -7672,8 +7747,8 @@
         </p:nvSpPr>
         <p:spPr>
           <a:xfrm>
-            <a:off x="5715000" y="4206240"/>
-            <a:ext cx="2103120" cy="960120"/>
+            <a:off x="5623560" y="4197096"/>
+            <a:ext cx="2240280" cy="1051560"/>
           </a:xfrm>
           <a:prstGeom prst="rect">
             <a:avLst/>
@@ -7703,12 +7778,26 @@
               <a:buNone/>
             </a:pPr>
             <a:r>
-              <a:rPr lang="en-US" sz="1300" dirty="0">
+              <a:rPr lang="en-US" sz="1200" dirty="0">
                 <a:solidFill>
                   <a:schemeClr val="tx1"/>
                 </a:solidFill>
               </a:rPr>
-              <a:t>hibrit arama: çözüm, çağrı, talep</a:t>
+              <a:t>Çözüm, çağrı, talep araması</a:t>
+            </a:r>
+            <a:endParaRPr lang="en-US" sz="1600" dirty="0"/>
+          </a:p>
+          <a:p>
+            <a:pPr algn="ctr" indent="0" marL="0">
+              <a:buNone/>
+            </a:pPr>
+            <a:r>
+              <a:rPr lang="en-US" sz="1200" dirty="0">
+                <a:solidFill>
+                  <a:schemeClr val="tx1"/>
+                </a:solidFill>
+              </a:rPr>
+              <a:t>Vektör + metin (hibrit)</a:t>
             </a:r>
             <a:endParaRPr lang="en-US" sz="1600" dirty="0"/>
           </a:p>
@@ -7747,7 +7836,7 @@
         <p:spPr>
           <a:xfrm flipV="1">
             <a:off x="5029200" y="1938528"/>
-            <a:ext cx="548640" cy="1078992"/>
+            <a:ext cx="457200" cy="1078992"/>
           </a:xfrm>
           <a:prstGeom prst="line">
             <a:avLst/>
@@ -7770,8 +7859,8 @@
         </p:nvSpPr>
         <p:spPr>
           <a:xfrm flipV="1">
-            <a:off x="5029200" y="3310128"/>
-            <a:ext cx="548640" cy="27432"/>
+            <a:off x="5029200" y="3328416"/>
+            <a:ext cx="457200" cy="9144"/>
           </a:xfrm>
           <a:prstGeom prst="line">
             <a:avLst/>
@@ -7795,7 +7884,7 @@
         <p:spPr>
           <a:xfrm>
             <a:off x="5029200" y="3657600"/>
-            <a:ext cx="548640" cy="1024128"/>
+            <a:ext cx="457200" cy="1060704"/>
           </a:xfrm>
           <a:prstGeom prst="line">
             <a:avLst/>
@@ -9859,7 +9948,7 @@
                 <a:gridCol w="3840480"/>
                 <a:gridCol w="4297680"/>
               </a:tblGrid>
-              <a:tr h="512064">
+              <a:tr h="429768">
                 <a:tc>
                   <a:txBody>
                     <a:bodyPr/>
@@ -10065,7 +10154,7 @@
                   </a:tcPr>
                 </a:tc>
               </a:tr>
-              <a:tr h="512064">
+              <a:tr h="429768">
                 <a:tc>
                   <a:txBody>
                     <a:bodyPr/>
@@ -10262,7 +10351,7 @@
                   </a:tcPr>
                 </a:tc>
               </a:tr>
-              <a:tr h="512064">
+              <a:tr h="429768">
                 <a:tc>
                   <a:txBody>
                     <a:bodyPr/>
@@ -10459,7 +10548,7 @@
                   </a:tcPr>
                 </a:tc>
               </a:tr>
-              <a:tr h="512064">
+              <a:tr h="429768">
                 <a:tc>
                   <a:txBody>
                     <a:bodyPr/>
@@ -10656,7 +10745,7 @@
                   </a:tcPr>
                 </a:tc>
               </a:tr>
-              <a:tr h="512064">
+              <a:tr h="429768">
                 <a:tc>
                   <a:txBody>
                     <a:bodyPr/>
@@ -10805,6 +10894,203 @@
                           <a:cs typeface="Calibri" pitchFamily="34" charset="-120"/>
                         </a:rPr>
                         <a:t>Ekranın çağrı geçmişi kapsamda</a:t>
+                      </a:r>
+                      <a:endParaRPr lang="en-US" sz="1400" dirty="0">
+                        <a:latin typeface="Calibri" charset="0"/>
+                        <a:ea typeface="Calibri" charset="0"/>
+                        <a:cs typeface="Calibri" charset="0"/>
+                      </a:endParaRPr>
+                    </a:p>
+                  </a:txBody>
+                  <a:tcPr marL="109728" marR="109728" marT="45720" marB="45720" anchor="ctr">
+                    <a:lnL w="12700" cap="flat" cmpd="sng" algn="ctr">
+                      <a:solidFill>
+                        <a:srgbClr val="DDE2E8"/>
+                      </a:solidFill>
+                      <a:prstDash val="solid"/>
+                      <a:round/>
+                      <a:headEnd type="none" w="med" len="med"/>
+                      <a:tailEnd type="none" w="med" len="med"/>
+                    </a:lnL>
+                    <a:lnR w="12700" cap="flat" cmpd="sng" algn="ctr">
+                      <a:solidFill>
+                        <a:srgbClr val="DDE2E8"/>
+                      </a:solidFill>
+                      <a:prstDash val="solid"/>
+                      <a:round/>
+                      <a:headEnd type="none" w="med" len="med"/>
+                      <a:tailEnd type="none" w="med" len="med"/>
+                    </a:lnR>
+                    <a:lnT w="12700" cap="flat" cmpd="sng" algn="ctr">
+                      <a:solidFill>
+                        <a:srgbClr val="DDE2E8"/>
+                      </a:solidFill>
+                      <a:prstDash val="solid"/>
+                      <a:round/>
+                      <a:headEnd type="none" w="med" len="med"/>
+                      <a:tailEnd type="none" w="med" len="med"/>
+                    </a:lnT>
+                    <a:lnB w="12700" cap="flat" cmpd="sng" algn="ctr">
+                      <a:solidFill>
+                        <a:srgbClr val="DDE2E8"/>
+                      </a:solidFill>
+                      <a:prstDash val="solid"/>
+                      <a:round/>
+                      <a:headEnd type="none" w="med" len="med"/>
+                      <a:tailEnd type="none" w="med" len="med"/>
+                    </a:lnB>
+                  </a:tcPr>
+                </a:tc>
+              </a:tr>
+              <a:tr h="429768">
+                <a:tc>
+                  <a:txBody>
+                    <a:bodyPr/>
+                    <a:lstStyle/>
+                    <a:p>
+                      <a:pPr indent="0" marL="0">
+                        <a:buNone/>
+                      </a:pPr>
+                      <a:r>
+                        <a:rPr lang="en-US" sz="1400" dirty="0">
+                          <a:solidFill>
+                            <a:schemeClr val="tx1"/>
+                          </a:solidFill>
+                          <a:latin typeface="Calibri" pitchFamily="34" charset="0"/>
+                          <a:ea typeface="Calibri" pitchFamily="34" charset="-122"/>
+                          <a:cs typeface="Calibri" pitchFamily="34" charset="-120"/>
+                        </a:rPr>
+                        <a:t>Yaygınlaştırma</a:t>
+                      </a:r>
+                      <a:endParaRPr lang="en-US" sz="1400" dirty="0">
+                        <a:latin typeface="Calibri" charset="0"/>
+                        <a:ea typeface="Calibri" charset="0"/>
+                        <a:cs typeface="Calibri" charset="0"/>
+                      </a:endParaRPr>
+                    </a:p>
+                  </a:txBody>
+                  <a:tcPr marL="109728" marR="109728" marT="45720" marB="45720" anchor="ctr">
+                    <a:lnL w="12700" cap="flat" cmpd="sng" algn="ctr">
+                      <a:solidFill>
+                        <a:srgbClr val="DDE2E8"/>
+                      </a:solidFill>
+                      <a:prstDash val="solid"/>
+                      <a:round/>
+                      <a:headEnd type="none" w="med" len="med"/>
+                      <a:tailEnd type="none" w="med" len="med"/>
+                    </a:lnL>
+                    <a:lnR w="12700" cap="flat" cmpd="sng" algn="ctr">
+                      <a:solidFill>
+                        <a:srgbClr val="DDE2E8"/>
+                      </a:solidFill>
+                      <a:prstDash val="solid"/>
+                      <a:round/>
+                      <a:headEnd type="none" w="med" len="med"/>
+                      <a:tailEnd type="none" w="med" len="med"/>
+                    </a:lnR>
+                    <a:lnT w="12700" cap="flat" cmpd="sng" algn="ctr">
+                      <a:solidFill>
+                        <a:srgbClr val="DDE2E8"/>
+                      </a:solidFill>
+                      <a:prstDash val="solid"/>
+                      <a:round/>
+                      <a:headEnd type="none" w="med" len="med"/>
+                      <a:tailEnd type="none" w="med" len="med"/>
+                    </a:lnT>
+                    <a:lnB w="12700" cap="flat" cmpd="sng" algn="ctr">
+                      <a:solidFill>
+                        <a:srgbClr val="DDE2E8"/>
+                      </a:solidFill>
+                      <a:prstDash val="solid"/>
+                      <a:round/>
+                      <a:headEnd type="none" w="med" len="med"/>
+                      <a:tailEnd type="none" w="med" len="med"/>
+                    </a:lnB>
+                  </a:tcPr>
+                </a:tc>
+                <a:tc>
+                  <a:txBody>
+                    <a:bodyPr/>
+                    <a:lstStyle/>
+                    <a:p>
+                      <a:pPr indent="0" marL="0">
+                        <a:buNone/>
+                      </a:pPr>
+                      <a:r>
+                        <a:rPr lang="en-US" sz="1400" dirty="0">
+                          <a:solidFill>
+                            <a:schemeClr val="tx1"/>
+                          </a:solidFill>
+                          <a:latin typeface="Calibri" pitchFamily="34" charset="0"/>
+                          <a:ea typeface="Calibri" pitchFamily="34" charset="-122"/>
+                          <a:cs typeface="Calibri" pitchFamily="34" charset="-120"/>
+                        </a:rPr>
+                        <a:t>Her kanal ve uygulama ayrı süreç</a:t>
+                      </a:r>
+                      <a:endParaRPr lang="en-US" sz="1400" dirty="0">
+                        <a:latin typeface="Calibri" charset="0"/>
+                        <a:ea typeface="Calibri" charset="0"/>
+                        <a:cs typeface="Calibri" charset="0"/>
+                      </a:endParaRPr>
+                    </a:p>
+                  </a:txBody>
+                  <a:tcPr marL="109728" marR="109728" marT="45720" marB="45720" anchor="ctr">
+                    <a:lnL w="12700" cap="flat" cmpd="sng" algn="ctr">
+                      <a:solidFill>
+                        <a:srgbClr val="DDE2E8"/>
+                      </a:solidFill>
+                      <a:prstDash val="solid"/>
+                      <a:round/>
+                      <a:headEnd type="none" w="med" len="med"/>
+                      <a:tailEnd type="none" w="med" len="med"/>
+                    </a:lnL>
+                    <a:lnR w="12700" cap="flat" cmpd="sng" algn="ctr">
+                      <a:solidFill>
+                        <a:srgbClr val="DDE2E8"/>
+                      </a:solidFill>
+                      <a:prstDash val="solid"/>
+                      <a:round/>
+                      <a:headEnd type="none" w="med" len="med"/>
+                      <a:tailEnd type="none" w="med" len="med"/>
+                    </a:lnR>
+                    <a:lnT w="12700" cap="flat" cmpd="sng" algn="ctr">
+                      <a:solidFill>
+                        <a:srgbClr val="DDE2E8"/>
+                      </a:solidFill>
+                      <a:prstDash val="solid"/>
+                      <a:round/>
+                      <a:headEnd type="none" w="med" len="med"/>
+                      <a:tailEnd type="none" w="med" len="med"/>
+                    </a:lnT>
+                    <a:lnB w="12700" cap="flat" cmpd="sng" algn="ctr">
+                      <a:solidFill>
+                        <a:srgbClr val="DDE2E8"/>
+                      </a:solidFill>
+                      <a:prstDash val="solid"/>
+                      <a:round/>
+                      <a:headEnd type="none" w="med" len="med"/>
+                      <a:tailEnd type="none" w="med" len="med"/>
+                    </a:lnB>
+                  </a:tcPr>
+                </a:tc>
+                <a:tc>
+                  <a:txBody>
+                    <a:bodyPr/>
+                    <a:lstStyle/>
+                    <a:p>
+                      <a:pPr indent="0" marL="0">
+                        <a:buNone/>
+                      </a:pPr>
+                      <a:r>
+                        <a:rPr lang="en-US" sz="1400" dirty="0">
+                          <a:solidFill>
+                            <a:schemeClr val="tx1"/>
+                          </a:solidFill>
+                          <a:latin typeface="Calibri" pitchFamily="34" charset="0"/>
+                          <a:ea typeface="Calibri" pitchFamily="34" charset="-122"/>
+                          <a:cs typeface="Calibri" pitchFamily="34" charset="-120"/>
+                        </a:rPr>
+                        <a:t>Aynı yapı tüm dijital kanallara ve iç uygulamalara</a:t>
                       </a:r>
                       <a:endParaRPr lang="en-US" sz="1400" dirty="0">
                         <a:latin typeface="Calibri" charset="0"/>

</xml_diff>

<commit_message>
Tüm dokümanları A–F senaryolarına göre güncelle
- Kapsam, iş planı, uygulama rehberi ve Copilot prompt'ları yeni senaryolara,
  Next.js + FastAPI mimarisine ve iki App Service'e göre yeniden yazıldı
- Sentetik veri planı ve üretim rehberi: yeni şema, katalog, senaryo rakamları,
  yasak kurallar, betikler, demo sıfırlama ve doğrulama tablosu
- Efor ve takvim kuralı netleştirildi (ana servis payı x 1,2), E servis payları
- Sunum: altı senaryo tek slaytta, canlı demo dört sahne, yeni taslak ekranlar
- README, doküman haritası ve anlatım cümleleri; hackathon öncesi maddeler kaldırıldı

Co-Authored-By: Claude Opus 5.5 <noreply@anthropic.com>
Claude-Session: https://claude.ai/code/session_01DTiHxbPkixs9Jadunw7PB9
</commit_message>
<xml_diff>
--- a/presentation/Mercek_AI_Overflow_Sunum.pptx
+++ b/presentation/Mercek_AI_Overflow_Sunum.pptx
@@ -117,27 +117,27 @@
   <p:extLst>
     <p:ext uri="{521415D9-36F7-43E2-AB2F-B90AF26B5E84}">
       <p14:sectionLst xmlns:p14="http://schemas.microsoft.com/office/powerpoint/2010/main">
-        <p14:section name="Açılış" id="{9d50512d-5699-2619-95c3-f5084f850c70}">
+        <p14:section name="Açılış" id="{09af6821-7671-46e2-a895-ba208dae7262}">
           <p14:sldIdLst>
             <p14:sldId id="256"/>
             <p14:sldId id="257"/>
           </p14:sldIdLst>
         </p14:section>
-        <p14:section name="Problem ve çözüm" id="{b11fcce0-9103-b751-8e80-fd09ee168271}">
+        <p14:section name="Problem ve çözüm" id="{8fca1847-e842-dd58-3b6e-aad0601d5fa8}">
           <p14:sldIdLst>
             <p14:sldId id="258"/>
             <p14:sldId id="259"/>
             <p14:sldId id="260"/>
           </p14:sldIdLst>
         </p14:section>
-        <p14:section name="Ürün" id="{5b887ed5-ae0d-4539-a403-e42e14df49e9}">
+        <p14:section name="Ürün" id="{5d874860-57a7-3349-037c-33dcd6f402ab}">
           <p14:sldIdLst>
             <p14:sldId id="261"/>
             <p14:sldId id="262"/>
             <p14:sldId id="263"/>
           </p14:sldIdLst>
         </p14:section>
-        <p14:section name="Değer ve kapanış" id="{4423d3af-e1dd-4230-0a6a-095b88b1adc6}">
+        <p14:section name="Değer ve kapanış" id="{f4bfd0a0-9299-8d09-8c68-a757cfc56efc}">
           <p14:sldIdLst>
             <p14:sldId id="264"/>
             <p14:sldId id="265"/>
@@ -636,7 +636,7 @@
           <a:p>
             <a:r>
               <a:rPr lang="en-US" dirty="0"/>
-              <a:t>4:40–4:55 · 'Tamamlanan' listesini 2. gün 12:00'de gerçek duruma göre güncelleyin. S-C: AI yanlışsa → eşik, kaynak, insan onayı, hesap kodda. Maliyet → küçük model, çağrı başına ölçülen maliyet. Kim kullanır → müşteri, L1/L2, analist.</a:t>
+              <a:t>4:45–4:55 · 'Tamamlanan' listesini 2. gün 12:00'de gerçek duruma göre güncelleyin. S-C: AI yanlışsa → eşik, kaynak, sayı doğrulaması, insan onayı. Maliyet → küçük model, kısa bağlam, analiz başına ölçülen token.</a:t>
             </a:r>
             <a:endParaRPr lang="en-US" dirty="0"/>
           </a:p>
@@ -900,7 +900,7 @@
           <a:p>
             <a:r>
               <a:rPr lang="en-US" dirty="0"/>
-              <a:t>0:20–0:50 · Ayşe'nin hikâyesi: EFT hatası, çağrı merkezi, L1, L2, ekip. Her adımda bağlam kayboluyor. Aynı ekrana gelen değişiklik talepleri de bu çağrı birikimini hiç görmüyor. (Süre ifadeleri varsayımdır; kurum içi gerçek rakam varsa onunla değiştirin.)</a:t>
+              <a:t>0:20–0:40 · Şube personeli işlem yapamadığında hata mı kural mı bilemiyor, çağrı açıyor. L1 ve L2 Kibana'da log arıyor, aynı kurum sorunu için onlarca çağrı açılıyor, bilinen çözümler kişilerde kalıyor. Yeni talepler de bu sorunlardan habersiz planlanıyor.</a:t>
             </a:r>
             <a:endParaRPr lang="en-US" dirty="0"/>
           </a:p>
@@ -988,7 +988,7 @@
           <a:p>
             <a:r>
               <a:rPr lang="en-US" dirty="0"/>
-              <a:t>0:50–1:05 · Tek cümle çözüm. İki modül ve aralarındaki köprü: çağrı verisi talep kapsamına giriyor. Hedef kullanıcılar.</a:t>
+              <a:t>0:40–0:50 · Tek cümle çözüm. İki modül ve köprü: loglar, çağrı ve müşteri verisi talep kapsamına giriyor. Mercek'i müşteri değil banka çalışanları kullanıyor.</a:t>
             </a:r>
             <a:endParaRPr lang="en-US" dirty="0"/>
           </a:p>
@@ -1076,7 +1076,7 @@
           <a:p>
             <a:r>
               <a:rPr lang="en-US" dirty="0"/>
-              <a:t>1:05–1:20 · Bugünkü araçlar çağrıyı kaydeder; Mercek çağrı açılmadan tespit eder, gerekirse kodu okur ve çağrı birikimini yeni talebe bağlar. AI'ın rolü sınırlı ve denetlenebilir: hesap kodda.</a:t>
+              <a:t>0:50–0:58 · Mercek çağrıyı kaydetmekle kalmıyor: açıklıyor, birleştiriyor, koda bağlıyor ve talebi gerekçelendiriyor. AI'ın rolü sınırlı ve denetlenebilir.</a:t>
             </a:r>
             <a:endParaRPr lang="en-US" dirty="0"/>
           </a:p>
@@ -1164,7 +1164,7 @@
           <a:p>
             <a:r>
               <a:rPr lang="en-US" dirty="0"/>
-              <a:t>1:20–1:35 · Tek App Service; Foundry'de sohbet ve embedding modeli; SQL yapısal veri; AI Search hibrit arama. CI/CD her PR'da test ve güvenlik taraması yapıyor. Sağda: AI'ın ve kuralların işi net ayrılmış. (Sadece gerçekten çalışan servisler bu slaytta kalmalı.)</a:t>
+              <a:t>0:58–1:05 · İki App Service (web ve api), Foundry'de sohbet ve embedding modeli, SQL yapısal veri, AI Search hibrit arama. CI/CD her PR'da test ve güvenlik taraması yapıyor. Sağda AI'ın ve kuralların işi. (Yalnızca gerçekten çalışan servisler bu slaytta kalmalı.)</a:t>
             </a:r>
             <a:endParaRPr lang="en-US" dirty="0"/>
           </a:p>
@@ -1252,7 +1252,7 @@
           <a:p>
             <a:r>
               <a:rPr lang="en-US" dirty="0"/>
-              <a:t>1:35–1:45 · Üç kullanıcı, üç ekran, tek akış. Detayı demoda göstereceğiz.</a:t>
+              <a:t>1:05–1:20 · Mercek'in altı kullanım senaryosu. 'CANLI' etiketliler birazdan canlı gösterilecek; diğerleri ekran görüntüsü veya kısa videoyla. (2. gün 12:00 kod dondurmada etiketleri gerçek duruma göre güncelleyin: canlı demoya yalnızca deploy edilmiş ortamda doğrulaması yeşil ve 3 provada hatasız olan senaryolar girer.)</a:t>
             </a:r>
             <a:endParaRPr lang="en-US" dirty="0"/>
           </a:p>
@@ -1340,7 +1340,7 @@
           <a:p>
             <a:r>
               <a:rPr lang="en-US" dirty="0"/>
-              <a:t>1:45–4:15 · CANLI DEMO (yaklaşık 2,5 dk). Sahne 1: Para Transferi'nde 2.500 TL EFT → hata → Sorun yaşıyorum → olası neden kartı → Bana göster (havale turu). Sahne 2: Destek Konsolu CAG-1042 (%93 eşleşme, kaynaklar) → CAG-1043 (%41, kod analizi, diff). Sahne 3: Talep Asistanı 'favori alıcı' → etki, 15–22 adam-gün, 9 Kasım → 4 Aralık → 312 çağrı → kapsama ekle → 9 Aralık. Bağlantı sorunu olursa yedek videoya geçin.</a:t>
+              <a:t>1:20–4:15 · CANLI DEMO (~3 dk), önce demo_reset çalıştırılmış olmalı. A: Elif KRDTKULL 400.000 / 3 ay → Sorun yaşıyorum → iş kuralı kartı → Bana göster. B: Mehmet ODMTFATR Başkentgaz (odm-dogalgaz turu) → Zeynep Mercek'e yazar → müşteriye söylenecek metin, CAG-2051 bağlı vaka 12 → Kerem %93 eşleşme. C: Elif İSKİ metni → 412 / %97 / 13 hane, duyuru → Kerem: %35, kod analizi, diff, ASKİ. D: Fatma talebi → analiz kartları → önerileri kabul et → 18 a/g, 9 Kasım–2 Aralık → köprü → Evet → 20 a/g, 4 Aralık. Canlıda olmayan sahneyi ekran görüntüsüyle 15 sn'de geçin; bir sahne bozulursa videosuna geçin.</a:t>
             </a:r>
             <a:endParaRPr lang="en-US" dirty="0"/>
           </a:p>
@@ -1428,7 +1428,7 @@
           <a:p>
             <a:r>
               <a:rPr lang="en-US" dirty="0"/>
-              <a:t>4:15–4:40 · Önce/sonra. Ölçümlerden gelen gerçek süreleri (tespit X sn, zenginleştirme Y sn, tahmin Z sn) büyük rakamların yerine koyun. Varsayımları açıkça söyleyin.</a:t>
+              <a:t>4:15–4:45 · Önce/sonra. Demo sırasında artan sayaçları ve ölçülen analiz süresini söyleyin. Varsayımları açıkça belirtin.</a:t>
             </a:r>
             <a:endParaRPr lang="en-US" dirty="0"/>
           </a:p>
@@ -2478,14 +2478,14 @@
               <a:buChar char="•"/>
             </a:pPr>
             <a:r>
-              <a:rPr lang="en-US" sz="1500" dirty="0">
+              <a:rPr lang="en-US" sz="1400" dirty="0">
                 <a:solidFill>
                   <a:schemeClr val="tx1"/>
                 </a:solidFill>
               </a:rPr>
-              <a:t>M1: tespit, zenginleştirme, eşleştirme, kod analizi</a:t>
-            </a:r>
-            <a:endParaRPr lang="en-US" sz="1500" dirty="0"/>
+              <a:t>M1: bağlam, log örüntüsü, servis ataması, ana kayıt, eşleştirme, kod analizi</a:t>
+            </a:r>
+            <a:endParaRPr lang="en-US" sz="1400" dirty="0"/>
           </a:p>
           <a:p>
             <a:pPr marL="342900" indent="-342900">
@@ -2496,14 +2496,14 @@
               <a:buChar char="•"/>
             </a:pPr>
             <a:r>
-              <a:rPr lang="en-US" sz="1500" dirty="0">
+              <a:rPr lang="en-US" sz="1400" dirty="0">
                 <a:solidFill>
                   <a:schemeClr val="tx1"/>
                 </a:solidFill>
               </a:rPr>
-              <a:t>M2: sınıflandırma, etki, efor, takvim, köprü</a:t>
-            </a:r>
-            <a:endParaRPr lang="en-US" sz="1500" dirty="0"/>
+              <a:t>M2: talep analizi, servis etkisi, adam-gün, takvim, köprü</a:t>
+            </a:r>
+            <a:endParaRPr lang="en-US" sz="1400" dirty="0"/>
           </a:p>
           <a:p>
             <a:pPr marL="342900" indent="-342900">
@@ -2514,14 +2514,14 @@
               <a:buChar char="•"/>
             </a:pPr>
             <a:r>
-              <a:rPr lang="en-US" sz="1500" dirty="0">
+              <a:rPr lang="en-US" sz="1400" dirty="0">
                 <a:solidFill>
                   <a:schemeClr val="tx1"/>
                 </a:solidFill>
               </a:rPr>
-              <a:t>Azure: App Service, Foundry, SQL, AI Search</a:t>
-            </a:r>
-            <a:endParaRPr lang="en-US" sz="1500" dirty="0"/>
+              <a:t>Azure: 2 App Service, Foundry, SQL, AI Search</a:t>
+            </a:r>
+            <a:endParaRPr lang="en-US" sz="1400" dirty="0"/>
           </a:p>
           <a:p>
             <a:pPr marL="342900" indent="-342900">
@@ -2532,14 +2532,14 @@
               <a:buChar char="•"/>
             </a:pPr>
             <a:r>
-              <a:rPr lang="en-US" sz="1500" dirty="0">
+              <a:rPr lang="en-US" sz="1400" dirty="0">
                 <a:solidFill>
                   <a:schemeClr val="tx1"/>
                 </a:solidFill>
               </a:rPr>
               <a:t>CI/CD ve PR'da güvenlik taraması</a:t>
             </a:r>
-            <a:endParaRPr lang="en-US" sz="1500" dirty="0"/>
+            <a:endParaRPr lang="en-US" sz="1400" dirty="0"/>
           </a:p>
         </p:txBody>
       </p:sp>
@@ -2684,14 +2684,14 @@
               <a:buChar char="•"/>
             </a:pPr>
             <a:r>
-              <a:rPr lang="en-US" sz="1500" dirty="0">
+              <a:rPr lang="en-US" sz="1400" dirty="0">
                 <a:solidFill>
                   <a:schemeClr val="tx1"/>
                 </a:solidFill>
               </a:rPr>
               <a:t>Veri tamamen sentetik</a:t>
             </a:r>
-            <a:endParaRPr lang="en-US" sz="1500" dirty="0"/>
+            <a:endParaRPr lang="en-US" sz="1400" dirty="0"/>
           </a:p>
           <a:p>
             <a:pPr marL="342900" indent="-342900">
@@ -2702,14 +2702,14 @@
               <a:buChar char="•"/>
             </a:pPr>
             <a:r>
-              <a:rPr lang="en-US" sz="1500" dirty="0">
+              <a:rPr lang="en-US" sz="1400" dirty="0">
                 <a:solidFill>
                   <a:schemeClr val="tx1"/>
                 </a:solidFill>
               </a:rPr>
               <a:t>Gerçek log, çağrı ve kod entegrasyonu yok</a:t>
             </a:r>
-            <a:endParaRPr lang="en-US" sz="1500" dirty="0"/>
+            <a:endParaRPr lang="en-US" sz="1400" dirty="0"/>
           </a:p>
           <a:p>
             <a:pPr marL="342900" indent="-342900">
@@ -2720,14 +2720,32 @@
               <a:buChar char="•"/>
             </a:pPr>
             <a:r>
-              <a:rPr lang="en-US" sz="1500" dirty="0">
+              <a:rPr lang="en-US" sz="1400" dirty="0">
                 <a:solidFill>
                   <a:schemeClr val="tx1"/>
                 </a:solidFill>
               </a:rPr>
               <a:t>Kod düzeltmeleri öneri; uygulama insan onaylı</a:t>
             </a:r>
-            <a:endParaRPr lang="en-US" sz="1500" dirty="0"/>
+            <a:endParaRPr lang="en-US" sz="1400" dirty="0"/>
+          </a:p>
+          <a:p>
+            <a:pPr marL="342900" indent="-342900">
+              <a:spcAft>
+                <a:spcPts val="800"/>
+              </a:spcAft>
+              <a:buSzPct val="100000"/>
+              <a:buChar char="•"/>
+            </a:pPr>
+            <a:r>
+              <a:rPr lang="en-US" sz="1400" dirty="0">
+                <a:solidFill>
+                  <a:schemeClr val="tx1"/>
+                </a:solidFill>
+              </a:rPr>
+              <a:t>E-posta ve SMS gönderimi simülasyon</a:t>
+            </a:r>
+            <a:endParaRPr lang="en-US" sz="1400" dirty="0"/>
           </a:p>
         </p:txBody>
       </p:sp>
@@ -2872,14 +2890,14 @@
               <a:buChar char="•"/>
             </a:pPr>
             <a:r>
-              <a:rPr lang="en-US" sz="1500" dirty="0">
+              <a:rPr lang="en-US" sz="1400" dirty="0">
                 <a:solidFill>
                   <a:schemeClr val="tx1"/>
                 </a:solidFill>
               </a:rPr>
-              <a:t>Log, çağrı ve kod reposu için salt-okur entegrasyon</a:t>
-            </a:r>
-            <a:endParaRPr lang="en-US" sz="1500" dirty="0"/>
+              <a:t>Log kaynağı: Kibana / Elasticsearch</a:t>
+            </a:r>
+            <a:endParaRPr lang="en-US" sz="1400" dirty="0"/>
           </a:p>
           <a:p>
             <a:pPr marL="342900" indent="-342900">
@@ -2890,14 +2908,14 @@
               <a:buChar char="•"/>
             </a:pPr>
             <a:r>
-              <a:rPr lang="en-US" sz="1500" dirty="0">
+              <a:rPr lang="en-US" sz="1400" dirty="0">
                 <a:solidFill>
                   <a:schemeClr val="tx1"/>
                 </a:solidFill>
               </a:rPr>
-              <a:t>KVKK: loglarda maskeleme</a:t>
-            </a:r>
-            <a:endParaRPr lang="en-US" sz="1500" dirty="0"/>
+              <a:t>Çağrı sistemi ve kod reposu için salt-okur entegrasyon</a:t>
+            </a:r>
+            <a:endParaRPr lang="en-US" sz="1400" dirty="0"/>
           </a:p>
           <a:p>
             <a:pPr marL="342900" indent="-342900">
@@ -2908,14 +2926,14 @@
               <a:buChar char="•"/>
             </a:pPr>
             <a:r>
-              <a:rPr lang="en-US" sz="1500" dirty="0">
+              <a:rPr lang="en-US" sz="1400" dirty="0">
                 <a:solidFill>
                   <a:schemeClr val="tx1"/>
                 </a:solidFill>
               </a:rPr>
-              <a:t>Pilot: tek kanal, tek ekran (Para Transferi)</a:t>
-            </a:r>
-            <a:endParaRPr lang="en-US" sz="1500" dirty="0"/>
+              <a:t>KVKK: loglarda maskeleme</a:t>
+            </a:r>
+            <a:endParaRPr lang="en-US" sz="1400" dirty="0"/>
           </a:p>
           <a:p>
             <a:pPr marL="342900" indent="-342900">
@@ -2926,14 +2944,14 @@
               <a:buChar char="•"/>
             </a:pPr>
             <a:r>
-              <a:rPr lang="en-US" sz="1500" dirty="0">
+              <a:rPr lang="en-US" sz="1400" dirty="0">
                 <a:solidFill>
                   <a:schemeClr val="tx1"/>
                 </a:solidFill>
               </a:rPr>
-              <a:t>AI maliyeti ve doğruluğunun izlenmesi</a:t>
-            </a:r>
-            <a:endParaRPr lang="en-US" sz="1500" dirty="0"/>
+              <a:t>Pilot: şube kanalı, KRDTKULL ve ODMTFATR</a:t>
+            </a:r>
+            <a:endParaRPr lang="en-US" sz="1400" dirty="0"/>
           </a:p>
         </p:txBody>
       </p:sp>
@@ -3235,7 +3253,7 @@
                   <a:schemeClr val="accent1"/>
                 </a:solidFill>
               </a:rPr>
-              <a:t>[mercek-app adresi]</a:t>
+              <a:t>[mercek-web adresi]</a:t>
             </a:r>
             <a:endParaRPr lang="en-US" sz="1800" dirty="0"/>
           </a:p>
@@ -3320,7 +3338,7 @@
                   <a:schemeClr val="bg1"/>
                 </a:solidFill>
               </a:rPr>
-              <a:t>Demo videosu</a:t>
+              <a:t>Senaryo videoları</a:t>
             </a:r>
             <a:endParaRPr lang="en-US" sz="1800" dirty="0"/>
           </a:p>
@@ -4344,7 +4362,7 @@
                   <a:schemeClr val="accent5"/>
                 </a:solidFill>
               </a:rPr>
-              <a:t>Görevler 19 maddelik sorumluluk listesinden herkesin kendi seçimiyle dağıtıldı.</a:t>
+              <a:t>Sorumluluklar 19 maddelik listeden herkesin kendi seçimiyle dağıtıldı.</a:t>
             </a:r>
             <a:endParaRPr lang="en-US" sz="1400" dirty="0"/>
           </a:p>
@@ -4452,7 +4470,7 @@
                   <a:schemeClr val="tx1"/>
                 </a:solidFill>
               </a:rPr>
-              <a:t>Bir EFT hatası, saatler süren bir yolculuk</a:t>
+              <a:t>Hata mı, kural mı? Bilinmeyince çağrı açılıyor</a:t>
             </a:r>
             <a:endParaRPr lang="en-US" sz="3600" dirty="0"/>
           </a:p>
@@ -4518,7 +4536,7 @@
         <p:spPr>
           <a:xfrm>
             <a:off x="868680" y="2423160"/>
-            <a:ext cx="2651760" cy="1463040"/>
+            <a:ext cx="2651760" cy="2011680"/>
           </a:xfrm>
           <a:prstGeom prst="rect">
             <a:avLst/>
@@ -4534,14 +4552,14 @@
               <a:buNone/>
             </a:pPr>
             <a:r>
-              <a:rPr lang="en-US" sz="2600" b="1" i="1" dirty="0">
+              <a:rPr lang="en-US" sz="2400" b="1" i="1" dirty="0">
                 <a:solidFill>
                   <a:schemeClr val="bg1"/>
                 </a:solidFill>
               </a:rPr>
-              <a:t>“Kiramı gönderemiyorum, acil.”</a:t>
-            </a:r>
-            <a:endParaRPr lang="en-US" sz="2600" dirty="0"/>
+              <a:t>“Ekran ‘kullandırılamaz’ diyor. Sistem mi bozuk?”</a:t>
+            </a:r>
+            <a:endParaRPr lang="en-US" sz="2400" dirty="0"/>
           </a:p>
         </p:txBody>
       </p:sp>
@@ -4575,7 +4593,7 @@
                   <a:schemeClr val="bg2"/>
                 </a:solidFill>
               </a:rPr>
-              <a:t>Ayşe, bireysel müşteri · Para Transferi ekranı</a:t>
+              <a:t>Elif, şube müşteri temsilcisi · KRDTKULL</a:t>
             </a:r>
             <a:endParaRPr lang="en-US" sz="1400" dirty="0"/>
           </a:p>
@@ -4694,14 +4712,14 @@
               <a:buNone/>
             </a:pPr>
             <a:r>
-              <a:rPr lang="en-US" sz="1400" dirty="0">
+              <a:rPr lang="en-US" sz="1300" dirty="0">
                 <a:solidFill>
                   <a:schemeClr val="tx1"/>
                 </a:solidFill>
               </a:rPr>
-              <a:t>Müşteri hata alır</a:t>
-            </a:r>
-            <a:endParaRPr lang="en-US" sz="1400" dirty="0"/>
+              <a:t>Temsilci uyarıyı görür</a:t>
+            </a:r>
+            <a:endParaRPr lang="en-US" sz="1300" dirty="0"/>
           </a:p>
         </p:txBody>
       </p:sp>
@@ -4818,14 +4836,14 @@
               <a:buNone/>
             </a:pPr>
             <a:r>
-              <a:rPr lang="en-US" sz="1400" dirty="0">
+              <a:rPr lang="en-US" sz="1300" dirty="0">
                 <a:solidFill>
                   <a:schemeClr val="tx1"/>
                 </a:solidFill>
               </a:rPr>
-              <a:t>Çağrı merkezini arar</a:t>
-            </a:r>
-            <a:endParaRPr lang="en-US" sz="1400" dirty="0"/>
+              <a:t>Çağrı açar</a:t>
+            </a:r>
+            <a:endParaRPr lang="en-US" sz="1300" dirty="0"/>
           </a:p>
         </p:txBody>
       </p:sp>
@@ -4942,14 +4960,14 @@
               <a:buNone/>
             </a:pPr>
             <a:r>
-              <a:rPr lang="en-US" sz="1400" dirty="0">
+              <a:rPr lang="en-US" sz="1300" dirty="0">
                 <a:solidFill>
                   <a:schemeClr val="tx1"/>
                 </a:solidFill>
               </a:rPr>
-              <a:t>L1 tek cümlelik kayıt açar</a:t>
-            </a:r>
-            <a:endParaRPr lang="en-US" sz="1400" dirty="0"/>
+              <a:t>L1 Kibana'da log arar</a:t>
+            </a:r>
+            <a:endParaRPr lang="en-US" sz="1300" dirty="0"/>
           </a:p>
         </p:txBody>
       </p:sp>
@@ -5066,14 +5084,14 @@
               <a:buNone/>
             </a:pPr>
             <a:r>
-              <a:rPr lang="en-US" sz="1400" dirty="0">
+              <a:rPr lang="en-US" sz="1300" dirty="0">
                 <a:solidFill>
                   <a:schemeClr val="tx1"/>
                 </a:solidFill>
               </a:rPr>
-              <a:t>L2 log arar, ekibi bulur</a:t>
-            </a:r>
-            <a:endParaRPr lang="en-US" sz="1400" dirty="0"/>
+              <a:t>L2 kurumu ve kodu inceler</a:t>
+            </a:r>
+            <a:endParaRPr lang="en-US" sz="1300" dirty="0"/>
           </a:p>
         </p:txBody>
       </p:sp>
@@ -5190,14 +5208,14 @@
               <a:buNone/>
             </a:pPr>
             <a:r>
-              <a:rPr lang="en-US" sz="1400" dirty="0">
+              <a:rPr lang="en-US" sz="1300" dirty="0">
                 <a:solidFill>
                   <a:schemeClr val="tx1"/>
                 </a:solidFill>
               </a:rPr>
-              <a:t>Ekip kök nedeni arar</a:t>
-            </a:r>
-            <a:endParaRPr lang="en-US" sz="1400" dirty="0"/>
+              <a:t>Yeni talep bu sorunlardan habersiz planlanır</a:t>
+            </a:r>
+            <a:endParaRPr lang="en-US" sz="1300" dirty="0"/>
           </a:p>
         </p:txBody>
       </p:sp>
@@ -5242,7 +5260,7 @@
                   <a:schemeClr val="accent3"/>
                 </a:solidFill>
               </a:rPr>
-              <a:t>saatlerce işlem yapamayan müşteri · her çağrıda çağrı merkezi, L1 ve L2 eforu · daha önce çözülmüş sorunun yeniden çözülmesi</a:t>
+              <a:t>işlem yapamayan müşteri · gereksiz çağrılar · aynı kurum sorunu için onlarca kayıt · veriden kopuk planlanan talepler</a:t>
             </a:r>
             <a:endParaRPr lang="en-US" sz="1400" dirty="0"/>
           </a:p>
@@ -5327,7 +5345,7 @@
                   <a:schemeClr val="tx1"/>
                 </a:solidFill>
               </a:rPr>
-              <a:t>Bağlam kaybolur</a:t>
+              <a:t>Hata mı kural mı belli değil</a:t>
             </a:r>
             <a:endParaRPr lang="en-US" sz="1600" dirty="0"/>
           </a:p>
@@ -5341,7 +5359,7 @@
                   <a:schemeClr val="accent5"/>
                 </a:solidFill>
               </a:rPr>
-              <a:t>Ekran, log ve kullanıcı adımları kayda girmiyor.</a:t>
+              <a:t>İş kuralı reddi ekranda teknik hatadan ayrılamıyor.</a:t>
             </a:r>
             <a:endParaRPr lang="en-US" sz="1600" dirty="0"/>
           </a:p>
@@ -5426,7 +5444,7 @@
                   <a:schemeClr val="tx1"/>
                 </a:solidFill>
               </a:rPr>
-              <a:t>Bilgi kişilerde</a:t>
+              <a:t>Aynı sorun, onlarca çağrı</a:t>
             </a:r>
             <a:endParaRPr lang="en-US" sz="1600" dirty="0"/>
           </a:p>
@@ -5440,7 +5458,7 @@
                   <a:schemeClr val="accent5"/>
                 </a:solidFill>
               </a:rPr>
-              <a:t>Aynı sorun daha önce çözülmüş ama aranamıyor.</a:t>
+              <a:t>Kurum kaynaklı sorunda her arama ayrı kayıt; çözüm kişilerde.</a:t>
             </a:r>
             <a:endParaRPr lang="en-US" sz="1600" dirty="0"/>
           </a:p>
@@ -5525,7 +5543,7 @@
                   <a:schemeClr val="tx1"/>
                 </a:solidFill>
               </a:rPr>
-              <a:t>Talepler kopuk</a:t>
+              <a:t>Talepler veriden kopuk</a:t>
             </a:r>
             <a:endParaRPr lang="en-US" sz="1600" dirty="0"/>
           </a:p>
@@ -5539,7 +5557,7 @@
                   <a:schemeClr val="accent5"/>
                 </a:solidFill>
               </a:rPr>
-              <a:t>Aynı ekrana gelen yeni talep, o ekranın çağrılarını görmüyor.</a:t>
+              <a:t>Efor toplantıda; erişim ve kapasite sorunları geç fark ediliyor.</a:t>
             </a:r>
             <a:endParaRPr lang="en-US" sz="1600" dirty="0"/>
           </a:p>
@@ -5678,14 +5696,14 @@
               <a:buNone/>
             </a:pPr>
             <a:r>
-              <a:rPr lang="en-US" sz="1800" dirty="0">
+              <a:rPr lang="en-US" sz="1700" dirty="0">
                 <a:solidFill>
                   <a:schemeClr val="tx2"/>
                 </a:solidFill>
               </a:rPr>
-              <a:t>Sorunu müşteri daha çağrı açarken tespit eder, doğru ekibe yönlendirip çözüm önerir ve bu çağrı birikimini yeni taleplerin kapsamına, maliyetine ve takvimine dönüştürür.</a:t>
-            </a:r>
-            <a:endParaRPr lang="en-US" sz="1800" dirty="0"/>
+              <a:t>Banka çalışanlarının ekranlarda yaşadığı sorunu loglardan, çağrı geçmişinden ve koddan açıklar; çağrıları doğru servise yönlendirip birleştirir ve iş birimi taleplerini servis bazlı efor ve takvimle plana dönüştürür.</a:t>
+            </a:r>
+            <a:endParaRPr lang="en-US" sz="1700" dirty="0"/>
           </a:p>
         </p:txBody>
       </p:sp>
@@ -5830,14 +5848,14 @@
               <a:buChar char="•"/>
             </a:pPr>
             <a:r>
-              <a:rPr lang="en-US" sz="1600" dirty="0">
+              <a:rPr lang="en-US" sz="1500" dirty="0">
                 <a:solidFill>
                   <a:schemeClr val="tx1"/>
                 </a:solidFill>
               </a:rPr>
-              <a:t>Hatayı müşteri yazmadan tespit eder</a:t>
-            </a:r>
-            <a:endParaRPr lang="en-US" sz="1600" dirty="0"/>
+              <a:t>Ekran bağlamıyla logu bulur, iş kuralını hatadan ayırır</a:t>
+            </a:r>
+            <a:endParaRPr lang="en-US" sz="1500" dirty="0"/>
           </a:p>
           <a:p>
             <a:pPr marL="342900" indent="-342900">
@@ -5848,14 +5866,14 @@
               <a:buChar char="•"/>
             </a:pPr>
             <a:r>
-              <a:rPr lang="en-US" sz="1600" dirty="0">
+              <a:rPr lang="en-US" sz="1500" dirty="0">
                 <a:solidFill>
                   <a:schemeClr val="tx1"/>
                 </a:solidFill>
               </a:rPr>
-              <a:t>Çağrıyı zenginleştirir, doğru ekibe yönlendirir</a:t>
-            </a:r>
-            <a:endParaRPr lang="en-US" sz="1600" dirty="0"/>
+              <a:t>Çağrıyı servise atar, mükerrerleri ana kayda bağlar</a:t>
+            </a:r>
+            <a:endParaRPr lang="en-US" sz="1500" dirty="0"/>
           </a:p>
           <a:p>
             <a:pPr marL="342900" indent="-342900">
@@ -5866,14 +5884,14 @@
               <a:buChar char="•"/>
             </a:pPr>
             <a:r>
-              <a:rPr lang="en-US" sz="1600" dirty="0">
+              <a:rPr lang="en-US" sz="1500" dirty="0">
                 <a:solidFill>
                   <a:schemeClr val="tx1"/>
                 </a:solidFill>
               </a:rPr>
-              <a:t>Geçmiş çözümü bulur; yoksa kodu inceler</a:t>
-            </a:r>
-            <a:endParaRPr lang="en-US" sz="1600" dirty="0"/>
+              <a:t>Geçmiş çözümü bulur; yoksa duyuruya ve koda bakar</a:t>
+            </a:r>
+            <a:endParaRPr lang="en-US" sz="1500" dirty="0"/>
           </a:p>
         </p:txBody>
       </p:sp>
@@ -5983,7 +6001,7 @@
                   <a:schemeClr val="tx1"/>
                 </a:solidFill>
               </a:rPr>
-              <a:t>Akıllı Talep Analizi, Maliyet ve Takvim</a:t>
+              <a:t>Akıllı Talep Analizi, Efor ve Takvim</a:t>
             </a:r>
             <a:endParaRPr lang="en-US" sz="2000" dirty="0"/>
           </a:p>
@@ -6018,14 +6036,14 @@
               <a:buChar char="•"/>
             </a:pPr>
             <a:r>
-              <a:rPr lang="en-US" sz="1600" dirty="0">
+              <a:rPr lang="en-US" sz="1500" dirty="0">
                 <a:solidFill>
                   <a:schemeClr val="tx1"/>
                 </a:solidFill>
               </a:rPr>
-              <a:t>Talebi sınıflar, etkilenen servisleri bulur</a:t>
-            </a:r>
-            <a:endParaRPr lang="en-US" sz="1600" dirty="0"/>
+              <a:t>Talebi bileşenlere ayırır, ekranları ve servisleri bulur</a:t>
+            </a:r>
+            <a:endParaRPr lang="en-US" sz="1500" dirty="0"/>
           </a:p>
           <a:p>
             <a:pPr marL="342900" indent="-342900">
@@ -6036,14 +6054,14 @@
               <a:buChar char="•"/>
             </a:pPr>
             <a:r>
-              <a:rPr lang="en-US" sz="1600" dirty="0">
+              <a:rPr lang="en-US" sz="1500" dirty="0">
                 <a:solidFill>
                   <a:schemeClr val="tx1"/>
                 </a:solidFill>
               </a:rPr>
-              <a:t>Benzer taleplerden efor, maliyet, takvim çıkarır</a:t>
-            </a:r>
-            <a:endParaRPr lang="en-US" sz="1600" dirty="0"/>
+              <a:t>Benzer taleplerden adam-gün, servis takviminden plan</a:t>
+            </a:r>
+            <a:endParaRPr lang="en-US" sz="1500" dirty="0"/>
           </a:p>
           <a:p>
             <a:pPr marL="342900" indent="-342900">
@@ -6054,14 +6072,14 @@
               <a:buChar char="•"/>
             </a:pPr>
             <a:r>
-              <a:rPr lang="en-US" sz="1600" dirty="0">
+              <a:rPr lang="en-US" sz="1500" dirty="0">
                 <a:solidFill>
                   <a:schemeClr val="tx1"/>
                 </a:solidFill>
               </a:rPr>
-              <a:t>Ekranın çağrı geçmişini kapsama ekler</a:t>
-            </a:r>
-            <a:endParaRPr lang="en-US" sz="1600" dirty="0"/>
+              <a:t>Çağrı ve müşteri verisiyle kapsamı düzeltir</a:t>
+            </a:r>
+            <a:endParaRPr lang="en-US" sz="1500" dirty="0"/>
           </a:p>
         </p:txBody>
       </p:sp>
@@ -6122,7 +6140,7 @@
                   <a:schemeClr val="accent1"/>
                 </a:solidFill>
               </a:rPr>
-              <a:t>çağrı</a:t>
+              <a:t>veri</a:t>
             </a:r>
             <a:endParaRPr lang="en-US" sz="1200" dirty="0"/>
           </a:p>
@@ -6186,7 +6204,7 @@
                   <a:schemeClr val="tx1"/>
                 </a:solidFill>
               </a:rPr>
-              <a:t>Hedef kullanıcılar</a:t>
+              <a:t>Kullanıcılar</a:t>
             </a:r>
             <a:endParaRPr lang="en-US" sz="1600" dirty="0"/>
           </a:p>
@@ -6268,14 +6286,14 @@
               <a:buNone/>
             </a:pPr>
             <a:r>
-              <a:rPr lang="en-US" sz="1400" dirty="0">
+              <a:rPr lang="en-US" sz="1300" dirty="0">
                 <a:solidFill>
                   <a:schemeClr val="tx1"/>
                 </a:solidFill>
               </a:rPr>
-              <a:t>Müşteri</a:t>
-            </a:r>
-            <a:endParaRPr lang="en-US" sz="1400" dirty="0"/>
+              <a:t>Şube, çağrı merkezi</a:t>
+            </a:r>
+            <a:endParaRPr lang="en-US" sz="1300" dirty="0"/>
           </a:p>
         </p:txBody>
       </p:sp>
@@ -6355,14 +6373,14 @@
               <a:buNone/>
             </a:pPr>
             <a:r>
-              <a:rPr lang="en-US" sz="1400" dirty="0">
+              <a:rPr lang="en-US" sz="1300" dirty="0">
                 <a:solidFill>
                   <a:schemeClr val="tx1"/>
                 </a:solidFill>
               </a:rPr>
-              <a:t>L1 / L2 destek</a:t>
-            </a:r>
-            <a:endParaRPr lang="en-US" sz="1400" dirty="0"/>
+              <a:t>L2, platform</a:t>
+            </a:r>
+            <a:endParaRPr lang="en-US" sz="1300" dirty="0"/>
           </a:p>
         </p:txBody>
       </p:sp>
@@ -6442,14 +6460,14 @@
               <a:buNone/>
             </a:pPr>
             <a:r>
-              <a:rPr lang="en-US" sz="1400" dirty="0">
+              <a:rPr lang="en-US" sz="1300" dirty="0">
                 <a:solidFill>
                   <a:schemeClr val="tx1"/>
                 </a:solidFill>
               </a:rPr>
-              <a:t>İş analisti</a:t>
-            </a:r>
-            <a:endParaRPr lang="en-US" sz="1400" dirty="0"/>
+              <a:t>İş birimleri</a:t>
+            </a:r>
+            <a:endParaRPr lang="en-US" sz="1300" dirty="0"/>
           </a:p>
         </p:txBody>
       </p:sp>
@@ -6529,14 +6547,14 @@
               <a:buNone/>
             </a:pPr>
             <a:r>
-              <a:rPr lang="en-US" sz="1400" dirty="0">
+              <a:rPr lang="en-US" sz="1300" dirty="0">
                 <a:solidFill>
                   <a:schemeClr val="tx1"/>
                 </a:solidFill>
               </a:rPr>
-              <a:t>Takım lideri</a:t>
-            </a:r>
-            <a:endParaRPr lang="en-US" sz="1400" dirty="0"/>
+              <a:t>İş analisti</a:t>
+            </a:r>
+            <a:endParaRPr lang="en-US" sz="1300" dirty="0"/>
           </a:p>
         </p:txBody>
       </p:sp>
@@ -6678,7 +6696,7 @@
                   <a:schemeClr val="tx2"/>
                 </a:solidFill>
               </a:rPr>
-              <a:t>Bugünkü çağrı araçları sorunu kaydeder; Mercek sorunu bulur, çözümü önerir ve yeni talebin planına bağlar.</a:t>
+              <a:t>Bugünkü araçlar sorunu kaydeder; Mercek sorunu açıklar, kaynağına bağlar ve yeni talebin planına taşır.</a:t>
             </a:r>
             <a:endParaRPr lang="en-US" sz="1800" dirty="0"/>
           </a:p>
@@ -6793,7 +6811,7 @@
                   <a:schemeClr val="tx1"/>
                 </a:solidFill>
               </a:rPr>
-              <a:t>Proaktif</a:t>
+              <a:t>Bağlamı bilir</a:t>
             </a:r>
             <a:endParaRPr lang="en-US" sz="2200" dirty="0"/>
           </a:p>
@@ -6805,12 +6823,12 @@
               <a:buNone/>
             </a:pPr>
             <a:r>
-              <a:rPr lang="en-US" sz="1600" dirty="0">
+              <a:rPr lang="en-US" sz="1500" dirty="0">
                 <a:solidFill>
                   <a:schemeClr val="tx2"/>
                 </a:solidFill>
               </a:rPr>
-              <a:t>Müşteri daha yazmadan, o ekranın canlı loglarından olası nedeni söyler ve alternatif yolu gösterir.</a:t>
+              <a:t>Ekran kodu, son işlemin logu ve temsilcinin cümlesiyle çalışır; kullanıcı yazmadan açıklar ve ekranı doğru değerlerle doldurur.</a:t>
             </a:r>
             <a:endParaRPr lang="en-US" sz="2200" dirty="0"/>
           </a:p>
@@ -6925,7 +6943,7 @@
                   <a:schemeClr val="tx1"/>
                 </a:solidFill>
               </a:rPr>
-              <a:t>Kodu okuyan AI</a:t>
+              <a:t>Üç kaynağı birleştirir</a:t>
             </a:r>
             <a:endParaRPr lang="en-US" sz="2200" dirty="0"/>
           </a:p>
@@ -6937,12 +6955,12 @@
               <a:buNone/>
             </a:pPr>
             <a:r>
-              <a:rPr lang="en-US" sz="1600" dirty="0">
+              <a:rPr lang="en-US" sz="1500" dirty="0">
                 <a:solidFill>
                   <a:schemeClr val="tx2"/>
                 </a:solidFill>
               </a:rPr>
-              <a:t>Geçmişte benzeri yoksa ilgili servis kodunu ve SP'yi inceler, satır düzeyinde düzeltme önerir.</a:t>
+              <a:t>Log (ne oluyor), kurum duyurusu (neden) ve uygulama kodu (nerede düzeltilir) tek analizde.</a:t>
             </a:r>
             <a:endParaRPr lang="en-US" sz="2200" dirty="0"/>
           </a:p>
@@ -7069,12 +7087,12 @@
               <a:buNone/>
             </a:pPr>
             <a:r>
-              <a:rPr lang="en-US" sz="1600" dirty="0">
+              <a:rPr lang="en-US" sz="1500" dirty="0">
                 <a:solidFill>
                   <a:schemeClr val="tx2"/>
                 </a:solidFill>
               </a:rPr>
-              <a:t>Bir ekranın çağrı birikimi, o ekrana gelen yeni talebin kapsamına ve maliyetine girer.</a:t>
+              <a:t>Çağrı ve müşteri verisi, talebin değerini kanıtlar ve eksik kapsamı talep anında gösterir.</a:t>
             </a:r>
             <a:endParaRPr lang="en-US" sz="2200" dirty="0"/>
           </a:p>
@@ -7201,12 +7219,12 @@
               <a:buNone/>
             </a:pPr>
             <a:r>
-              <a:rPr lang="en-US" sz="1600" dirty="0">
+              <a:rPr lang="en-US" sz="1500" dirty="0">
                 <a:solidFill>
                   <a:schemeClr val="tx2"/>
                 </a:solidFill>
               </a:rPr>
-              <a:t>Hesabı kod yapar, AI açıklar. Eşik altında öneri yok; her öneri kaynağıyla birlikte gelir.</a:t>
+              <a:t>Hesabı kod yapar, AI açıklar. Eşik altında öneri yok; her rakam ve kod satırı doğrulanır.</a:t>
             </a:r>
             <a:endParaRPr lang="en-US" sz="2200" dirty="0"/>
           </a:p>
@@ -7355,8 +7373,8 @@
         </p:nvSpPr>
         <p:spPr>
           <a:xfrm>
-            <a:off x="685800" y="2240280"/>
-            <a:ext cx="1463040" cy="2194560"/>
+            <a:off x="658368" y="2221992"/>
+            <a:ext cx="1517904" cy="2231136"/>
           </a:xfrm>
           <a:prstGeom prst="rect">
             <a:avLst/>
@@ -7372,14 +7390,14 @@
               <a:buNone/>
             </a:pPr>
             <a:r>
-              <a:rPr lang="en-US" sz="1600" b="1" dirty="0">
+              <a:rPr lang="en-US" sz="1500" b="1" dirty="0">
                 <a:solidFill>
                   <a:schemeClr val="tx1"/>
                 </a:solidFill>
               </a:rPr>
               <a:t>Kullanıcılar</a:t>
             </a:r>
-            <a:endParaRPr lang="en-US" sz="1600" dirty="0"/>
+            <a:endParaRPr lang="en-US" sz="1500" dirty="0"/>
           </a:p>
           <a:p>
             <a:pPr algn="ctr" indent="0" marL="0">
@@ -7391,9 +7409,9 @@
                   <a:schemeClr val="tx1"/>
                 </a:solidFill>
               </a:rPr>
-              <a:t>Müşteri</a:t>
-            </a:r>
-            <a:endParaRPr lang="en-US" sz="1600" dirty="0"/>
+              <a:t>Şube, çağrı merkezi</a:t>
+            </a:r>
+            <a:endParaRPr lang="en-US" sz="1500" dirty="0"/>
           </a:p>
           <a:p>
             <a:pPr algn="ctr" indent="0" marL="0">
@@ -7405,9 +7423,9 @@
                   <a:schemeClr val="tx1"/>
                 </a:solidFill>
               </a:rPr>
-              <a:t>Destek ekibi</a:t>
-            </a:r>
-            <a:endParaRPr lang="en-US" sz="1600" dirty="0"/>
+              <a:t>L2 destek</a:t>
+            </a:r>
+            <a:endParaRPr lang="en-US" sz="1500" dirty="0"/>
           </a:p>
           <a:p>
             <a:pPr algn="ctr" indent="0" marL="0">
@@ -7419,26 +7437,26 @@
                   <a:schemeClr val="tx1"/>
                 </a:solidFill>
               </a:rPr>
-              <a:t>İş analisti</a:t>
-            </a:r>
-            <a:endParaRPr lang="en-US" sz="1600" dirty="0"/>
-          </a:p>
-        </p:txBody>
-      </p:sp>
-      <p:sp>
-        <p:nvSpPr>
-          <p:cNvPr id="5" name="arch-app"/>
+              <a:t>İş birimi, analist</a:t>
+            </a:r>
+            <a:endParaRPr lang="en-US" sz="1500" dirty="0"/>
+          </a:p>
+        </p:txBody>
+      </p:sp>
+      <p:sp>
+        <p:nvSpPr>
+          <p:cNvPr id="5" name="arch-web"/>
           <p:cNvSpPr/>
           <p:nvPr/>
         </p:nvSpPr>
         <p:spPr>
           <a:xfrm>
-            <a:off x="2788920" y="2148840"/>
-            <a:ext cx="2240280" cy="2377440"/>
+            <a:off x="2743200" y="1325880"/>
+            <a:ext cx="2331720" cy="1554480"/>
           </a:xfrm>
           <a:prstGeom prst="roundRect">
             <a:avLst>
-              <a:gd name="adj" fmla="val 4898"/>
+              <a:gd name="adj" fmla="val 7059"/>
             </a:avLst>
           </a:prstGeom>
           <a:solidFill>
@@ -7460,8 +7478,8 @@
         </p:nvSpPr>
         <p:spPr>
           <a:xfrm>
-            <a:off x="2926080" y="2240280"/>
-            <a:ext cx="1965960" cy="2194560"/>
+            <a:off x="2852928" y="1399032"/>
+            <a:ext cx="2112264" cy="1408176"/>
           </a:xfrm>
           <a:prstGeom prst="rect">
             <a:avLst/>
@@ -7477,14 +7495,14 @@
               <a:buNone/>
             </a:pPr>
             <a:r>
-              <a:rPr lang="en-US" sz="1600" b="1" dirty="0">
+              <a:rPr lang="en-US" sz="1500" b="1" dirty="0">
                 <a:solidFill>
                   <a:schemeClr val="bg1"/>
                 </a:solidFill>
               </a:rPr>
-              <a:t>Azure App Service</a:t>
-            </a:r>
-            <a:endParaRPr lang="en-US" sz="1600" dirty="0"/>
+              <a:t>App Service · web</a:t>
+            </a:r>
+            <a:endParaRPr lang="en-US" sz="1500" dirty="0"/>
           </a:p>
           <a:p>
             <a:pPr algn="ctr" indent="0" marL="0">
@@ -7496,9 +7514,9 @@
                   <a:schemeClr val="bg1"/>
                 </a:solidFill>
               </a:rPr>
-              <a:t>React + FastAPI</a:t>
-            </a:r>
-            <a:endParaRPr lang="en-US" sz="1600" dirty="0"/>
+              <a:t>Next.js 16</a:t>
+            </a:r>
+            <a:endParaRPr lang="en-US" sz="1500" dirty="0"/>
           </a:p>
           <a:p>
             <a:pPr algn="ctr" indent="0" marL="0">
@@ -7510,9 +7528,9 @@
                   <a:schemeClr val="bg1"/>
                 </a:solidFill>
               </a:rPr>
-              <a:t>Tek dağıtım,</a:t>
-            </a:r>
-            <a:endParaRPr lang="en-US" sz="1600" dirty="0"/>
+              <a:t>Bankacılık ekranları,</a:t>
+            </a:r>
+            <a:endParaRPr lang="en-US" sz="1500" dirty="0"/>
           </a:p>
           <a:p>
             <a:pPr algn="ctr" indent="0" marL="0">
@@ -7524,15 +7542,120 @@
                   <a:schemeClr val="bg1"/>
                 </a:solidFill>
               </a:rPr>
-              <a:t>sağlık kontrolü</a:t>
-            </a:r>
-            <a:endParaRPr lang="en-US" sz="1600" dirty="0"/>
-          </a:p>
-        </p:txBody>
-      </p:sp>
-      <p:sp>
-        <p:nvSpPr>
-          <p:cNvPr id="7" name="arch-foundry"/>
+              <a:t>Mercek, Talep Yönlendirme</a:t>
+            </a:r>
+            <a:endParaRPr lang="en-US" sz="1500" dirty="0"/>
+          </a:p>
+        </p:txBody>
+      </p:sp>
+      <p:sp>
+        <p:nvSpPr>
+          <p:cNvPr id="7" name="arch-api"/>
+          <p:cNvSpPr/>
+          <p:nvPr/>
+        </p:nvSpPr>
+        <p:spPr>
+          <a:xfrm>
+            <a:off x="2743200" y="3794760"/>
+            <a:ext cx="2331720" cy="1554480"/>
+          </a:xfrm>
+          <a:prstGeom prst="roundRect">
+            <a:avLst>
+              <a:gd name="adj" fmla="val 7059"/>
+            </a:avLst>
+          </a:prstGeom>
+          <a:solidFill>
+            <a:schemeClr val="tx2"/>
+          </a:solidFill>
+          <a:ln w="12700">
+            <a:solidFill>
+              <a:schemeClr val="tx2"/>
+            </a:solidFill>
+            <a:prstDash val="solid"/>
+          </a:ln>
+        </p:spPr>
+      </p:sp>
+      <p:sp>
+        <p:nvSpPr>
+          <p:cNvPr id="8" name="Text 6"/>
+          <p:cNvSpPr txBox="1"/>
+          <p:nvPr/>
+        </p:nvSpPr>
+        <p:spPr>
+          <a:xfrm>
+            <a:off x="2852928" y="3867912"/>
+            <a:ext cx="2112264" cy="1408176"/>
+          </a:xfrm>
+          <a:prstGeom prst="rect">
+            <a:avLst/>
+          </a:prstGeom>
+          <a:noFill/>
+          <a:ln/>
+        </p:spPr>
+        <p:txBody>
+          <a:bodyPr wrap="square" lIns="0" tIns="0" rIns="0" bIns="0" rtlCol="0" anchor="ctr"/>
+          <a:lstStyle/>
+          <a:p>
+            <a:pPr algn="ctr" indent="0" marL="0">
+              <a:buNone/>
+            </a:pPr>
+            <a:r>
+              <a:rPr lang="en-US" sz="1500" b="1" dirty="0">
+                <a:solidFill>
+                  <a:schemeClr val="bg1"/>
+                </a:solidFill>
+              </a:rPr>
+              <a:t>App Service · api</a:t>
+            </a:r>
+            <a:endParaRPr lang="en-US" sz="1500" dirty="0"/>
+          </a:p>
+          <a:p>
+            <a:pPr algn="ctr" indent="0" marL="0">
+              <a:buNone/>
+            </a:pPr>
+            <a:r>
+              <a:rPr lang="en-US" sz="1200" dirty="0">
+                <a:solidFill>
+                  <a:schemeClr val="bg1"/>
+                </a:solidFill>
+              </a:rPr>
+              <a:t>FastAPI</a:t>
+            </a:r>
+            <a:endParaRPr lang="en-US" sz="1500" dirty="0"/>
+          </a:p>
+          <a:p>
+            <a:pPr algn="ctr" indent="0" marL="0">
+              <a:buNone/>
+            </a:pPr>
+            <a:r>
+              <a:rPr lang="en-US" sz="1200" dirty="0">
+                <a:solidFill>
+                  <a:schemeClr val="bg1"/>
+                </a:solidFill>
+              </a:rPr>
+              <a:t>/api/health · orkestrasyon,</a:t>
+            </a:r>
+            <a:endParaRPr lang="en-US" sz="1500" dirty="0"/>
+          </a:p>
+          <a:p>
+            <a:pPr algn="ctr" indent="0" marL="0">
+              <a:buNone/>
+            </a:pPr>
+            <a:r>
+              <a:rPr lang="en-US" sz="1200" dirty="0">
+                <a:solidFill>
+                  <a:schemeClr val="bg1"/>
+                </a:solidFill>
+              </a:rPr>
+              <a:t>hesap ve doğrulama</a:t>
+            </a:r>
+            <a:endParaRPr lang="en-US" sz="1500" dirty="0"/>
+          </a:p>
+        </p:txBody>
+      </p:sp>
+      <p:sp>
+        <p:nvSpPr>
+          <p:cNvPr id="9" name="arch-foundry"/>
           <p:cNvSpPr/>
           <p:nvPr/>
         </p:nvSpPr>
@@ -7559,14 +7682,14 @@
       </p:sp>
       <p:sp>
         <p:nvSpPr>
-          <p:cNvPr id="8" name="Text 6"/>
+          <p:cNvPr id="10" name="Text 8"/>
           <p:cNvSpPr txBox="1"/>
           <p:nvPr/>
         </p:nvSpPr>
         <p:spPr>
           <a:xfrm>
-            <a:off x="5623560" y="1417320"/>
-            <a:ext cx="2240280" cy="1051560"/>
+            <a:off x="5596128" y="1399032"/>
+            <a:ext cx="2295144" cy="1088136"/>
           </a:xfrm>
           <a:prstGeom prst="rect">
             <a:avLst/>
@@ -7582,14 +7705,14 @@
               <a:buNone/>
             </a:pPr>
             <a:r>
-              <a:rPr lang="en-US" sz="1600" b="1" dirty="0">
+              <a:rPr lang="en-US" sz="1500" b="1" dirty="0">
                 <a:solidFill>
                   <a:schemeClr val="tx1"/>
                 </a:solidFill>
               </a:rPr>
               <a:t>Azure AI Foundry</a:t>
             </a:r>
-            <a:endParaRPr lang="en-US" sz="1600" dirty="0"/>
+            <a:endParaRPr lang="en-US" sz="1500" dirty="0"/>
           </a:p>
           <a:p>
             <a:pPr algn="ctr" indent="0" marL="0">
@@ -7603,27 +7726,13 @@
               </a:rPr>
               <a:t>chat + embedding modeli</a:t>
             </a:r>
-            <a:endParaRPr lang="en-US" sz="1600" dirty="0"/>
-          </a:p>
-          <a:p>
-            <a:pPr algn="ctr" indent="0" marL="0">
-              <a:buNone/>
-            </a:pPr>
-            <a:r>
-              <a:rPr lang="en-US" sz="1200" dirty="0">
-                <a:solidFill>
-                  <a:schemeClr val="tx1"/>
-                </a:solidFill>
-              </a:rPr>
-              <a:t>Yönetilen, kurumsal model erişimi</a:t>
-            </a:r>
-            <a:endParaRPr lang="en-US" sz="1600" dirty="0"/>
-          </a:p>
-        </p:txBody>
-      </p:sp>
-      <p:sp>
-        <p:nvSpPr>
-          <p:cNvPr id="9" name="arch-sql"/>
+            <a:endParaRPr lang="en-US" sz="1500" dirty="0"/>
+          </a:p>
+        </p:txBody>
+      </p:sp>
+      <p:sp>
+        <p:nvSpPr>
+          <p:cNvPr id="11" name="arch-sql"/>
           <p:cNvSpPr/>
           <p:nvPr/>
         </p:nvSpPr>
@@ -7650,14 +7759,14 @@
       </p:sp>
       <p:sp>
         <p:nvSpPr>
-          <p:cNvPr id="10" name="Text 8"/>
+          <p:cNvPr id="12" name="Text 10"/>
           <p:cNvSpPr txBox="1"/>
           <p:nvPr/>
         </p:nvSpPr>
         <p:spPr>
           <a:xfrm>
-            <a:off x="5623560" y="2807208"/>
-            <a:ext cx="2240280" cy="1051560"/>
+            <a:off x="5596128" y="2788920"/>
+            <a:ext cx="2295144" cy="1088136"/>
           </a:xfrm>
           <a:prstGeom prst="rect">
             <a:avLst/>
@@ -7673,14 +7782,14 @@
               <a:buNone/>
             </a:pPr>
             <a:r>
-              <a:rPr lang="en-US" sz="1600" b="1" dirty="0">
+              <a:rPr lang="en-US" sz="1500" b="1" dirty="0">
                 <a:solidFill>
                   <a:schemeClr val="tx1"/>
                 </a:solidFill>
               </a:rPr>
               <a:t>Azure SQL</a:t>
             </a:r>
-            <a:endParaRPr lang="en-US" sz="1600" dirty="0"/>
+            <a:endParaRPr lang="en-US" sz="1500" dirty="0"/>
           </a:p>
           <a:p>
             <a:pPr algn="ctr" indent="0" marL="0">
@@ -7692,9 +7801,9 @@
                   <a:schemeClr val="tx1"/>
                 </a:solidFill>
               </a:rPr>
-              <a:t>Log, çağrı, talep, takvim</a:t>
-            </a:r>
-            <a:endParaRPr lang="en-US" sz="1600" dirty="0"/>
+              <a:t>Log, katalog, portföy,</a:t>
+            </a:r>
+            <a:endParaRPr lang="en-US" sz="1500" dirty="0"/>
           </a:p>
           <a:p>
             <a:pPr algn="ctr" indent="0" marL="0">
@@ -7706,15 +7815,15 @@
                   <a:schemeClr val="tx1"/>
                 </a:solidFill>
               </a:rPr>
-              <a:t>İlişkisel sorgu ve istatistik</a:t>
-            </a:r>
-            <a:endParaRPr lang="en-US" sz="1600" dirty="0"/>
-          </a:p>
-        </p:txBody>
-      </p:sp>
-      <p:sp>
-        <p:nvSpPr>
-          <p:cNvPr id="11" name="arch-search"/>
+              <a:t>çağrı, talep, takvim</a:t>
+            </a:r>
+            <a:endParaRPr lang="en-US" sz="1500" dirty="0"/>
+          </a:p>
+        </p:txBody>
+      </p:sp>
+      <p:sp>
+        <p:nvSpPr>
+          <p:cNvPr id="13" name="arch-search"/>
           <p:cNvSpPr/>
           <p:nvPr/>
         </p:nvSpPr>
@@ -7741,14 +7850,14 @@
       </p:sp>
       <p:sp>
         <p:nvSpPr>
-          <p:cNvPr id="12" name="Text 10"/>
+          <p:cNvPr id="14" name="Text 12"/>
           <p:cNvSpPr txBox="1"/>
           <p:nvPr/>
         </p:nvSpPr>
         <p:spPr>
           <a:xfrm>
-            <a:off x="5623560" y="4197096"/>
-            <a:ext cx="2240280" cy="1051560"/>
+            <a:off x="5596128" y="4178808"/>
+            <a:ext cx="2295144" cy="1088136"/>
           </a:xfrm>
           <a:prstGeom prst="rect">
             <a:avLst/>
@@ -7764,14 +7873,14 @@
               <a:buNone/>
             </a:pPr>
             <a:r>
-              <a:rPr lang="en-US" sz="1600" b="1" dirty="0">
+              <a:rPr lang="en-US" sz="1500" b="1" dirty="0">
                 <a:solidFill>
                   <a:schemeClr val="tx1"/>
                 </a:solidFill>
               </a:rPr>
               <a:t>Azure AI Search</a:t>
             </a:r>
-            <a:endParaRPr lang="en-US" sz="1600" dirty="0"/>
+            <a:endParaRPr lang="en-US" sz="1500" dirty="0"/>
           </a:p>
           <a:p>
             <a:pPr algn="ctr" indent="0" marL="0">
@@ -7783,9 +7892,9 @@
                   <a:schemeClr val="tx1"/>
                 </a:solidFill>
               </a:rPr>
-              <a:t>Çözüm, çağrı, talep araması</a:t>
-            </a:r>
-            <a:endParaRPr lang="en-US" sz="1600" dirty="0"/>
+              <a:t>Çözüm, talep, duyuru</a:t>
+            </a:r>
+            <a:endParaRPr lang="en-US" sz="1500" dirty="0"/>
           </a:p>
           <a:p>
             <a:pPr algn="ctr" indent="0" marL="0">
@@ -7797,22 +7906,22 @@
                   <a:schemeClr val="tx1"/>
                 </a:solidFill>
               </a:rPr>
-              <a:t>Vektör + metin (hibrit)</a:t>
-            </a:r>
-            <a:endParaRPr lang="en-US" sz="1600" dirty="0"/>
-          </a:p>
-        </p:txBody>
-      </p:sp>
-      <p:sp>
-        <p:nvSpPr>
-          <p:cNvPr id="13" name="arrow-users-app"/>
+              <a:t>hibrit arama</a:t>
+            </a:r>
+            <a:endParaRPr lang="en-US" sz="1500" dirty="0"/>
+          </a:p>
+        </p:txBody>
+      </p:sp>
+      <p:sp>
+        <p:nvSpPr>
+          <p:cNvPr id="15" name="arrow-users-web"/>
           <p:cNvSpPr/>
           <p:nvPr/>
         </p:nvSpPr>
         <p:spPr>
-          <a:xfrm>
-            <a:off x="2286000" y="3337560"/>
-            <a:ext cx="502920" cy="914"/>
+          <a:xfrm flipV="1">
+            <a:off x="2286000" y="2103120"/>
+            <a:ext cx="457200" cy="640080"/>
           </a:xfrm>
           <a:prstGeom prst="line">
             <a:avLst/>
@@ -7829,14 +7938,14 @@
       </p:sp>
       <p:sp>
         <p:nvSpPr>
-          <p:cNvPr id="14" name="arrow-app-foundry"/>
+          <p:cNvPr id="16" name="arrow-web-api"/>
           <p:cNvSpPr/>
           <p:nvPr/>
         </p:nvSpPr>
         <p:spPr>
-          <a:xfrm flipV="1">
-            <a:off x="5029200" y="1938528"/>
-            <a:ext cx="457200" cy="1078992"/>
+          <a:xfrm>
+            <a:off x="3909060" y="2880360"/>
+            <a:ext cx="914" cy="914400"/>
           </a:xfrm>
           <a:prstGeom prst="line">
             <a:avLst/>
@@ -7853,14 +7962,14 @@
       </p:sp>
       <p:sp>
         <p:nvSpPr>
-          <p:cNvPr id="15" name="arrow-app-sql"/>
+          <p:cNvPr id="17" name="arrow-api-foundry"/>
           <p:cNvSpPr/>
           <p:nvPr/>
         </p:nvSpPr>
         <p:spPr>
           <a:xfrm flipV="1">
-            <a:off x="5029200" y="3328416"/>
-            <a:ext cx="457200" cy="9144"/>
+            <a:off x="5074920" y="1938528"/>
+            <a:ext cx="411480" cy="2267712"/>
           </a:xfrm>
           <a:prstGeom prst="line">
             <a:avLst/>
@@ -7877,14 +7986,14 @@
       </p:sp>
       <p:sp>
         <p:nvSpPr>
-          <p:cNvPr id="16" name="arrow-app-search"/>
+          <p:cNvPr id="18" name="arrow-api-sql"/>
           <p:cNvSpPr/>
           <p:nvPr/>
         </p:nvSpPr>
         <p:spPr>
-          <a:xfrm>
-            <a:off x="5029200" y="3657600"/>
-            <a:ext cx="457200" cy="1060704"/>
+          <a:xfrm flipV="1">
+            <a:off x="5074920" y="3328416"/>
+            <a:ext cx="411480" cy="1106424"/>
           </a:xfrm>
           <a:prstGeom prst="line">
             <a:avLst/>
@@ -7901,14 +8010,38 @@
       </p:sp>
       <p:sp>
         <p:nvSpPr>
-          <p:cNvPr id="17" name="arch-cicd"/>
+          <p:cNvPr id="19" name="arrow-api-search"/>
           <p:cNvSpPr/>
           <p:nvPr/>
         </p:nvSpPr>
         <p:spPr>
           <a:xfrm>
-            <a:off x="548640" y="5486400"/>
-            <a:ext cx="7406640" cy="731520"/>
+            <a:off x="5074920" y="4663440"/>
+            <a:ext cx="411480" cy="54864"/>
+          </a:xfrm>
+          <a:prstGeom prst="line">
+            <a:avLst/>
+          </a:prstGeom>
+          <a:noFill/>
+          <a:ln w="25400">
+            <a:solidFill>
+              <a:schemeClr val="accent5"/>
+            </a:solidFill>
+            <a:prstDash val="solid"/>
+            <a:tailEnd type="triangle"/>
+          </a:ln>
+        </p:spPr>
+      </p:sp>
+      <p:sp>
+        <p:nvSpPr>
+          <p:cNvPr id="20" name="arch-cicd"/>
+          <p:cNvSpPr/>
+          <p:nvPr/>
+        </p:nvSpPr>
+        <p:spPr>
+          <a:xfrm>
+            <a:off x="548640" y="5532120"/>
+            <a:ext cx="7452360" cy="731520"/>
           </a:xfrm>
           <a:prstGeom prst="roundRect">
             <a:avLst>
@@ -7928,7 +8061,7 @@
       </p:sp>
       <p:pic>
         <p:nvPicPr>
-          <p:cNvPr id="18" name="arch-github" descr="preencoded.png">    </p:cNvPr>
+          <p:cNvPr id="21" name="arch-github" descr="preencoded.png">    </p:cNvPr>
           <p:cNvPicPr>
             <a:picLocks noChangeAspect="1"/>
           </p:cNvPicPr>
@@ -7942,7 +8075,7 @@
         </p:blipFill>
         <p:spPr>
           <a:xfrm>
-            <a:off x="731520" y="5641848"/>
+            <a:off x="731520" y="5687568"/>
             <a:ext cx="411480" cy="411480"/>
           </a:xfrm>
           <a:prstGeom prst="rect">
@@ -7952,14 +8085,14 @@
       </p:pic>
       <p:sp>
         <p:nvSpPr>
-          <p:cNvPr id="19" name="Text 16"/>
+          <p:cNvPr id="22" name="Text 19"/>
           <p:cNvSpPr txBox="1"/>
           <p:nvPr/>
         </p:nvSpPr>
         <p:spPr>
           <a:xfrm>
-            <a:off x="1280160" y="5486400"/>
-            <a:ext cx="6583680" cy="731520"/>
+            <a:off x="1280160" y="5532120"/>
+            <a:ext cx="6629400" cy="731520"/>
           </a:xfrm>
           <a:prstGeom prst="rect">
             <a:avLst/>
@@ -7975,7 +8108,7 @@
               <a:buNone/>
             </a:pPr>
             <a:r>
-              <a:rPr lang="en-US" sz="1300" b="1" dirty="0">
+              <a:rPr lang="en-US" sz="1200" b="1" dirty="0">
                 <a:solidFill>
                   <a:schemeClr val="tx1"/>
                 </a:solidFill>
@@ -7986,18 +8119,18 @@
               <a:buNone/>
             </a:pPr>
             <a:r>
-              <a:rPr lang="en-US" sz="1300" dirty="0">
+              <a:rPr lang="en-US" sz="1200" dirty="0">
                 <a:solidFill>
                   <a:schemeClr val="tx1"/>
                 </a:solidFill>
               </a:rPr>
-              <a:t>lint · test · audit · gitleaks → build → deploy → health check   </a:t>
+              <a:t>lint · test · audit · gitleaks → build → 2 deploy → smoke test   </a:t>
             </a:r>
             <a:pPr indent="0" marL="0">
               <a:buNone/>
             </a:pPr>
             <a:r>
-              <a:rPr lang="en-US" sz="1300" b="1" dirty="0">
+              <a:rPr lang="en-US" sz="1200" b="1" dirty="0">
                 <a:solidFill>
                   <a:schemeClr val="tx1"/>
                 </a:solidFill>
@@ -8008,20 +8141,20 @@
               <a:buNone/>
             </a:pPr>
             <a:r>
-              <a:rPr lang="en-US" sz="1300" dirty="0">
+              <a:rPr lang="en-US" sz="1200" dirty="0">
                 <a:solidFill>
                   <a:schemeClr val="tx1"/>
                 </a:solidFill>
               </a:rPr>
               <a:t>CodeQL · Dependabot · secret scanning</a:t>
             </a:r>
-            <a:endParaRPr lang="en-US" sz="1300" dirty="0"/>
-          </a:p>
-        </p:txBody>
-      </p:sp>
-      <p:sp>
-        <p:nvSpPr>
-          <p:cNvPr id="20" name="ai-card"/>
+            <a:endParaRPr lang="en-US" sz="1200" dirty="0"/>
+          </a:p>
+        </p:txBody>
+      </p:sp>
+      <p:sp>
+        <p:nvSpPr>
+          <p:cNvPr id="23" name="ai-card"/>
           <p:cNvSpPr/>
           <p:nvPr/>
         </p:nvSpPr>
@@ -8048,7 +8181,7 @@
       </p:sp>
       <p:sp>
         <p:nvSpPr>
-          <p:cNvPr id="21" name="Text 18"/>
+          <p:cNvPr id="24" name="Text 21"/>
           <p:cNvSpPr txBox="1"/>
           <p:nvPr/>
         </p:nvSpPr>
@@ -8097,7 +8230,7 @@
                   <a:schemeClr val="bg1"/>
                 </a:solidFill>
               </a:rPr>
-              <a:t>Sınıflandırma ve özet</a:t>
+              <a:t>Metinden bilgi çıkarma, açıklama</a:t>
             </a:r>
             <a:endParaRPr lang="en-US" sz="1600" dirty="0"/>
           </a:p>
@@ -8169,7 +8302,7 @@
                   <a:schemeClr val="bg1"/>
                 </a:solidFill>
               </a:rPr>
-              <a:t>Gerekçe yazma</a:t>
+              <a:t>Talep bileşenleri ve sorular</a:t>
             </a:r>
             <a:endParaRPr lang="en-US" sz="1600" dirty="0"/>
           </a:p>
@@ -8177,18 +8310,18 @@
       </p:sp>
       <p:sp>
         <p:nvSpPr>
-          <p:cNvPr id="22" name="code-card"/>
+          <p:cNvPr id="25" name="code-card"/>
           <p:cNvSpPr/>
           <p:nvPr/>
         </p:nvSpPr>
         <p:spPr>
           <a:xfrm>
             <a:off x="8321040" y="3886200"/>
-            <a:ext cx="3319272" cy="2331720"/>
+            <a:ext cx="3319272" cy="2377440"/>
           </a:xfrm>
           <a:prstGeom prst="roundRect">
             <a:avLst>
-              <a:gd name="adj" fmla="val 4706"/>
+              <a:gd name="adj" fmla="val 4615"/>
             </a:avLst>
           </a:prstGeom>
           <a:solidFill>
@@ -8204,14 +8337,14 @@
       </p:sp>
       <p:sp>
         <p:nvSpPr>
-          <p:cNvPr id="23" name="Text 20"/>
+          <p:cNvPr id="26" name="Text 23"/>
           <p:cNvSpPr txBox="1"/>
           <p:nvPr/>
         </p:nvSpPr>
         <p:spPr>
           <a:xfrm>
             <a:off x="8503920" y="3977640"/>
-            <a:ext cx="3017520" cy="2148840"/>
+            <a:ext cx="3017520" cy="2194560"/>
           </a:xfrm>
           <a:prstGeom prst="rect">
             <a:avLst/>
@@ -8253,7 +8386,7 @@
                   <a:schemeClr val="bg1"/>
                 </a:solidFill>
               </a:rPr>
-              <a:t>Eşik ve güven kararları</a:t>
+              <a:t>Log örüntüsü, kredi hesabı</a:t>
             </a:r>
             <a:endParaRPr lang="en-US" sz="1600" dirty="0"/>
           </a:p>
@@ -8271,7 +8404,7 @@
                   <a:schemeClr val="bg1"/>
                 </a:solidFill>
               </a:rPr>
-              <a:t>Servis ve ekip ataması</a:t>
+              <a:t>Eşik, servis ataması, ana kayıt</a:t>
             </a:r>
             <a:endParaRPr lang="en-US" sz="1600" dirty="0"/>
           </a:p>
@@ -8289,7 +8422,7 @@
                   <a:schemeClr val="bg1"/>
                 </a:solidFill>
               </a:rPr>
-              <a:t>Efor ve maliyet hesabı</a:t>
+              <a:t>Adam-gün medyanı, takvim</a:t>
             </a:r>
             <a:endParaRPr lang="en-US" sz="1600" dirty="0"/>
           </a:p>
@@ -8307,7 +8440,7 @@
                   <a:schemeClr val="bg1"/>
                 </a:solidFill>
               </a:rPr>
-              <a:t>Takvim planı</a:t>
+              <a:t>Köprü sayıları</a:t>
             </a:r>
             <a:endParaRPr lang="en-US" sz="1600" dirty="0"/>
           </a:p>
@@ -8325,7 +8458,7 @@
                   <a:schemeClr val="bg1"/>
                 </a:solidFill>
               </a:rPr>
-              <a:t>AI çıktısını doğrulama</a:t>
+              <a:t>AI çıktısındaki sayı ve satırları doğrulama</a:t>
             </a:r>
             <a:endParaRPr lang="en-US" sz="1600" dirty="0"/>
           </a:p>
@@ -8433,94 +8566,49 @@
                   <a:schemeClr val="tx1"/>
                 </a:solidFill>
               </a:rPr>
-              <a:t>Üç kullanıcı, tek akış</a:t>
+              <a:t>Altı kullanım senaryosu</a:t>
             </a:r>
             <a:endParaRPr lang="en-US" sz="3600" dirty="0"/>
           </a:p>
         </p:txBody>
       </p:sp>
-      <p:pic>
-        <p:nvPicPr>
-          <p:cNvPr id="3" name="ux-image-1" descr="/home/claude/zthackathonstudy/presentation/mockups/m-bank-issue.png">    </p:cNvPr>
-          <p:cNvPicPr>
-            <a:picLocks noChangeAspect="1"/>
-          </p:cNvPicPr>
-          <p:nvPr/>
-        </p:nvPicPr>
-        <p:blipFill>
-          <a:blip r:embed="rId1"/>
-          <a:stretch>
-            <a:fillRect/>
-          </a:stretch>
-        </p:blipFill>
-        <p:spPr>
-          <a:xfrm>
-            <a:off x="868680" y="1280160"/>
-            <a:ext cx="1783080" cy="3657600"/>
-          </a:xfrm>
-          <a:prstGeom prst="rect">
-            <a:avLst/>
-          </a:prstGeom>
-        </p:spPr>
-      </p:pic>
-      <p:pic>
-        <p:nvPicPr>
-          <p:cNvPr id="4" name="ux-image-2" descr="/home/claude/zthackathonstudy/presentation/mockups/m-console-match.png">    </p:cNvPr>
-          <p:cNvPicPr>
-            <a:picLocks noChangeAspect="1"/>
-          </p:cNvPicPr>
-          <p:nvPr/>
-        </p:nvPicPr>
-        <p:blipFill>
-          <a:blip r:embed="rId2"/>
-          <a:stretch>
-            <a:fillRect/>
-          </a:stretch>
-        </p:blipFill>
-        <p:spPr>
-          <a:xfrm>
-            <a:off x="3246120" y="1920240"/>
-            <a:ext cx="4069080" cy="1746504"/>
-          </a:xfrm>
-          <a:prstGeom prst="rect">
-            <a:avLst/>
-          </a:prstGeom>
-        </p:spPr>
-      </p:pic>
-      <p:pic>
-        <p:nvPicPr>
-          <p:cNvPr id="5" name="ux-image-3" descr="/home/claude/zthackathonstudy/presentation/mockups/m-request.png">    </p:cNvPr>
-          <p:cNvPicPr>
-            <a:picLocks noChangeAspect="1"/>
-          </p:cNvPicPr>
-          <p:nvPr/>
-        </p:nvPicPr>
-        <p:blipFill>
-          <a:blip r:embed="rId3"/>
-          <a:stretch>
-            <a:fillRect/>
-          </a:stretch>
-        </p:blipFill>
-        <p:spPr>
-          <a:xfrm>
-            <a:off x="7562088" y="1920240"/>
-            <a:ext cx="4069080" cy="1773936"/>
-          </a:xfrm>
-          <a:prstGeom prst="rect">
-            <a:avLst/>
-          </a:prstGeom>
-        </p:spPr>
-      </p:pic>
-      <p:sp>
-        <p:nvSpPr>
-          <p:cNvPr id="6" name="ux-num-1"/>
+      <p:sp>
+        <p:nvSpPr>
+          <p:cNvPr id="3" name="scen-card-A"/>
           <p:cNvSpPr/>
           <p:nvPr/>
         </p:nvSpPr>
         <p:spPr>
           <a:xfrm>
-            <a:off x="548640" y="5120640"/>
-            <a:ext cx="384048" cy="384048"/>
+            <a:off x="548640" y="1325880"/>
+            <a:ext cx="3520440" cy="2331720"/>
+          </a:xfrm>
+          <a:prstGeom prst="roundRect">
+            <a:avLst>
+              <a:gd name="adj" fmla="val 4706"/>
+            </a:avLst>
+          </a:prstGeom>
+          <a:solidFill>
+            <a:schemeClr val="bg2"/>
+          </a:solidFill>
+          <a:ln w="12700">
+            <a:solidFill>
+              <a:schemeClr val="bg2"/>
+            </a:solidFill>
+            <a:prstDash val="solid"/>
+          </a:ln>
+        </p:spPr>
+      </p:sp>
+      <p:sp>
+        <p:nvSpPr>
+          <p:cNvPr id="4" name="scen-letter-A"/>
+          <p:cNvSpPr/>
+          <p:nvPr/>
+        </p:nvSpPr>
+        <p:spPr>
+          <a:xfrm>
+            <a:off x="777240" y="1554480"/>
+            <a:ext cx="548640" cy="548640"/>
           </a:xfrm>
           <a:prstGeom prst="ellipse">
             <a:avLst/>
@@ -8538,14 +8626,14 @@
       </p:sp>
       <p:sp>
         <p:nvSpPr>
-          <p:cNvPr id="7" name="Text 2"/>
+          <p:cNvPr id="5" name="Text 3"/>
           <p:cNvSpPr txBox="1"/>
           <p:nvPr/>
         </p:nvSpPr>
         <p:spPr>
           <a:xfrm>
-            <a:off x="548640" y="5120640"/>
-            <a:ext cx="384048" cy="384048"/>
+            <a:off x="777240" y="1554480"/>
+            <a:ext cx="548640" cy="548640"/>
           </a:xfrm>
           <a:prstGeom prst="rect">
             <a:avLst/>
@@ -8561,27 +8649,27 @@
               <a:buNone/>
             </a:pPr>
             <a:r>
-              <a:rPr lang="en-US" sz="1400" b="1" dirty="0">
-                <a:solidFill>
-                  <a:schemeClr val="tx1"/>
-                </a:solidFill>
-              </a:rPr>
-              <a:t>1</a:t>
-            </a:r>
-            <a:endParaRPr lang="en-US" sz="1400" dirty="0"/>
-          </a:p>
-        </p:txBody>
-      </p:sp>
-      <p:sp>
-        <p:nvSpPr>
-          <p:cNvPr id="8" name="Text 3"/>
+              <a:rPr lang="en-US" sz="2000" b="1" dirty="0">
+                <a:solidFill>
+                  <a:schemeClr val="bg1"/>
+                </a:solidFill>
+              </a:rPr>
+              <a:t>A</a:t>
+            </a:r>
+            <a:endParaRPr lang="en-US" sz="2000" dirty="0"/>
+          </a:p>
+        </p:txBody>
+      </p:sp>
+      <p:sp>
+        <p:nvSpPr>
+          <p:cNvPr id="6" name="Text 4"/>
           <p:cNvSpPr txBox="1"/>
           <p:nvPr/>
         </p:nvSpPr>
         <p:spPr>
           <a:xfrm>
-            <a:off x="1051560" y="5074920"/>
-            <a:ext cx="2057400" cy="1097280"/>
+            <a:off x="1463040" y="1508760"/>
+            <a:ext cx="2468880" cy="685800"/>
           </a:xfrm>
           <a:prstGeom prst="rect">
             <a:avLst/>
@@ -8590,6 +8678,56 @@
           <a:ln/>
         </p:spPr>
         <p:txBody>
+          <a:bodyPr wrap="square" lIns="0" tIns="0" rIns="0" bIns="0" rtlCol="0" anchor="ctr"/>
+          <a:lstStyle/>
+          <a:p>
+            <a:pPr indent="0" marL="0">
+              <a:buNone/>
+            </a:pPr>
+            <a:r>
+              <a:rPr lang="en-US" sz="1600" b="1" dirty="0">
+                <a:solidFill>
+                  <a:schemeClr val="tx1"/>
+                </a:solidFill>
+              </a:rPr>
+              <a:t>Hata mı, kural mı?</a:t>
+            </a:r>
+            <a:endParaRPr lang="en-US" sz="1600" dirty="0"/>
+          </a:p>
+          <a:p>
+            <a:pPr indent="0" marL="0">
+              <a:buNone/>
+            </a:pPr>
+            <a:r>
+              <a:rPr lang="en-US" sz="1100" dirty="0">
+                <a:solidFill>
+                  <a:schemeClr val="accent5"/>
+                </a:solidFill>
+              </a:rPr>
+              <a:t>KRDTKULL · Elif (şube)</a:t>
+            </a:r>
+            <a:endParaRPr lang="en-US" sz="1600" dirty="0"/>
+          </a:p>
+        </p:txBody>
+      </p:sp>
+      <p:sp>
+        <p:nvSpPr>
+          <p:cNvPr id="7" name="Text 5"/>
+          <p:cNvSpPr txBox="1"/>
+          <p:nvPr/>
+        </p:nvSpPr>
+        <p:spPr>
+          <a:xfrm>
+            <a:off x="777240" y="2286000"/>
+            <a:ext cx="3063240" cy="594360"/>
+          </a:xfrm>
+          <a:prstGeom prst="rect">
+            <a:avLst/>
+          </a:prstGeom>
+          <a:noFill/>
+          <a:ln/>
+        </p:spPr>
+        <p:txBody>
           <a:bodyPr wrap="square" lIns="0" tIns="0" rIns="0" bIns="0" rtlCol="0" anchor="t"/>
           <a:lstStyle/>
           <a:p>
@@ -8597,51 +8735,75 @@
               <a:buNone/>
             </a:pPr>
             <a:r>
-              <a:rPr lang="en-US" sz="1600" b="1" dirty="0">
+              <a:rPr lang="en-US" sz="1300" dirty="0">
+                <a:solidFill>
+                  <a:schemeClr val="tx2"/>
+                </a:solidFill>
+              </a:rPr>
+              <a:t>İş kuralı açıklandı, uygun tutar ekrana dolduruldu</a:t>
+            </a:r>
+            <a:endParaRPr lang="en-US" sz="1300" dirty="0"/>
+          </a:p>
+        </p:txBody>
+      </p:sp>
+      <p:sp>
+        <p:nvSpPr>
+          <p:cNvPr id="8" name="Text 6"/>
+          <p:cNvSpPr txBox="1"/>
+          <p:nvPr/>
+        </p:nvSpPr>
+        <p:spPr>
+          <a:xfrm>
+            <a:off x="777240" y="2926080"/>
+            <a:ext cx="2103120" cy="502920"/>
+          </a:xfrm>
+          <a:prstGeom prst="rect">
+            <a:avLst/>
+          </a:prstGeom>
+          <a:noFill/>
+          <a:ln/>
+        </p:spPr>
+        <p:txBody>
+          <a:bodyPr wrap="square" lIns="0" tIns="0" rIns="0" bIns="0" rtlCol="0" anchor="ctr"/>
+          <a:lstStyle/>
+          <a:p>
+            <a:pPr indent="0" marL="0">
+              <a:buNone/>
+            </a:pPr>
+            <a:r>
+              <a:rPr lang="en-US" sz="1300" b="1" dirty="0">
                 <a:solidFill>
                   <a:schemeClr val="tx1"/>
                 </a:solidFill>
               </a:rPr>
-              <a:t>Ayşe sorunu bildirir</a:t>
-            </a:r>
-            <a:endParaRPr lang="en-US" sz="1600" dirty="0"/>
-          </a:p>
-          <a:p>
-            <a:pPr indent="0" marL="0">
-              <a:buNone/>
-            </a:pPr>
-            <a:r>
-              <a:rPr lang="en-US" sz="1400" dirty="0">
-                <a:solidFill>
-                  <a:schemeClr val="accent5"/>
-                </a:solidFill>
-              </a:rPr>
-              <a:t>Tek dokunuş; Mercek nedeni ve alternatif yolu söyler.</a:t>
-            </a:r>
-            <a:endParaRPr lang="en-US" sz="1600" dirty="0"/>
-          </a:p>
-        </p:txBody>
-      </p:sp>
-      <p:sp>
-        <p:nvSpPr>
-          <p:cNvPr id="9" name="ux-num-2"/>
+              <a:t>Çağrı açılmadı</a:t>
+            </a:r>
+            <a:endParaRPr lang="en-US" sz="1300" dirty="0"/>
+          </a:p>
+        </p:txBody>
+      </p:sp>
+      <p:sp>
+        <p:nvSpPr>
+          <p:cNvPr id="9" name="scen-status-A"/>
           <p:cNvSpPr/>
           <p:nvPr/>
         </p:nvSpPr>
         <p:spPr>
           <a:xfrm>
-            <a:off x="3246120" y="3931920"/>
-            <a:ext cx="384048" cy="384048"/>
-          </a:xfrm>
-          <a:prstGeom prst="ellipse">
-            <a:avLst/>
+            <a:off x="2880360" y="3017520"/>
+            <a:ext cx="1005840" cy="329184"/>
+          </a:xfrm>
+          <a:prstGeom prst="roundRect">
+            <a:avLst>
+              <a:gd name="adj" fmla="val 50000"/>
+            </a:avLst>
           </a:prstGeom>
           <a:solidFill>
-            <a:schemeClr val="accent1"/>
+            <a:schemeClr val="accent2"/>
           </a:solidFill>
           <a:ln w="12700">
             <a:solidFill>
-              <a:schemeClr val="accent1"/>
+              <a:schemeClr val="accent2"/>
             </a:solidFill>
             <a:prstDash val="solid"/>
           </a:ln>
@@ -8649,14 +8811,14 @@
       </p:sp>
       <p:sp>
         <p:nvSpPr>
-          <p:cNvPr id="10" name="Text 5"/>
+          <p:cNvPr id="10" name="Text 8"/>
           <p:cNvSpPr txBox="1"/>
           <p:nvPr/>
         </p:nvSpPr>
         <p:spPr>
           <a:xfrm>
-            <a:off x="3246120" y="3931920"/>
-            <a:ext cx="384048" cy="384048"/>
+            <a:off x="2880360" y="3017520"/>
+            <a:ext cx="1005840" cy="329184"/>
           </a:xfrm>
           <a:prstGeom prst="rect">
             <a:avLst/>
@@ -8672,87 +8834,39 @@
               <a:buNone/>
             </a:pPr>
             <a:r>
-              <a:rPr lang="en-US" sz="1400" b="1" dirty="0">
-                <a:solidFill>
-                  <a:schemeClr val="tx1"/>
-                </a:solidFill>
-              </a:rPr>
-              <a:t>2</a:t>
-            </a:r>
-            <a:endParaRPr lang="en-US" sz="1400" dirty="0"/>
-          </a:p>
-        </p:txBody>
-      </p:sp>
-      <p:sp>
-        <p:nvSpPr>
-          <p:cNvPr id="11" name="Text 6"/>
-          <p:cNvSpPr txBox="1"/>
-          <p:nvPr/>
-        </p:nvSpPr>
-        <p:spPr>
-          <a:xfrm>
-            <a:off x="3749040" y="3886200"/>
-            <a:ext cx="3566160" cy="1097280"/>
-          </a:xfrm>
-          <a:prstGeom prst="rect">
-            <a:avLst/>
-          </a:prstGeom>
-          <a:noFill/>
-          <a:ln/>
-        </p:spPr>
-        <p:txBody>
-          <a:bodyPr wrap="square" lIns="0" tIns="0" rIns="0" bIns="0" rtlCol="0" anchor="t"/>
-          <a:lstStyle/>
-          <a:p>
-            <a:pPr indent="0" marL="0">
-              <a:buNone/>
-            </a:pPr>
-            <a:r>
-              <a:rPr lang="en-US" sz="1600" b="1" dirty="0">
-                <a:solidFill>
-                  <a:schemeClr val="tx1"/>
-                </a:solidFill>
-              </a:rPr>
-              <a:t>Mert çözümü onaylar</a:t>
-            </a:r>
-            <a:endParaRPr lang="en-US" sz="1600" dirty="0"/>
-          </a:p>
-          <a:p>
-            <a:pPr indent="0" marL="0">
-              <a:buNone/>
-            </a:pPr>
-            <a:r>
-              <a:rPr lang="en-US" sz="1400" dirty="0">
-                <a:solidFill>
-                  <a:schemeClr val="accent5"/>
-                </a:solidFill>
-              </a:rPr>
-              <a:t>Destek Konsolu: zenginleştirilmiş kayıt, eşleşen çözüm, kaynaklar.</a:t>
-            </a:r>
-            <a:endParaRPr lang="en-US" sz="1600" dirty="0"/>
-          </a:p>
-        </p:txBody>
-      </p:sp>
-      <p:sp>
-        <p:nvSpPr>
-          <p:cNvPr id="12" name="ux-num-3"/>
+              <a:rPr lang="en-US" sz="1100" b="1" dirty="0">
+                <a:solidFill>
+                  <a:schemeClr val="bg1"/>
+                </a:solidFill>
+              </a:rPr>
+              <a:t>CANLI</a:t>
+            </a:r>
+            <a:endParaRPr lang="en-US" sz="1100" dirty="0"/>
+          </a:p>
+        </p:txBody>
+      </p:sp>
+      <p:sp>
+        <p:nvSpPr>
+          <p:cNvPr id="11" name="scen-card-B"/>
           <p:cNvSpPr/>
           <p:nvPr/>
         </p:nvSpPr>
         <p:spPr>
           <a:xfrm>
-            <a:off x="7562088" y="3931920"/>
-            <a:ext cx="384048" cy="384048"/>
-          </a:xfrm>
-          <a:prstGeom prst="ellipse">
-            <a:avLst/>
+            <a:off x="4297680" y="1325880"/>
+            <a:ext cx="3520440" cy="2331720"/>
+          </a:xfrm>
+          <a:prstGeom prst="roundRect">
+            <a:avLst>
+              <a:gd name="adj" fmla="val 4706"/>
+            </a:avLst>
           </a:prstGeom>
           <a:solidFill>
-            <a:schemeClr val="accent1"/>
+            <a:schemeClr val="bg2"/>
           </a:solidFill>
           <a:ln w="12700">
             <a:solidFill>
-              <a:schemeClr val="accent1"/>
+              <a:schemeClr val="bg2"/>
             </a:solidFill>
             <a:prstDash val="solid"/>
           </a:ln>
@@ -8760,14 +8874,39 @@
       </p:sp>
       <p:sp>
         <p:nvSpPr>
-          <p:cNvPr id="13" name="Text 8"/>
+          <p:cNvPr id="12" name="scen-letter-B"/>
+          <p:cNvSpPr/>
+          <p:nvPr/>
+        </p:nvSpPr>
+        <p:spPr>
+          <a:xfrm>
+            <a:off x="4526280" y="1554480"/>
+            <a:ext cx="548640" cy="548640"/>
+          </a:xfrm>
+          <a:prstGeom prst="ellipse">
+            <a:avLst/>
+          </a:prstGeom>
+          <a:solidFill>
+            <a:schemeClr val="accent2"/>
+          </a:solidFill>
+          <a:ln w="12700">
+            <a:solidFill>
+              <a:schemeClr val="accent2"/>
+            </a:solidFill>
+            <a:prstDash val="solid"/>
+          </a:ln>
+        </p:spPr>
+      </p:sp>
+      <p:sp>
+        <p:nvSpPr>
+          <p:cNvPr id="13" name="Text 11"/>
           <p:cNvSpPr txBox="1"/>
           <p:nvPr/>
         </p:nvSpPr>
         <p:spPr>
           <a:xfrm>
-            <a:off x="7562088" y="3931920"/>
-            <a:ext cx="384048" cy="384048"/>
+            <a:off x="4526280" y="1554480"/>
+            <a:ext cx="548640" cy="548640"/>
           </a:xfrm>
           <a:prstGeom prst="rect">
             <a:avLst/>
@@ -8783,27 +8922,27 @@
               <a:buNone/>
             </a:pPr>
             <a:r>
-              <a:rPr lang="en-US" sz="1400" b="1" dirty="0">
-                <a:solidFill>
-                  <a:schemeClr val="tx1"/>
-                </a:solidFill>
-              </a:rPr>
-              <a:t>3</a:t>
-            </a:r>
-            <a:endParaRPr lang="en-US" sz="1400" dirty="0"/>
-          </a:p>
-        </p:txBody>
-      </p:sp>
-      <p:sp>
-        <p:nvSpPr>
-          <p:cNvPr id="14" name="Text 9"/>
+              <a:rPr lang="en-US" sz="2000" b="1" dirty="0">
+                <a:solidFill>
+                  <a:schemeClr val="bg1"/>
+                </a:solidFill>
+              </a:rPr>
+              <a:t>B</a:t>
+            </a:r>
+            <a:endParaRPr lang="en-US" sz="2000" dirty="0"/>
+          </a:p>
+        </p:txBody>
+      </p:sp>
+      <p:sp>
+        <p:nvSpPr>
+          <p:cNvPr id="14" name="Text 12"/>
           <p:cNvSpPr txBox="1"/>
           <p:nvPr/>
         </p:nvSpPr>
         <p:spPr>
           <a:xfrm>
-            <a:off x="8065008" y="3886200"/>
-            <a:ext cx="3566160" cy="1097280"/>
+            <a:off x="5212080" y="1508760"/>
+            <a:ext cx="2468880" cy="685800"/>
           </a:xfrm>
           <a:prstGeom prst="rect">
             <a:avLst/>
@@ -8812,7 +8951,7 @@
           <a:ln/>
         </p:spPr>
         <p:txBody>
-          <a:bodyPr wrap="square" lIns="0" tIns="0" rIns="0" bIns="0" rtlCol="0" anchor="t"/>
+          <a:bodyPr wrap="square" lIns="0" tIns="0" rIns="0" bIns="0" rtlCol="0" anchor="ctr"/>
           <a:lstStyle/>
           <a:p>
             <a:pPr indent="0" marL="0">
@@ -8824,7 +8963,7 @@
                   <a:schemeClr val="tx1"/>
                 </a:solidFill>
               </a:rPr>
-              <a:t>Zeynep talebi planlar</a:t>
+              <a:t>Yaygın sorun, bilinen çözüm</a:t>
             </a:r>
             <a:endParaRPr lang="en-US" sz="1600" dirty="0"/>
           </a:p>
@@ -8833,12 +8972,12 @@
               <a:buNone/>
             </a:pPr>
             <a:r>
-              <a:rPr lang="en-US" sz="1400" dirty="0">
+              <a:rPr lang="en-US" sz="1100" dirty="0">
                 <a:solidFill>
                   <a:schemeClr val="accent5"/>
                 </a:solidFill>
               </a:rPr>
-              <a:t>Talep Asistanı: etki, efor, takvim ve ekranın çağrı geçmişi.</a:t>
+              <a:t>ODMTFATR · Mehmet → Zeynep → Kerem</a:t>
             </a:r>
             <a:endParaRPr lang="en-US" sz="1600" dirty="0"/>
           </a:p>
@@ -8846,14 +8985,14 @@
       </p:sp>
       <p:sp>
         <p:nvSpPr>
-          <p:cNvPr id="15" name="draft-note"/>
+          <p:cNvPr id="15" name="Text 13"/>
           <p:cNvSpPr txBox="1"/>
           <p:nvPr/>
         </p:nvSpPr>
         <p:spPr>
           <a:xfrm>
-            <a:off x="3246120" y="5989320"/>
-            <a:ext cx="8229600" cy="256032"/>
+            <a:off x="4526280" y="2286000"/>
+            <a:ext cx="3063240" cy="594360"/>
           </a:xfrm>
           <a:prstGeom prst="rect">
             <a:avLst/>
@@ -8862,6 +9001,42 @@
           <a:ln/>
         </p:spPr>
         <p:txBody>
+          <a:bodyPr wrap="square" lIns="0" tIns="0" rIns="0" bIns="0" rtlCol="0" anchor="t"/>
+          <a:lstStyle/>
+          <a:p>
+            <a:pPr indent="0" marL="0">
+              <a:buNone/>
+            </a:pPr>
+            <a:r>
+              <a:rPr lang="en-US" sz="1300" dirty="0">
+                <a:solidFill>
+                  <a:schemeClr val="tx2"/>
+                </a:solidFill>
+              </a:rPr>
+              <a:t>Müşteriye hazır açıklama, %93 eşleşen çözüm</a:t>
+            </a:r>
+            <a:endParaRPr lang="en-US" sz="1300" dirty="0"/>
+          </a:p>
+        </p:txBody>
+      </p:sp>
+      <p:sp>
+        <p:nvSpPr>
+          <p:cNvPr id="16" name="Text 14"/>
+          <p:cNvSpPr txBox="1"/>
+          <p:nvPr/>
+        </p:nvSpPr>
+        <p:spPr>
+          <a:xfrm>
+            <a:off x="4526280" y="2926080"/>
+            <a:ext cx="2103120" cy="502920"/>
+          </a:xfrm>
+          <a:prstGeom prst="rect">
+            <a:avLst/>
+          </a:prstGeom>
+          <a:noFill/>
+          <a:ln/>
+        </p:spPr>
+        <p:txBody>
           <a:bodyPr wrap="square" lIns="0" tIns="0" rIns="0" bIns="0" rtlCol="0" anchor="ctr"/>
           <a:lstStyle/>
           <a:p>
@@ -8869,14 +9044,1169 @@
               <a:buNone/>
             </a:pPr>
             <a:r>
-              <a:rPr lang="en-US" sz="1000" i="1" dirty="0">
+              <a:rPr lang="en-US" sz="1300" b="1" dirty="0">
+                <a:solidFill>
+                  <a:schemeClr val="tx1"/>
+                </a:solidFill>
+              </a:rPr>
+              <a:t>Onlarca arama tek kayıtta</a:t>
+            </a:r>
+            <a:endParaRPr lang="en-US" sz="1300" dirty="0"/>
+          </a:p>
+        </p:txBody>
+      </p:sp>
+      <p:sp>
+        <p:nvSpPr>
+          <p:cNvPr id="17" name="scen-status-B"/>
+          <p:cNvSpPr/>
+          <p:nvPr/>
+        </p:nvSpPr>
+        <p:spPr>
+          <a:xfrm>
+            <a:off x="6629400" y="3017520"/>
+            <a:ext cx="1005840" cy="329184"/>
+          </a:xfrm>
+          <a:prstGeom prst="roundRect">
+            <a:avLst>
+              <a:gd name="adj" fmla="val 50000"/>
+            </a:avLst>
+          </a:prstGeom>
+          <a:solidFill>
+            <a:schemeClr val="accent2"/>
+          </a:solidFill>
+          <a:ln w="12700">
+            <a:solidFill>
+              <a:schemeClr val="accent2"/>
+            </a:solidFill>
+            <a:prstDash val="solid"/>
+          </a:ln>
+        </p:spPr>
+      </p:sp>
+      <p:sp>
+        <p:nvSpPr>
+          <p:cNvPr id="18" name="Text 16"/>
+          <p:cNvSpPr txBox="1"/>
+          <p:nvPr/>
+        </p:nvSpPr>
+        <p:spPr>
+          <a:xfrm>
+            <a:off x="6629400" y="3017520"/>
+            <a:ext cx="1005840" cy="329184"/>
+          </a:xfrm>
+          <a:prstGeom prst="rect">
+            <a:avLst/>
+          </a:prstGeom>
+          <a:noFill/>
+          <a:ln/>
+        </p:spPr>
+        <p:txBody>
+          <a:bodyPr wrap="square" lIns="0" tIns="0" rIns="0" bIns="0" rtlCol="0" anchor="ctr"/>
+          <a:lstStyle/>
+          <a:p>
+            <a:pPr algn="ctr" indent="0" marL="0">
+              <a:buNone/>
+            </a:pPr>
+            <a:r>
+              <a:rPr lang="en-US" sz="1100" b="1" dirty="0">
+                <a:solidFill>
+                  <a:schemeClr val="bg1"/>
+                </a:solidFill>
+              </a:rPr>
+              <a:t>CANLI</a:t>
+            </a:r>
+            <a:endParaRPr lang="en-US" sz="1100" dirty="0"/>
+          </a:p>
+        </p:txBody>
+      </p:sp>
+      <p:sp>
+        <p:nvSpPr>
+          <p:cNvPr id="19" name="scen-card-C"/>
+          <p:cNvSpPr/>
+          <p:nvPr/>
+        </p:nvSpPr>
+        <p:spPr>
+          <a:xfrm>
+            <a:off x="8046720" y="1325880"/>
+            <a:ext cx="3520440" cy="2331720"/>
+          </a:xfrm>
+          <a:prstGeom prst="roundRect">
+            <a:avLst>
+              <a:gd name="adj" fmla="val 4706"/>
+            </a:avLst>
+          </a:prstGeom>
+          <a:solidFill>
+            <a:schemeClr val="bg2"/>
+          </a:solidFill>
+          <a:ln w="12700">
+            <a:solidFill>
+              <a:schemeClr val="bg2"/>
+            </a:solidFill>
+            <a:prstDash val="solid"/>
+          </a:ln>
+        </p:spPr>
+      </p:sp>
+      <p:sp>
+        <p:nvSpPr>
+          <p:cNvPr id="20" name="scen-letter-C"/>
+          <p:cNvSpPr/>
+          <p:nvPr/>
+        </p:nvSpPr>
+        <p:spPr>
+          <a:xfrm>
+            <a:off x="8275320" y="1554480"/>
+            <a:ext cx="548640" cy="548640"/>
+          </a:xfrm>
+          <a:prstGeom prst="ellipse">
+            <a:avLst/>
+          </a:prstGeom>
+          <a:solidFill>
+            <a:schemeClr val="accent3"/>
+          </a:solidFill>
+          <a:ln w="12700">
+            <a:solidFill>
+              <a:schemeClr val="accent3"/>
+            </a:solidFill>
+            <a:prstDash val="solid"/>
+          </a:ln>
+        </p:spPr>
+      </p:sp>
+      <p:sp>
+        <p:nvSpPr>
+          <p:cNvPr id="21" name="Text 19"/>
+          <p:cNvSpPr txBox="1"/>
+          <p:nvPr/>
+        </p:nvSpPr>
+        <p:spPr>
+          <a:xfrm>
+            <a:off x="8275320" y="1554480"/>
+            <a:ext cx="548640" cy="548640"/>
+          </a:xfrm>
+          <a:prstGeom prst="rect">
+            <a:avLst/>
+          </a:prstGeom>
+          <a:noFill/>
+          <a:ln/>
+        </p:spPr>
+        <p:txBody>
+          <a:bodyPr wrap="square" lIns="0" tIns="0" rIns="0" bIns="0" rtlCol="0" anchor="ctr"/>
+          <a:lstStyle/>
+          <a:p>
+            <a:pPr algn="ctr" indent="0" marL="0">
+              <a:buNone/>
+            </a:pPr>
+            <a:r>
+              <a:rPr lang="en-US" sz="2000" b="1" dirty="0">
+                <a:solidFill>
+                  <a:schemeClr val="bg1"/>
+                </a:solidFill>
+              </a:rPr>
+              <a:t>C</a:t>
+            </a:r>
+            <a:endParaRPr lang="en-US" sz="2000" dirty="0"/>
+          </a:p>
+        </p:txBody>
+      </p:sp>
+      <p:sp>
+        <p:nvSpPr>
+          <p:cNvPr id="22" name="Text 20"/>
+          <p:cNvSpPr txBox="1"/>
+          <p:nvPr/>
+        </p:nvSpPr>
+        <p:spPr>
+          <a:xfrm>
+            <a:off x="8961120" y="1508760"/>
+            <a:ext cx="2468880" cy="685800"/>
+          </a:xfrm>
+          <a:prstGeom prst="rect">
+            <a:avLst/>
+          </a:prstGeom>
+          <a:noFill/>
+          <a:ln/>
+        </p:spPr>
+        <p:txBody>
+          <a:bodyPr wrap="square" lIns="0" tIns="0" rIns="0" bIns="0" rtlCol="0" anchor="ctr"/>
+          <a:lstStyle/>
+          <a:p>
+            <a:pPr indent="0" marL="0">
+              <a:buNone/>
+            </a:pPr>
+            <a:r>
+              <a:rPr lang="en-US" sz="1600" b="1" dirty="0">
+                <a:solidFill>
+                  <a:schemeClr val="tx1"/>
+                </a:solidFill>
+              </a:rPr>
+              <a:t>Dış dünya değişti</a:t>
+            </a:r>
+            <a:endParaRPr lang="en-US" sz="1600" dirty="0"/>
+          </a:p>
+          <a:p>
+            <a:pPr indent="0" marL="0">
+              <a:buNone/>
+            </a:pPr>
+            <a:r>
+              <a:rPr lang="en-US" sz="1100" dirty="0">
                 <a:solidFill>
                   <a:schemeClr val="accent5"/>
                 </a:solidFill>
               </a:rPr>
-              <a:t>Taslak görsel — gerçek ekran görüntüsüyle değiştirilecek</a:t>
-            </a:r>
-            <a:endParaRPr lang="en-US" sz="1000" dirty="0"/>
+              <a:t>ODMTFATR · Elif → Kerem</a:t>
+            </a:r>
+            <a:endParaRPr lang="en-US" sz="1600" dirty="0"/>
+          </a:p>
+        </p:txBody>
+      </p:sp>
+      <p:sp>
+        <p:nvSpPr>
+          <p:cNvPr id="23" name="Text 21"/>
+          <p:cNvSpPr txBox="1"/>
+          <p:nvPr/>
+        </p:nvSpPr>
+        <p:spPr>
+          <a:xfrm>
+            <a:off x="8275320" y="2286000"/>
+            <a:ext cx="3063240" cy="594360"/>
+          </a:xfrm>
+          <a:prstGeom prst="rect">
+            <a:avLst/>
+          </a:prstGeom>
+          <a:noFill/>
+          <a:ln/>
+        </p:spPr>
+        <p:txBody>
+          <a:bodyPr wrap="square" lIns="0" tIns="0" rIns="0" bIns="0" rtlCol="0" anchor="t"/>
+          <a:lstStyle/>
+          <a:p>
+            <a:pPr indent="0" marL="0">
+              <a:buNone/>
+            </a:pPr>
+            <a:r>
+              <a:rPr lang="en-US" sz="1300" dirty="0">
+                <a:solidFill>
+                  <a:schemeClr val="tx2"/>
+                </a:solidFill>
+              </a:rPr>
+              <a:t>Log + kurum duyurusu + kod; düzeltme önerisi</a:t>
+            </a:r>
+            <a:endParaRPr lang="en-US" sz="1300" dirty="0"/>
+          </a:p>
+        </p:txBody>
+      </p:sp>
+      <p:sp>
+        <p:nvSpPr>
+          <p:cNvPr id="24" name="Text 22"/>
+          <p:cNvSpPr txBox="1"/>
+          <p:nvPr/>
+        </p:nvSpPr>
+        <p:spPr>
+          <a:xfrm>
+            <a:off x="8275320" y="2926080"/>
+            <a:ext cx="2103120" cy="502920"/>
+          </a:xfrm>
+          <a:prstGeom prst="rect">
+            <a:avLst/>
+          </a:prstGeom>
+          <a:noFill/>
+          <a:ln/>
+        </p:spPr>
+        <p:txBody>
+          <a:bodyPr wrap="square" lIns="0" tIns="0" rIns="0" bIns="0" rtlCol="0" anchor="ctr"/>
+          <a:lstStyle/>
+          <a:p>
+            <a:pPr indent="0" marL="0">
+              <a:buNone/>
+            </a:pPr>
+            <a:r>
+              <a:rPr lang="en-US" sz="1300" b="1" dirty="0">
+                <a:solidFill>
+                  <a:schemeClr val="tx1"/>
+                </a:solidFill>
+              </a:rPr>
+              <a:t>187 müşteri · ASKİ önceden</a:t>
+            </a:r>
+            <a:endParaRPr lang="en-US" sz="1300" dirty="0"/>
+          </a:p>
+        </p:txBody>
+      </p:sp>
+      <p:sp>
+        <p:nvSpPr>
+          <p:cNvPr id="25" name="scen-status-C"/>
+          <p:cNvSpPr/>
+          <p:nvPr/>
+        </p:nvSpPr>
+        <p:spPr>
+          <a:xfrm>
+            <a:off x="10378440" y="3017520"/>
+            <a:ext cx="1005840" cy="329184"/>
+          </a:xfrm>
+          <a:prstGeom prst="roundRect">
+            <a:avLst>
+              <a:gd name="adj" fmla="val 50000"/>
+            </a:avLst>
+          </a:prstGeom>
+          <a:solidFill>
+            <a:schemeClr val="accent2"/>
+          </a:solidFill>
+          <a:ln w="12700">
+            <a:solidFill>
+              <a:schemeClr val="accent2"/>
+            </a:solidFill>
+            <a:prstDash val="solid"/>
+          </a:ln>
+        </p:spPr>
+      </p:sp>
+      <p:sp>
+        <p:nvSpPr>
+          <p:cNvPr id="26" name="Text 24"/>
+          <p:cNvSpPr txBox="1"/>
+          <p:nvPr/>
+        </p:nvSpPr>
+        <p:spPr>
+          <a:xfrm>
+            <a:off x="10378440" y="3017520"/>
+            <a:ext cx="1005840" cy="329184"/>
+          </a:xfrm>
+          <a:prstGeom prst="rect">
+            <a:avLst/>
+          </a:prstGeom>
+          <a:noFill/>
+          <a:ln/>
+        </p:spPr>
+        <p:txBody>
+          <a:bodyPr wrap="square" lIns="0" tIns="0" rIns="0" bIns="0" rtlCol="0" anchor="ctr"/>
+          <a:lstStyle/>
+          <a:p>
+            <a:pPr algn="ctr" indent="0" marL="0">
+              <a:buNone/>
+            </a:pPr>
+            <a:r>
+              <a:rPr lang="en-US" sz="1100" b="1" dirty="0">
+                <a:solidFill>
+                  <a:schemeClr val="bg1"/>
+                </a:solidFill>
+              </a:rPr>
+              <a:t>CANLI</a:t>
+            </a:r>
+            <a:endParaRPr lang="en-US" sz="1100" dirty="0"/>
+          </a:p>
+        </p:txBody>
+      </p:sp>
+      <p:sp>
+        <p:nvSpPr>
+          <p:cNvPr id="27" name="scen-card-D"/>
+          <p:cNvSpPr/>
+          <p:nvPr/>
+        </p:nvSpPr>
+        <p:spPr>
+          <a:xfrm>
+            <a:off x="548640" y="3840480"/>
+            <a:ext cx="3520440" cy="2331720"/>
+          </a:xfrm>
+          <a:prstGeom prst="roundRect">
+            <a:avLst>
+              <a:gd name="adj" fmla="val 4706"/>
+            </a:avLst>
+          </a:prstGeom>
+          <a:solidFill>
+            <a:schemeClr val="bg2"/>
+          </a:solidFill>
+          <a:ln w="12700">
+            <a:solidFill>
+              <a:schemeClr val="bg2"/>
+            </a:solidFill>
+            <a:prstDash val="solid"/>
+          </a:ln>
+        </p:spPr>
+      </p:sp>
+      <p:sp>
+        <p:nvSpPr>
+          <p:cNvPr id="28" name="scen-letter-D"/>
+          <p:cNvSpPr/>
+          <p:nvPr/>
+        </p:nvSpPr>
+        <p:spPr>
+          <a:xfrm>
+            <a:off x="777240" y="4069080"/>
+            <a:ext cx="548640" cy="548640"/>
+          </a:xfrm>
+          <a:prstGeom prst="ellipse">
+            <a:avLst/>
+          </a:prstGeom>
+          <a:solidFill>
+            <a:schemeClr val="tx2"/>
+          </a:solidFill>
+          <a:ln w="12700">
+            <a:solidFill>
+              <a:schemeClr val="tx2"/>
+            </a:solidFill>
+            <a:prstDash val="solid"/>
+          </a:ln>
+        </p:spPr>
+      </p:sp>
+      <p:sp>
+        <p:nvSpPr>
+          <p:cNvPr id="29" name="Text 27"/>
+          <p:cNvSpPr txBox="1"/>
+          <p:nvPr/>
+        </p:nvSpPr>
+        <p:spPr>
+          <a:xfrm>
+            <a:off x="777240" y="4069080"/>
+            <a:ext cx="548640" cy="548640"/>
+          </a:xfrm>
+          <a:prstGeom prst="rect">
+            <a:avLst/>
+          </a:prstGeom>
+          <a:noFill/>
+          <a:ln/>
+        </p:spPr>
+        <p:txBody>
+          <a:bodyPr wrap="square" lIns="0" tIns="0" rIns="0" bIns="0" rtlCol="0" anchor="ctr"/>
+          <a:lstStyle/>
+          <a:p>
+            <a:pPr algn="ctr" indent="0" marL="0">
+              <a:buNone/>
+            </a:pPr>
+            <a:r>
+              <a:rPr lang="en-US" sz="2000" b="1" dirty="0">
+                <a:solidFill>
+                  <a:schemeClr val="bg1"/>
+                </a:solidFill>
+              </a:rPr>
+              <a:t>D</a:t>
+            </a:r>
+            <a:endParaRPr lang="en-US" sz="2000" dirty="0"/>
+          </a:p>
+        </p:txBody>
+      </p:sp>
+      <p:sp>
+        <p:nvSpPr>
+          <p:cNvPr id="30" name="Text 28"/>
+          <p:cNvSpPr txBox="1"/>
+          <p:nvPr/>
+        </p:nvSpPr>
+        <p:spPr>
+          <a:xfrm>
+            <a:off x="1463040" y="4023360"/>
+            <a:ext cx="2468880" cy="685800"/>
+          </a:xfrm>
+          <a:prstGeom prst="rect">
+            <a:avLst/>
+          </a:prstGeom>
+          <a:noFill/>
+          <a:ln/>
+        </p:spPr>
+        <p:txBody>
+          <a:bodyPr wrap="square" lIns="0" tIns="0" rIns="0" bIns="0" rtlCol="0" anchor="ctr"/>
+          <a:lstStyle/>
+          <a:p>
+            <a:pPr indent="0" marL="0">
+              <a:buNone/>
+            </a:pPr>
+            <a:r>
+              <a:rPr lang="en-US" sz="1600" b="1" dirty="0">
+                <a:solidFill>
+                  <a:schemeClr val="tx1"/>
+                </a:solidFill>
+              </a:rPr>
+              <a:t>Talepten plana</a:t>
+            </a:r>
+            <a:endParaRPr lang="en-US" sz="1600" dirty="0"/>
+          </a:p>
+          <a:p>
+            <a:pPr indent="0" marL="0">
+              <a:buNone/>
+            </a:pPr>
+            <a:r>
+              <a:rPr lang="en-US" sz="1100" dirty="0">
+                <a:solidFill>
+                  <a:schemeClr val="accent5"/>
+                </a:solidFill>
+              </a:rPr>
+              <a:t>Talep Yönlendirme · Fatma → Ayşe</a:t>
+            </a:r>
+            <a:endParaRPr lang="en-US" sz="1600" dirty="0"/>
+          </a:p>
+        </p:txBody>
+      </p:sp>
+      <p:sp>
+        <p:nvSpPr>
+          <p:cNvPr id="31" name="Text 29"/>
+          <p:cNvSpPr txBox="1"/>
+          <p:nvPr/>
+        </p:nvSpPr>
+        <p:spPr>
+          <a:xfrm>
+            <a:off x="777240" y="4800600"/>
+            <a:ext cx="3063240" cy="594360"/>
+          </a:xfrm>
+          <a:prstGeom prst="rect">
+            <a:avLst/>
+          </a:prstGeom>
+          <a:noFill/>
+          <a:ln/>
+        </p:spPr>
+        <p:txBody>
+          <a:bodyPr wrap="square" lIns="0" tIns="0" rIns="0" bIns="0" rtlCol="0" anchor="t"/>
+          <a:lstStyle/>
+          <a:p>
+            <a:pPr indent="0" marL="0">
+              <a:buNone/>
+            </a:pPr>
+            <a:r>
+              <a:rPr lang="en-US" sz="1300" dirty="0">
+                <a:solidFill>
+                  <a:schemeClr val="tx2"/>
+                </a:solidFill>
+              </a:rPr>
+              <a:t>Servis, adam-gün, takvim; veriyle kapsam</a:t>
+            </a:r>
+            <a:endParaRPr lang="en-US" sz="1300" dirty="0"/>
+          </a:p>
+        </p:txBody>
+      </p:sp>
+      <p:sp>
+        <p:nvSpPr>
+          <p:cNvPr id="32" name="Text 30"/>
+          <p:cNvSpPr txBox="1"/>
+          <p:nvPr/>
+        </p:nvSpPr>
+        <p:spPr>
+          <a:xfrm>
+            <a:off x="777240" y="5440680"/>
+            <a:ext cx="2103120" cy="502920"/>
+          </a:xfrm>
+          <a:prstGeom prst="rect">
+            <a:avLst/>
+          </a:prstGeom>
+          <a:noFill/>
+          <a:ln/>
+        </p:spPr>
+        <p:txBody>
+          <a:bodyPr wrap="square" lIns="0" tIns="0" rIns="0" bIns="0" rtlCol="0" anchor="ctr"/>
+          <a:lstStyle/>
+          <a:p>
+            <a:pPr indent="0" marL="0">
+              <a:buNone/>
+            </a:pPr>
+            <a:r>
+              <a:rPr lang="en-US" sz="1300" b="1" dirty="0">
+                <a:solidFill>
+                  <a:schemeClr val="tx1"/>
+                </a:solidFill>
+              </a:rPr>
+              <a:t>Erişim %58 → %89 · 20 a/g</a:t>
+            </a:r>
+            <a:endParaRPr lang="en-US" sz="1300" dirty="0"/>
+          </a:p>
+        </p:txBody>
+      </p:sp>
+      <p:sp>
+        <p:nvSpPr>
+          <p:cNvPr id="33" name="scen-status-D"/>
+          <p:cNvSpPr/>
+          <p:nvPr/>
+        </p:nvSpPr>
+        <p:spPr>
+          <a:xfrm>
+            <a:off x="2880360" y="5532120"/>
+            <a:ext cx="1005840" cy="329184"/>
+          </a:xfrm>
+          <a:prstGeom prst="roundRect">
+            <a:avLst>
+              <a:gd name="adj" fmla="val 50000"/>
+            </a:avLst>
+          </a:prstGeom>
+          <a:solidFill>
+            <a:schemeClr val="accent2"/>
+          </a:solidFill>
+          <a:ln w="12700">
+            <a:solidFill>
+              <a:schemeClr val="accent2"/>
+            </a:solidFill>
+            <a:prstDash val="solid"/>
+          </a:ln>
+        </p:spPr>
+      </p:sp>
+      <p:sp>
+        <p:nvSpPr>
+          <p:cNvPr id="34" name="Text 32"/>
+          <p:cNvSpPr txBox="1"/>
+          <p:nvPr/>
+        </p:nvSpPr>
+        <p:spPr>
+          <a:xfrm>
+            <a:off x="2880360" y="5532120"/>
+            <a:ext cx="1005840" cy="329184"/>
+          </a:xfrm>
+          <a:prstGeom prst="rect">
+            <a:avLst/>
+          </a:prstGeom>
+          <a:noFill/>
+          <a:ln/>
+        </p:spPr>
+        <p:txBody>
+          <a:bodyPr wrap="square" lIns="0" tIns="0" rIns="0" bIns="0" rtlCol="0" anchor="ctr"/>
+          <a:lstStyle/>
+          <a:p>
+            <a:pPr algn="ctr" indent="0" marL="0">
+              <a:buNone/>
+            </a:pPr>
+            <a:r>
+              <a:rPr lang="en-US" sz="1100" b="1" dirty="0">
+                <a:solidFill>
+                  <a:schemeClr val="bg1"/>
+                </a:solidFill>
+              </a:rPr>
+              <a:t>CANLI</a:t>
+            </a:r>
+            <a:endParaRPr lang="en-US" sz="1100" dirty="0"/>
+          </a:p>
+        </p:txBody>
+      </p:sp>
+      <p:sp>
+        <p:nvSpPr>
+          <p:cNvPr id="35" name="scen-card-E"/>
+          <p:cNvSpPr/>
+          <p:nvPr/>
+        </p:nvSpPr>
+        <p:spPr>
+          <a:xfrm>
+            <a:off x="4297680" y="3840480"/>
+            <a:ext cx="3520440" cy="2331720"/>
+          </a:xfrm>
+          <a:prstGeom prst="roundRect">
+            <a:avLst>
+              <a:gd name="adj" fmla="val 4706"/>
+            </a:avLst>
+          </a:prstGeom>
+          <a:solidFill>
+            <a:schemeClr val="bg2"/>
+          </a:solidFill>
+          <a:ln w="12700">
+            <a:solidFill>
+              <a:schemeClr val="bg2"/>
+            </a:solidFill>
+            <a:prstDash val="solid"/>
+          </a:ln>
+        </p:spPr>
+      </p:sp>
+      <p:sp>
+        <p:nvSpPr>
+          <p:cNvPr id="36" name="scen-letter-E"/>
+          <p:cNvSpPr/>
+          <p:nvPr/>
+        </p:nvSpPr>
+        <p:spPr>
+          <a:xfrm>
+            <a:off x="4526280" y="4069080"/>
+            <a:ext cx="548640" cy="548640"/>
+          </a:xfrm>
+          <a:prstGeom prst="ellipse">
+            <a:avLst/>
+          </a:prstGeom>
+          <a:solidFill>
+            <a:schemeClr val="accent5"/>
+          </a:solidFill>
+          <a:ln w="12700">
+            <a:solidFill>
+              <a:schemeClr val="accent5"/>
+            </a:solidFill>
+            <a:prstDash val="solid"/>
+          </a:ln>
+        </p:spPr>
+      </p:sp>
+      <p:sp>
+        <p:nvSpPr>
+          <p:cNvPr id="37" name="Text 35"/>
+          <p:cNvSpPr txBox="1"/>
+          <p:nvPr/>
+        </p:nvSpPr>
+        <p:spPr>
+          <a:xfrm>
+            <a:off x="4526280" y="4069080"/>
+            <a:ext cx="548640" cy="548640"/>
+          </a:xfrm>
+          <a:prstGeom prst="rect">
+            <a:avLst/>
+          </a:prstGeom>
+          <a:noFill/>
+          <a:ln/>
+        </p:spPr>
+        <p:txBody>
+          <a:bodyPr wrap="square" lIns="0" tIns="0" rIns="0" bIns="0" rtlCol="0" anchor="ctr"/>
+          <a:lstStyle/>
+          <a:p>
+            <a:pPr algn="ctr" indent="0" marL="0">
+              <a:buNone/>
+            </a:pPr>
+            <a:r>
+              <a:rPr lang="en-US" sz="2000" b="1" dirty="0">
+                <a:solidFill>
+                  <a:schemeClr val="bg1"/>
+                </a:solidFill>
+              </a:rPr>
+              <a:t>E</a:t>
+            </a:r>
+            <a:endParaRPr lang="en-US" sz="2000" dirty="0"/>
+          </a:p>
+        </p:txBody>
+      </p:sp>
+      <p:sp>
+        <p:nvSpPr>
+          <p:cNvPr id="38" name="Text 36"/>
+          <p:cNvSpPr txBox="1"/>
+          <p:nvPr/>
+        </p:nvSpPr>
+        <p:spPr>
+          <a:xfrm>
+            <a:off x="5212080" y="4023360"/>
+            <a:ext cx="2468880" cy="685800"/>
+          </a:xfrm>
+          <a:prstGeom prst="rect">
+            <a:avLst/>
+          </a:prstGeom>
+          <a:noFill/>
+          <a:ln/>
+        </p:spPr>
+        <p:txBody>
+          <a:bodyPr wrap="square" lIns="0" tIns="0" rIns="0" bIns="0" rtlCol="0" anchor="ctr"/>
+          <a:lstStyle/>
+          <a:p>
+            <a:pPr indent="0" marL="0">
+              <a:buNone/>
+            </a:pPr>
+            <a:r>
+              <a:rPr lang="en-US" sz="1600" b="1" dirty="0">
+                <a:solidFill>
+                  <a:schemeClr val="tx1"/>
+                </a:solidFill>
+              </a:rPr>
+              <a:t>Acil yeni ekran</a:t>
+            </a:r>
+            <a:endParaRPr lang="en-US" sz="1600" dirty="0"/>
+          </a:p>
+          <a:p>
+            <a:pPr indent="0" marL="0">
+              <a:buNone/>
+            </a:pPr>
+            <a:r>
+              <a:rPr lang="en-US" sz="1100" dirty="0">
+                <a:solidFill>
+                  <a:schemeClr val="accent5"/>
+                </a:solidFill>
+              </a:rPr>
+              <a:t>KRDTERTL (yeni) · Hakan → Ayşe</a:t>
+            </a:r>
+            <a:endParaRPr lang="en-US" sz="1600" dirty="0"/>
+          </a:p>
+        </p:txBody>
+      </p:sp>
+      <p:sp>
+        <p:nvSpPr>
+          <p:cNvPr id="39" name="Text 37"/>
+          <p:cNvSpPr txBox="1"/>
+          <p:nvPr/>
+        </p:nvSpPr>
+        <p:spPr>
+          <a:xfrm>
+            <a:off x="4526280" y="4800600"/>
+            <a:ext cx="3063240" cy="594360"/>
+          </a:xfrm>
+          <a:prstGeom prst="rect">
+            <a:avLst/>
+          </a:prstGeom>
+          <a:noFill/>
+          <a:ln/>
+        </p:spPr>
+        <p:txBody>
+          <a:bodyPr wrap="square" lIns="0" tIns="0" rIns="0" bIns="0" rtlCol="0" anchor="t"/>
+          <a:lstStyle/>
+          <a:p>
+            <a:pPr indent="0" marL="0">
+              <a:buNone/>
+            </a:pPr>
+            <a:r>
+              <a:rPr lang="en-US" sz="1300" dirty="0">
+                <a:solidFill>
+                  <a:schemeClr val="tx2"/>
+                </a:solidFill>
+              </a:rPr>
+              <a:t>Etkilenen müşteri, riskli sorular, kapasite çatışması</a:t>
+            </a:r>
+            <a:endParaRPr lang="en-US" sz="1300" dirty="0"/>
+          </a:p>
+        </p:txBody>
+      </p:sp>
+      <p:sp>
+        <p:nvSpPr>
+          <p:cNvPr id="40" name="Text 38"/>
+          <p:cNvSpPr txBox="1"/>
+          <p:nvPr/>
+        </p:nvSpPr>
+        <p:spPr>
+          <a:xfrm>
+            <a:off x="4526280" y="5440680"/>
+            <a:ext cx="2103120" cy="502920"/>
+          </a:xfrm>
+          <a:prstGeom prst="rect">
+            <a:avLst/>
+          </a:prstGeom>
+          <a:noFill/>
+          <a:ln/>
+        </p:spPr>
+        <p:txBody>
+          <a:bodyPr wrap="square" lIns="0" tIns="0" rIns="0" bIns="0" rtlCol="0" anchor="ctr"/>
+          <a:lstStyle/>
+          <a:p>
+            <a:pPr indent="0" marL="0">
+              <a:buNone/>
+            </a:pPr>
+            <a:r>
+              <a:rPr lang="en-US" sz="1300" b="1" dirty="0">
+                <a:solidFill>
+                  <a:schemeClr val="tx1"/>
+                </a:solidFill>
+              </a:rPr>
+              <a:t>Aynı gün karar · 17 a/g</a:t>
+            </a:r>
+            <a:endParaRPr lang="en-US" sz="1300" dirty="0"/>
+          </a:p>
+        </p:txBody>
+      </p:sp>
+      <p:sp>
+        <p:nvSpPr>
+          <p:cNvPr id="41" name="scen-status-E"/>
+          <p:cNvSpPr/>
+          <p:nvPr/>
+        </p:nvSpPr>
+        <p:spPr>
+          <a:xfrm>
+            <a:off x="6629400" y="5532120"/>
+            <a:ext cx="1005840" cy="329184"/>
+          </a:xfrm>
+          <a:prstGeom prst="roundRect">
+            <a:avLst>
+              <a:gd name="adj" fmla="val 50000"/>
+            </a:avLst>
+          </a:prstGeom>
+          <a:solidFill>
+            <a:schemeClr val="accent5"/>
+          </a:solidFill>
+          <a:ln w="12700">
+            <a:solidFill>
+              <a:schemeClr val="accent5"/>
+            </a:solidFill>
+            <a:prstDash val="solid"/>
+          </a:ln>
+        </p:spPr>
+      </p:sp>
+      <p:sp>
+        <p:nvSpPr>
+          <p:cNvPr id="42" name="Text 40"/>
+          <p:cNvSpPr txBox="1"/>
+          <p:nvPr/>
+        </p:nvSpPr>
+        <p:spPr>
+          <a:xfrm>
+            <a:off x="6629400" y="5532120"/>
+            <a:ext cx="1005840" cy="329184"/>
+          </a:xfrm>
+          <a:prstGeom prst="rect">
+            <a:avLst/>
+          </a:prstGeom>
+          <a:noFill/>
+          <a:ln/>
+        </p:spPr>
+        <p:txBody>
+          <a:bodyPr wrap="square" lIns="0" tIns="0" rIns="0" bIns="0" rtlCol="0" anchor="ctr"/>
+          <a:lstStyle/>
+          <a:p>
+            <a:pPr algn="ctr" indent="0" marL="0">
+              <a:buNone/>
+            </a:pPr>
+            <a:r>
+              <a:rPr lang="en-US" sz="1100" b="1" dirty="0">
+                <a:solidFill>
+                  <a:schemeClr val="bg1"/>
+                </a:solidFill>
+              </a:rPr>
+              <a:t>KAYIT</a:t>
+            </a:r>
+            <a:endParaRPr lang="en-US" sz="1100" dirty="0"/>
+          </a:p>
+        </p:txBody>
+      </p:sp>
+      <p:sp>
+        <p:nvSpPr>
+          <p:cNvPr id="43" name="scen-card-F"/>
+          <p:cNvSpPr/>
+          <p:nvPr/>
+        </p:nvSpPr>
+        <p:spPr>
+          <a:xfrm>
+            <a:off x="8046720" y="3840480"/>
+            <a:ext cx="3520440" cy="2331720"/>
+          </a:xfrm>
+          <a:prstGeom prst="roundRect">
+            <a:avLst>
+              <a:gd name="adj" fmla="val 4706"/>
+            </a:avLst>
+          </a:prstGeom>
+          <a:solidFill>
+            <a:schemeClr val="bg2"/>
+          </a:solidFill>
+          <a:ln w="12700">
+            <a:solidFill>
+              <a:schemeClr val="bg2"/>
+            </a:solidFill>
+            <a:prstDash val="solid"/>
+          </a:ln>
+        </p:spPr>
+      </p:sp>
+      <p:sp>
+        <p:nvSpPr>
+          <p:cNvPr id="44" name="scen-letter-F"/>
+          <p:cNvSpPr/>
+          <p:nvPr/>
+        </p:nvSpPr>
+        <p:spPr>
+          <a:xfrm>
+            <a:off x="8275320" y="4069080"/>
+            <a:ext cx="548640" cy="548640"/>
+          </a:xfrm>
+          <a:prstGeom prst="ellipse">
+            <a:avLst/>
+          </a:prstGeom>
+          <a:solidFill>
+            <a:schemeClr val="accent5"/>
+          </a:solidFill>
+          <a:ln w="12700">
+            <a:solidFill>
+              <a:schemeClr val="accent5"/>
+            </a:solidFill>
+            <a:prstDash val="solid"/>
+          </a:ln>
+        </p:spPr>
+      </p:sp>
+      <p:sp>
+        <p:nvSpPr>
+          <p:cNvPr id="45" name="Text 43"/>
+          <p:cNvSpPr txBox="1"/>
+          <p:nvPr/>
+        </p:nvSpPr>
+        <p:spPr>
+          <a:xfrm>
+            <a:off x="8275320" y="4069080"/>
+            <a:ext cx="548640" cy="548640"/>
+          </a:xfrm>
+          <a:prstGeom prst="rect">
+            <a:avLst/>
+          </a:prstGeom>
+          <a:noFill/>
+          <a:ln/>
+        </p:spPr>
+        <p:txBody>
+          <a:bodyPr wrap="square" lIns="0" tIns="0" rIns="0" bIns="0" rtlCol="0" anchor="ctr"/>
+          <a:lstStyle/>
+          <a:p>
+            <a:pPr algn="ctr" indent="0" marL="0">
+              <a:buNone/>
+            </a:pPr>
+            <a:r>
+              <a:rPr lang="en-US" sz="2000" b="1" dirty="0">
+                <a:solidFill>
+                  <a:schemeClr val="bg1"/>
+                </a:solidFill>
+              </a:rPr>
+              <a:t>F</a:t>
+            </a:r>
+            <a:endParaRPr lang="en-US" sz="2000" dirty="0"/>
+          </a:p>
+        </p:txBody>
+      </p:sp>
+      <p:sp>
+        <p:nvSpPr>
+          <p:cNvPr id="46" name="Text 44"/>
+          <p:cNvSpPr txBox="1"/>
+          <p:nvPr/>
+        </p:nvSpPr>
+        <p:spPr>
+          <a:xfrm>
+            <a:off x="8961120" y="4023360"/>
+            <a:ext cx="2468880" cy="685800"/>
+          </a:xfrm>
+          <a:prstGeom prst="rect">
+            <a:avLst/>
+          </a:prstGeom>
+          <a:noFill/>
+          <a:ln/>
+        </p:spPr>
+        <p:txBody>
+          <a:bodyPr wrap="square" lIns="0" tIns="0" rIns="0" bIns="0" rtlCol="0" anchor="ctr"/>
+          <a:lstStyle/>
+          <a:p>
+            <a:pPr indent="0" marL="0">
+              <a:buNone/>
+            </a:pPr>
+            <a:r>
+              <a:rPr lang="en-US" sz="1600" b="1" dirty="0">
+                <a:solidFill>
+                  <a:schemeClr val="tx1"/>
+                </a:solidFill>
+              </a:rPr>
+              <a:t>Günlük durum özeti</a:t>
+            </a:r>
+            <a:endParaRPr lang="en-US" sz="1600" dirty="0"/>
+          </a:p>
+          <a:p>
+            <a:pPr indent="0" marL="0">
+              <a:buNone/>
+            </a:pPr>
+            <a:r>
+              <a:rPr lang="en-US" sz="1100" dirty="0">
+                <a:solidFill>
+                  <a:schemeClr val="accent5"/>
+                </a:solidFill>
+              </a:rPr>
+              <a:t>Mercek sohbet · Kerem</a:t>
+            </a:r>
+            <a:endParaRPr lang="en-US" sz="1600" dirty="0"/>
+          </a:p>
+        </p:txBody>
+      </p:sp>
+      <p:sp>
+        <p:nvSpPr>
+          <p:cNvPr id="47" name="Text 45"/>
+          <p:cNvSpPr txBox="1"/>
+          <p:nvPr/>
+        </p:nvSpPr>
+        <p:spPr>
+          <a:xfrm>
+            <a:off x="8275320" y="4800600"/>
+            <a:ext cx="3063240" cy="594360"/>
+          </a:xfrm>
+          <a:prstGeom prst="rect">
+            <a:avLst/>
+          </a:prstGeom>
+          <a:noFill/>
+          <a:ln/>
+        </p:spPr>
+        <p:txBody>
+          <a:bodyPr wrap="square" lIns="0" tIns="0" rIns="0" bIns="0" rtlCol="0" anchor="t"/>
+          <a:lstStyle/>
+          <a:p>
+            <a:pPr indent="0" marL="0">
+              <a:buNone/>
+            </a:pPr>
+            <a:r>
+              <a:rPr lang="en-US" sz="1300" dirty="0">
+                <a:solidFill>
+                  <a:schemeClr val="tx2"/>
+                </a:solidFill>
+              </a:rPr>
+              <a:t>Kibana bilgisi gerektirmeden sohbetle özet</a:t>
+            </a:r>
+            <a:endParaRPr lang="en-US" sz="1300" dirty="0"/>
+          </a:p>
+        </p:txBody>
+      </p:sp>
+      <p:sp>
+        <p:nvSpPr>
+          <p:cNvPr id="48" name="Text 46"/>
+          <p:cNvSpPr txBox="1"/>
+          <p:nvPr/>
+        </p:nvSpPr>
+        <p:spPr>
+          <a:xfrm>
+            <a:off x="8275320" y="5440680"/>
+            <a:ext cx="2103120" cy="502920"/>
+          </a:xfrm>
+          <a:prstGeom prst="rect">
+            <a:avLst/>
+          </a:prstGeom>
+          <a:noFill/>
+          <a:ln/>
+        </p:spPr>
+        <p:txBody>
+          <a:bodyPr wrap="square" lIns="0" tIns="0" rIns="0" bIns="0" rtlCol="0" anchor="ctr"/>
+          <a:lstStyle/>
+          <a:p>
+            <a:pPr indent="0" marL="0">
+              <a:buNone/>
+            </a:pPr>
+            <a:r>
+              <a:rPr lang="en-US" sz="1300" b="1" dirty="0">
+                <a:solidFill>
+                  <a:schemeClr val="tx1"/>
+                </a:solidFill>
+              </a:rPr>
+              <a:t>En sorunlu ekran: ODMTFATR</a:t>
+            </a:r>
+            <a:endParaRPr lang="en-US" sz="1300" dirty="0"/>
+          </a:p>
+        </p:txBody>
+      </p:sp>
+      <p:sp>
+        <p:nvSpPr>
+          <p:cNvPr id="49" name="scen-status-F"/>
+          <p:cNvSpPr/>
+          <p:nvPr/>
+        </p:nvSpPr>
+        <p:spPr>
+          <a:xfrm>
+            <a:off x="10378440" y="5532120"/>
+            <a:ext cx="1005840" cy="329184"/>
+          </a:xfrm>
+          <a:prstGeom prst="roundRect">
+            <a:avLst>
+              <a:gd name="adj" fmla="val 50000"/>
+            </a:avLst>
+          </a:prstGeom>
+          <a:solidFill>
+            <a:schemeClr val="accent5"/>
+          </a:solidFill>
+          <a:ln w="12700">
+            <a:solidFill>
+              <a:schemeClr val="accent5"/>
+            </a:solidFill>
+            <a:prstDash val="solid"/>
+          </a:ln>
+        </p:spPr>
+      </p:sp>
+      <p:sp>
+        <p:nvSpPr>
+          <p:cNvPr id="50" name="Text 48"/>
+          <p:cNvSpPr txBox="1"/>
+          <p:nvPr/>
+        </p:nvSpPr>
+        <p:spPr>
+          <a:xfrm>
+            <a:off x="10378440" y="5532120"/>
+            <a:ext cx="1005840" cy="329184"/>
+          </a:xfrm>
+          <a:prstGeom prst="rect">
+            <a:avLst/>
+          </a:prstGeom>
+          <a:noFill/>
+          <a:ln/>
+        </p:spPr>
+        <p:txBody>
+          <a:bodyPr wrap="square" lIns="0" tIns="0" rIns="0" bIns="0" rtlCol="0" anchor="ctr"/>
+          <a:lstStyle/>
+          <a:p>
+            <a:pPr algn="ctr" indent="0" marL="0">
+              <a:buNone/>
+            </a:pPr>
+            <a:r>
+              <a:rPr lang="en-US" sz="1100" b="1" dirty="0">
+                <a:solidFill>
+                  <a:schemeClr val="bg1"/>
+                </a:solidFill>
+              </a:rPr>
+              <a:t>KAYIT</a:t>
+            </a:r>
+            <a:endParaRPr lang="en-US" sz="1100" dirty="0"/>
           </a:p>
         </p:txBody>
       </p:sp>
@@ -8982,7 +10312,7 @@
                   <a:schemeClr val="tx1"/>
                 </a:solidFill>
               </a:rPr>
-              <a:t>Demo: üç sahnede Mercek</a:t>
+              <a:t>Canlı demo: dört sahne</a:t>
             </a:r>
             <a:endParaRPr lang="en-US" sz="3600" dirty="0"/>
           </a:p>
@@ -8996,12 +10326,12 @@
         </p:nvSpPr>
         <p:spPr>
           <a:xfrm>
-            <a:off x="548640" y="1371600"/>
-            <a:ext cx="3520440" cy="4800600"/>
+            <a:off x="548640" y="1280160"/>
+            <a:ext cx="5440680" cy="2377440"/>
           </a:xfrm>
           <a:prstGeom prst="roundRect">
             <a:avLst>
-              <a:gd name="adj" fmla="val 3117"/>
+              <a:gd name="adj" fmla="val 4615"/>
             </a:avLst>
           </a:prstGeom>
           <a:solidFill>
@@ -9015,16 +10345,40 @@
           </a:ln>
         </p:spPr>
       </p:sp>
-      <p:sp>
-        <p:nvSpPr>
-          <p:cNvPr id="4" name="scene-time-1"/>
+      <p:pic>
+        <p:nvPicPr>
+          <p:cNvPr id="4" name="demo-image-1" descr="/home/claude/zthackathonstudy/presentation/mockups/m-a-panel.png">    </p:cNvPr>
+          <p:cNvPicPr>
+            <a:picLocks noChangeAspect="1"/>
+          </p:cNvPicPr>
+          <p:nvPr/>
+        </p:nvPicPr>
+        <p:blipFill>
+          <a:blip r:embed="rId1"/>
+          <a:stretch>
+            <a:fillRect/>
+          </a:stretch>
+        </p:blipFill>
+        <p:spPr>
+          <a:xfrm>
+            <a:off x="731520" y="1463040"/>
+            <a:ext cx="3397032" cy="2011680"/>
+          </a:xfrm>
+          <a:prstGeom prst="rect">
+            <a:avLst/>
+          </a:prstGeom>
+        </p:spPr>
+      </p:pic>
+      <p:sp>
+        <p:nvSpPr>
+          <p:cNvPr id="5" name="scene-time-1"/>
           <p:cNvSpPr/>
           <p:nvPr/>
         </p:nvSpPr>
         <p:spPr>
           <a:xfrm>
-            <a:off x="777240" y="1554480"/>
-            <a:ext cx="914400" cy="329184"/>
+            <a:off x="4311432" y="1463040"/>
+            <a:ext cx="868680" cy="310896"/>
           </a:xfrm>
           <a:prstGeom prst="roundRect">
             <a:avLst>
@@ -9044,14 +10398,14 @@
       </p:sp>
       <p:sp>
         <p:nvSpPr>
-          <p:cNvPr id="5" name="Text 3"/>
+          <p:cNvPr id="6" name="Text 3"/>
           <p:cNvSpPr txBox="1"/>
           <p:nvPr/>
         </p:nvSpPr>
         <p:spPr>
           <a:xfrm>
-            <a:off x="777240" y="1554480"/>
-            <a:ext cx="914400" cy="329184"/>
+            <a:off x="4311432" y="1463040"/>
+            <a:ext cx="868680" cy="310896"/>
           </a:xfrm>
           <a:prstGeom prst="rect">
             <a:avLst/>
@@ -9067,27 +10421,27 @@
               <a:buNone/>
             </a:pPr>
             <a:r>
-              <a:rPr lang="en-US" sz="1200" b="1" dirty="0">
+              <a:rPr lang="en-US" sz="1100" b="1" dirty="0">
                 <a:solidFill>
                   <a:schemeClr val="tx1"/>
                 </a:solidFill>
               </a:rPr>
-              <a:t>~60 sn</a:t>
-            </a:r>
-            <a:endParaRPr lang="en-US" sz="1200" dirty="0"/>
-          </a:p>
-        </p:txBody>
-      </p:sp>
-      <p:sp>
-        <p:nvSpPr>
-          <p:cNvPr id="6" name="Text 4"/>
+              <a:t>~45 sn</a:t>
+            </a:r>
+            <a:endParaRPr lang="en-US" sz="1100" dirty="0"/>
+          </a:p>
+        </p:txBody>
+      </p:sp>
+      <p:sp>
+        <p:nvSpPr>
+          <p:cNvPr id="7" name="Text 4"/>
           <p:cNvSpPr txBox="1"/>
           <p:nvPr/>
         </p:nvSpPr>
         <p:spPr>
           <a:xfrm>
-            <a:off x="777240" y="1965960"/>
-            <a:ext cx="3063240" cy="411480"/>
+            <a:off x="4311432" y="1847088"/>
+            <a:ext cx="1495008" cy="457200"/>
           </a:xfrm>
           <a:prstGeom prst="rect">
             <a:avLst/>
@@ -9096,48 +10450,24 @@
           <a:ln/>
         </p:spPr>
         <p:txBody>
-          <a:bodyPr wrap="square" lIns="0" tIns="0" rIns="0" bIns="0" rtlCol="0" anchor="ctr"/>
+          <a:bodyPr wrap="square" lIns="0" tIns="0" rIns="0" bIns="0" rtlCol="0" anchor="t"/>
           <a:lstStyle/>
           <a:p>
             <a:pPr indent="0" marL="0">
               <a:buNone/>
             </a:pPr>
             <a:r>
-              <a:rPr lang="en-US" sz="1700" b="1" dirty="0">
+              <a:rPr lang="en-US" sz="1500" b="1" dirty="0">
                 <a:solidFill>
                   <a:schemeClr val="tx1"/>
                 </a:solidFill>
               </a:rPr>
-              <a:t>Sahne 1 · Para gönderemiyorum</a:t>
-            </a:r>
-            <a:endParaRPr lang="en-US" sz="1700" dirty="0"/>
-          </a:p>
-        </p:txBody>
-      </p:sp>
-      <p:pic>
-        <p:nvPicPr>
-          <p:cNvPr id="7" name="demo-image-1" descr="/home/claude/zthackathonstudy/presentation/mockups/m-bank-tour.png">    </p:cNvPr>
-          <p:cNvPicPr>
-            <a:picLocks noChangeAspect="1"/>
-          </p:cNvPicPr>
-          <p:nvPr/>
-        </p:nvPicPr>
-        <p:blipFill>
-          <a:blip r:embed="rId1"/>
-          <a:stretch>
-            <a:fillRect/>
-          </a:stretch>
-        </p:blipFill>
-        <p:spPr>
-          <a:xfrm>
-            <a:off x="1740503" y="2468880"/>
-            <a:ext cx="1136713" cy="2331720"/>
-          </a:xfrm>
-          <a:prstGeom prst="rect">
-            <a:avLst/>
-          </a:prstGeom>
-        </p:spPr>
-      </p:pic>
+              <a:t>A · Hata mı, kural mı?</a:t>
+            </a:r>
+            <a:endParaRPr lang="en-US" sz="1500" dirty="0"/>
+          </a:p>
+        </p:txBody>
+      </p:sp>
       <p:sp>
         <p:nvSpPr>
           <p:cNvPr id="8" name="Text 5"/>
@@ -9146,8 +10476,8 @@
         </p:nvSpPr>
         <p:spPr>
           <a:xfrm>
-            <a:off x="777240" y="4892040"/>
-            <a:ext cx="3063240" cy="1188720"/>
+            <a:off x="4311432" y="2304288"/>
+            <a:ext cx="1495008" cy="1234440"/>
           </a:xfrm>
           <a:prstGeom prst="rect">
             <a:avLst/>
@@ -9163,14 +10493,14 @@
               <a:buNone/>
             </a:pPr>
             <a:r>
-              <a:rPr lang="en-US" sz="1400" dirty="0">
+              <a:rPr lang="en-US" sz="1150" dirty="0">
                 <a:solidFill>
                   <a:schemeClr val="tx2"/>
                 </a:solidFill>
               </a:rPr>
-              <a:t>Ayşe EFT yapamıyor. Mercek o yazmadan nedeni söylüyor, havale yolunu gösteriyor ve çağrıyı açıyor.</a:t>
-            </a:r>
-            <a:endParaRPr lang="en-US" sz="1400" dirty="0"/>
+              <a:t>Elif yazmadan Mercek iş kuralını açıklıyor, 'Bana göster' ile 330.000 TL / 36 ay dolduruluyor. Çağrı açılmıyor.</a:t>
+            </a:r>
+            <a:endParaRPr lang="en-US" sz="1150" dirty="0"/>
           </a:p>
         </p:txBody>
       </p:sp>
@@ -9182,12 +10512,12 @@
         </p:nvSpPr>
         <p:spPr>
           <a:xfrm>
-            <a:off x="4297680" y="1371600"/>
-            <a:ext cx="3520440" cy="4800600"/>
+            <a:off x="6172200" y="1280160"/>
+            <a:ext cx="5440680" cy="2377440"/>
           </a:xfrm>
           <a:prstGeom prst="roundRect">
             <a:avLst>
-              <a:gd name="adj" fmla="val 3117"/>
+              <a:gd name="adj" fmla="val 4615"/>
             </a:avLst>
           </a:prstGeom>
           <a:solidFill>
@@ -9201,16 +10531,40 @@
           </a:ln>
         </p:spPr>
       </p:sp>
-      <p:sp>
-        <p:nvSpPr>
-          <p:cNvPr id="10" name="scene-time-2"/>
+      <p:pic>
+        <p:nvPicPr>
+          <p:cNvPr id="10" name="demo-image-2" descr="/home/claude/zthackathonstudy/presentation/mockups/m-b-callcenter.png">    </p:cNvPr>
+          <p:cNvPicPr>
+            <a:picLocks noChangeAspect="1"/>
+          </p:cNvPicPr>
+          <p:nvPr/>
+        </p:nvPicPr>
+        <p:blipFill>
+          <a:blip r:embed="rId2"/>
+          <a:stretch>
+            <a:fillRect/>
+          </a:stretch>
+        </p:blipFill>
+        <p:spPr>
+          <a:xfrm>
+            <a:off x="6355080" y="1463040"/>
+            <a:ext cx="3397032" cy="2011680"/>
+          </a:xfrm>
+          <a:prstGeom prst="rect">
+            <a:avLst/>
+          </a:prstGeom>
+        </p:spPr>
+      </p:pic>
+      <p:sp>
+        <p:nvSpPr>
+          <p:cNvPr id="11" name="scene-time-2"/>
           <p:cNvSpPr/>
           <p:nvPr/>
         </p:nvSpPr>
         <p:spPr>
           <a:xfrm>
-            <a:off x="4526280" y="1554480"/>
-            <a:ext cx="914400" cy="329184"/>
+            <a:off x="9934992" y="1463040"/>
+            <a:ext cx="868680" cy="310896"/>
           </a:xfrm>
           <a:prstGeom prst="roundRect">
             <a:avLst>
@@ -9230,14 +10584,14 @@
       </p:sp>
       <p:sp>
         <p:nvSpPr>
-          <p:cNvPr id="11" name="Text 8"/>
+          <p:cNvPr id="12" name="Text 8"/>
           <p:cNvSpPr txBox="1"/>
           <p:nvPr/>
         </p:nvSpPr>
         <p:spPr>
           <a:xfrm>
-            <a:off x="4526280" y="1554480"/>
-            <a:ext cx="914400" cy="329184"/>
+            <a:off x="9934992" y="1463040"/>
+            <a:ext cx="868680" cy="310896"/>
           </a:xfrm>
           <a:prstGeom prst="rect">
             <a:avLst/>
@@ -9253,27 +10607,27 @@
               <a:buNone/>
             </a:pPr>
             <a:r>
-              <a:rPr lang="en-US" sz="1200" b="1" dirty="0">
+              <a:rPr lang="en-US" sz="1100" b="1" dirty="0">
                 <a:solidFill>
                   <a:schemeClr val="tx1"/>
                 </a:solidFill>
               </a:rPr>
-              <a:t>~60 sn</a:t>
-            </a:r>
-            <a:endParaRPr lang="en-US" sz="1200" dirty="0"/>
-          </a:p>
-        </p:txBody>
-      </p:sp>
-      <p:sp>
-        <p:nvSpPr>
-          <p:cNvPr id="12" name="Text 9"/>
+              <a:t>~50 sn</a:t>
+            </a:r>
+            <a:endParaRPr lang="en-US" sz="1100" dirty="0"/>
+          </a:p>
+        </p:txBody>
+      </p:sp>
+      <p:sp>
+        <p:nvSpPr>
+          <p:cNvPr id="13" name="Text 9"/>
           <p:cNvSpPr txBox="1"/>
           <p:nvPr/>
         </p:nvSpPr>
         <p:spPr>
           <a:xfrm>
-            <a:off x="4526280" y="1965960"/>
-            <a:ext cx="3063240" cy="411480"/>
+            <a:off x="9934992" y="1847088"/>
+            <a:ext cx="1495008" cy="457200"/>
           </a:xfrm>
           <a:prstGeom prst="rect">
             <a:avLst/>
@@ -9282,48 +10636,24 @@
           <a:ln/>
         </p:spPr>
         <p:txBody>
-          <a:bodyPr wrap="square" lIns="0" tIns="0" rIns="0" bIns="0" rtlCol="0" anchor="ctr"/>
+          <a:bodyPr wrap="square" lIns="0" tIns="0" rIns="0" bIns="0" rtlCol="0" anchor="t"/>
           <a:lstStyle/>
           <a:p>
             <a:pPr indent="0" marL="0">
               <a:buNone/>
             </a:pPr>
             <a:r>
-              <a:rPr lang="en-US" sz="1700" b="1" dirty="0">
+              <a:rPr lang="en-US" sz="1500" b="1" dirty="0">
                 <a:solidFill>
                   <a:schemeClr val="tx1"/>
                 </a:solidFill>
               </a:rPr>
-              <a:t>Sahne 2 · AI kodu okur</a:t>
-            </a:r>
-            <a:endParaRPr lang="en-US" sz="1700" dirty="0"/>
-          </a:p>
-        </p:txBody>
-      </p:sp>
-      <p:pic>
-        <p:nvPicPr>
-          <p:cNvPr id="13" name="demo-image-2" descr="/home/claude/zthackathonstudy/presentation/mockups/m-console-code.png">    </p:cNvPr>
-          <p:cNvPicPr>
-            <a:picLocks noChangeAspect="1"/>
-          </p:cNvPicPr>
-          <p:nvPr/>
-        </p:nvPicPr>
-        <p:blipFill>
-          <a:blip r:embed="rId2"/>
-          <a:stretch>
-            <a:fillRect/>
-          </a:stretch>
-        </p:blipFill>
-        <p:spPr>
-          <a:xfrm>
-            <a:off x="4526280" y="3008930"/>
-            <a:ext cx="3063240" cy="1251621"/>
-          </a:xfrm>
-          <a:prstGeom prst="rect">
-            <a:avLst/>
-          </a:prstGeom>
-        </p:spPr>
-      </p:pic>
+              <a:t>B · Bilinen çözüm</a:t>
+            </a:r>
+            <a:endParaRPr lang="en-US" sz="1500" dirty="0"/>
+          </a:p>
+        </p:txBody>
+      </p:sp>
       <p:sp>
         <p:nvSpPr>
           <p:cNvPr id="14" name="Text 10"/>
@@ -9332,8 +10662,8 @@
         </p:nvSpPr>
         <p:spPr>
           <a:xfrm>
-            <a:off x="4526280" y="4892040"/>
-            <a:ext cx="3063240" cy="1188720"/>
+            <a:off x="9934992" y="2304288"/>
+            <a:ext cx="1495008" cy="1234440"/>
           </a:xfrm>
           <a:prstGeom prst="rect">
             <a:avLst/>
@@ -9349,14 +10679,14 @@
               <a:buNone/>
             </a:pPr>
             <a:r>
-              <a:rPr lang="en-US" sz="1400" dirty="0">
+              <a:rPr lang="en-US" sz="1150" dirty="0">
                 <a:solidFill>
                   <a:schemeClr val="tx2"/>
                 </a:solidFill>
               </a:rPr>
-              <a:t>Mert %93 eşleşmeyle çözümü görüyor. Eşleşmeyen çağrıda Mercek SP'deki yuvarlama hatasını buluyor.</a:t>
-            </a:r>
-            <a:endParaRPr lang="en-US" sz="1400" dirty="0"/>
+              <a:t>Zeynep'e müşteriye söylenecek metin; vaka CAG-2051'e bağlanıyor; Kerem'e %93 eşleşen çözüm.</a:t>
+            </a:r>
+            <a:endParaRPr lang="en-US" sz="1150" dirty="0"/>
           </a:p>
         </p:txBody>
       </p:sp>
@@ -9368,12 +10698,12 @@
         </p:nvSpPr>
         <p:spPr>
           <a:xfrm>
-            <a:off x="8046720" y="1371600"/>
-            <a:ext cx="3520440" cy="4800600"/>
+            <a:off x="548640" y="3794760"/>
+            <a:ext cx="5440680" cy="2377440"/>
           </a:xfrm>
           <a:prstGeom prst="roundRect">
             <a:avLst>
-              <a:gd name="adj" fmla="val 3117"/>
+              <a:gd name="adj" fmla="val 4615"/>
             </a:avLst>
           </a:prstGeom>
           <a:solidFill>
@@ -9387,16 +10717,40 @@
           </a:ln>
         </p:spPr>
       </p:sp>
-      <p:sp>
-        <p:nvSpPr>
-          <p:cNvPr id="16" name="scene-time-3"/>
+      <p:pic>
+        <p:nvPicPr>
+          <p:cNvPr id="16" name="demo-image-3" descr="/home/claude/zthackathonstudy/presentation/mockups/m-c-code.png">    </p:cNvPr>
+          <p:cNvPicPr>
+            <a:picLocks noChangeAspect="1"/>
+          </p:cNvPicPr>
+          <p:nvPr/>
+        </p:nvPicPr>
+        <p:blipFill>
+          <a:blip r:embed="rId3"/>
+          <a:stretch>
+            <a:fillRect/>
+          </a:stretch>
+        </p:blipFill>
+        <p:spPr>
+          <a:xfrm>
+            <a:off x="731520" y="3977640"/>
+            <a:ext cx="3397032" cy="2011680"/>
+          </a:xfrm>
+          <a:prstGeom prst="rect">
+            <a:avLst/>
+          </a:prstGeom>
+        </p:spPr>
+      </p:pic>
+      <p:sp>
+        <p:nvSpPr>
+          <p:cNvPr id="17" name="scene-time-3"/>
           <p:cNvSpPr/>
           <p:nvPr/>
         </p:nvSpPr>
         <p:spPr>
           <a:xfrm>
-            <a:off x="8275320" y="1554480"/>
-            <a:ext cx="914400" cy="329184"/>
+            <a:off x="4311432" y="3977640"/>
+            <a:ext cx="868680" cy="310896"/>
           </a:xfrm>
           <a:prstGeom prst="roundRect">
             <a:avLst>
@@ -9416,14 +10770,14 @@
       </p:sp>
       <p:sp>
         <p:nvSpPr>
-          <p:cNvPr id="17" name="Text 13"/>
+          <p:cNvPr id="18" name="Text 13"/>
           <p:cNvSpPr txBox="1"/>
           <p:nvPr/>
         </p:nvSpPr>
         <p:spPr>
           <a:xfrm>
-            <a:off x="8275320" y="1554480"/>
-            <a:ext cx="914400" cy="329184"/>
+            <a:off x="4311432" y="3977640"/>
+            <a:ext cx="868680" cy="310896"/>
           </a:xfrm>
           <a:prstGeom prst="rect">
             <a:avLst/>
@@ -9439,27 +10793,27 @@
               <a:buNone/>
             </a:pPr>
             <a:r>
-              <a:rPr lang="en-US" sz="1200" b="1" dirty="0">
+              <a:rPr lang="en-US" sz="1100" b="1" dirty="0">
                 <a:solidFill>
                   <a:schemeClr val="tx1"/>
                 </a:solidFill>
               </a:rPr>
-              <a:t>~30 sn</a:t>
-            </a:r>
-            <a:endParaRPr lang="en-US" sz="1200" dirty="0"/>
-          </a:p>
-        </p:txBody>
-      </p:sp>
-      <p:sp>
-        <p:nvSpPr>
-          <p:cNvPr id="18" name="Text 14"/>
+              <a:t>~35 sn</a:t>
+            </a:r>
+            <a:endParaRPr lang="en-US" sz="1100" dirty="0"/>
+          </a:p>
+        </p:txBody>
+      </p:sp>
+      <p:sp>
+        <p:nvSpPr>
+          <p:cNvPr id="19" name="Text 14"/>
           <p:cNvSpPr txBox="1"/>
           <p:nvPr/>
         </p:nvSpPr>
         <p:spPr>
           <a:xfrm>
-            <a:off x="8275320" y="1965960"/>
-            <a:ext cx="3063240" cy="411480"/>
+            <a:off x="4311432" y="4361688"/>
+            <a:ext cx="1495008" cy="457200"/>
           </a:xfrm>
           <a:prstGeom prst="rect">
             <a:avLst/>
@@ -9468,42 +10822,105 @@
           <a:ln/>
         </p:spPr>
         <p:txBody>
-          <a:bodyPr wrap="square" lIns="0" tIns="0" rIns="0" bIns="0" rtlCol="0" anchor="ctr"/>
+          <a:bodyPr wrap="square" lIns="0" tIns="0" rIns="0" bIns="0" rtlCol="0" anchor="t"/>
           <a:lstStyle/>
           <a:p>
             <a:pPr indent="0" marL="0">
               <a:buNone/>
             </a:pPr>
             <a:r>
-              <a:rPr lang="en-US" sz="1700" b="1" dirty="0">
+              <a:rPr lang="en-US" sz="1500" b="1" dirty="0">
                 <a:solidFill>
                   <a:schemeClr val="tx1"/>
                 </a:solidFill>
               </a:rPr>
-              <a:t>Sahne 3 · Talepten plana</a:t>
-            </a:r>
-            <a:endParaRPr lang="en-US" sz="1700" dirty="0"/>
-          </a:p>
-        </p:txBody>
+              <a:t>C · Dış dünya değişti</a:t>
+            </a:r>
+            <a:endParaRPr lang="en-US" sz="1500" dirty="0"/>
+          </a:p>
+        </p:txBody>
+      </p:sp>
+      <p:sp>
+        <p:nvSpPr>
+          <p:cNvPr id="20" name="Text 15"/>
+          <p:cNvSpPr txBox="1"/>
+          <p:nvPr/>
+        </p:nvSpPr>
+        <p:spPr>
+          <a:xfrm>
+            <a:off x="4311432" y="4818888"/>
+            <a:ext cx="1495008" cy="1234440"/>
+          </a:xfrm>
+          <a:prstGeom prst="rect">
+            <a:avLst/>
+          </a:prstGeom>
+          <a:noFill/>
+          <a:ln/>
+        </p:spPr>
+        <p:txBody>
+          <a:bodyPr wrap="square" lIns="0" tIns="0" rIns="0" bIns="0" rtlCol="0" anchor="t"/>
+          <a:lstStyle/>
+          <a:p>
+            <a:pPr indent="0" marL="0">
+              <a:buNone/>
+            </a:pPr>
+            <a:r>
+              <a:rPr lang="en-US" sz="1150" dirty="0">
+                <a:solidFill>
+                  <a:schemeClr val="tx2"/>
+                </a:solidFill>
+              </a:rPr>
+              <a:t>412 hata, %97 İSKİ, 13 hane; İSKİ duyurusu; kuralın koddaki iki yeri ve düzeltme; ASKİ uyarısı.</a:t>
+            </a:r>
+            <a:endParaRPr lang="en-US" sz="1150" dirty="0"/>
+          </a:p>
+        </p:txBody>
+      </p:sp>
+      <p:sp>
+        <p:nvSpPr>
+          <p:cNvPr id="21" name="scene-card-4"/>
+          <p:cNvSpPr/>
+          <p:nvPr/>
+        </p:nvSpPr>
+        <p:spPr>
+          <a:xfrm>
+            <a:off x="6172200" y="3794760"/>
+            <a:ext cx="5440680" cy="2377440"/>
+          </a:xfrm>
+          <a:prstGeom prst="roundRect">
+            <a:avLst>
+              <a:gd name="adj" fmla="val 4615"/>
+            </a:avLst>
+          </a:prstGeom>
+          <a:solidFill>
+            <a:schemeClr val="bg2"/>
+          </a:solidFill>
+          <a:ln w="12700">
+            <a:solidFill>
+              <a:schemeClr val="bg2"/>
+            </a:solidFill>
+            <a:prstDash val="solid"/>
+          </a:ln>
+        </p:spPr>
       </p:sp>
       <p:pic>
         <p:nvPicPr>
-          <p:cNvPr id="19" name="demo-image-3" descr="/home/claude/zthackathonstudy/presentation/mockups/m-request.png">    </p:cNvPr>
+          <p:cNvPr id="22" name="demo-image-4" descr="/home/claude/zthackathonstudy/presentation/mockups/m-d-request.png">    </p:cNvPr>
           <p:cNvPicPr>
             <a:picLocks noChangeAspect="1"/>
           </p:cNvPicPr>
           <p:nvPr/>
         </p:nvPicPr>
         <p:blipFill>
-          <a:blip r:embed="rId3"/>
+          <a:blip r:embed="rId4"/>
           <a:stretch>
             <a:fillRect/>
           </a:stretch>
         </p:blipFill>
         <p:spPr>
           <a:xfrm>
-            <a:off x="8275320" y="2967049"/>
-            <a:ext cx="3063240" cy="1335381"/>
+            <a:off x="6355080" y="3977640"/>
+            <a:ext cx="3397032" cy="2011680"/>
           </a:xfrm>
           <a:prstGeom prst="rect">
             <a:avLst/>
@@ -9512,14 +10929,41 @@
       </p:pic>
       <p:sp>
         <p:nvSpPr>
-          <p:cNvPr id="20" name="Text 15"/>
+          <p:cNvPr id="23" name="scene-time-4"/>
+          <p:cNvSpPr/>
+          <p:nvPr/>
+        </p:nvSpPr>
+        <p:spPr>
+          <a:xfrm>
+            <a:off x="9934992" y="3977640"/>
+            <a:ext cx="868680" cy="310896"/>
+          </a:xfrm>
+          <a:prstGeom prst="roundRect">
+            <a:avLst>
+              <a:gd name="adj" fmla="val 50000"/>
+            </a:avLst>
+          </a:prstGeom>
+          <a:solidFill>
+            <a:schemeClr val="accent1"/>
+          </a:solidFill>
+          <a:ln w="12700">
+            <a:solidFill>
+              <a:schemeClr val="accent1"/>
+            </a:solidFill>
+            <a:prstDash val="solid"/>
+          </a:ln>
+        </p:spPr>
+      </p:sp>
+      <p:sp>
+        <p:nvSpPr>
+          <p:cNvPr id="24" name="Text 18"/>
           <p:cNvSpPr txBox="1"/>
           <p:nvPr/>
         </p:nvSpPr>
         <p:spPr>
           <a:xfrm>
-            <a:off x="8275320" y="4892040"/>
-            <a:ext cx="3063240" cy="1188720"/>
+            <a:off x="9934992" y="3977640"/>
+            <a:ext cx="868680" cy="310896"/>
           </a:xfrm>
           <a:prstGeom prst="rect">
             <a:avLst/>
@@ -9528,6 +10972,42 @@
           <a:ln/>
         </p:spPr>
         <p:txBody>
+          <a:bodyPr wrap="square" lIns="0" tIns="0" rIns="0" bIns="0" rtlCol="0" anchor="ctr"/>
+          <a:lstStyle/>
+          <a:p>
+            <a:pPr algn="ctr" indent="0" marL="0">
+              <a:buNone/>
+            </a:pPr>
+            <a:r>
+              <a:rPr lang="en-US" sz="1100" b="1" dirty="0">
+                <a:solidFill>
+                  <a:schemeClr val="tx1"/>
+                </a:solidFill>
+              </a:rPr>
+              <a:t>~45 sn</a:t>
+            </a:r>
+            <a:endParaRPr lang="en-US" sz="1100" dirty="0"/>
+          </a:p>
+        </p:txBody>
+      </p:sp>
+      <p:sp>
+        <p:nvSpPr>
+          <p:cNvPr id="25" name="Text 19"/>
+          <p:cNvSpPr txBox="1"/>
+          <p:nvPr/>
+        </p:nvSpPr>
+        <p:spPr>
+          <a:xfrm>
+            <a:off x="9934992" y="4361688"/>
+            <a:ext cx="1495008" cy="457200"/>
+          </a:xfrm>
+          <a:prstGeom prst="rect">
+            <a:avLst/>
+          </a:prstGeom>
+          <a:noFill/>
+          <a:ln/>
+        </p:spPr>
+        <p:txBody>
           <a:bodyPr wrap="square" lIns="0" tIns="0" rIns="0" bIns="0" rtlCol="0" anchor="t"/>
           <a:lstStyle/>
           <a:p>
@@ -9535,26 +11015,62 @@
               <a:buNone/>
             </a:pPr>
             <a:r>
-              <a:rPr lang="en-US" sz="1400" dirty="0">
+              <a:rPr lang="en-US" sz="1500" b="1" dirty="0">
+                <a:solidFill>
+                  <a:schemeClr val="tx1"/>
+                </a:solidFill>
+              </a:rPr>
+              <a:t>D · Talepten plana</a:t>
+            </a:r>
+            <a:endParaRPr lang="en-US" sz="1500" dirty="0"/>
+          </a:p>
+        </p:txBody>
+      </p:sp>
+      <p:sp>
+        <p:nvSpPr>
+          <p:cNvPr id="26" name="Text 20"/>
+          <p:cNvSpPr txBox="1"/>
+          <p:nvPr/>
+        </p:nvSpPr>
+        <p:spPr>
+          <a:xfrm>
+            <a:off x="9934992" y="4818888"/>
+            <a:ext cx="1495008" cy="1234440"/>
+          </a:xfrm>
+          <a:prstGeom prst="rect">
+            <a:avLst/>
+          </a:prstGeom>
+          <a:noFill/>
+          <a:ln/>
+        </p:spPr>
+        <p:txBody>
+          <a:bodyPr wrap="square" lIns="0" tIns="0" rIns="0" bIns="0" rtlCol="0" anchor="t"/>
+          <a:lstStyle/>
+          <a:p>
+            <a:pPr indent="0" marL="0">
+              <a:buNone/>
+            </a:pPr>
+            <a:r>
+              <a:rPr lang="en-US" sz="1150" dirty="0">
                 <a:solidFill>
                   <a:schemeClr val="tx2"/>
                 </a:solidFill>
               </a:rPr>
-              <a:t>Zeynep'in talebi için etki, efor, takvim. 312 çağrının kalıcı çözümü kapsama giriyor.</a:t>
-            </a:r>
-            <a:endParaRPr lang="en-US" sz="1400" dirty="0"/>
-          </a:p>
-        </p:txBody>
-      </p:sp>
-      <p:sp>
-        <p:nvSpPr>
-          <p:cNvPr id="21" name="draft-note"/>
+              <a:t>Fatma'nın talebi: KRDRTKSR'ye buton + batch işi, 18 a/g; SMS ile erişim %58 → %89, 20 a/g, 4 Aralık.</a:t>
+            </a:r>
+            <a:endParaRPr lang="en-US" sz="1150" dirty="0"/>
+          </a:p>
+        </p:txBody>
+      </p:sp>
+      <p:sp>
+        <p:nvSpPr>
+          <p:cNvPr id="27" name="draft-note"/>
           <p:cNvSpPr txBox="1"/>
           <p:nvPr/>
         </p:nvSpPr>
         <p:spPr>
           <a:xfrm>
-            <a:off x="548640" y="6199632"/>
+            <a:off x="548640" y="6263640"/>
             <a:ext cx="7315200" cy="256032"/>
           </a:xfrm>
           <a:prstGeom prst="rect">
@@ -9742,14 +11258,14 @@
               <a:buNone/>
             </a:pPr>
             <a:r>
-              <a:rPr lang="en-US" sz="2400" b="1" dirty="0">
+              <a:rPr lang="en-US" sz="2200" b="1" dirty="0">
                 <a:solidFill>
                   <a:schemeClr val="accent2"/>
                 </a:solidFill>
               </a:rPr>
-              <a:t>Saatler → saniyeler</a:t>
-            </a:r>
-            <a:endParaRPr lang="en-US" sz="2400" dirty="0"/>
+              <a:t>Çağrı hiç açılmıyor</a:t>
+            </a:r>
+            <a:endParaRPr lang="en-US" sz="2200" dirty="0"/>
           </a:p>
           <a:p>
             <a:pPr indent="0" marL="0">
@@ -9761,9 +11277,9 @@
                   <a:schemeClr val="accent5"/>
                 </a:solidFill>
               </a:rPr>
-              <a:t>Sorunun ilk tespiti</a:t>
-            </a:r>
-            <a:endParaRPr lang="en-US" sz="2400" dirty="0"/>
+              <a:t>İş kuralı reddinde (A)</a:t>
+            </a:r>
+            <a:endParaRPr lang="en-US" sz="2200" dirty="0"/>
           </a:p>
         </p:txBody>
       </p:sp>
@@ -9819,14 +11335,14 @@
               <a:buNone/>
             </a:pPr>
             <a:r>
-              <a:rPr lang="en-US" sz="2400" b="1" dirty="0">
+              <a:rPr lang="en-US" sz="2200" b="1" dirty="0">
                 <a:solidFill>
                   <a:schemeClr val="accent1"/>
                 </a:solidFill>
               </a:rPr>
-              <a:t>Tek cümle → tam kayıt</a:t>
-            </a:r>
-            <a:endParaRPr lang="en-US" sz="2400" dirty="0"/>
+              <a:t>Onlarca arama → tek kayıt</a:t>
+            </a:r>
+            <a:endParaRPr lang="en-US" sz="2200" dirty="0"/>
           </a:p>
           <a:p>
             <a:pPr indent="0" marL="0">
@@ -9838,9 +11354,9 @@
                   <a:schemeClr val="accent5"/>
                 </a:solidFill>
               </a:rPr>
-              <a:t>Çağrı kaydının kalitesi</a:t>
-            </a:r>
-            <a:endParaRPr lang="en-US" sz="2400" dirty="0"/>
+              <a:t>Kurum kaynaklı sorunda (B)</a:t>
+            </a:r>
+            <a:endParaRPr lang="en-US" sz="2200" dirty="0"/>
           </a:p>
         </p:txBody>
       </p:sp>
@@ -9896,14 +11412,14 @@
               <a:buNone/>
             </a:pPr>
             <a:r>
-              <a:rPr lang="en-US" sz="2400" b="1" dirty="0">
+              <a:rPr lang="en-US" sz="2200" b="1" dirty="0">
                 <a:solidFill>
                   <a:schemeClr val="tx2"/>
                 </a:solidFill>
               </a:rPr>
-              <a:t>Günler → dakikalar</a:t>
-            </a:r>
-            <a:endParaRPr lang="en-US" sz="2400" dirty="0"/>
+              <a:t>Toplantı → dakikalar</a:t>
+            </a:r>
+            <a:endParaRPr lang="en-US" sz="2200" dirty="0"/>
           </a:p>
           <a:p>
             <a:pPr indent="0" marL="0">
@@ -9915,9 +11431,9 @@
                   <a:schemeClr val="accent5"/>
                 </a:solidFill>
               </a:rPr>
-              <a:t>Talep efor tahmini</a:t>
-            </a:r>
-            <a:endParaRPr lang="en-US" sz="2400" dirty="0"/>
+              <a:t>Talep analizi ve planı (D)</a:t>
+            </a:r>
+            <a:endParaRPr lang="en-US" sz="2200" dirty="0"/>
           </a:p>
         </p:txBody>
       </p:sp>
@@ -9944,9 +11460,9 @@
             <a:tbl>
               <a:tblPr/>
               <a:tblGrid>
-                <a:gridCol w="2926080"/>
+                <a:gridCol w="2743200"/>
                 <a:gridCol w="3840480"/>
-                <a:gridCol w="4297680"/>
+                <a:gridCol w="4480560"/>
               </a:tblGrid>
               <a:tr h="429768">
                 <a:tc>
@@ -9958,7 +11474,7 @@
                         <a:buNone/>
                       </a:pPr>
                       <a:r>
-                        <a:rPr lang="en-US" sz="1400" b="1" dirty="0">
+                        <a:rPr lang="en-US" sz="1300" b="1" dirty="0">
                           <a:solidFill>
                             <a:schemeClr val="bg1"/>
                           </a:solidFill>
@@ -9968,7 +11484,7 @@
                         </a:rPr>
                         <a:t>Ölçü</a:t>
                       </a:r>
-                      <a:endParaRPr lang="en-US" sz="1400" dirty="0">
+                      <a:endParaRPr lang="en-US" sz="1300" dirty="0">
                         <a:latin typeface="Calibri" charset="0"/>
                         <a:ea typeface="Calibri" charset="0"/>
                         <a:cs typeface="Calibri" charset="0"/>
@@ -10026,7 +11542,7 @@
                         <a:buNone/>
                       </a:pPr>
                       <a:r>
-                        <a:rPr lang="en-US" sz="1400" b="1" dirty="0">
+                        <a:rPr lang="en-US" sz="1300" b="1" dirty="0">
                           <a:solidFill>
                             <a:schemeClr val="bg1"/>
                           </a:solidFill>
@@ -10036,7 +11552,7 @@
                         </a:rPr>
                         <a:t>Bugün</a:t>
                       </a:r>
-                      <a:endParaRPr lang="en-US" sz="1400" dirty="0">
+                      <a:endParaRPr lang="en-US" sz="1300" dirty="0">
                         <a:latin typeface="Calibri" charset="0"/>
                         <a:ea typeface="Calibri" charset="0"/>
                         <a:cs typeface="Calibri" charset="0"/>
@@ -10094,7 +11610,7 @@
                         <a:buNone/>
                       </a:pPr>
                       <a:r>
-                        <a:rPr lang="en-US" sz="1400" b="1" dirty="0">
+                        <a:rPr lang="en-US" sz="1300" b="1" dirty="0">
                           <a:solidFill>
                             <a:schemeClr val="bg1"/>
                           </a:solidFill>
@@ -10104,7 +11620,7 @@
                         </a:rPr>
                         <a:t>Mercek ile</a:t>
                       </a:r>
-                      <a:endParaRPr lang="en-US" sz="1400" dirty="0">
+                      <a:endParaRPr lang="en-US" sz="1300" dirty="0">
                         <a:latin typeface="Calibri" charset="0"/>
                         <a:ea typeface="Calibri" charset="0"/>
                         <a:cs typeface="Calibri" charset="0"/>
@@ -10164,7 +11680,7 @@
                         <a:buNone/>
                       </a:pPr>
                       <a:r>
-                        <a:rPr lang="en-US" sz="1400" dirty="0">
+                        <a:rPr lang="en-US" sz="1300" dirty="0">
                           <a:solidFill>
                             <a:schemeClr val="tx1"/>
                           </a:solidFill>
@@ -10172,9 +11688,9 @@
                           <a:ea typeface="Calibri" pitchFamily="34" charset="-122"/>
                           <a:cs typeface="Calibri" pitchFamily="34" charset="-120"/>
                         </a:rPr>
-                        <a:t>Doğru ekibe yönlendirme</a:t>
+                        <a:t>İş kuralı reddi</a:t>
                       </a:r>
-                      <a:endParaRPr lang="en-US" sz="1400" dirty="0">
+                      <a:endParaRPr lang="en-US" sz="1300" dirty="0">
                         <a:latin typeface="Calibri" charset="0"/>
                         <a:ea typeface="Calibri" charset="0"/>
                         <a:cs typeface="Calibri" charset="0"/>
@@ -10229,7 +11745,7 @@
                         <a:buNone/>
                       </a:pPr>
                       <a:r>
-                        <a:rPr lang="en-US" sz="1400" dirty="0">
+                        <a:rPr lang="en-US" sz="1300" dirty="0">
                           <a:solidFill>
                             <a:schemeClr val="tx1"/>
                           </a:solidFill>
@@ -10237,9 +11753,9 @@
                           <a:ea typeface="Calibri" pitchFamily="34" charset="-122"/>
                           <a:cs typeface="Calibri" pitchFamily="34" charset="-120"/>
                         </a:rPr>
-                        <a:t>L1 tahmini, yeniden atamalar</a:t>
+                        <a:t>Çağrı açılır, L1 kuralı açıklar</a:t>
                       </a:r>
-                      <a:endParaRPr lang="en-US" sz="1400" dirty="0">
+                      <a:endParaRPr lang="en-US" sz="1300" dirty="0">
                         <a:latin typeface="Calibri" charset="0"/>
                         <a:ea typeface="Calibri" charset="0"/>
                         <a:cs typeface="Calibri" charset="0"/>
@@ -10294,7 +11810,7 @@
                         <a:buNone/>
                       </a:pPr>
                       <a:r>
-                        <a:rPr lang="en-US" sz="1400" dirty="0">
+                        <a:rPr lang="en-US" sz="1300" dirty="0">
                           <a:solidFill>
                             <a:schemeClr val="tx1"/>
                           </a:solidFill>
@@ -10302,9 +11818,9 @@
                           <a:ea typeface="Calibri" pitchFamily="34" charset="-122"/>
                           <a:cs typeface="Calibri" pitchFamily="34" charset="-120"/>
                         </a:rPr>
-                        <a:t>Hata kodu ve servis haritasıyla ilk seferde</a:t>
+                        <a:t>Ekranda açıklanır, uygun alternatif hesaplanır</a:t>
                       </a:r>
-                      <a:endParaRPr lang="en-US" sz="1400" dirty="0">
+                      <a:endParaRPr lang="en-US" sz="1300" dirty="0">
                         <a:latin typeface="Calibri" charset="0"/>
                         <a:ea typeface="Calibri" charset="0"/>
                         <a:cs typeface="Calibri" charset="0"/>
@@ -10361,7 +11877,7 @@
                         <a:buNone/>
                       </a:pPr>
                       <a:r>
-                        <a:rPr lang="en-US" sz="1400" dirty="0">
+                        <a:rPr lang="en-US" sz="1300" dirty="0">
                           <a:solidFill>
                             <a:schemeClr val="tx1"/>
                           </a:solidFill>
@@ -10369,9 +11885,9 @@
                           <a:ea typeface="Calibri" pitchFamily="34" charset="-122"/>
                           <a:cs typeface="Calibri" pitchFamily="34" charset="-120"/>
                         </a:rPr>
-                        <a:t>Bilinen sorunun çözümü</a:t>
+                        <a:t>Yaygın kurum sorunu</a:t>
                       </a:r>
-                      <a:endParaRPr lang="en-US" sz="1400" dirty="0">
+                      <a:endParaRPr lang="en-US" sz="1300" dirty="0">
                         <a:latin typeface="Calibri" charset="0"/>
                         <a:ea typeface="Calibri" charset="0"/>
                         <a:cs typeface="Calibri" charset="0"/>
@@ -10426,7 +11942,7 @@
                         <a:buNone/>
                       </a:pPr>
                       <a:r>
-                        <a:rPr lang="en-US" sz="1400" dirty="0">
+                        <a:rPr lang="en-US" sz="1300" dirty="0">
                           <a:solidFill>
                             <a:schemeClr val="tx1"/>
                           </a:solidFill>
@@ -10434,9 +11950,9 @@
                           <a:ea typeface="Calibri" pitchFamily="34" charset="-122"/>
                           <a:cs typeface="Calibri" pitchFamily="34" charset="-120"/>
                         </a:rPr>
-                        <a:t>Bilgi kişilerde, aranamıyor</a:t>
+                        <a:t>Her arama ayrı çağrı</a:t>
                       </a:r>
-                      <a:endParaRPr lang="en-US" sz="1400" dirty="0">
+                      <a:endParaRPr lang="en-US" sz="1300" dirty="0">
                         <a:latin typeface="Calibri" charset="0"/>
                         <a:ea typeface="Calibri" charset="0"/>
                         <a:cs typeface="Calibri" charset="0"/>
@@ -10491,7 +12007,7 @@
                         <a:buNone/>
                       </a:pPr>
                       <a:r>
-                        <a:rPr lang="en-US" sz="1400" dirty="0">
+                        <a:rPr lang="en-US" sz="1300" dirty="0">
                           <a:solidFill>
                             <a:schemeClr val="tx1"/>
                           </a:solidFill>
@@ -10499,9 +12015,9 @@
                           <a:ea typeface="Calibri" pitchFamily="34" charset="-122"/>
                           <a:cs typeface="Calibri" pitchFamily="34" charset="-120"/>
                         </a:rPr>
-                        <a:t>Geçmiş çözüm saniyeler içinde, kaynaklı</a:t>
+                        <a:t>Tek ana kayıt, temsilciye hazır müşteri açıklaması</a:t>
                       </a:r>
-                      <a:endParaRPr lang="en-US" sz="1400" dirty="0">
+                      <a:endParaRPr lang="en-US" sz="1300" dirty="0">
                         <a:latin typeface="Calibri" charset="0"/>
                         <a:ea typeface="Calibri" charset="0"/>
                         <a:cs typeface="Calibri" charset="0"/>
@@ -10558,7 +12074,7 @@
                         <a:buNone/>
                       </a:pPr>
                       <a:r>
-                        <a:rPr lang="en-US" sz="1400" dirty="0">
+                        <a:rPr lang="en-US" sz="1300" dirty="0">
                           <a:solidFill>
                             <a:schemeClr val="tx1"/>
                           </a:solidFill>
@@ -10566,9 +12082,9 @@
                           <a:ea typeface="Calibri" pitchFamily="34" charset="-122"/>
                           <a:cs typeface="Calibri" pitchFamily="34" charset="-120"/>
                         </a:rPr>
-                        <a:t>Yeni sorunun kök nedeni</a:t>
+                        <a:t>Bilinen sorun</a:t>
                       </a:r>
-                      <a:endParaRPr lang="en-US" sz="1400" dirty="0">
+                      <a:endParaRPr lang="en-US" sz="1300" dirty="0">
                         <a:latin typeface="Calibri" charset="0"/>
                         <a:ea typeface="Calibri" charset="0"/>
                         <a:cs typeface="Calibri" charset="0"/>
@@ -10623,7 +12139,7 @@
                         <a:buNone/>
                       </a:pPr>
                       <a:r>
-                        <a:rPr lang="en-US" sz="1400" dirty="0">
+                        <a:rPr lang="en-US" sz="1300" dirty="0">
                           <a:solidFill>
                             <a:schemeClr val="tx1"/>
                           </a:solidFill>
@@ -10631,9 +12147,9 @@
                           <a:ea typeface="Calibri" pitchFamily="34" charset="-122"/>
                           <a:cs typeface="Calibri" pitchFamily="34" charset="-120"/>
                         </a:rPr>
-                        <a:t>Ekip kodu baştan inceler</a:t>
+                        <a:t>L2 log arar, çözüm kişide</a:t>
                       </a:r>
-                      <a:endParaRPr lang="en-US" sz="1400" dirty="0">
+                      <a:endParaRPr lang="en-US" sz="1300" dirty="0">
                         <a:latin typeface="Calibri" charset="0"/>
                         <a:ea typeface="Calibri" charset="0"/>
                         <a:cs typeface="Calibri" charset="0"/>
@@ -10688,7 +12204,7 @@
                         <a:buNone/>
                       </a:pPr>
                       <a:r>
-                        <a:rPr lang="en-US" sz="1400" dirty="0">
+                        <a:rPr lang="en-US" sz="1300" dirty="0">
                           <a:solidFill>
                             <a:schemeClr val="tx1"/>
                           </a:solidFill>
@@ -10696,9 +12212,9 @@
                           <a:ea typeface="Calibri" pitchFamily="34" charset="-122"/>
                           <a:cs typeface="Calibri" pitchFamily="34" charset="-120"/>
                         </a:rPr>
-                        <a:t>Satır düzeyinde düzeltme önerisi</a:t>
+                        <a:t>Kaynaklı eşleşen çözüm, saniyeler içinde</a:t>
                       </a:r>
-                      <a:endParaRPr lang="en-US" sz="1400" dirty="0">
+                      <a:endParaRPr lang="en-US" sz="1300" dirty="0">
                         <a:latin typeface="Calibri" charset="0"/>
                         <a:ea typeface="Calibri" charset="0"/>
                         <a:cs typeface="Calibri" charset="0"/>
@@ -10755,7 +12271,7 @@
                         <a:buNone/>
                       </a:pPr>
                       <a:r>
-                        <a:rPr lang="en-US" sz="1400" dirty="0">
+                        <a:rPr lang="en-US" sz="1300" dirty="0">
                           <a:solidFill>
                             <a:schemeClr val="tx1"/>
                           </a:solidFill>
@@ -10763,9 +12279,9 @@
                           <a:ea typeface="Calibri" pitchFamily="34" charset="-122"/>
                           <a:cs typeface="Calibri" pitchFamily="34" charset="-120"/>
                         </a:rPr>
-                        <a:t>Talep kapsamı</a:t>
+                        <a:t>Yeni sorun</a:t>
                       </a:r>
-                      <a:endParaRPr lang="en-US" sz="1400" dirty="0">
+                      <a:endParaRPr lang="en-US" sz="1300" dirty="0">
                         <a:latin typeface="Calibri" charset="0"/>
                         <a:ea typeface="Calibri" charset="0"/>
                         <a:cs typeface="Calibri" charset="0"/>
@@ -10820,7 +12336,7 @@
                         <a:buNone/>
                       </a:pPr>
                       <a:r>
-                        <a:rPr lang="en-US" sz="1400" dirty="0">
+                        <a:rPr lang="en-US" sz="1300" dirty="0">
                           <a:solidFill>
                             <a:schemeClr val="tx1"/>
                           </a:solidFill>
@@ -10828,9 +12344,9 @@
                           <a:ea typeface="Calibri" pitchFamily="34" charset="-122"/>
                           <a:cs typeface="Calibri" pitchFamily="34" charset="-120"/>
                         </a:rPr>
-                        <a:t>Çağrı verisinden kopuk</a:t>
+                        <a:t>Kök neden günlerce aranır</a:t>
                       </a:r>
-                      <a:endParaRPr lang="en-US" sz="1400" dirty="0">
+                      <a:endParaRPr lang="en-US" sz="1300" dirty="0">
                         <a:latin typeface="Calibri" charset="0"/>
                         <a:ea typeface="Calibri" charset="0"/>
                         <a:cs typeface="Calibri" charset="0"/>
@@ -10885,7 +12401,7 @@
                         <a:buNone/>
                       </a:pPr>
                       <a:r>
-                        <a:rPr lang="en-US" sz="1400" dirty="0">
+                        <a:rPr lang="en-US" sz="1300" dirty="0">
                           <a:solidFill>
                             <a:schemeClr val="tx1"/>
                           </a:solidFill>
@@ -10893,9 +12409,9 @@
                           <a:ea typeface="Calibri" pitchFamily="34" charset="-122"/>
                           <a:cs typeface="Calibri" pitchFamily="34" charset="-120"/>
                         </a:rPr>
-                        <a:t>Ekranın çağrı geçmişi kapsamda</a:t>
+                        <a:t>Log + duyuru + kod; sonraki olay önceden görülür</a:t>
                       </a:r>
-                      <a:endParaRPr lang="en-US" sz="1400" dirty="0">
+                      <a:endParaRPr lang="en-US" sz="1300" dirty="0">
                         <a:latin typeface="Calibri" charset="0"/>
                         <a:ea typeface="Calibri" charset="0"/>
                         <a:cs typeface="Calibri" charset="0"/>
@@ -10952,7 +12468,7 @@
                         <a:buNone/>
                       </a:pPr>
                       <a:r>
-                        <a:rPr lang="en-US" sz="1400" dirty="0">
+                        <a:rPr lang="en-US" sz="1300" dirty="0">
                           <a:solidFill>
                             <a:schemeClr val="tx1"/>
                           </a:solidFill>
@@ -10960,9 +12476,9 @@
                           <a:ea typeface="Calibri" pitchFamily="34" charset="-122"/>
                           <a:cs typeface="Calibri" pitchFamily="34" charset="-120"/>
                         </a:rPr>
-                        <a:t>Yaygınlaştırma</a:t>
+                        <a:t>Talep planı</a:t>
                       </a:r>
-                      <a:endParaRPr lang="en-US" sz="1400" dirty="0">
+                      <a:endParaRPr lang="en-US" sz="1300" dirty="0">
                         <a:latin typeface="Calibri" charset="0"/>
                         <a:ea typeface="Calibri" charset="0"/>
                         <a:cs typeface="Calibri" charset="0"/>
@@ -11017,7 +12533,7 @@
                         <a:buNone/>
                       </a:pPr>
                       <a:r>
-                        <a:rPr lang="en-US" sz="1400" dirty="0">
+                        <a:rPr lang="en-US" sz="1300" dirty="0">
                           <a:solidFill>
                             <a:schemeClr val="tx1"/>
                           </a:solidFill>
@@ -11025,9 +12541,9 @@
                           <a:ea typeface="Calibri" pitchFamily="34" charset="-122"/>
                           <a:cs typeface="Calibri" pitchFamily="34" charset="-120"/>
                         </a:rPr>
-                        <a:t>Her kanal ve uygulama ayrı süreç</a:t>
+                        <a:t>Servisler ve erişim sorunu geç fark edilir</a:t>
                       </a:r>
-                      <a:endParaRPr lang="en-US" sz="1400" dirty="0">
+                      <a:endParaRPr lang="en-US" sz="1300" dirty="0">
                         <a:latin typeface="Calibri" charset="0"/>
                         <a:ea typeface="Calibri" charset="0"/>
                         <a:cs typeface="Calibri" charset="0"/>
@@ -11082,7 +12598,7 @@
                         <a:buNone/>
                       </a:pPr>
                       <a:r>
-                        <a:rPr lang="en-US" sz="1400" dirty="0">
+                        <a:rPr lang="en-US" sz="1300" dirty="0">
                           <a:solidFill>
                             <a:schemeClr val="tx1"/>
                           </a:solidFill>
@@ -11090,9 +12606,9 @@
                           <a:ea typeface="Calibri" pitchFamily="34" charset="-122"/>
                           <a:cs typeface="Calibri" pitchFamily="34" charset="-120"/>
                         </a:rPr>
-                        <a:t>Aynı yapı tüm dijital kanallara ve iç uygulamalara</a:t>
+                        <a:t>Servis bazlı a/g ve takvim; kapsam veriyle düzeltilir</a:t>
                       </a:r>
-                      <a:endParaRPr lang="en-US" sz="1400" dirty="0">
+                      <a:endParaRPr lang="en-US" sz="1300" dirty="0">
                         <a:latin typeface="Calibri" charset="0"/>
                         <a:ea typeface="Calibri" charset="0"/>
                         <a:cs typeface="Calibri" charset="0"/>
@@ -11173,7 +12689,7 @@
                   <a:schemeClr val="accent5"/>
                 </a:solidFill>
               </a:rPr>
-              <a:t>Rakamlar sentetik veriye ve varsayımlara dayanır; demo ölçümleriyle güncellenecek.</a:t>
+              <a:t>Rakamlar sentetik veriye dayanır; demo sırasında Mercek'in sayaçları (önlenen çağrı, bağlanan vaka, analiz süresi) gösterilir.</a:t>
             </a:r>
             <a:endParaRPr lang="en-US" sz="1100" dirty="0"/>
           </a:p>

</xml_diff>

<commit_message>
Sunuma Mercek logosu ekle: kapakta büyük mercek, içerik slaytlarında küçük logo
Co-Authored-By: Claude Opus 5.5 <noreply@anthropic.com>
Claude-Session: https://claude.ai/code/session_01DTiHxbPkixs9Jadunw7PB9
</commit_message>
<xml_diff>
--- a/presentation/Mercek_AI_Overflow_Sunum.pptx
+++ b/presentation/Mercek_AI_Overflow_Sunum.pptx
@@ -4562,8 +4562,8 @@
         </p:nvSpPr>
         <p:spPr>
           <a:xfrm>
-            <a:off x="1371600" y="1965960"/>
-            <a:ext cx="9445752" cy="914400"/>
+            <a:off x="914400" y="1417320"/>
+            <a:ext cx="6217920" cy="365760"/>
           </a:xfrm>
           <a:prstGeom prst="rect">
             <a:avLst/>
@@ -4576,13 +4576,52 @@
           </a:bodyPr>
           <a:lstStyle/>
           <a:p>
-            <a:pPr algn="ctr">
+            <a:pPr algn="l">
               <a:spcAft>
                 <a:spcPts val="400"/>
               </a:spcAft>
             </a:pPr>
             <a:r>
-              <a:rPr sz="5400" b="1" i="0">
+              <a:rPr sz="1400" b="1" i="0">
+                <a:solidFill>
+                  <a:srgbClr val="E10514"/>
+                </a:solidFill>
+                <a:latin typeface="Calibri"/>
+              </a:rPr>
+              <a:t>ZİRAAT TEKNOLOJİ YAPAY ZEKÂ HACKATHONU · TEMA 2</a:t>
+            </a:r>
+          </a:p>
+        </p:txBody>
+      </p:sp>
+      <p:sp>
+        <p:nvSpPr>
+          <p:cNvPr id="3" name="TextBox 2"/>
+          <p:cNvSpPr txBox="1"/>
+          <p:nvPr/>
+        </p:nvSpPr>
+        <p:spPr>
+          <a:xfrm>
+            <a:off x="914400" y="1828800"/>
+            <a:ext cx="6217920" cy="1188720"/>
+          </a:xfrm>
+          <a:prstGeom prst="rect">
+            <a:avLst/>
+          </a:prstGeom>
+          <a:noFill/>
+        </p:spPr>
+        <p:txBody>
+          <a:bodyPr wrap="square" anchor="t" lIns="0" rIns="0" tIns="0" bIns="0">
+            <a:spAutoFit/>
+          </a:bodyPr>
+          <a:lstStyle/>
+          <a:p>
+            <a:pPr algn="l">
+              <a:spcAft>
+                <a:spcPts val="400"/>
+              </a:spcAft>
+            </a:pPr>
+            <a:r>
+              <a:rPr sz="7200" b="1" i="0">
                 <a:solidFill>
                   <a:srgbClr val="1E1E1E"/>
                 </a:solidFill>
@@ -4595,13 +4634,13 @@
       </p:sp>
       <p:sp>
         <p:nvSpPr>
-          <p:cNvPr id="3" name="Rectangle 2"/>
+          <p:cNvPr id="4" name="Rectangle 3"/>
           <p:cNvSpPr/>
           <p:nvPr/>
         </p:nvSpPr>
         <p:spPr>
           <a:xfrm>
-            <a:off x="5550408" y="2926080"/>
+            <a:off x="960120" y="3063240"/>
             <a:ext cx="1097280" cy="64008"/>
           </a:xfrm>
           <a:prstGeom prst="rect">
@@ -4623,14 +4662,14 @@
       </p:sp>
       <p:sp>
         <p:nvSpPr>
-          <p:cNvPr id="4" name="TextBox 3"/>
+          <p:cNvPr id="5" name="TextBox 4"/>
           <p:cNvSpPr txBox="1"/>
           <p:nvPr/>
         </p:nvSpPr>
         <p:spPr>
           <a:xfrm>
-            <a:off x="1371600" y="3154680"/>
-            <a:ext cx="9445752" cy="457200"/>
+            <a:off x="914400" y="3291840"/>
+            <a:ext cx="6217920" cy="548640"/>
           </a:xfrm>
           <a:prstGeom prst="rect">
             <a:avLst/>
@@ -4643,13 +4682,13 @@
           </a:bodyPr>
           <a:lstStyle/>
           <a:p>
-            <a:pPr algn="ctr">
+            <a:pPr algn="l">
               <a:spcAft>
                 <a:spcPts val="400"/>
               </a:spcAft>
             </a:pPr>
             <a:r>
-              <a:rPr sz="2400" b="0" i="1">
+              <a:rPr sz="2600" b="0" i="1">
                 <a:solidFill>
                   <a:srgbClr val="B90F0A"/>
                 </a:solidFill>
@@ -4662,14 +4701,14 @@
       </p:sp>
       <p:sp>
         <p:nvSpPr>
-          <p:cNvPr id="5" name="TextBox 4"/>
+          <p:cNvPr id="6" name="TextBox 5"/>
           <p:cNvSpPr txBox="1"/>
           <p:nvPr/>
         </p:nvSpPr>
         <p:spPr>
           <a:xfrm>
-            <a:off x="1371600" y="3977639"/>
-            <a:ext cx="9445752" cy="914400"/>
+            <a:off x="914400" y="4343400"/>
+            <a:ext cx="6217920" cy="822960"/>
           </a:xfrm>
           <a:prstGeom prst="rect">
             <a:avLst/>
@@ -4682,13 +4721,13 @@
           </a:bodyPr>
           <a:lstStyle/>
           <a:p>
-            <a:pPr algn="ctr">
+            <a:pPr algn="l">
               <a:spcAft>
                 <a:spcPts val="400"/>
               </a:spcAft>
             </a:pPr>
             <a:r>
-              <a:rPr sz="1800" b="1" i="0">
+              <a:rPr sz="2000" b="1" i="0">
                 <a:solidFill>
                   <a:srgbClr val="1E1E1E"/>
                 </a:solidFill>
@@ -4698,21 +4737,126 @@
             </a:r>
           </a:p>
           <a:p>
-            <a:pPr algn="ctr">
+            <a:pPr algn="l">
               <a:spcAft>
                 <a:spcPts val="400"/>
               </a:spcAft>
             </a:pPr>
             <a:r>
-              <a:rPr sz="1400" b="0" i="0">
+              <a:rPr sz="1600" b="0" i="0">
                 <a:solidFill>
                   <a:srgbClr val="91969B"/>
                 </a:solidFill>
                 <a:latin typeface="Calibri"/>
               </a:rPr>
-              <a:t>Ziraat Teknoloji Yapay Zekâ Hackathonu · Tema 2 · 17 Ekim 2026</a:t>
-            </a:r>
-          </a:p>
+              <a:t>17 Ekim 2026</a:t>
+            </a:r>
+          </a:p>
+        </p:txBody>
+      </p:sp>
+      <p:cxnSp>
+        <p:nvCxnSpPr>
+          <p:cNvPr id="7" name="Connector 6"/>
+          <p:cNvCxnSpPr/>
+          <p:nvPr/>
+        </p:nvCxnSpPr>
+        <p:spPr>
+          <a:xfrm>
+            <a:off x="9886651" y="4125931"/>
+            <a:ext cx="825996" cy="825996"/>
+          </a:xfrm>
+          <a:prstGeom prst="line">
+            <a:avLst/>
+          </a:prstGeom>
+          <a:ln w="333375" cap="rnd">
+            <a:solidFill>
+              <a:srgbClr val="870F00"/>
+            </a:solidFill>
+          </a:ln>
+        </p:spPr>
+      </p:cxnSp>
+      <p:sp>
+        <p:nvSpPr>
+          <p:cNvPr id="8" name="Oval 7"/>
+          <p:cNvSpPr/>
+          <p:nvPr/>
+        </p:nvSpPr>
+        <p:spPr>
+          <a:xfrm>
+            <a:off x="7132320" y="1371600"/>
+            <a:ext cx="3200400" cy="3200400"/>
+          </a:xfrm>
+          <a:prstGeom prst="ellipse">
+            <a:avLst/>
+          </a:prstGeom>
+          <a:noFill/>
+          <a:ln w="155575">
+            <a:solidFill>
+              <a:srgbClr val="E10514"/>
+            </a:solidFill>
+          </a:ln>
+          <a:effectLst/>
+        </p:spPr>
+        <p:txBody>
+          <a:bodyPr rtlCol="0" anchor="ctr"/>
+          <a:lstStyle/>
+          <a:p/>
+        </p:txBody>
+      </p:sp>
+      <p:sp>
+        <p:nvSpPr>
+          <p:cNvPr id="9" name="Oval 8"/>
+          <p:cNvSpPr/>
+          <p:nvPr/>
+        </p:nvSpPr>
+        <p:spPr>
+          <a:xfrm>
+            <a:off x="7740396" y="1979676"/>
+            <a:ext cx="1984248" cy="1984248"/>
+          </a:xfrm>
+          <a:prstGeom prst="ellipse">
+            <a:avLst/>
+          </a:prstGeom>
+          <a:noFill/>
+          <a:ln w="77787">
+            <a:solidFill>
+              <a:srgbClr val="B4BEC3"/>
+            </a:solidFill>
+          </a:ln>
+          <a:effectLst/>
+        </p:spPr>
+        <p:txBody>
+          <a:bodyPr rtlCol="0" anchor="ctr"/>
+          <a:lstStyle/>
+          <a:p/>
+        </p:txBody>
+      </p:sp>
+      <p:sp>
+        <p:nvSpPr>
+          <p:cNvPr id="10" name="Oval 9"/>
+          <p:cNvSpPr/>
+          <p:nvPr/>
+        </p:nvSpPr>
+        <p:spPr>
+          <a:xfrm>
+            <a:off x="8380476" y="2619756"/>
+            <a:ext cx="704088" cy="704088"/>
+          </a:xfrm>
+          <a:prstGeom prst="ellipse">
+            <a:avLst/>
+          </a:prstGeom>
+          <a:solidFill>
+            <a:srgbClr val="E10514"/>
+          </a:solidFill>
+          <a:ln>
+            <a:noFill/>
+          </a:ln>
+          <a:effectLst/>
+        </p:spPr>
+        <p:txBody>
+          <a:bodyPr rtlCol="0" anchor="ctr"/>
+          <a:lstStyle/>
+          <a:p/>
         </p:txBody>
       </p:sp>
     </p:spTree>
@@ -4742,7 +4886,7 @@
         <p:spPr>
           <a:xfrm>
             <a:off x="137160" y="91440"/>
-            <a:ext cx="11795760" cy="566928"/>
+            <a:ext cx="10058400" cy="566928"/>
           </a:xfrm>
           <a:prstGeom prst="rect">
             <a:avLst/>
@@ -4774,7 +4918,130 @@
       </p:sp>
       <p:sp>
         <p:nvSpPr>
-          <p:cNvPr id="3" name="TextBox 2"/>
+          <p:cNvPr id="3" name="Oval 2"/>
+          <p:cNvSpPr/>
+          <p:nvPr/>
+        </p:nvSpPr>
+        <p:spPr>
+          <a:xfrm>
+            <a:off x="10594238" y="188366"/>
+            <a:ext cx="285292" cy="285292"/>
+          </a:xfrm>
+          <a:prstGeom prst="ellipse">
+            <a:avLst/>
+          </a:prstGeom>
+          <a:noFill/>
+          <a:ln w="13868">
+            <a:solidFill>
+              <a:srgbClr val="E10514"/>
+            </a:solidFill>
+          </a:ln>
+          <a:effectLst/>
+        </p:spPr>
+        <p:txBody>
+          <a:bodyPr rtlCol="0" anchor="ctr"/>
+          <a:lstStyle/>
+          <a:p/>
+        </p:txBody>
+      </p:sp>
+      <p:sp>
+        <p:nvSpPr>
+          <p:cNvPr id="4" name="Oval 3"/>
+          <p:cNvSpPr/>
+          <p:nvPr/>
+        </p:nvSpPr>
+        <p:spPr>
+          <a:xfrm>
+            <a:off x="10648444" y="242572"/>
+            <a:ext cx="176881" cy="176881"/>
+          </a:xfrm>
+          <a:prstGeom prst="ellipse">
+            <a:avLst/>
+          </a:prstGeom>
+          <a:noFill/>
+          <a:ln w="6934">
+            <a:solidFill>
+              <a:srgbClr val="B4BEC3"/>
+            </a:solidFill>
+          </a:ln>
+          <a:effectLst/>
+        </p:spPr>
+        <p:txBody>
+          <a:bodyPr rtlCol="0" anchor="ctr"/>
+          <a:lstStyle/>
+          <a:p/>
+        </p:txBody>
+      </p:sp>
+      <p:sp>
+        <p:nvSpPr>
+          <p:cNvPr id="5" name="Oval 4"/>
+          <p:cNvSpPr/>
+          <p:nvPr/>
+        </p:nvSpPr>
+        <p:spPr>
+          <a:xfrm>
+            <a:off x="10705502" y="299630"/>
+            <a:ext cx="62764" cy="62764"/>
+          </a:xfrm>
+          <a:prstGeom prst="ellipse">
+            <a:avLst/>
+          </a:prstGeom>
+          <a:solidFill>
+            <a:srgbClr val="E10514"/>
+          </a:solidFill>
+          <a:ln>
+            <a:noFill/>
+          </a:ln>
+          <a:effectLst/>
+        </p:spPr>
+        <p:txBody>
+          <a:bodyPr rtlCol="0" anchor="ctr"/>
+          <a:lstStyle/>
+          <a:p/>
+        </p:txBody>
+      </p:sp>
+      <p:sp>
+        <p:nvSpPr>
+          <p:cNvPr id="6" name="TextBox 5"/>
+          <p:cNvSpPr txBox="1"/>
+          <p:nvPr/>
+        </p:nvSpPr>
+        <p:spPr>
+          <a:xfrm>
+            <a:off x="10972800" y="155448"/>
+            <a:ext cx="1645919" cy="351129"/>
+          </a:xfrm>
+          <a:prstGeom prst="rect">
+            <a:avLst/>
+          </a:prstGeom>
+          <a:noFill/>
+        </p:spPr>
+        <p:txBody>
+          <a:bodyPr wrap="square" anchor="ctr" lIns="0" rIns="0" tIns="0" bIns="0">
+            <a:spAutoFit/>
+          </a:bodyPr>
+          <a:lstStyle/>
+          <a:p>
+            <a:pPr algn="l">
+              <a:spcAft>
+                <a:spcPts val="400"/>
+              </a:spcAft>
+            </a:pPr>
+            <a:r>
+              <a:rPr sz="1500" b="1" i="0">
+                <a:solidFill>
+                  <a:srgbClr val="1E1E1E"/>
+                </a:solidFill>
+                <a:latin typeface="Calibri"/>
+              </a:rPr>
+              <a:t>MERCEK</a:t>
+            </a:r>
+          </a:p>
+        </p:txBody>
+      </p:sp>
+      <p:sp>
+        <p:nvSpPr>
+          <p:cNvPr id="7" name="TextBox 6"/>
           <p:cNvSpPr txBox="1"/>
           <p:nvPr/>
         </p:nvSpPr>
@@ -4813,7 +5080,7 @@
       </p:sp>
       <p:sp>
         <p:nvSpPr>
-          <p:cNvPr id="4" name="Rounded Rectangle 3"/>
+          <p:cNvPr id="8" name="Rounded Rectangle 7"/>
           <p:cNvSpPr/>
           <p:nvPr/>
         </p:nvSpPr>
@@ -4843,7 +5110,7 @@
       </p:sp>
       <p:sp>
         <p:nvSpPr>
-          <p:cNvPr id="5" name="Oval 4"/>
+          <p:cNvPr id="9" name="Oval 8"/>
           <p:cNvSpPr/>
           <p:nvPr/>
         </p:nvSpPr>
@@ -4871,7 +5138,7 @@
       </p:sp>
       <p:pic>
         <p:nvPicPr>
-          <p:cNvPr id="6" name="Picture 5" descr="check-w.png"/>
+          <p:cNvPr id="10" name="Picture 9" descr="check-w.png"/>
           <p:cNvPicPr>
             <a:picLocks noChangeAspect="1"/>
           </p:cNvPicPr>
@@ -4895,7 +5162,7 @@
       </p:pic>
       <p:sp>
         <p:nvSpPr>
-          <p:cNvPr id="7" name="TextBox 6"/>
+          <p:cNvPr id="11" name="TextBox 10"/>
           <p:cNvSpPr txBox="1"/>
           <p:nvPr/>
         </p:nvSpPr>
@@ -4934,7 +5201,7 @@
       </p:sp>
       <p:sp>
         <p:nvSpPr>
-          <p:cNvPr id="8" name="TextBox 7"/>
+          <p:cNvPr id="12" name="TextBox 11"/>
           <p:cNvSpPr txBox="1"/>
           <p:nvPr/>
         </p:nvSpPr>
@@ -5041,7 +5308,7 @@
       </p:sp>
       <p:sp>
         <p:nvSpPr>
-          <p:cNvPr id="9" name="Rounded Rectangle 8"/>
+          <p:cNvPr id="13" name="Rounded Rectangle 12"/>
           <p:cNvSpPr/>
           <p:nvPr/>
         </p:nvSpPr>
@@ -5071,7 +5338,7 @@
       </p:sp>
       <p:sp>
         <p:nvSpPr>
-          <p:cNvPr id="10" name="Oval 9"/>
+          <p:cNvPr id="14" name="Oval 13"/>
           <p:cNvSpPr/>
           <p:nvPr/>
         </p:nvSpPr>
@@ -5099,7 +5366,7 @@
       </p:sp>
       <p:pic>
         <p:nvPicPr>
-          <p:cNvPr id="11" name="Picture 10" descr="warn-w.png"/>
+          <p:cNvPr id="15" name="Picture 14" descr="warn-w.png"/>
           <p:cNvPicPr>
             <a:picLocks noChangeAspect="1"/>
           </p:cNvPicPr>
@@ -5123,7 +5390,7 @@
       </p:pic>
       <p:sp>
         <p:nvSpPr>
-          <p:cNvPr id="12" name="TextBox 11"/>
+          <p:cNvPr id="16" name="TextBox 15"/>
           <p:cNvSpPr txBox="1"/>
           <p:nvPr/>
         </p:nvSpPr>
@@ -5162,7 +5429,7 @@
       </p:sp>
       <p:sp>
         <p:nvSpPr>
-          <p:cNvPr id="13" name="TextBox 12"/>
+          <p:cNvPr id="17" name="TextBox 16"/>
           <p:cNvSpPr txBox="1"/>
           <p:nvPr/>
         </p:nvSpPr>
@@ -5269,7 +5536,7 @@
       </p:sp>
       <p:sp>
         <p:nvSpPr>
-          <p:cNvPr id="14" name="Rounded Rectangle 13"/>
+          <p:cNvPr id="18" name="Rounded Rectangle 17"/>
           <p:cNvSpPr/>
           <p:nvPr/>
         </p:nvSpPr>
@@ -5299,7 +5566,7 @@
       </p:sp>
       <p:sp>
         <p:nvSpPr>
-          <p:cNvPr id="15" name="Oval 14"/>
+          <p:cNvPr id="19" name="Oval 18"/>
           <p:cNvSpPr/>
           <p:nvPr/>
         </p:nvSpPr>
@@ -5327,7 +5594,7 @@
       </p:sp>
       <p:pic>
         <p:nvPicPr>
-          <p:cNvPr id="16" name="Picture 15" descr="route-w.png"/>
+          <p:cNvPr id="20" name="Picture 19" descr="route-w.png"/>
           <p:cNvPicPr>
             <a:picLocks noChangeAspect="1"/>
           </p:cNvPicPr>
@@ -5351,7 +5618,7 @@
       </p:pic>
       <p:sp>
         <p:nvSpPr>
-          <p:cNvPr id="17" name="TextBox 16"/>
+          <p:cNvPr id="21" name="TextBox 20"/>
           <p:cNvSpPr txBox="1"/>
           <p:nvPr/>
         </p:nvSpPr>
@@ -5390,7 +5657,7 @@
       </p:sp>
       <p:sp>
         <p:nvSpPr>
-          <p:cNvPr id="18" name="TextBox 17"/>
+          <p:cNvPr id="22" name="TextBox 21"/>
           <p:cNvSpPr txBox="1"/>
           <p:nvPr/>
         </p:nvSpPr>
@@ -5522,7 +5789,7 @@
         <p:spPr>
           <a:xfrm>
             <a:off x="137160" y="91440"/>
-            <a:ext cx="11795760" cy="566928"/>
+            <a:ext cx="10058400" cy="566928"/>
           </a:xfrm>
           <a:prstGeom prst="rect">
             <a:avLst/>
@@ -5554,7 +5821,130 @@
       </p:sp>
       <p:sp>
         <p:nvSpPr>
-          <p:cNvPr id="3" name="TextBox 2"/>
+          <p:cNvPr id="3" name="Oval 2"/>
+          <p:cNvSpPr/>
+          <p:nvPr/>
+        </p:nvSpPr>
+        <p:spPr>
+          <a:xfrm>
+            <a:off x="10594238" y="188366"/>
+            <a:ext cx="285292" cy="285292"/>
+          </a:xfrm>
+          <a:prstGeom prst="ellipse">
+            <a:avLst/>
+          </a:prstGeom>
+          <a:noFill/>
+          <a:ln w="13868">
+            <a:solidFill>
+              <a:srgbClr val="E10514"/>
+            </a:solidFill>
+          </a:ln>
+          <a:effectLst/>
+        </p:spPr>
+        <p:txBody>
+          <a:bodyPr rtlCol="0" anchor="ctr"/>
+          <a:lstStyle/>
+          <a:p/>
+        </p:txBody>
+      </p:sp>
+      <p:sp>
+        <p:nvSpPr>
+          <p:cNvPr id="4" name="Oval 3"/>
+          <p:cNvSpPr/>
+          <p:nvPr/>
+        </p:nvSpPr>
+        <p:spPr>
+          <a:xfrm>
+            <a:off x="10648444" y="242572"/>
+            <a:ext cx="176881" cy="176881"/>
+          </a:xfrm>
+          <a:prstGeom prst="ellipse">
+            <a:avLst/>
+          </a:prstGeom>
+          <a:noFill/>
+          <a:ln w="6934">
+            <a:solidFill>
+              <a:srgbClr val="B4BEC3"/>
+            </a:solidFill>
+          </a:ln>
+          <a:effectLst/>
+        </p:spPr>
+        <p:txBody>
+          <a:bodyPr rtlCol="0" anchor="ctr"/>
+          <a:lstStyle/>
+          <a:p/>
+        </p:txBody>
+      </p:sp>
+      <p:sp>
+        <p:nvSpPr>
+          <p:cNvPr id="5" name="Oval 4"/>
+          <p:cNvSpPr/>
+          <p:nvPr/>
+        </p:nvSpPr>
+        <p:spPr>
+          <a:xfrm>
+            <a:off x="10705502" y="299630"/>
+            <a:ext cx="62764" cy="62764"/>
+          </a:xfrm>
+          <a:prstGeom prst="ellipse">
+            <a:avLst/>
+          </a:prstGeom>
+          <a:solidFill>
+            <a:srgbClr val="E10514"/>
+          </a:solidFill>
+          <a:ln>
+            <a:noFill/>
+          </a:ln>
+          <a:effectLst/>
+        </p:spPr>
+        <p:txBody>
+          <a:bodyPr rtlCol="0" anchor="ctr"/>
+          <a:lstStyle/>
+          <a:p/>
+        </p:txBody>
+      </p:sp>
+      <p:sp>
+        <p:nvSpPr>
+          <p:cNvPr id="6" name="TextBox 5"/>
+          <p:cNvSpPr txBox="1"/>
+          <p:nvPr/>
+        </p:nvSpPr>
+        <p:spPr>
+          <a:xfrm>
+            <a:off x="10972800" y="155448"/>
+            <a:ext cx="1645919" cy="351129"/>
+          </a:xfrm>
+          <a:prstGeom prst="rect">
+            <a:avLst/>
+          </a:prstGeom>
+          <a:noFill/>
+        </p:spPr>
+        <p:txBody>
+          <a:bodyPr wrap="square" anchor="ctr" lIns="0" rIns="0" tIns="0" bIns="0">
+            <a:spAutoFit/>
+          </a:bodyPr>
+          <a:lstStyle/>
+          <a:p>
+            <a:pPr algn="l">
+              <a:spcAft>
+                <a:spcPts val="400"/>
+              </a:spcAft>
+            </a:pPr>
+            <a:r>
+              <a:rPr sz="1500" b="1" i="0">
+                <a:solidFill>
+                  <a:srgbClr val="1E1E1E"/>
+                </a:solidFill>
+                <a:latin typeface="Calibri"/>
+              </a:rPr>
+              <a:t>MERCEK</a:t>
+            </a:r>
+          </a:p>
+        </p:txBody>
+      </p:sp>
+      <p:sp>
+        <p:nvSpPr>
+          <p:cNvPr id="7" name="TextBox 6"/>
           <p:cNvSpPr txBox="1"/>
           <p:nvPr/>
         </p:nvSpPr>
@@ -5593,7 +5983,7 @@
       </p:sp>
       <p:sp>
         <p:nvSpPr>
-          <p:cNvPr id="4" name="Oval 3"/>
+          <p:cNvPr id="8" name="Oval 7"/>
           <p:cNvSpPr/>
           <p:nvPr/>
         </p:nvSpPr>
@@ -5621,7 +6011,7 @@
       </p:sp>
       <p:pic>
         <p:nvPicPr>
-          <p:cNvPr id="5" name="Picture 4" descr="github-w.png"/>
+          <p:cNvPr id="9" name="Picture 8" descr="github-w.png"/>
           <p:cNvPicPr>
             <a:picLocks noChangeAspect="1"/>
           </p:cNvPicPr>
@@ -5645,7 +6035,7 @@
       </p:pic>
       <p:sp>
         <p:nvSpPr>
-          <p:cNvPr id="6" name="TextBox 5"/>
+          <p:cNvPr id="10" name="TextBox 9"/>
           <p:cNvSpPr txBox="1"/>
           <p:nvPr/>
         </p:nvSpPr>
@@ -5700,7 +6090,7 @@
       </p:sp>
       <p:sp>
         <p:nvSpPr>
-          <p:cNvPr id="7" name="Oval 6"/>
+          <p:cNvPr id="11" name="Oval 10"/>
           <p:cNvSpPr/>
           <p:nvPr/>
         </p:nvSpPr>
@@ -5728,7 +6118,7 @@
       </p:sp>
       <p:pic>
         <p:nvPicPr>
-          <p:cNvPr id="8" name="Picture 7" descr="globe-w.png"/>
+          <p:cNvPr id="12" name="Picture 11" descr="globe-w.png"/>
           <p:cNvPicPr>
             <a:picLocks noChangeAspect="1"/>
           </p:cNvPicPr>
@@ -5752,7 +6142,7 @@
       </p:pic>
       <p:sp>
         <p:nvSpPr>
-          <p:cNvPr id="9" name="TextBox 8"/>
+          <p:cNvPr id="13" name="TextBox 12"/>
           <p:cNvSpPr txBox="1"/>
           <p:nvPr/>
         </p:nvSpPr>
@@ -5807,7 +6197,7 @@
       </p:sp>
       <p:sp>
         <p:nvSpPr>
-          <p:cNvPr id="10" name="Oval 9"/>
+          <p:cNvPr id="14" name="Oval 13"/>
           <p:cNvSpPr/>
           <p:nvPr/>
         </p:nvSpPr>
@@ -5835,7 +6225,7 @@
       </p:sp>
       <p:pic>
         <p:nvPicPr>
-          <p:cNvPr id="11" name="Picture 10" descr="video-w.png"/>
+          <p:cNvPr id="15" name="Picture 14" descr="video-w.png"/>
           <p:cNvPicPr>
             <a:picLocks noChangeAspect="1"/>
           </p:cNvPicPr>
@@ -5859,7 +6249,7 @@
       </p:pic>
       <p:sp>
         <p:nvSpPr>
-          <p:cNvPr id="12" name="TextBox 11"/>
+          <p:cNvPr id="16" name="TextBox 15"/>
           <p:cNvSpPr txBox="1"/>
           <p:nvPr/>
         </p:nvSpPr>
@@ -5912,24 +6302,99 @@
           </a:p>
         </p:txBody>
       </p:sp>
-      <p:sp>
-        <p:nvSpPr>
-          <p:cNvPr id="13" name="Rounded Rectangle 12"/>
+      <p:cxnSp>
+        <p:nvCxnSpPr>
+          <p:cNvPr id="17" name="Connector 16"/>
+          <p:cNvCxnSpPr/>
+          <p:nvPr/>
+        </p:nvCxnSpPr>
+        <p:spPr>
+          <a:xfrm>
+            <a:off x="9602619" y="3430419"/>
+            <a:ext cx="589997" cy="589997"/>
+          </a:xfrm>
+          <a:prstGeom prst="line">
+            <a:avLst/>
+          </a:prstGeom>
+          <a:ln w="238125" cap="rnd">
+            <a:solidFill>
+              <a:srgbClr val="870F00"/>
+            </a:solidFill>
+          </a:ln>
+        </p:spPr>
+      </p:cxnSp>
+      <p:sp>
+        <p:nvSpPr>
+          <p:cNvPr id="18" name="Oval 17"/>
           <p:cNvSpPr/>
           <p:nvPr/>
         </p:nvSpPr>
         <p:spPr>
           <a:xfrm>
-            <a:off x="6949440" y="1371600"/>
-            <a:ext cx="4800600" cy="2926080"/>
-          </a:xfrm>
-          <a:prstGeom prst="roundRect">
-            <a:avLst>
-              <a:gd name="adj" fmla="val 6000"/>
-            </a:avLst>
+            <a:off x="7635240" y="1463040"/>
+            <a:ext cx="2286000" cy="2286000"/>
+          </a:xfrm>
+          <a:prstGeom prst="ellipse">
+            <a:avLst/>
+          </a:prstGeom>
+          <a:noFill/>
+          <a:ln w="111125">
+            <a:solidFill>
+              <a:srgbClr val="E10514"/>
+            </a:solidFill>
+          </a:ln>
+          <a:effectLst/>
+        </p:spPr>
+        <p:txBody>
+          <a:bodyPr rtlCol="0" anchor="ctr"/>
+          <a:lstStyle/>
+          <a:p/>
+        </p:txBody>
+      </p:sp>
+      <p:sp>
+        <p:nvSpPr>
+          <p:cNvPr id="19" name="Oval 18"/>
+          <p:cNvSpPr/>
+          <p:nvPr/>
+        </p:nvSpPr>
+        <p:spPr>
+          <a:xfrm>
+            <a:off x="8069579" y="1897380"/>
+            <a:ext cx="1417320" cy="1417320"/>
+          </a:xfrm>
+          <a:prstGeom prst="ellipse">
+            <a:avLst/>
+          </a:prstGeom>
+          <a:noFill/>
+          <a:ln w="55562">
+            <a:solidFill>
+              <a:srgbClr val="B4BEC3"/>
+            </a:solidFill>
+          </a:ln>
+          <a:effectLst/>
+        </p:spPr>
+        <p:txBody>
+          <a:bodyPr rtlCol="0" anchor="ctr"/>
+          <a:lstStyle/>
+          <a:p/>
+        </p:txBody>
+      </p:sp>
+      <p:sp>
+        <p:nvSpPr>
+          <p:cNvPr id="20" name="Oval 19"/>
+          <p:cNvSpPr/>
+          <p:nvPr/>
+        </p:nvSpPr>
+        <p:spPr>
+          <a:xfrm>
+            <a:off x="8526780" y="2354580"/>
+            <a:ext cx="502920" cy="502920"/>
+          </a:xfrm>
+          <a:prstGeom prst="ellipse">
+            <a:avLst/>
           </a:prstGeom>
           <a:solidFill>
-            <a:srgbClr val="B90F0A"/>
+            <a:srgbClr val="E10514"/>
           </a:solidFill>
           <a:ln>
             <a:noFill/>
@@ -5944,14 +6409,14 @@
       </p:sp>
       <p:sp>
         <p:nvSpPr>
-          <p:cNvPr id="14" name="TextBox 13"/>
+          <p:cNvPr id="21" name="TextBox 20"/>
           <p:cNvSpPr txBox="1"/>
           <p:nvPr/>
         </p:nvSpPr>
         <p:spPr>
           <a:xfrm>
-            <a:off x="7223760" y="1371600"/>
-            <a:ext cx="4297680" cy="2926080"/>
+            <a:off x="6949440" y="4434840"/>
+            <a:ext cx="4572000" cy="914400"/>
           </a:xfrm>
           <a:prstGeom prst="rect">
             <a:avLst/>
@@ -5959,20 +6424,20 @@
           <a:noFill/>
         </p:spPr>
         <p:txBody>
-          <a:bodyPr wrap="square" anchor="ctr" lIns="0" rIns="0" tIns="0" bIns="0">
+          <a:bodyPr wrap="square" anchor="t" lIns="0" rIns="0" tIns="0" bIns="0">
             <a:spAutoFit/>
           </a:bodyPr>
           <a:lstStyle/>
           <a:p>
-            <a:pPr algn="l">
-              <a:spcAft>
-                <a:spcPts val="1000"/>
-              </a:spcAft>
-            </a:pPr>
-            <a:r>
-              <a:rPr sz="3600" b="1" i="0">
-                <a:solidFill>
-                  <a:srgbClr val="FFFFFF"/>
+            <a:pPr algn="ctr">
+              <a:spcAft>
+                <a:spcPts val="400"/>
+              </a:spcAft>
+            </a:pPr>
+            <a:r>
+              <a:rPr sz="3200" b="1" i="0">
+                <a:solidFill>
+                  <a:srgbClr val="1E1E1E"/>
                 </a:solidFill>
                 <a:latin typeface="Calibri"/>
               </a:rPr>
@@ -5980,15 +6445,15 @@
             </a:r>
           </a:p>
           <a:p>
-            <a:pPr algn="l">
-              <a:spcAft>
-                <a:spcPts val="1000"/>
-              </a:spcAft>
-            </a:pPr>
-            <a:r>
-              <a:rPr sz="2200" b="0" i="1">
-                <a:solidFill>
-                  <a:srgbClr val="FFFFFF"/>
+            <a:pPr algn="ctr">
+              <a:spcAft>
+                <a:spcPts val="400"/>
+              </a:spcAft>
+            </a:pPr>
+            <a:r>
+              <a:rPr sz="1800" b="0" i="1">
+                <a:solidFill>
+                  <a:srgbClr val="B90F0A"/>
                 </a:solidFill>
                 <a:latin typeface="Calibri"/>
               </a:rPr>
@@ -5999,7 +6464,7 @@
       </p:sp>
       <p:sp>
         <p:nvSpPr>
-          <p:cNvPr id="15" name="TextBox 14"/>
+          <p:cNvPr id="22" name="TextBox 21"/>
           <p:cNvSpPr txBox="1"/>
           <p:nvPr/>
         </p:nvSpPr>
@@ -6063,7 +6528,7 @@
         <p:spPr>
           <a:xfrm>
             <a:off x="137160" y="91440"/>
-            <a:ext cx="11795760" cy="566928"/>
+            <a:ext cx="10058400" cy="566928"/>
           </a:xfrm>
           <a:prstGeom prst="rect">
             <a:avLst/>
@@ -6095,7 +6560,130 @@
       </p:sp>
       <p:sp>
         <p:nvSpPr>
-          <p:cNvPr id="3" name="TextBox 2"/>
+          <p:cNvPr id="3" name="Oval 2"/>
+          <p:cNvSpPr/>
+          <p:nvPr/>
+        </p:nvSpPr>
+        <p:spPr>
+          <a:xfrm>
+            <a:off x="10594238" y="188366"/>
+            <a:ext cx="285292" cy="285292"/>
+          </a:xfrm>
+          <a:prstGeom prst="ellipse">
+            <a:avLst/>
+          </a:prstGeom>
+          <a:noFill/>
+          <a:ln w="13868">
+            <a:solidFill>
+              <a:srgbClr val="E10514"/>
+            </a:solidFill>
+          </a:ln>
+          <a:effectLst/>
+        </p:spPr>
+        <p:txBody>
+          <a:bodyPr rtlCol="0" anchor="ctr"/>
+          <a:lstStyle/>
+          <a:p/>
+        </p:txBody>
+      </p:sp>
+      <p:sp>
+        <p:nvSpPr>
+          <p:cNvPr id="4" name="Oval 3"/>
+          <p:cNvSpPr/>
+          <p:nvPr/>
+        </p:nvSpPr>
+        <p:spPr>
+          <a:xfrm>
+            <a:off x="10648444" y="242572"/>
+            <a:ext cx="176881" cy="176881"/>
+          </a:xfrm>
+          <a:prstGeom prst="ellipse">
+            <a:avLst/>
+          </a:prstGeom>
+          <a:noFill/>
+          <a:ln w="6934">
+            <a:solidFill>
+              <a:srgbClr val="B4BEC3"/>
+            </a:solidFill>
+          </a:ln>
+          <a:effectLst/>
+        </p:spPr>
+        <p:txBody>
+          <a:bodyPr rtlCol="0" anchor="ctr"/>
+          <a:lstStyle/>
+          <a:p/>
+        </p:txBody>
+      </p:sp>
+      <p:sp>
+        <p:nvSpPr>
+          <p:cNvPr id="5" name="Oval 4"/>
+          <p:cNvSpPr/>
+          <p:nvPr/>
+        </p:nvSpPr>
+        <p:spPr>
+          <a:xfrm>
+            <a:off x="10705502" y="299630"/>
+            <a:ext cx="62764" cy="62764"/>
+          </a:xfrm>
+          <a:prstGeom prst="ellipse">
+            <a:avLst/>
+          </a:prstGeom>
+          <a:solidFill>
+            <a:srgbClr val="E10514"/>
+          </a:solidFill>
+          <a:ln>
+            <a:noFill/>
+          </a:ln>
+          <a:effectLst/>
+        </p:spPr>
+        <p:txBody>
+          <a:bodyPr rtlCol="0" anchor="ctr"/>
+          <a:lstStyle/>
+          <a:p/>
+        </p:txBody>
+      </p:sp>
+      <p:sp>
+        <p:nvSpPr>
+          <p:cNvPr id="6" name="TextBox 5"/>
+          <p:cNvSpPr txBox="1"/>
+          <p:nvPr/>
+        </p:nvSpPr>
+        <p:spPr>
+          <a:xfrm>
+            <a:off x="10972800" y="155448"/>
+            <a:ext cx="1645919" cy="351129"/>
+          </a:xfrm>
+          <a:prstGeom prst="rect">
+            <a:avLst/>
+          </a:prstGeom>
+          <a:noFill/>
+        </p:spPr>
+        <p:txBody>
+          <a:bodyPr wrap="square" anchor="ctr" lIns="0" rIns="0" tIns="0" bIns="0">
+            <a:spAutoFit/>
+          </a:bodyPr>
+          <a:lstStyle/>
+          <a:p>
+            <a:pPr algn="l">
+              <a:spcAft>
+                <a:spcPts val="400"/>
+              </a:spcAft>
+            </a:pPr>
+            <a:r>
+              <a:rPr sz="1500" b="1" i="0">
+                <a:solidFill>
+                  <a:srgbClr val="1E1E1E"/>
+                </a:solidFill>
+                <a:latin typeface="Calibri"/>
+              </a:rPr>
+              <a:t>MERCEK</a:t>
+            </a:r>
+          </a:p>
+        </p:txBody>
+      </p:sp>
+      <p:sp>
+        <p:nvSpPr>
+          <p:cNvPr id="7" name="TextBox 6"/>
           <p:cNvSpPr txBox="1"/>
           <p:nvPr/>
         </p:nvSpPr>
@@ -6134,7 +6722,7 @@
       </p:sp>
       <p:sp>
         <p:nvSpPr>
-          <p:cNvPr id="4" name="Rounded Rectangle 3"/>
+          <p:cNvPr id="8" name="Rounded Rectangle 7"/>
           <p:cNvSpPr/>
           <p:nvPr/>
         </p:nvSpPr>
@@ -6164,7 +6752,7 @@
       </p:sp>
       <p:sp>
         <p:nvSpPr>
-          <p:cNvPr id="5" name="Oval 4"/>
+          <p:cNvPr id="9" name="Oval 8"/>
           <p:cNvSpPr/>
           <p:nvPr/>
         </p:nvSpPr>
@@ -6194,7 +6782,7 @@
       </p:sp>
       <p:pic>
         <p:nvPicPr>
-          <p:cNvPr id="6" name="Picture 5" descr="user-g.png"/>
+          <p:cNvPr id="10" name="Picture 9" descr="user-g.png"/>
           <p:cNvPicPr>
             <a:picLocks noChangeAspect="1"/>
           </p:cNvPicPr>
@@ -6218,7 +6806,7 @@
       </p:pic>
       <p:sp>
         <p:nvSpPr>
-          <p:cNvPr id="7" name="TextBox 6"/>
+          <p:cNvPr id="11" name="TextBox 10"/>
           <p:cNvSpPr txBox="1"/>
           <p:nvPr/>
         </p:nvSpPr>
@@ -6289,7 +6877,7 @@
       </p:sp>
       <p:sp>
         <p:nvSpPr>
-          <p:cNvPr id="8" name="Rounded Rectangle 7"/>
+          <p:cNvPr id="12" name="Rounded Rectangle 11"/>
           <p:cNvSpPr/>
           <p:nvPr/>
         </p:nvSpPr>
@@ -6319,7 +6907,7 @@
       </p:sp>
       <p:sp>
         <p:nvSpPr>
-          <p:cNvPr id="9" name="Oval 8"/>
+          <p:cNvPr id="13" name="Oval 12"/>
           <p:cNvSpPr/>
           <p:nvPr/>
         </p:nvSpPr>
@@ -6349,7 +6937,7 @@
       </p:sp>
       <p:pic>
         <p:nvPicPr>
-          <p:cNvPr id="10" name="Picture 9" descr="user-g.png"/>
+          <p:cNvPr id="14" name="Picture 13" descr="user-g.png"/>
           <p:cNvPicPr>
             <a:picLocks noChangeAspect="1"/>
           </p:cNvPicPr>
@@ -6373,7 +6961,7 @@
       </p:pic>
       <p:sp>
         <p:nvSpPr>
-          <p:cNvPr id="11" name="TextBox 10"/>
+          <p:cNvPr id="15" name="TextBox 14"/>
           <p:cNvSpPr txBox="1"/>
           <p:nvPr/>
         </p:nvSpPr>
@@ -6444,7 +7032,7 @@
       </p:sp>
       <p:sp>
         <p:nvSpPr>
-          <p:cNvPr id="12" name="Rounded Rectangle 11"/>
+          <p:cNvPr id="16" name="Rounded Rectangle 15"/>
           <p:cNvSpPr/>
           <p:nvPr/>
         </p:nvSpPr>
@@ -6474,7 +7062,7 @@
       </p:sp>
       <p:sp>
         <p:nvSpPr>
-          <p:cNvPr id="13" name="Oval 12"/>
+          <p:cNvPr id="17" name="Oval 16"/>
           <p:cNvSpPr/>
           <p:nvPr/>
         </p:nvSpPr>
@@ -6504,7 +7092,7 @@
       </p:sp>
       <p:pic>
         <p:nvPicPr>
-          <p:cNvPr id="14" name="Picture 13" descr="user-g.png"/>
+          <p:cNvPr id="18" name="Picture 17" descr="user-g.png"/>
           <p:cNvPicPr>
             <a:picLocks noChangeAspect="1"/>
           </p:cNvPicPr>
@@ -6528,7 +7116,7 @@
       </p:pic>
       <p:sp>
         <p:nvSpPr>
-          <p:cNvPr id="15" name="TextBox 14"/>
+          <p:cNvPr id="19" name="TextBox 18"/>
           <p:cNvSpPr txBox="1"/>
           <p:nvPr/>
         </p:nvSpPr>
@@ -6599,7 +7187,7 @@
       </p:sp>
       <p:sp>
         <p:nvSpPr>
-          <p:cNvPr id="16" name="Rounded Rectangle 15"/>
+          <p:cNvPr id="20" name="Rounded Rectangle 19"/>
           <p:cNvSpPr/>
           <p:nvPr/>
         </p:nvSpPr>
@@ -6629,7 +7217,7 @@
       </p:sp>
       <p:sp>
         <p:nvSpPr>
-          <p:cNvPr id="17" name="Oval 16"/>
+          <p:cNvPr id="21" name="Oval 20"/>
           <p:cNvSpPr/>
           <p:nvPr/>
         </p:nvSpPr>
@@ -6659,7 +7247,7 @@
       </p:sp>
       <p:pic>
         <p:nvPicPr>
-          <p:cNvPr id="18" name="Picture 17" descr="user-g.png"/>
+          <p:cNvPr id="22" name="Picture 21" descr="user-g.png"/>
           <p:cNvPicPr>
             <a:picLocks noChangeAspect="1"/>
           </p:cNvPicPr>
@@ -6683,7 +7271,7 @@
       </p:pic>
       <p:sp>
         <p:nvSpPr>
-          <p:cNvPr id="19" name="TextBox 18"/>
+          <p:cNvPr id="23" name="TextBox 22"/>
           <p:cNvSpPr txBox="1"/>
           <p:nvPr/>
         </p:nvSpPr>
@@ -6754,7 +7342,7 @@
       </p:sp>
       <p:sp>
         <p:nvSpPr>
-          <p:cNvPr id="20" name="Rounded Rectangle 19"/>
+          <p:cNvPr id="24" name="Rounded Rectangle 23"/>
           <p:cNvSpPr/>
           <p:nvPr/>
         </p:nvSpPr>
@@ -6784,7 +7372,7 @@
       </p:sp>
       <p:sp>
         <p:nvSpPr>
-          <p:cNvPr id="21" name="Oval 20"/>
+          <p:cNvPr id="25" name="Oval 24"/>
           <p:cNvSpPr/>
           <p:nvPr/>
         </p:nvSpPr>
@@ -6814,7 +7402,7 @@
       </p:sp>
       <p:pic>
         <p:nvPicPr>
-          <p:cNvPr id="22" name="Picture 21" descr="user-g.png"/>
+          <p:cNvPr id="26" name="Picture 25" descr="user-g.png"/>
           <p:cNvPicPr>
             <a:picLocks noChangeAspect="1"/>
           </p:cNvPicPr>
@@ -6838,7 +7426,7 @@
       </p:pic>
       <p:sp>
         <p:nvSpPr>
-          <p:cNvPr id="23" name="TextBox 22"/>
+          <p:cNvPr id="27" name="TextBox 26"/>
           <p:cNvSpPr txBox="1"/>
           <p:nvPr/>
         </p:nvSpPr>
@@ -6909,7 +7497,7 @@
       </p:sp>
       <p:sp>
         <p:nvSpPr>
-          <p:cNvPr id="24" name="TextBox 23"/>
+          <p:cNvPr id="28" name="TextBox 27"/>
           <p:cNvSpPr txBox="1"/>
           <p:nvPr/>
         </p:nvSpPr>
@@ -6973,7 +7561,7 @@
         <p:spPr>
           <a:xfrm>
             <a:off x="137160" y="91440"/>
-            <a:ext cx="11795760" cy="566928"/>
+            <a:ext cx="10058400" cy="566928"/>
           </a:xfrm>
           <a:prstGeom prst="rect">
             <a:avLst/>
@@ -7005,7 +7593,130 @@
       </p:sp>
       <p:sp>
         <p:nvSpPr>
-          <p:cNvPr id="3" name="TextBox 2"/>
+          <p:cNvPr id="3" name="Oval 2"/>
+          <p:cNvSpPr/>
+          <p:nvPr/>
+        </p:nvSpPr>
+        <p:spPr>
+          <a:xfrm>
+            <a:off x="10594238" y="188366"/>
+            <a:ext cx="285292" cy="285292"/>
+          </a:xfrm>
+          <a:prstGeom prst="ellipse">
+            <a:avLst/>
+          </a:prstGeom>
+          <a:noFill/>
+          <a:ln w="13868">
+            <a:solidFill>
+              <a:srgbClr val="E10514"/>
+            </a:solidFill>
+          </a:ln>
+          <a:effectLst/>
+        </p:spPr>
+        <p:txBody>
+          <a:bodyPr rtlCol="0" anchor="ctr"/>
+          <a:lstStyle/>
+          <a:p/>
+        </p:txBody>
+      </p:sp>
+      <p:sp>
+        <p:nvSpPr>
+          <p:cNvPr id="4" name="Oval 3"/>
+          <p:cNvSpPr/>
+          <p:nvPr/>
+        </p:nvSpPr>
+        <p:spPr>
+          <a:xfrm>
+            <a:off x="10648444" y="242572"/>
+            <a:ext cx="176881" cy="176881"/>
+          </a:xfrm>
+          <a:prstGeom prst="ellipse">
+            <a:avLst/>
+          </a:prstGeom>
+          <a:noFill/>
+          <a:ln w="6934">
+            <a:solidFill>
+              <a:srgbClr val="B4BEC3"/>
+            </a:solidFill>
+          </a:ln>
+          <a:effectLst/>
+        </p:spPr>
+        <p:txBody>
+          <a:bodyPr rtlCol="0" anchor="ctr"/>
+          <a:lstStyle/>
+          <a:p/>
+        </p:txBody>
+      </p:sp>
+      <p:sp>
+        <p:nvSpPr>
+          <p:cNvPr id="5" name="Oval 4"/>
+          <p:cNvSpPr/>
+          <p:nvPr/>
+        </p:nvSpPr>
+        <p:spPr>
+          <a:xfrm>
+            <a:off x="10705502" y="299630"/>
+            <a:ext cx="62764" cy="62764"/>
+          </a:xfrm>
+          <a:prstGeom prst="ellipse">
+            <a:avLst/>
+          </a:prstGeom>
+          <a:solidFill>
+            <a:srgbClr val="E10514"/>
+          </a:solidFill>
+          <a:ln>
+            <a:noFill/>
+          </a:ln>
+          <a:effectLst/>
+        </p:spPr>
+        <p:txBody>
+          <a:bodyPr rtlCol="0" anchor="ctr"/>
+          <a:lstStyle/>
+          <a:p/>
+        </p:txBody>
+      </p:sp>
+      <p:sp>
+        <p:nvSpPr>
+          <p:cNvPr id="6" name="TextBox 5"/>
+          <p:cNvSpPr txBox="1"/>
+          <p:nvPr/>
+        </p:nvSpPr>
+        <p:spPr>
+          <a:xfrm>
+            <a:off x="10972800" y="155448"/>
+            <a:ext cx="1645919" cy="351129"/>
+          </a:xfrm>
+          <a:prstGeom prst="rect">
+            <a:avLst/>
+          </a:prstGeom>
+          <a:noFill/>
+        </p:spPr>
+        <p:txBody>
+          <a:bodyPr wrap="square" anchor="ctr" lIns="0" rIns="0" tIns="0" bIns="0">
+            <a:spAutoFit/>
+          </a:bodyPr>
+          <a:lstStyle/>
+          <a:p>
+            <a:pPr algn="l">
+              <a:spcAft>
+                <a:spcPts val="400"/>
+              </a:spcAft>
+            </a:pPr>
+            <a:r>
+              <a:rPr sz="1500" b="1" i="0">
+                <a:solidFill>
+                  <a:srgbClr val="1E1E1E"/>
+                </a:solidFill>
+                <a:latin typeface="Calibri"/>
+              </a:rPr>
+              <a:t>MERCEK</a:t>
+            </a:r>
+          </a:p>
+        </p:txBody>
+      </p:sp>
+      <p:sp>
+        <p:nvSpPr>
+          <p:cNvPr id="7" name="TextBox 6"/>
           <p:cNvSpPr txBox="1"/>
           <p:nvPr/>
         </p:nvSpPr>
@@ -7044,7 +7755,7 @@
       </p:sp>
       <p:sp>
         <p:nvSpPr>
-          <p:cNvPr id="4" name="Rounded Rectangle 3"/>
+          <p:cNvPr id="8" name="Rounded Rectangle 7"/>
           <p:cNvSpPr/>
           <p:nvPr/>
         </p:nvSpPr>
@@ -7074,7 +7785,7 @@
       </p:sp>
       <p:pic>
         <p:nvPicPr>
-          <p:cNvPr id="5" name="Picture 4" descr="quote-w.png"/>
+          <p:cNvPr id="9" name="Picture 8" descr="quote-w.png"/>
           <p:cNvPicPr>
             <a:picLocks noChangeAspect="1"/>
           </p:cNvPicPr>
@@ -7098,7 +7809,7 @@
       </p:pic>
       <p:sp>
         <p:nvSpPr>
-          <p:cNvPr id="6" name="TextBox 5"/>
+          <p:cNvPr id="10" name="TextBox 9"/>
           <p:cNvSpPr txBox="1"/>
           <p:nvPr/>
         </p:nvSpPr>
@@ -7137,7 +7848,7 @@
       </p:sp>
       <p:sp>
         <p:nvSpPr>
-          <p:cNvPr id="7" name="TextBox 6"/>
+          <p:cNvPr id="11" name="TextBox 10"/>
           <p:cNvSpPr txBox="1"/>
           <p:nvPr/>
         </p:nvSpPr>
@@ -7176,7 +7887,7 @@
       </p:sp>
       <p:sp>
         <p:nvSpPr>
-          <p:cNvPr id="8" name="Rounded Rectangle 7"/>
+          <p:cNvPr id="12" name="Rounded Rectangle 11"/>
           <p:cNvSpPr/>
           <p:nvPr/>
         </p:nvSpPr>
@@ -7206,7 +7917,7 @@
       </p:sp>
       <p:sp>
         <p:nvSpPr>
-          <p:cNvPr id="9" name="Oval 8"/>
+          <p:cNvPr id="13" name="Oval 12"/>
           <p:cNvSpPr/>
           <p:nvPr/>
         </p:nvSpPr>
@@ -7234,7 +7945,7 @@
       </p:sp>
       <p:sp>
         <p:nvSpPr>
-          <p:cNvPr id="10" name="TextBox 9"/>
+          <p:cNvPr id="14" name="TextBox 13"/>
           <p:cNvSpPr txBox="1"/>
           <p:nvPr/>
         </p:nvSpPr>
@@ -7273,7 +7984,7 @@
       </p:sp>
       <p:sp>
         <p:nvSpPr>
-          <p:cNvPr id="11" name="TextBox 10"/>
+          <p:cNvPr id="15" name="TextBox 14"/>
           <p:cNvSpPr txBox="1"/>
           <p:nvPr/>
         </p:nvSpPr>
@@ -7312,7 +8023,7 @@
       </p:sp>
       <p:sp>
         <p:nvSpPr>
-          <p:cNvPr id="12" name="Rounded Rectangle 11"/>
+          <p:cNvPr id="16" name="Rounded Rectangle 15"/>
           <p:cNvSpPr/>
           <p:nvPr/>
         </p:nvSpPr>
@@ -7342,7 +8053,7 @@
       </p:sp>
       <p:sp>
         <p:nvSpPr>
-          <p:cNvPr id="13" name="Oval 12"/>
+          <p:cNvPr id="17" name="Oval 16"/>
           <p:cNvSpPr/>
           <p:nvPr/>
         </p:nvSpPr>
@@ -7370,7 +8081,7 @@
       </p:sp>
       <p:sp>
         <p:nvSpPr>
-          <p:cNvPr id="14" name="TextBox 13"/>
+          <p:cNvPr id="18" name="TextBox 17"/>
           <p:cNvSpPr txBox="1"/>
           <p:nvPr/>
         </p:nvSpPr>
@@ -7409,7 +8120,7 @@
       </p:sp>
       <p:sp>
         <p:nvSpPr>
-          <p:cNvPr id="15" name="TextBox 14"/>
+          <p:cNvPr id="19" name="TextBox 18"/>
           <p:cNvSpPr txBox="1"/>
           <p:nvPr/>
         </p:nvSpPr>
@@ -7448,7 +8159,7 @@
       </p:sp>
       <p:sp>
         <p:nvSpPr>
-          <p:cNvPr id="16" name="Rounded Rectangle 15"/>
+          <p:cNvPr id="20" name="Rounded Rectangle 19"/>
           <p:cNvSpPr/>
           <p:nvPr/>
         </p:nvSpPr>
@@ -7478,7 +8189,7 @@
       </p:sp>
       <p:sp>
         <p:nvSpPr>
-          <p:cNvPr id="17" name="Oval 16"/>
+          <p:cNvPr id="21" name="Oval 20"/>
           <p:cNvSpPr/>
           <p:nvPr/>
         </p:nvSpPr>
@@ -7506,7 +8217,7 @@
       </p:sp>
       <p:sp>
         <p:nvSpPr>
-          <p:cNvPr id="18" name="TextBox 17"/>
+          <p:cNvPr id="22" name="TextBox 21"/>
           <p:cNvSpPr txBox="1"/>
           <p:nvPr/>
         </p:nvSpPr>
@@ -7545,7 +8256,7 @@
       </p:sp>
       <p:sp>
         <p:nvSpPr>
-          <p:cNvPr id="19" name="TextBox 18"/>
+          <p:cNvPr id="23" name="TextBox 22"/>
           <p:cNvSpPr txBox="1"/>
           <p:nvPr/>
         </p:nvSpPr>
@@ -7584,7 +8295,7 @@
       </p:sp>
       <p:sp>
         <p:nvSpPr>
-          <p:cNvPr id="20" name="Rounded Rectangle 19"/>
+          <p:cNvPr id="24" name="Rounded Rectangle 23"/>
           <p:cNvSpPr/>
           <p:nvPr/>
         </p:nvSpPr>
@@ -7614,7 +8325,7 @@
       </p:sp>
       <p:sp>
         <p:nvSpPr>
-          <p:cNvPr id="21" name="Oval 20"/>
+          <p:cNvPr id="25" name="Oval 24"/>
           <p:cNvSpPr/>
           <p:nvPr/>
         </p:nvSpPr>
@@ -7642,7 +8353,7 @@
       </p:sp>
       <p:sp>
         <p:nvSpPr>
-          <p:cNvPr id="22" name="TextBox 21"/>
+          <p:cNvPr id="26" name="TextBox 25"/>
           <p:cNvSpPr txBox="1"/>
           <p:nvPr/>
         </p:nvSpPr>
@@ -7681,7 +8392,7 @@
       </p:sp>
       <p:sp>
         <p:nvSpPr>
-          <p:cNvPr id="23" name="TextBox 22"/>
+          <p:cNvPr id="27" name="TextBox 26"/>
           <p:cNvSpPr txBox="1"/>
           <p:nvPr/>
         </p:nvSpPr>
@@ -7720,7 +8431,7 @@
       </p:sp>
       <p:sp>
         <p:nvSpPr>
-          <p:cNvPr id="24" name="Rounded Rectangle 23"/>
+          <p:cNvPr id="28" name="Rounded Rectangle 27"/>
           <p:cNvSpPr/>
           <p:nvPr/>
         </p:nvSpPr>
@@ -7750,7 +8461,7 @@
       </p:sp>
       <p:sp>
         <p:nvSpPr>
-          <p:cNvPr id="25" name="Oval 24"/>
+          <p:cNvPr id="29" name="Oval 28"/>
           <p:cNvSpPr/>
           <p:nvPr/>
         </p:nvSpPr>
@@ -7778,7 +8489,7 @@
       </p:sp>
       <p:sp>
         <p:nvSpPr>
-          <p:cNvPr id="26" name="TextBox 25"/>
+          <p:cNvPr id="30" name="TextBox 29"/>
           <p:cNvSpPr txBox="1"/>
           <p:nvPr/>
         </p:nvSpPr>
@@ -7817,7 +8528,7 @@
       </p:sp>
       <p:sp>
         <p:nvSpPr>
-          <p:cNvPr id="27" name="TextBox 26"/>
+          <p:cNvPr id="31" name="TextBox 30"/>
           <p:cNvSpPr txBox="1"/>
           <p:nvPr/>
         </p:nvSpPr>
@@ -7856,7 +8567,7 @@
       </p:sp>
       <p:sp>
         <p:nvSpPr>
-          <p:cNvPr id="28" name="TextBox 27"/>
+          <p:cNvPr id="32" name="TextBox 31"/>
           <p:cNvSpPr txBox="1"/>
           <p:nvPr/>
         </p:nvSpPr>
@@ -7904,7 +8615,7 @@
       </p:sp>
       <p:sp>
         <p:nvSpPr>
-          <p:cNvPr id="29" name="Oval 28"/>
+          <p:cNvPr id="33" name="Oval 32"/>
           <p:cNvSpPr/>
           <p:nvPr/>
         </p:nvSpPr>
@@ -7932,7 +8643,7 @@
       </p:sp>
       <p:pic>
         <p:nvPicPr>
-          <p:cNvPr id="30" name="Picture 29" descr="eye-w.png"/>
+          <p:cNvPr id="34" name="Picture 33" descr="eye-w.png"/>
           <p:cNvPicPr>
             <a:picLocks noChangeAspect="1"/>
           </p:cNvPicPr>
@@ -7956,7 +8667,7 @@
       </p:pic>
       <p:sp>
         <p:nvSpPr>
-          <p:cNvPr id="31" name="TextBox 30"/>
+          <p:cNvPr id="35" name="TextBox 34"/>
           <p:cNvSpPr txBox="1"/>
           <p:nvPr/>
         </p:nvSpPr>
@@ -8011,7 +8722,7 @@
       </p:sp>
       <p:sp>
         <p:nvSpPr>
-          <p:cNvPr id="32" name="Oval 31"/>
+          <p:cNvPr id="36" name="Oval 35"/>
           <p:cNvSpPr/>
           <p:nvPr/>
         </p:nvSpPr>
@@ -8039,7 +8750,7 @@
       </p:sp>
       <p:pic>
         <p:nvPicPr>
-          <p:cNvPr id="33" name="Picture 32" descr="users-w.png"/>
+          <p:cNvPr id="37" name="Picture 36" descr="users-w.png"/>
           <p:cNvPicPr>
             <a:picLocks noChangeAspect="1"/>
           </p:cNvPicPr>
@@ -8063,7 +8774,7 @@
       </p:pic>
       <p:sp>
         <p:nvSpPr>
-          <p:cNvPr id="34" name="TextBox 33"/>
+          <p:cNvPr id="38" name="TextBox 37"/>
           <p:cNvSpPr txBox="1"/>
           <p:nvPr/>
         </p:nvSpPr>
@@ -8118,7 +8829,7 @@
       </p:sp>
       <p:sp>
         <p:nvSpPr>
-          <p:cNvPr id="35" name="Oval 34"/>
+          <p:cNvPr id="39" name="Oval 38"/>
           <p:cNvSpPr/>
           <p:nvPr/>
         </p:nvSpPr>
@@ -8146,7 +8857,7 @@
       </p:sp>
       <p:pic>
         <p:nvPicPr>
-          <p:cNvPr id="36" name="Picture 35" descr="unlink-w.png"/>
+          <p:cNvPr id="40" name="Picture 39" descr="unlink-w.png"/>
           <p:cNvPicPr>
             <a:picLocks noChangeAspect="1"/>
           </p:cNvPicPr>
@@ -8170,7 +8881,7 @@
       </p:pic>
       <p:sp>
         <p:nvSpPr>
-          <p:cNvPr id="37" name="TextBox 36"/>
+          <p:cNvPr id="41" name="TextBox 40"/>
           <p:cNvSpPr txBox="1"/>
           <p:nvPr/>
         </p:nvSpPr>
@@ -8250,7 +8961,7 @@
         <p:spPr>
           <a:xfrm>
             <a:off x="137160" y="91440"/>
-            <a:ext cx="11795760" cy="566928"/>
+            <a:ext cx="10058400" cy="566928"/>
           </a:xfrm>
           <a:prstGeom prst="rect">
             <a:avLst/>
@@ -8282,7 +8993,130 @@
       </p:sp>
       <p:sp>
         <p:nvSpPr>
-          <p:cNvPr id="3" name="TextBox 2"/>
+          <p:cNvPr id="3" name="Oval 2"/>
+          <p:cNvSpPr/>
+          <p:nvPr/>
+        </p:nvSpPr>
+        <p:spPr>
+          <a:xfrm>
+            <a:off x="10594238" y="188366"/>
+            <a:ext cx="285292" cy="285292"/>
+          </a:xfrm>
+          <a:prstGeom prst="ellipse">
+            <a:avLst/>
+          </a:prstGeom>
+          <a:noFill/>
+          <a:ln w="13868">
+            <a:solidFill>
+              <a:srgbClr val="E10514"/>
+            </a:solidFill>
+          </a:ln>
+          <a:effectLst/>
+        </p:spPr>
+        <p:txBody>
+          <a:bodyPr rtlCol="0" anchor="ctr"/>
+          <a:lstStyle/>
+          <a:p/>
+        </p:txBody>
+      </p:sp>
+      <p:sp>
+        <p:nvSpPr>
+          <p:cNvPr id="4" name="Oval 3"/>
+          <p:cNvSpPr/>
+          <p:nvPr/>
+        </p:nvSpPr>
+        <p:spPr>
+          <a:xfrm>
+            <a:off x="10648444" y="242572"/>
+            <a:ext cx="176881" cy="176881"/>
+          </a:xfrm>
+          <a:prstGeom prst="ellipse">
+            <a:avLst/>
+          </a:prstGeom>
+          <a:noFill/>
+          <a:ln w="6934">
+            <a:solidFill>
+              <a:srgbClr val="B4BEC3"/>
+            </a:solidFill>
+          </a:ln>
+          <a:effectLst/>
+        </p:spPr>
+        <p:txBody>
+          <a:bodyPr rtlCol="0" anchor="ctr"/>
+          <a:lstStyle/>
+          <a:p/>
+        </p:txBody>
+      </p:sp>
+      <p:sp>
+        <p:nvSpPr>
+          <p:cNvPr id="5" name="Oval 4"/>
+          <p:cNvSpPr/>
+          <p:nvPr/>
+        </p:nvSpPr>
+        <p:spPr>
+          <a:xfrm>
+            <a:off x="10705502" y="299630"/>
+            <a:ext cx="62764" cy="62764"/>
+          </a:xfrm>
+          <a:prstGeom prst="ellipse">
+            <a:avLst/>
+          </a:prstGeom>
+          <a:solidFill>
+            <a:srgbClr val="E10514"/>
+          </a:solidFill>
+          <a:ln>
+            <a:noFill/>
+          </a:ln>
+          <a:effectLst/>
+        </p:spPr>
+        <p:txBody>
+          <a:bodyPr rtlCol="0" anchor="ctr"/>
+          <a:lstStyle/>
+          <a:p/>
+        </p:txBody>
+      </p:sp>
+      <p:sp>
+        <p:nvSpPr>
+          <p:cNvPr id="6" name="TextBox 5"/>
+          <p:cNvSpPr txBox="1"/>
+          <p:nvPr/>
+        </p:nvSpPr>
+        <p:spPr>
+          <a:xfrm>
+            <a:off x="10972800" y="155448"/>
+            <a:ext cx="1645919" cy="351129"/>
+          </a:xfrm>
+          <a:prstGeom prst="rect">
+            <a:avLst/>
+          </a:prstGeom>
+          <a:noFill/>
+        </p:spPr>
+        <p:txBody>
+          <a:bodyPr wrap="square" anchor="ctr" lIns="0" rIns="0" tIns="0" bIns="0">
+            <a:spAutoFit/>
+          </a:bodyPr>
+          <a:lstStyle/>
+          <a:p>
+            <a:pPr algn="l">
+              <a:spcAft>
+                <a:spcPts val="400"/>
+              </a:spcAft>
+            </a:pPr>
+            <a:r>
+              <a:rPr sz="1500" b="1" i="0">
+                <a:solidFill>
+                  <a:srgbClr val="1E1E1E"/>
+                </a:solidFill>
+                <a:latin typeface="Calibri"/>
+              </a:rPr>
+              <a:t>MERCEK</a:t>
+            </a:r>
+          </a:p>
+        </p:txBody>
+      </p:sp>
+      <p:sp>
+        <p:nvSpPr>
+          <p:cNvPr id="7" name="TextBox 6"/>
           <p:cNvSpPr txBox="1"/>
           <p:nvPr/>
         </p:nvSpPr>
@@ -8321,7 +9155,7 @@
       </p:sp>
       <p:sp>
         <p:nvSpPr>
-          <p:cNvPr id="4" name="TextBox 3"/>
+          <p:cNvPr id="8" name="TextBox 7"/>
           <p:cNvSpPr txBox="1"/>
           <p:nvPr/>
         </p:nvSpPr>
@@ -8360,7 +9194,7 @@
       </p:sp>
       <p:sp>
         <p:nvSpPr>
-          <p:cNvPr id="5" name="Rounded Rectangle 4"/>
+          <p:cNvPr id="9" name="Rounded Rectangle 8"/>
           <p:cNvSpPr/>
           <p:nvPr/>
         </p:nvSpPr>
@@ -8390,7 +9224,7 @@
       </p:sp>
       <p:sp>
         <p:nvSpPr>
-          <p:cNvPr id="6" name="Rounded Rectangle 5"/>
+          <p:cNvPr id="10" name="Rounded Rectangle 9"/>
           <p:cNvSpPr/>
           <p:nvPr/>
         </p:nvSpPr>
@@ -8420,7 +9254,7 @@
       </p:sp>
       <p:sp>
         <p:nvSpPr>
-          <p:cNvPr id="7" name="Oval 6"/>
+          <p:cNvPr id="11" name="Oval 10"/>
           <p:cNvSpPr/>
           <p:nvPr/>
         </p:nvSpPr>
@@ -8448,7 +9282,7 @@
       </p:sp>
       <p:pic>
         <p:nvPicPr>
-          <p:cNvPr id="8" name="Picture 7" descr="headset-w.png"/>
+          <p:cNvPr id="12" name="Picture 11" descr="headset-w.png"/>
           <p:cNvPicPr>
             <a:picLocks noChangeAspect="1"/>
           </p:cNvPicPr>
@@ -8472,7 +9306,7 @@
       </p:pic>
       <p:sp>
         <p:nvSpPr>
-          <p:cNvPr id="9" name="TextBox 8"/>
+          <p:cNvPr id="13" name="TextBox 12"/>
           <p:cNvSpPr txBox="1"/>
           <p:nvPr/>
         </p:nvSpPr>
@@ -8511,7 +9345,7 @@
       </p:sp>
       <p:sp>
         <p:nvSpPr>
-          <p:cNvPr id="10" name="TextBox 9"/>
+          <p:cNvPr id="14" name="TextBox 13"/>
           <p:cNvSpPr txBox="1"/>
           <p:nvPr/>
         </p:nvSpPr>
@@ -8597,7 +9431,7 @@
       </p:sp>
       <p:sp>
         <p:nvSpPr>
-          <p:cNvPr id="11" name="Rounded Rectangle 10"/>
+          <p:cNvPr id="15" name="Rounded Rectangle 14"/>
           <p:cNvSpPr/>
           <p:nvPr/>
         </p:nvSpPr>
@@ -8627,7 +9461,7 @@
       </p:sp>
       <p:sp>
         <p:nvSpPr>
-          <p:cNvPr id="12" name="Rounded Rectangle 11"/>
+          <p:cNvPr id="16" name="Rounded Rectangle 15"/>
           <p:cNvSpPr/>
           <p:nvPr/>
         </p:nvSpPr>
@@ -8657,7 +9491,7 @@
       </p:sp>
       <p:sp>
         <p:nvSpPr>
-          <p:cNvPr id="13" name="Oval 12"/>
+          <p:cNvPr id="17" name="Oval 16"/>
           <p:cNvSpPr/>
           <p:nvPr/>
         </p:nvSpPr>
@@ -8685,7 +9519,7 @@
       </p:sp>
       <p:pic>
         <p:nvPicPr>
-          <p:cNvPr id="14" name="Picture 13" descr="clip-w.png"/>
+          <p:cNvPr id="18" name="Picture 17" descr="clip-w.png"/>
           <p:cNvPicPr>
             <a:picLocks noChangeAspect="1"/>
           </p:cNvPicPr>
@@ -8709,7 +9543,7 @@
       </p:pic>
       <p:sp>
         <p:nvSpPr>
-          <p:cNvPr id="15" name="TextBox 14"/>
+          <p:cNvPr id="19" name="TextBox 18"/>
           <p:cNvSpPr txBox="1"/>
           <p:nvPr/>
         </p:nvSpPr>
@@ -8748,7 +9582,7 @@
       </p:sp>
       <p:sp>
         <p:nvSpPr>
-          <p:cNvPr id="16" name="TextBox 15"/>
+          <p:cNvPr id="20" name="TextBox 19"/>
           <p:cNvSpPr txBox="1"/>
           <p:nvPr/>
         </p:nvSpPr>
@@ -8834,7 +9668,7 @@
       </p:sp>
       <p:sp>
         <p:nvSpPr>
-          <p:cNvPr id="17" name="Rounded Rectangle 16"/>
+          <p:cNvPr id="21" name="Rounded Rectangle 20"/>
           <p:cNvSpPr/>
           <p:nvPr/>
         </p:nvSpPr>
@@ -8864,7 +9698,7 @@
       </p:sp>
       <p:sp>
         <p:nvSpPr>
-          <p:cNvPr id="18" name="TextBox 17"/>
+          <p:cNvPr id="22" name="TextBox 21"/>
           <p:cNvSpPr txBox="1"/>
           <p:nvPr/>
         </p:nvSpPr>
@@ -8935,7 +9769,7 @@
       </p:sp>
       <p:sp>
         <p:nvSpPr>
-          <p:cNvPr id="19" name="TextBox 18"/>
+          <p:cNvPr id="23" name="TextBox 22"/>
           <p:cNvSpPr txBox="1"/>
           <p:nvPr/>
         </p:nvSpPr>
@@ -8974,7 +9808,7 @@
       </p:sp>
       <p:sp>
         <p:nvSpPr>
-          <p:cNvPr id="20" name="Rounded Rectangle 19"/>
+          <p:cNvPr id="24" name="Rounded Rectangle 23"/>
           <p:cNvSpPr/>
           <p:nvPr/>
         </p:nvSpPr>
@@ -9004,7 +9838,7 @@
       </p:sp>
       <p:sp>
         <p:nvSpPr>
-          <p:cNvPr id="21" name="TextBox 20"/>
+          <p:cNvPr id="25" name="TextBox 24"/>
           <p:cNvSpPr txBox="1"/>
           <p:nvPr/>
         </p:nvSpPr>
@@ -9043,7 +9877,7 @@
       </p:sp>
       <p:sp>
         <p:nvSpPr>
-          <p:cNvPr id="22" name="Rounded Rectangle 21"/>
+          <p:cNvPr id="26" name="Rounded Rectangle 25"/>
           <p:cNvSpPr/>
           <p:nvPr/>
         </p:nvSpPr>
@@ -9073,7 +9907,7 @@
       </p:sp>
       <p:sp>
         <p:nvSpPr>
-          <p:cNvPr id="23" name="TextBox 22"/>
+          <p:cNvPr id="27" name="TextBox 26"/>
           <p:cNvSpPr txBox="1"/>
           <p:nvPr/>
         </p:nvSpPr>
@@ -9112,7 +9946,7 @@
       </p:sp>
       <p:sp>
         <p:nvSpPr>
-          <p:cNvPr id="24" name="Rounded Rectangle 23"/>
+          <p:cNvPr id="28" name="Rounded Rectangle 27"/>
           <p:cNvSpPr/>
           <p:nvPr/>
         </p:nvSpPr>
@@ -9142,7 +9976,7 @@
       </p:sp>
       <p:sp>
         <p:nvSpPr>
-          <p:cNvPr id="25" name="TextBox 24"/>
+          <p:cNvPr id="29" name="TextBox 28"/>
           <p:cNvSpPr txBox="1"/>
           <p:nvPr/>
         </p:nvSpPr>
@@ -9181,7 +10015,7 @@
       </p:sp>
       <p:sp>
         <p:nvSpPr>
-          <p:cNvPr id="26" name="Rounded Rectangle 25"/>
+          <p:cNvPr id="30" name="Rounded Rectangle 29"/>
           <p:cNvSpPr/>
           <p:nvPr/>
         </p:nvSpPr>
@@ -9211,7 +10045,7 @@
       </p:sp>
       <p:sp>
         <p:nvSpPr>
-          <p:cNvPr id="27" name="TextBox 26"/>
+          <p:cNvPr id="31" name="TextBox 30"/>
           <p:cNvSpPr txBox="1"/>
           <p:nvPr/>
         </p:nvSpPr>
@@ -9275,7 +10109,7 @@
         <p:spPr>
           <a:xfrm>
             <a:off x="137160" y="91440"/>
-            <a:ext cx="11795760" cy="566928"/>
+            <a:ext cx="10058400" cy="566928"/>
           </a:xfrm>
           <a:prstGeom prst="rect">
             <a:avLst/>
@@ -9307,7 +10141,130 @@
       </p:sp>
       <p:sp>
         <p:nvSpPr>
-          <p:cNvPr id="3" name="TextBox 2"/>
+          <p:cNvPr id="3" name="Oval 2"/>
+          <p:cNvSpPr/>
+          <p:nvPr/>
+        </p:nvSpPr>
+        <p:spPr>
+          <a:xfrm>
+            <a:off x="10594238" y="188366"/>
+            <a:ext cx="285292" cy="285292"/>
+          </a:xfrm>
+          <a:prstGeom prst="ellipse">
+            <a:avLst/>
+          </a:prstGeom>
+          <a:noFill/>
+          <a:ln w="13868">
+            <a:solidFill>
+              <a:srgbClr val="E10514"/>
+            </a:solidFill>
+          </a:ln>
+          <a:effectLst/>
+        </p:spPr>
+        <p:txBody>
+          <a:bodyPr rtlCol="0" anchor="ctr"/>
+          <a:lstStyle/>
+          <a:p/>
+        </p:txBody>
+      </p:sp>
+      <p:sp>
+        <p:nvSpPr>
+          <p:cNvPr id="4" name="Oval 3"/>
+          <p:cNvSpPr/>
+          <p:nvPr/>
+        </p:nvSpPr>
+        <p:spPr>
+          <a:xfrm>
+            <a:off x="10648444" y="242572"/>
+            <a:ext cx="176881" cy="176881"/>
+          </a:xfrm>
+          <a:prstGeom prst="ellipse">
+            <a:avLst/>
+          </a:prstGeom>
+          <a:noFill/>
+          <a:ln w="6934">
+            <a:solidFill>
+              <a:srgbClr val="B4BEC3"/>
+            </a:solidFill>
+          </a:ln>
+          <a:effectLst/>
+        </p:spPr>
+        <p:txBody>
+          <a:bodyPr rtlCol="0" anchor="ctr"/>
+          <a:lstStyle/>
+          <a:p/>
+        </p:txBody>
+      </p:sp>
+      <p:sp>
+        <p:nvSpPr>
+          <p:cNvPr id="5" name="Oval 4"/>
+          <p:cNvSpPr/>
+          <p:nvPr/>
+        </p:nvSpPr>
+        <p:spPr>
+          <a:xfrm>
+            <a:off x="10705502" y="299630"/>
+            <a:ext cx="62764" cy="62764"/>
+          </a:xfrm>
+          <a:prstGeom prst="ellipse">
+            <a:avLst/>
+          </a:prstGeom>
+          <a:solidFill>
+            <a:srgbClr val="E10514"/>
+          </a:solidFill>
+          <a:ln>
+            <a:noFill/>
+          </a:ln>
+          <a:effectLst/>
+        </p:spPr>
+        <p:txBody>
+          <a:bodyPr rtlCol="0" anchor="ctr"/>
+          <a:lstStyle/>
+          <a:p/>
+        </p:txBody>
+      </p:sp>
+      <p:sp>
+        <p:nvSpPr>
+          <p:cNvPr id="6" name="TextBox 5"/>
+          <p:cNvSpPr txBox="1"/>
+          <p:nvPr/>
+        </p:nvSpPr>
+        <p:spPr>
+          <a:xfrm>
+            <a:off x="10972800" y="155448"/>
+            <a:ext cx="1645919" cy="351129"/>
+          </a:xfrm>
+          <a:prstGeom prst="rect">
+            <a:avLst/>
+          </a:prstGeom>
+          <a:noFill/>
+        </p:spPr>
+        <p:txBody>
+          <a:bodyPr wrap="square" anchor="ctr" lIns="0" rIns="0" tIns="0" bIns="0">
+            <a:spAutoFit/>
+          </a:bodyPr>
+          <a:lstStyle/>
+          <a:p>
+            <a:pPr algn="l">
+              <a:spcAft>
+                <a:spcPts val="400"/>
+              </a:spcAft>
+            </a:pPr>
+            <a:r>
+              <a:rPr sz="1500" b="1" i="0">
+                <a:solidFill>
+                  <a:srgbClr val="1E1E1E"/>
+                </a:solidFill>
+                <a:latin typeface="Calibri"/>
+              </a:rPr>
+              <a:t>MERCEK</a:t>
+            </a:r>
+          </a:p>
+        </p:txBody>
+      </p:sp>
+      <p:sp>
+        <p:nvSpPr>
+          <p:cNvPr id="7" name="TextBox 6"/>
           <p:cNvSpPr txBox="1"/>
           <p:nvPr/>
         </p:nvSpPr>
@@ -9346,7 +10303,7 @@
       </p:sp>
       <p:sp>
         <p:nvSpPr>
-          <p:cNvPr id="4" name="TextBox 3"/>
+          <p:cNvPr id="8" name="TextBox 7"/>
           <p:cNvSpPr txBox="1"/>
           <p:nvPr/>
         </p:nvSpPr>
@@ -9385,7 +10342,7 @@
       </p:sp>
       <p:sp>
         <p:nvSpPr>
-          <p:cNvPr id="5" name="Rounded Rectangle 4"/>
+          <p:cNvPr id="9" name="Rounded Rectangle 8"/>
           <p:cNvSpPr/>
           <p:nvPr/>
         </p:nvSpPr>
@@ -9415,7 +10372,7 @@
       </p:sp>
       <p:sp>
         <p:nvSpPr>
-          <p:cNvPr id="6" name="Oval 5"/>
+          <p:cNvPr id="10" name="Oval 9"/>
           <p:cNvSpPr/>
           <p:nvPr/>
         </p:nvSpPr>
@@ -9443,7 +10400,7 @@
       </p:sp>
       <p:pic>
         <p:nvPicPr>
-          <p:cNvPr id="7" name="Picture 6" descr="bolt-w.png"/>
+          <p:cNvPr id="11" name="Picture 10" descr="bolt-w.png"/>
           <p:cNvPicPr>
             <a:picLocks noChangeAspect="1"/>
           </p:cNvPicPr>
@@ -9467,7 +10424,7 @@
       </p:pic>
       <p:sp>
         <p:nvSpPr>
-          <p:cNvPr id="8" name="TextBox 7"/>
+          <p:cNvPr id="12" name="TextBox 11"/>
           <p:cNvSpPr txBox="1"/>
           <p:nvPr/>
         </p:nvSpPr>
@@ -9522,7 +10479,7 @@
       </p:sp>
       <p:sp>
         <p:nvSpPr>
-          <p:cNvPr id="9" name="Rounded Rectangle 8"/>
+          <p:cNvPr id="13" name="Rounded Rectangle 12"/>
           <p:cNvSpPr/>
           <p:nvPr/>
         </p:nvSpPr>
@@ -9552,7 +10509,7 @@
       </p:sp>
       <p:sp>
         <p:nvSpPr>
-          <p:cNvPr id="10" name="Oval 9"/>
+          <p:cNvPr id="14" name="Oval 13"/>
           <p:cNvSpPr/>
           <p:nvPr/>
         </p:nvSpPr>
@@ -9580,7 +10537,7 @@
       </p:sp>
       <p:pic>
         <p:nvPicPr>
-          <p:cNvPr id="11" name="Picture 10" descr="code-w.png"/>
+          <p:cNvPr id="15" name="Picture 14" descr="code-w.png"/>
           <p:cNvPicPr>
             <a:picLocks noChangeAspect="1"/>
           </p:cNvPicPr>
@@ -9604,7 +10561,7 @@
       </p:pic>
       <p:sp>
         <p:nvSpPr>
-          <p:cNvPr id="12" name="TextBox 11"/>
+          <p:cNvPr id="16" name="TextBox 15"/>
           <p:cNvSpPr txBox="1"/>
           <p:nvPr/>
         </p:nvSpPr>
@@ -9659,7 +10616,7 @@
       </p:sp>
       <p:sp>
         <p:nvSpPr>
-          <p:cNvPr id="13" name="Rounded Rectangle 12"/>
+          <p:cNvPr id="17" name="Rounded Rectangle 16"/>
           <p:cNvSpPr/>
           <p:nvPr/>
         </p:nvSpPr>
@@ -9689,7 +10646,7 @@
       </p:sp>
       <p:sp>
         <p:nvSpPr>
-          <p:cNvPr id="14" name="Oval 13"/>
+          <p:cNvPr id="18" name="Oval 17"/>
           <p:cNvSpPr/>
           <p:nvPr/>
         </p:nvSpPr>
@@ -9717,7 +10674,7 @@
       </p:sp>
       <p:pic>
         <p:nvPicPr>
-          <p:cNvPr id="15" name="Picture 14" descr="sync-w.png"/>
+          <p:cNvPr id="19" name="Picture 18" descr="sync-w.png"/>
           <p:cNvPicPr>
             <a:picLocks noChangeAspect="1"/>
           </p:cNvPicPr>
@@ -9741,7 +10698,7 @@
       </p:pic>
       <p:sp>
         <p:nvSpPr>
-          <p:cNvPr id="16" name="TextBox 15"/>
+          <p:cNvPr id="20" name="TextBox 19"/>
           <p:cNvSpPr txBox="1"/>
           <p:nvPr/>
         </p:nvSpPr>
@@ -9796,7 +10753,7 @@
       </p:sp>
       <p:sp>
         <p:nvSpPr>
-          <p:cNvPr id="17" name="Rounded Rectangle 16"/>
+          <p:cNvPr id="21" name="Rounded Rectangle 20"/>
           <p:cNvSpPr/>
           <p:nvPr/>
         </p:nvSpPr>
@@ -9826,7 +10783,7 @@
       </p:sp>
       <p:sp>
         <p:nvSpPr>
-          <p:cNvPr id="18" name="Oval 17"/>
+          <p:cNvPr id="22" name="Oval 21"/>
           <p:cNvSpPr/>
           <p:nvPr/>
         </p:nvSpPr>
@@ -9854,7 +10811,7 @@
       </p:sp>
       <p:pic>
         <p:nvPicPr>
-          <p:cNvPr id="19" name="Picture 18" descr="shield-w.png"/>
+          <p:cNvPr id="23" name="Picture 22" descr="shield-w.png"/>
           <p:cNvPicPr>
             <a:picLocks noChangeAspect="1"/>
           </p:cNvPicPr>
@@ -9878,7 +10835,7 @@
       </p:pic>
       <p:sp>
         <p:nvSpPr>
-          <p:cNvPr id="20" name="TextBox 19"/>
+          <p:cNvPr id="24" name="TextBox 23"/>
           <p:cNvSpPr txBox="1"/>
           <p:nvPr/>
         </p:nvSpPr>
@@ -9958,7 +10915,7 @@
         <p:spPr>
           <a:xfrm>
             <a:off x="137160" y="91440"/>
-            <a:ext cx="11795760" cy="566928"/>
+            <a:ext cx="10058400" cy="566928"/>
           </a:xfrm>
           <a:prstGeom prst="rect">
             <a:avLst/>
@@ -9990,7 +10947,130 @@
       </p:sp>
       <p:sp>
         <p:nvSpPr>
-          <p:cNvPr id="3" name="TextBox 2"/>
+          <p:cNvPr id="3" name="Oval 2"/>
+          <p:cNvSpPr/>
+          <p:nvPr/>
+        </p:nvSpPr>
+        <p:spPr>
+          <a:xfrm>
+            <a:off x="10594238" y="188366"/>
+            <a:ext cx="285292" cy="285292"/>
+          </a:xfrm>
+          <a:prstGeom prst="ellipse">
+            <a:avLst/>
+          </a:prstGeom>
+          <a:noFill/>
+          <a:ln w="13868">
+            <a:solidFill>
+              <a:srgbClr val="E10514"/>
+            </a:solidFill>
+          </a:ln>
+          <a:effectLst/>
+        </p:spPr>
+        <p:txBody>
+          <a:bodyPr rtlCol="0" anchor="ctr"/>
+          <a:lstStyle/>
+          <a:p/>
+        </p:txBody>
+      </p:sp>
+      <p:sp>
+        <p:nvSpPr>
+          <p:cNvPr id="4" name="Oval 3"/>
+          <p:cNvSpPr/>
+          <p:nvPr/>
+        </p:nvSpPr>
+        <p:spPr>
+          <a:xfrm>
+            <a:off x="10648444" y="242572"/>
+            <a:ext cx="176881" cy="176881"/>
+          </a:xfrm>
+          <a:prstGeom prst="ellipse">
+            <a:avLst/>
+          </a:prstGeom>
+          <a:noFill/>
+          <a:ln w="6934">
+            <a:solidFill>
+              <a:srgbClr val="B4BEC3"/>
+            </a:solidFill>
+          </a:ln>
+          <a:effectLst/>
+        </p:spPr>
+        <p:txBody>
+          <a:bodyPr rtlCol="0" anchor="ctr"/>
+          <a:lstStyle/>
+          <a:p/>
+        </p:txBody>
+      </p:sp>
+      <p:sp>
+        <p:nvSpPr>
+          <p:cNvPr id="5" name="Oval 4"/>
+          <p:cNvSpPr/>
+          <p:nvPr/>
+        </p:nvSpPr>
+        <p:spPr>
+          <a:xfrm>
+            <a:off x="10705502" y="299630"/>
+            <a:ext cx="62764" cy="62764"/>
+          </a:xfrm>
+          <a:prstGeom prst="ellipse">
+            <a:avLst/>
+          </a:prstGeom>
+          <a:solidFill>
+            <a:srgbClr val="E10514"/>
+          </a:solidFill>
+          <a:ln>
+            <a:noFill/>
+          </a:ln>
+          <a:effectLst/>
+        </p:spPr>
+        <p:txBody>
+          <a:bodyPr rtlCol="0" anchor="ctr"/>
+          <a:lstStyle/>
+          <a:p/>
+        </p:txBody>
+      </p:sp>
+      <p:sp>
+        <p:nvSpPr>
+          <p:cNvPr id="6" name="TextBox 5"/>
+          <p:cNvSpPr txBox="1"/>
+          <p:nvPr/>
+        </p:nvSpPr>
+        <p:spPr>
+          <a:xfrm>
+            <a:off x="10972800" y="155448"/>
+            <a:ext cx="1645919" cy="351129"/>
+          </a:xfrm>
+          <a:prstGeom prst="rect">
+            <a:avLst/>
+          </a:prstGeom>
+          <a:noFill/>
+        </p:spPr>
+        <p:txBody>
+          <a:bodyPr wrap="square" anchor="ctr" lIns="0" rIns="0" tIns="0" bIns="0">
+            <a:spAutoFit/>
+          </a:bodyPr>
+          <a:lstStyle/>
+          <a:p>
+            <a:pPr algn="l">
+              <a:spcAft>
+                <a:spcPts val="400"/>
+              </a:spcAft>
+            </a:pPr>
+            <a:r>
+              <a:rPr sz="1500" b="1" i="0">
+                <a:solidFill>
+                  <a:srgbClr val="1E1E1E"/>
+                </a:solidFill>
+                <a:latin typeface="Calibri"/>
+              </a:rPr>
+              <a:t>MERCEK</a:t>
+            </a:r>
+          </a:p>
+        </p:txBody>
+      </p:sp>
+      <p:sp>
+        <p:nvSpPr>
+          <p:cNvPr id="7" name="TextBox 6"/>
           <p:cNvSpPr txBox="1"/>
           <p:nvPr/>
         </p:nvSpPr>
@@ -10029,7 +11109,7 @@
       </p:sp>
       <p:sp>
         <p:nvSpPr>
-          <p:cNvPr id="4" name="Rounded Rectangle 3"/>
+          <p:cNvPr id="8" name="Rounded Rectangle 7"/>
           <p:cNvSpPr/>
           <p:nvPr/>
         </p:nvSpPr>
@@ -10059,7 +11139,7 @@
       </p:sp>
       <p:sp>
         <p:nvSpPr>
-          <p:cNvPr id="5" name="TextBox 4"/>
+          <p:cNvPr id="9" name="TextBox 8"/>
           <p:cNvSpPr txBox="1"/>
           <p:nvPr/>
         </p:nvSpPr>
@@ -10116,7 +11196,7 @@
       </p:sp>
       <p:sp>
         <p:nvSpPr>
-          <p:cNvPr id="6" name="Rounded Rectangle 5"/>
+          <p:cNvPr id="10" name="Rounded Rectangle 9"/>
           <p:cNvSpPr/>
           <p:nvPr/>
         </p:nvSpPr>
@@ -10146,7 +11226,7 @@
       </p:sp>
       <p:sp>
         <p:nvSpPr>
-          <p:cNvPr id="7" name="TextBox 6"/>
+          <p:cNvPr id="11" name="TextBox 10"/>
           <p:cNvSpPr txBox="1"/>
           <p:nvPr/>
         </p:nvSpPr>
@@ -10203,7 +11283,7 @@
       </p:sp>
       <p:sp>
         <p:nvSpPr>
-          <p:cNvPr id="8" name="Rounded Rectangle 7"/>
+          <p:cNvPr id="12" name="Rounded Rectangle 11"/>
           <p:cNvSpPr/>
           <p:nvPr/>
         </p:nvSpPr>
@@ -10233,7 +11313,7 @@
       </p:sp>
       <p:sp>
         <p:nvSpPr>
-          <p:cNvPr id="9" name="TextBox 8"/>
+          <p:cNvPr id="13" name="TextBox 12"/>
           <p:cNvSpPr txBox="1"/>
           <p:nvPr/>
         </p:nvSpPr>
@@ -10290,7 +11370,7 @@
       </p:sp>
       <p:sp>
         <p:nvSpPr>
-          <p:cNvPr id="10" name="Rounded Rectangle 9"/>
+          <p:cNvPr id="14" name="Rounded Rectangle 13"/>
           <p:cNvSpPr/>
           <p:nvPr/>
         </p:nvSpPr>
@@ -10322,7 +11402,7 @@
       </p:sp>
       <p:sp>
         <p:nvSpPr>
-          <p:cNvPr id="11" name="TextBox 10"/>
+          <p:cNvPr id="15" name="TextBox 14"/>
           <p:cNvSpPr txBox="1"/>
           <p:nvPr/>
         </p:nvSpPr>
@@ -10377,7 +11457,7 @@
       </p:sp>
       <p:sp>
         <p:nvSpPr>
-          <p:cNvPr id="12" name="Rounded Rectangle 11"/>
+          <p:cNvPr id="16" name="Rounded Rectangle 15"/>
           <p:cNvSpPr/>
           <p:nvPr/>
         </p:nvSpPr>
@@ -10409,7 +11489,7 @@
       </p:sp>
       <p:sp>
         <p:nvSpPr>
-          <p:cNvPr id="13" name="TextBox 12"/>
+          <p:cNvPr id="17" name="TextBox 16"/>
           <p:cNvSpPr txBox="1"/>
           <p:nvPr/>
         </p:nvSpPr>
@@ -10465,7 +11545,7 @@
       </p:sp>
       <p:sp>
         <p:nvSpPr>
-          <p:cNvPr id="14" name="Rounded Rectangle 13"/>
+          <p:cNvPr id="18" name="Rounded Rectangle 17"/>
           <p:cNvSpPr/>
           <p:nvPr/>
         </p:nvSpPr>
@@ -10497,7 +11577,7 @@
       </p:sp>
       <p:sp>
         <p:nvSpPr>
-          <p:cNvPr id="15" name="TextBox 14"/>
+          <p:cNvPr id="19" name="TextBox 18"/>
           <p:cNvSpPr txBox="1"/>
           <p:nvPr/>
         </p:nvSpPr>
@@ -10553,7 +11633,7 @@
       </p:sp>
       <p:cxnSp>
         <p:nvCxnSpPr>
-          <p:cNvPr id="16" name="Connector 15"/>
+          <p:cNvPr id="20" name="Connector 19"/>
           <p:cNvCxnSpPr/>
           <p:nvPr/>
         </p:nvCxnSpPr>
@@ -10589,7 +11669,7 @@
       </p:cxnSp>
       <p:cxnSp>
         <p:nvCxnSpPr>
-          <p:cNvPr id="17" name="Connector 16"/>
+          <p:cNvPr id="21" name="Connector 20"/>
           <p:cNvCxnSpPr/>
           <p:nvPr/>
         </p:nvCxnSpPr>
@@ -10625,7 +11705,7 @@
       </p:cxnSp>
       <p:cxnSp>
         <p:nvCxnSpPr>
-          <p:cNvPr id="18" name="Connector 17"/>
+          <p:cNvPr id="22" name="Connector 21"/>
           <p:cNvCxnSpPr/>
           <p:nvPr/>
         </p:nvCxnSpPr>
@@ -10661,7 +11741,7 @@
       </p:cxnSp>
       <p:cxnSp>
         <p:nvCxnSpPr>
-          <p:cNvPr id="19" name="Connector 18"/>
+          <p:cNvPr id="23" name="Connector 22"/>
           <p:cNvCxnSpPr/>
           <p:nvPr/>
         </p:nvCxnSpPr>
@@ -10697,7 +11777,7 @@
       </p:cxnSp>
       <p:cxnSp>
         <p:nvCxnSpPr>
-          <p:cNvPr id="20" name="Connector 19"/>
+          <p:cNvPr id="24" name="Connector 23"/>
           <p:cNvCxnSpPr/>
           <p:nvPr/>
         </p:nvCxnSpPr>
@@ -10733,7 +11813,7 @@
       </p:cxnSp>
       <p:sp>
         <p:nvSpPr>
-          <p:cNvPr id="21" name="Rounded Rectangle 20"/>
+          <p:cNvPr id="25" name="Rounded Rectangle 24"/>
           <p:cNvSpPr/>
           <p:nvPr/>
         </p:nvSpPr>
@@ -10763,7 +11843,7 @@
       </p:sp>
       <p:pic>
         <p:nvPicPr>
-          <p:cNvPr id="22" name="Picture 21" descr="github-g.png"/>
+          <p:cNvPr id="26" name="Picture 25" descr="github-g.png"/>
           <p:cNvPicPr>
             <a:picLocks noChangeAspect="1"/>
           </p:cNvPicPr>
@@ -10787,7 +11867,7 @@
       </p:pic>
       <p:sp>
         <p:nvSpPr>
-          <p:cNvPr id="23" name="TextBox 22"/>
+          <p:cNvPr id="27" name="TextBox 26"/>
           <p:cNvSpPr txBox="1"/>
           <p:nvPr/>
         </p:nvSpPr>
@@ -10853,7 +11933,7 @@
       </p:sp>
       <p:sp>
         <p:nvSpPr>
-          <p:cNvPr id="24" name="Rounded Rectangle 23"/>
+          <p:cNvPr id="28" name="Rounded Rectangle 27"/>
           <p:cNvSpPr/>
           <p:nvPr/>
         </p:nvSpPr>
@@ -10883,7 +11963,7 @@
       </p:sp>
       <p:sp>
         <p:nvSpPr>
-          <p:cNvPr id="25" name="TextBox 24"/>
+          <p:cNvPr id="29" name="TextBox 28"/>
           <p:cNvSpPr txBox="1"/>
           <p:nvPr/>
         </p:nvSpPr>
@@ -11002,7 +12082,7 @@
       </p:sp>
       <p:sp>
         <p:nvSpPr>
-          <p:cNvPr id="26" name="Rounded Rectangle 25"/>
+          <p:cNvPr id="30" name="Rounded Rectangle 29"/>
           <p:cNvSpPr/>
           <p:nvPr/>
         </p:nvSpPr>
@@ -11032,7 +12112,7 @@
       </p:sp>
       <p:sp>
         <p:nvSpPr>
-          <p:cNvPr id="27" name="TextBox 26"/>
+          <p:cNvPr id="31" name="TextBox 30"/>
           <p:cNvSpPr txBox="1"/>
           <p:nvPr/>
         </p:nvSpPr>
@@ -11176,7 +12256,7 @@
         <p:spPr>
           <a:xfrm>
             <a:off x="137160" y="91440"/>
-            <a:ext cx="11795760" cy="566928"/>
+            <a:ext cx="10058400" cy="566928"/>
           </a:xfrm>
           <a:prstGeom prst="rect">
             <a:avLst/>
@@ -11208,7 +12288,130 @@
       </p:sp>
       <p:sp>
         <p:nvSpPr>
-          <p:cNvPr id="3" name="TextBox 2"/>
+          <p:cNvPr id="3" name="Oval 2"/>
+          <p:cNvSpPr/>
+          <p:nvPr/>
+        </p:nvSpPr>
+        <p:spPr>
+          <a:xfrm>
+            <a:off x="10594238" y="188366"/>
+            <a:ext cx="285292" cy="285292"/>
+          </a:xfrm>
+          <a:prstGeom prst="ellipse">
+            <a:avLst/>
+          </a:prstGeom>
+          <a:noFill/>
+          <a:ln w="13868">
+            <a:solidFill>
+              <a:srgbClr val="E10514"/>
+            </a:solidFill>
+          </a:ln>
+          <a:effectLst/>
+        </p:spPr>
+        <p:txBody>
+          <a:bodyPr rtlCol="0" anchor="ctr"/>
+          <a:lstStyle/>
+          <a:p/>
+        </p:txBody>
+      </p:sp>
+      <p:sp>
+        <p:nvSpPr>
+          <p:cNvPr id="4" name="Oval 3"/>
+          <p:cNvSpPr/>
+          <p:nvPr/>
+        </p:nvSpPr>
+        <p:spPr>
+          <a:xfrm>
+            <a:off x="10648444" y="242572"/>
+            <a:ext cx="176881" cy="176881"/>
+          </a:xfrm>
+          <a:prstGeom prst="ellipse">
+            <a:avLst/>
+          </a:prstGeom>
+          <a:noFill/>
+          <a:ln w="6934">
+            <a:solidFill>
+              <a:srgbClr val="B4BEC3"/>
+            </a:solidFill>
+          </a:ln>
+          <a:effectLst/>
+        </p:spPr>
+        <p:txBody>
+          <a:bodyPr rtlCol="0" anchor="ctr"/>
+          <a:lstStyle/>
+          <a:p/>
+        </p:txBody>
+      </p:sp>
+      <p:sp>
+        <p:nvSpPr>
+          <p:cNvPr id="5" name="Oval 4"/>
+          <p:cNvSpPr/>
+          <p:nvPr/>
+        </p:nvSpPr>
+        <p:spPr>
+          <a:xfrm>
+            <a:off x="10705502" y="299630"/>
+            <a:ext cx="62764" cy="62764"/>
+          </a:xfrm>
+          <a:prstGeom prst="ellipse">
+            <a:avLst/>
+          </a:prstGeom>
+          <a:solidFill>
+            <a:srgbClr val="E10514"/>
+          </a:solidFill>
+          <a:ln>
+            <a:noFill/>
+          </a:ln>
+          <a:effectLst/>
+        </p:spPr>
+        <p:txBody>
+          <a:bodyPr rtlCol="0" anchor="ctr"/>
+          <a:lstStyle/>
+          <a:p/>
+        </p:txBody>
+      </p:sp>
+      <p:sp>
+        <p:nvSpPr>
+          <p:cNvPr id="6" name="TextBox 5"/>
+          <p:cNvSpPr txBox="1"/>
+          <p:nvPr/>
+        </p:nvSpPr>
+        <p:spPr>
+          <a:xfrm>
+            <a:off x="10972800" y="155448"/>
+            <a:ext cx="1645919" cy="351129"/>
+          </a:xfrm>
+          <a:prstGeom prst="rect">
+            <a:avLst/>
+          </a:prstGeom>
+          <a:noFill/>
+        </p:spPr>
+        <p:txBody>
+          <a:bodyPr wrap="square" anchor="ctr" lIns="0" rIns="0" tIns="0" bIns="0">
+            <a:spAutoFit/>
+          </a:bodyPr>
+          <a:lstStyle/>
+          <a:p>
+            <a:pPr algn="l">
+              <a:spcAft>
+                <a:spcPts val="400"/>
+              </a:spcAft>
+            </a:pPr>
+            <a:r>
+              <a:rPr sz="1500" b="1" i="0">
+                <a:solidFill>
+                  <a:srgbClr val="1E1E1E"/>
+                </a:solidFill>
+                <a:latin typeface="Calibri"/>
+              </a:rPr>
+              <a:t>MERCEK</a:t>
+            </a:r>
+          </a:p>
+        </p:txBody>
+      </p:sp>
+      <p:sp>
+        <p:nvSpPr>
+          <p:cNvPr id="7" name="TextBox 6"/>
           <p:cNvSpPr txBox="1"/>
           <p:nvPr/>
         </p:nvSpPr>
@@ -11247,7 +12450,7 @@
       </p:sp>
       <p:sp>
         <p:nvSpPr>
-          <p:cNvPr id="4" name="Rounded Rectangle 3"/>
+          <p:cNvPr id="8" name="Rounded Rectangle 7"/>
           <p:cNvSpPr/>
           <p:nvPr/>
         </p:nvSpPr>
@@ -11277,7 +12480,7 @@
       </p:sp>
       <p:sp>
         <p:nvSpPr>
-          <p:cNvPr id="5" name="Oval 4"/>
+          <p:cNvPr id="9" name="Oval 8"/>
           <p:cNvSpPr/>
           <p:nvPr/>
         </p:nvSpPr>
@@ -11305,7 +12508,7 @@
       </p:sp>
       <p:sp>
         <p:nvSpPr>
-          <p:cNvPr id="6" name="TextBox 5"/>
+          <p:cNvPr id="10" name="TextBox 9"/>
           <p:cNvSpPr txBox="1"/>
           <p:nvPr/>
         </p:nvSpPr>
@@ -11344,7 +12547,7 @@
       </p:sp>
       <p:sp>
         <p:nvSpPr>
-          <p:cNvPr id="7" name="TextBox 6"/>
+          <p:cNvPr id="11" name="TextBox 10"/>
           <p:cNvSpPr txBox="1"/>
           <p:nvPr/>
         </p:nvSpPr>
@@ -11399,7 +12602,7 @@
       </p:sp>
       <p:sp>
         <p:nvSpPr>
-          <p:cNvPr id="8" name="TextBox 7"/>
+          <p:cNvPr id="12" name="TextBox 11"/>
           <p:cNvSpPr txBox="1"/>
           <p:nvPr/>
         </p:nvSpPr>
@@ -11438,7 +12641,7 @@
       </p:sp>
       <p:sp>
         <p:nvSpPr>
-          <p:cNvPr id="9" name="TextBox 8"/>
+          <p:cNvPr id="13" name="TextBox 12"/>
           <p:cNvSpPr txBox="1"/>
           <p:nvPr/>
         </p:nvSpPr>
@@ -11477,7 +12680,7 @@
       </p:sp>
       <p:sp>
         <p:nvSpPr>
-          <p:cNvPr id="10" name="Rounded Rectangle 9"/>
+          <p:cNvPr id="14" name="Rounded Rectangle 13"/>
           <p:cNvSpPr/>
           <p:nvPr/>
         </p:nvSpPr>
@@ -11507,7 +12710,7 @@
       </p:sp>
       <p:sp>
         <p:nvSpPr>
-          <p:cNvPr id="11" name="TextBox 10"/>
+          <p:cNvPr id="15" name="TextBox 14"/>
           <p:cNvSpPr txBox="1"/>
           <p:nvPr/>
         </p:nvSpPr>
@@ -11546,7 +12749,7 @@
       </p:sp>
       <p:sp>
         <p:nvSpPr>
-          <p:cNvPr id="12" name="Rounded Rectangle 11"/>
+          <p:cNvPr id="16" name="Rounded Rectangle 15"/>
           <p:cNvSpPr/>
           <p:nvPr/>
         </p:nvSpPr>
@@ -11576,7 +12779,7 @@
       </p:sp>
       <p:sp>
         <p:nvSpPr>
-          <p:cNvPr id="13" name="Oval 12"/>
+          <p:cNvPr id="17" name="Oval 16"/>
           <p:cNvSpPr/>
           <p:nvPr/>
         </p:nvSpPr>
@@ -11604,7 +12807,7 @@
       </p:sp>
       <p:sp>
         <p:nvSpPr>
-          <p:cNvPr id="14" name="TextBox 13"/>
+          <p:cNvPr id="18" name="TextBox 17"/>
           <p:cNvSpPr txBox="1"/>
           <p:nvPr/>
         </p:nvSpPr>
@@ -11643,7 +12846,7 @@
       </p:sp>
       <p:sp>
         <p:nvSpPr>
-          <p:cNvPr id="15" name="TextBox 14"/>
+          <p:cNvPr id="19" name="TextBox 18"/>
           <p:cNvSpPr txBox="1"/>
           <p:nvPr/>
         </p:nvSpPr>
@@ -11698,7 +12901,7 @@
       </p:sp>
       <p:sp>
         <p:nvSpPr>
-          <p:cNvPr id="16" name="TextBox 15"/>
+          <p:cNvPr id="20" name="TextBox 19"/>
           <p:cNvSpPr txBox="1"/>
           <p:nvPr/>
         </p:nvSpPr>
@@ -11737,7 +12940,7 @@
       </p:sp>
       <p:sp>
         <p:nvSpPr>
-          <p:cNvPr id="17" name="TextBox 16"/>
+          <p:cNvPr id="21" name="TextBox 20"/>
           <p:cNvSpPr txBox="1"/>
           <p:nvPr/>
         </p:nvSpPr>
@@ -11776,7 +12979,7 @@
       </p:sp>
       <p:sp>
         <p:nvSpPr>
-          <p:cNvPr id="18" name="Rounded Rectangle 17"/>
+          <p:cNvPr id="22" name="Rounded Rectangle 21"/>
           <p:cNvSpPr/>
           <p:nvPr/>
         </p:nvSpPr>
@@ -11806,7 +13009,7 @@
       </p:sp>
       <p:sp>
         <p:nvSpPr>
-          <p:cNvPr id="19" name="TextBox 18"/>
+          <p:cNvPr id="23" name="TextBox 22"/>
           <p:cNvSpPr txBox="1"/>
           <p:nvPr/>
         </p:nvSpPr>
@@ -11845,7 +13048,7 @@
       </p:sp>
       <p:sp>
         <p:nvSpPr>
-          <p:cNvPr id="20" name="Rounded Rectangle 19"/>
+          <p:cNvPr id="24" name="Rounded Rectangle 23"/>
           <p:cNvSpPr/>
           <p:nvPr/>
         </p:nvSpPr>
@@ -11875,7 +13078,7 @@
       </p:sp>
       <p:sp>
         <p:nvSpPr>
-          <p:cNvPr id="21" name="Oval 20"/>
+          <p:cNvPr id="25" name="Oval 24"/>
           <p:cNvSpPr/>
           <p:nvPr/>
         </p:nvSpPr>
@@ -11903,7 +13106,7 @@
       </p:sp>
       <p:sp>
         <p:nvSpPr>
-          <p:cNvPr id="22" name="TextBox 21"/>
+          <p:cNvPr id="26" name="TextBox 25"/>
           <p:cNvSpPr txBox="1"/>
           <p:nvPr/>
         </p:nvSpPr>
@@ -11942,7 +13145,7 @@
       </p:sp>
       <p:sp>
         <p:nvSpPr>
-          <p:cNvPr id="23" name="TextBox 22"/>
+          <p:cNvPr id="27" name="TextBox 26"/>
           <p:cNvSpPr txBox="1"/>
           <p:nvPr/>
         </p:nvSpPr>
@@ -11997,7 +13200,7 @@
       </p:sp>
       <p:sp>
         <p:nvSpPr>
-          <p:cNvPr id="24" name="TextBox 23"/>
+          <p:cNvPr id="28" name="TextBox 27"/>
           <p:cNvSpPr txBox="1"/>
           <p:nvPr/>
         </p:nvSpPr>
@@ -12036,7 +13239,7 @@
       </p:sp>
       <p:sp>
         <p:nvSpPr>
-          <p:cNvPr id="25" name="TextBox 24"/>
+          <p:cNvPr id="29" name="TextBox 28"/>
           <p:cNvSpPr txBox="1"/>
           <p:nvPr/>
         </p:nvSpPr>
@@ -12075,7 +13278,7 @@
       </p:sp>
       <p:sp>
         <p:nvSpPr>
-          <p:cNvPr id="26" name="Rounded Rectangle 25"/>
+          <p:cNvPr id="30" name="Rounded Rectangle 29"/>
           <p:cNvSpPr/>
           <p:nvPr/>
         </p:nvSpPr>
@@ -12105,7 +13308,7 @@
       </p:sp>
       <p:sp>
         <p:nvSpPr>
-          <p:cNvPr id="27" name="TextBox 26"/>
+          <p:cNvPr id="31" name="TextBox 30"/>
           <p:cNvSpPr txBox="1"/>
           <p:nvPr/>
         </p:nvSpPr>
@@ -12144,7 +13347,7 @@
       </p:sp>
       <p:sp>
         <p:nvSpPr>
-          <p:cNvPr id="28" name="Rounded Rectangle 27"/>
+          <p:cNvPr id="32" name="Rounded Rectangle 31"/>
           <p:cNvSpPr/>
           <p:nvPr/>
         </p:nvSpPr>
@@ -12174,7 +13377,7 @@
       </p:sp>
       <p:sp>
         <p:nvSpPr>
-          <p:cNvPr id="29" name="Oval 28"/>
+          <p:cNvPr id="33" name="Oval 32"/>
           <p:cNvSpPr/>
           <p:nvPr/>
         </p:nvSpPr>
@@ -12202,7 +13405,7 @@
       </p:sp>
       <p:sp>
         <p:nvSpPr>
-          <p:cNvPr id="30" name="TextBox 29"/>
+          <p:cNvPr id="34" name="TextBox 33"/>
           <p:cNvSpPr txBox="1"/>
           <p:nvPr/>
         </p:nvSpPr>
@@ -12241,7 +13444,7 @@
       </p:sp>
       <p:sp>
         <p:nvSpPr>
-          <p:cNvPr id="31" name="TextBox 30"/>
+          <p:cNvPr id="35" name="TextBox 34"/>
           <p:cNvSpPr txBox="1"/>
           <p:nvPr/>
         </p:nvSpPr>
@@ -12296,7 +13499,7 @@
       </p:sp>
       <p:sp>
         <p:nvSpPr>
-          <p:cNvPr id="32" name="TextBox 31"/>
+          <p:cNvPr id="36" name="TextBox 35"/>
           <p:cNvSpPr txBox="1"/>
           <p:nvPr/>
         </p:nvSpPr>
@@ -12335,7 +13538,7 @@
       </p:sp>
       <p:sp>
         <p:nvSpPr>
-          <p:cNvPr id="33" name="TextBox 32"/>
+          <p:cNvPr id="37" name="TextBox 36"/>
           <p:cNvSpPr txBox="1"/>
           <p:nvPr/>
         </p:nvSpPr>
@@ -12374,7 +13577,7 @@
       </p:sp>
       <p:sp>
         <p:nvSpPr>
-          <p:cNvPr id="34" name="Rounded Rectangle 33"/>
+          <p:cNvPr id="38" name="Rounded Rectangle 37"/>
           <p:cNvSpPr/>
           <p:nvPr/>
         </p:nvSpPr>
@@ -12404,7 +13607,7 @@
       </p:sp>
       <p:sp>
         <p:nvSpPr>
-          <p:cNvPr id="35" name="TextBox 34"/>
+          <p:cNvPr id="39" name="TextBox 38"/>
           <p:cNvSpPr txBox="1"/>
           <p:nvPr/>
         </p:nvSpPr>
@@ -12443,7 +13646,7 @@
       </p:sp>
       <p:sp>
         <p:nvSpPr>
-          <p:cNvPr id="36" name="Rounded Rectangle 35"/>
+          <p:cNvPr id="40" name="Rounded Rectangle 39"/>
           <p:cNvSpPr/>
           <p:nvPr/>
         </p:nvSpPr>
@@ -12473,7 +13676,7 @@
       </p:sp>
       <p:sp>
         <p:nvSpPr>
-          <p:cNvPr id="37" name="Oval 36"/>
+          <p:cNvPr id="41" name="Oval 40"/>
           <p:cNvSpPr/>
           <p:nvPr/>
         </p:nvSpPr>
@@ -12501,7 +13704,7 @@
       </p:sp>
       <p:sp>
         <p:nvSpPr>
-          <p:cNvPr id="38" name="TextBox 37"/>
+          <p:cNvPr id="42" name="TextBox 41"/>
           <p:cNvSpPr txBox="1"/>
           <p:nvPr/>
         </p:nvSpPr>
@@ -12540,7 +13743,7 @@
       </p:sp>
       <p:sp>
         <p:nvSpPr>
-          <p:cNvPr id="39" name="TextBox 38"/>
+          <p:cNvPr id="43" name="TextBox 42"/>
           <p:cNvSpPr txBox="1"/>
           <p:nvPr/>
         </p:nvSpPr>
@@ -12595,7 +13798,7 @@
       </p:sp>
       <p:sp>
         <p:nvSpPr>
-          <p:cNvPr id="40" name="TextBox 39"/>
+          <p:cNvPr id="44" name="TextBox 43"/>
           <p:cNvSpPr txBox="1"/>
           <p:nvPr/>
         </p:nvSpPr>
@@ -12634,7 +13837,7 @@
       </p:sp>
       <p:sp>
         <p:nvSpPr>
-          <p:cNvPr id="41" name="TextBox 40"/>
+          <p:cNvPr id="45" name="TextBox 44"/>
           <p:cNvSpPr txBox="1"/>
           <p:nvPr/>
         </p:nvSpPr>
@@ -12673,7 +13876,7 @@
       </p:sp>
       <p:sp>
         <p:nvSpPr>
-          <p:cNvPr id="42" name="Rounded Rectangle 41"/>
+          <p:cNvPr id="46" name="Rounded Rectangle 45"/>
           <p:cNvSpPr/>
           <p:nvPr/>
         </p:nvSpPr>
@@ -12703,7 +13906,7 @@
       </p:sp>
       <p:sp>
         <p:nvSpPr>
-          <p:cNvPr id="43" name="TextBox 42"/>
+          <p:cNvPr id="47" name="TextBox 46"/>
           <p:cNvSpPr txBox="1"/>
           <p:nvPr/>
         </p:nvSpPr>
@@ -12742,7 +13945,7 @@
       </p:sp>
       <p:sp>
         <p:nvSpPr>
-          <p:cNvPr id="44" name="Rounded Rectangle 43"/>
+          <p:cNvPr id="48" name="Rounded Rectangle 47"/>
           <p:cNvSpPr/>
           <p:nvPr/>
         </p:nvSpPr>
@@ -12772,7 +13975,7 @@
       </p:sp>
       <p:sp>
         <p:nvSpPr>
-          <p:cNvPr id="45" name="Oval 44"/>
+          <p:cNvPr id="49" name="Oval 48"/>
           <p:cNvSpPr/>
           <p:nvPr/>
         </p:nvSpPr>
@@ -12800,7 +14003,7 @@
       </p:sp>
       <p:sp>
         <p:nvSpPr>
-          <p:cNvPr id="46" name="TextBox 45"/>
+          <p:cNvPr id="50" name="TextBox 49"/>
           <p:cNvSpPr txBox="1"/>
           <p:nvPr/>
         </p:nvSpPr>
@@ -12839,7 +14042,7 @@
       </p:sp>
       <p:sp>
         <p:nvSpPr>
-          <p:cNvPr id="47" name="TextBox 46"/>
+          <p:cNvPr id="51" name="TextBox 50"/>
           <p:cNvSpPr txBox="1"/>
           <p:nvPr/>
         </p:nvSpPr>
@@ -12894,7 +14097,7 @@
       </p:sp>
       <p:sp>
         <p:nvSpPr>
-          <p:cNvPr id="48" name="TextBox 47"/>
+          <p:cNvPr id="52" name="TextBox 51"/>
           <p:cNvSpPr txBox="1"/>
           <p:nvPr/>
         </p:nvSpPr>
@@ -12933,7 +14136,7 @@
       </p:sp>
       <p:sp>
         <p:nvSpPr>
-          <p:cNvPr id="49" name="TextBox 48"/>
+          <p:cNvPr id="53" name="TextBox 52"/>
           <p:cNvSpPr txBox="1"/>
           <p:nvPr/>
         </p:nvSpPr>
@@ -12972,7 +14175,7 @@
       </p:sp>
       <p:sp>
         <p:nvSpPr>
-          <p:cNvPr id="50" name="Rounded Rectangle 49"/>
+          <p:cNvPr id="54" name="Rounded Rectangle 53"/>
           <p:cNvSpPr/>
           <p:nvPr/>
         </p:nvSpPr>
@@ -13002,7 +14205,7 @@
       </p:sp>
       <p:sp>
         <p:nvSpPr>
-          <p:cNvPr id="51" name="TextBox 50"/>
+          <p:cNvPr id="55" name="TextBox 54"/>
           <p:cNvSpPr txBox="1"/>
           <p:nvPr/>
         </p:nvSpPr>
@@ -13066,7 +14269,7 @@
         <p:spPr>
           <a:xfrm>
             <a:off x="137160" y="91440"/>
-            <a:ext cx="11795760" cy="566928"/>
+            <a:ext cx="10058400" cy="566928"/>
           </a:xfrm>
           <a:prstGeom prst="rect">
             <a:avLst/>
@@ -13098,7 +14301,130 @@
       </p:sp>
       <p:sp>
         <p:nvSpPr>
-          <p:cNvPr id="3" name="TextBox 2"/>
+          <p:cNvPr id="3" name="Oval 2"/>
+          <p:cNvSpPr/>
+          <p:nvPr/>
+        </p:nvSpPr>
+        <p:spPr>
+          <a:xfrm>
+            <a:off x="10594238" y="188366"/>
+            <a:ext cx="285292" cy="285292"/>
+          </a:xfrm>
+          <a:prstGeom prst="ellipse">
+            <a:avLst/>
+          </a:prstGeom>
+          <a:noFill/>
+          <a:ln w="13868">
+            <a:solidFill>
+              <a:srgbClr val="E10514"/>
+            </a:solidFill>
+          </a:ln>
+          <a:effectLst/>
+        </p:spPr>
+        <p:txBody>
+          <a:bodyPr rtlCol="0" anchor="ctr"/>
+          <a:lstStyle/>
+          <a:p/>
+        </p:txBody>
+      </p:sp>
+      <p:sp>
+        <p:nvSpPr>
+          <p:cNvPr id="4" name="Oval 3"/>
+          <p:cNvSpPr/>
+          <p:nvPr/>
+        </p:nvSpPr>
+        <p:spPr>
+          <a:xfrm>
+            <a:off x="10648444" y="242572"/>
+            <a:ext cx="176881" cy="176881"/>
+          </a:xfrm>
+          <a:prstGeom prst="ellipse">
+            <a:avLst/>
+          </a:prstGeom>
+          <a:noFill/>
+          <a:ln w="6934">
+            <a:solidFill>
+              <a:srgbClr val="B4BEC3"/>
+            </a:solidFill>
+          </a:ln>
+          <a:effectLst/>
+        </p:spPr>
+        <p:txBody>
+          <a:bodyPr rtlCol="0" anchor="ctr"/>
+          <a:lstStyle/>
+          <a:p/>
+        </p:txBody>
+      </p:sp>
+      <p:sp>
+        <p:nvSpPr>
+          <p:cNvPr id="5" name="Oval 4"/>
+          <p:cNvSpPr/>
+          <p:nvPr/>
+        </p:nvSpPr>
+        <p:spPr>
+          <a:xfrm>
+            <a:off x="10705502" y="299630"/>
+            <a:ext cx="62764" cy="62764"/>
+          </a:xfrm>
+          <a:prstGeom prst="ellipse">
+            <a:avLst/>
+          </a:prstGeom>
+          <a:solidFill>
+            <a:srgbClr val="E10514"/>
+          </a:solidFill>
+          <a:ln>
+            <a:noFill/>
+          </a:ln>
+          <a:effectLst/>
+        </p:spPr>
+        <p:txBody>
+          <a:bodyPr rtlCol="0" anchor="ctr"/>
+          <a:lstStyle/>
+          <a:p/>
+        </p:txBody>
+      </p:sp>
+      <p:sp>
+        <p:nvSpPr>
+          <p:cNvPr id="6" name="TextBox 5"/>
+          <p:cNvSpPr txBox="1"/>
+          <p:nvPr/>
+        </p:nvSpPr>
+        <p:spPr>
+          <a:xfrm>
+            <a:off x="10972800" y="155448"/>
+            <a:ext cx="1645919" cy="351129"/>
+          </a:xfrm>
+          <a:prstGeom prst="rect">
+            <a:avLst/>
+          </a:prstGeom>
+          <a:noFill/>
+        </p:spPr>
+        <p:txBody>
+          <a:bodyPr wrap="square" anchor="ctr" lIns="0" rIns="0" tIns="0" bIns="0">
+            <a:spAutoFit/>
+          </a:bodyPr>
+          <a:lstStyle/>
+          <a:p>
+            <a:pPr algn="l">
+              <a:spcAft>
+                <a:spcPts val="400"/>
+              </a:spcAft>
+            </a:pPr>
+            <a:r>
+              <a:rPr sz="1500" b="1" i="0">
+                <a:solidFill>
+                  <a:srgbClr val="1E1E1E"/>
+                </a:solidFill>
+                <a:latin typeface="Calibri"/>
+              </a:rPr>
+              <a:t>MERCEK</a:t>
+            </a:r>
+          </a:p>
+        </p:txBody>
+      </p:sp>
+      <p:sp>
+        <p:nvSpPr>
+          <p:cNvPr id="7" name="TextBox 6"/>
           <p:cNvSpPr txBox="1"/>
           <p:nvPr/>
         </p:nvSpPr>
@@ -13137,7 +14463,7 @@
       </p:sp>
       <p:sp>
         <p:nvSpPr>
-          <p:cNvPr id="4" name="Rounded Rectangle 3"/>
+          <p:cNvPr id="8" name="Rounded Rectangle 7"/>
           <p:cNvSpPr/>
           <p:nvPr/>
         </p:nvSpPr>
@@ -13167,7 +14493,7 @@
       </p:sp>
       <p:pic>
         <p:nvPicPr>
-          <p:cNvPr id="5" name="Picture 4" descr="m-a-panel.png"/>
+          <p:cNvPr id="9" name="Picture 8" descr="m-a-panel.png"/>
           <p:cNvPicPr>
             <a:picLocks noChangeAspect="1"/>
           </p:cNvPicPr>
@@ -13196,7 +14522,7 @@
       </p:pic>
       <p:sp>
         <p:nvSpPr>
-          <p:cNvPr id="6" name="Rounded Rectangle 5"/>
+          <p:cNvPr id="10" name="Rounded Rectangle 9"/>
           <p:cNvSpPr/>
           <p:nvPr/>
         </p:nvSpPr>
@@ -13226,7 +14552,7 @@
       </p:sp>
       <p:sp>
         <p:nvSpPr>
-          <p:cNvPr id="7" name="TextBox 6"/>
+          <p:cNvPr id="11" name="TextBox 10"/>
           <p:cNvSpPr txBox="1"/>
           <p:nvPr/>
         </p:nvSpPr>
@@ -13265,7 +14591,7 @@
       </p:sp>
       <p:sp>
         <p:nvSpPr>
-          <p:cNvPr id="8" name="TextBox 7"/>
+          <p:cNvPr id="12" name="TextBox 11"/>
           <p:cNvSpPr txBox="1"/>
           <p:nvPr/>
         </p:nvSpPr>
@@ -13304,7 +14630,7 @@
       </p:sp>
       <p:sp>
         <p:nvSpPr>
-          <p:cNvPr id="9" name="TextBox 8"/>
+          <p:cNvPr id="13" name="TextBox 12"/>
           <p:cNvSpPr txBox="1"/>
           <p:nvPr/>
         </p:nvSpPr>
@@ -13343,7 +14669,7 @@
       </p:sp>
       <p:sp>
         <p:nvSpPr>
-          <p:cNvPr id="10" name="Rounded Rectangle 9"/>
+          <p:cNvPr id="14" name="Rounded Rectangle 13"/>
           <p:cNvSpPr/>
           <p:nvPr/>
         </p:nvSpPr>
@@ -13373,7 +14699,7 @@
       </p:sp>
       <p:pic>
         <p:nvPicPr>
-          <p:cNvPr id="11" name="Picture 10" descr="m-b-callcenter.png"/>
+          <p:cNvPr id="15" name="Picture 14" descr="m-b-callcenter.png"/>
           <p:cNvPicPr>
             <a:picLocks noChangeAspect="1"/>
           </p:cNvPicPr>
@@ -13402,7 +14728,7 @@
       </p:pic>
       <p:sp>
         <p:nvSpPr>
-          <p:cNvPr id="12" name="Rounded Rectangle 11"/>
+          <p:cNvPr id="16" name="Rounded Rectangle 15"/>
           <p:cNvSpPr/>
           <p:nvPr/>
         </p:nvSpPr>
@@ -13432,7 +14758,7 @@
       </p:sp>
       <p:sp>
         <p:nvSpPr>
-          <p:cNvPr id="13" name="TextBox 12"/>
+          <p:cNvPr id="17" name="TextBox 16"/>
           <p:cNvSpPr txBox="1"/>
           <p:nvPr/>
         </p:nvSpPr>
@@ -13471,7 +14797,7 @@
       </p:sp>
       <p:sp>
         <p:nvSpPr>
-          <p:cNvPr id="14" name="TextBox 13"/>
+          <p:cNvPr id="18" name="TextBox 17"/>
           <p:cNvSpPr txBox="1"/>
           <p:nvPr/>
         </p:nvSpPr>
@@ -13510,7 +14836,7 @@
       </p:sp>
       <p:sp>
         <p:nvSpPr>
-          <p:cNvPr id="15" name="TextBox 14"/>
+          <p:cNvPr id="19" name="TextBox 18"/>
           <p:cNvSpPr txBox="1"/>
           <p:nvPr/>
         </p:nvSpPr>
@@ -13549,7 +14875,7 @@
       </p:sp>
       <p:sp>
         <p:nvSpPr>
-          <p:cNvPr id="16" name="Rounded Rectangle 15"/>
+          <p:cNvPr id="20" name="Rounded Rectangle 19"/>
           <p:cNvSpPr/>
           <p:nvPr/>
         </p:nvSpPr>
@@ -13579,7 +14905,7 @@
       </p:sp>
       <p:pic>
         <p:nvPicPr>
-          <p:cNvPr id="17" name="Picture 16" descr="m-c-code.png"/>
+          <p:cNvPr id="21" name="Picture 20" descr="m-c-code.png"/>
           <p:cNvPicPr>
             <a:picLocks noChangeAspect="1"/>
           </p:cNvPicPr>
@@ -13608,7 +14934,7 @@
       </p:pic>
       <p:sp>
         <p:nvSpPr>
-          <p:cNvPr id="18" name="Rounded Rectangle 17"/>
+          <p:cNvPr id="22" name="Rounded Rectangle 21"/>
           <p:cNvSpPr/>
           <p:nvPr/>
         </p:nvSpPr>
@@ -13638,7 +14964,7 @@
       </p:sp>
       <p:sp>
         <p:nvSpPr>
-          <p:cNvPr id="19" name="TextBox 18"/>
+          <p:cNvPr id="23" name="TextBox 22"/>
           <p:cNvSpPr txBox="1"/>
           <p:nvPr/>
         </p:nvSpPr>
@@ -13677,7 +15003,7 @@
       </p:sp>
       <p:sp>
         <p:nvSpPr>
-          <p:cNvPr id="20" name="TextBox 19"/>
+          <p:cNvPr id="24" name="TextBox 23"/>
           <p:cNvSpPr txBox="1"/>
           <p:nvPr/>
         </p:nvSpPr>
@@ -13716,7 +15042,7 @@
       </p:sp>
       <p:sp>
         <p:nvSpPr>
-          <p:cNvPr id="21" name="TextBox 20"/>
+          <p:cNvPr id="25" name="TextBox 24"/>
           <p:cNvSpPr txBox="1"/>
           <p:nvPr/>
         </p:nvSpPr>
@@ -13755,7 +15081,7 @@
       </p:sp>
       <p:sp>
         <p:nvSpPr>
-          <p:cNvPr id="22" name="Rounded Rectangle 21"/>
+          <p:cNvPr id="26" name="Rounded Rectangle 25"/>
           <p:cNvSpPr/>
           <p:nvPr/>
         </p:nvSpPr>
@@ -13785,7 +15111,7 @@
       </p:sp>
       <p:pic>
         <p:nvPicPr>
-          <p:cNvPr id="23" name="Picture 22" descr="m-d-request.png"/>
+          <p:cNvPr id="27" name="Picture 26" descr="m-d-request.png"/>
           <p:cNvPicPr>
             <a:picLocks noChangeAspect="1"/>
           </p:cNvPicPr>
@@ -13814,7 +15140,7 @@
       </p:pic>
       <p:sp>
         <p:nvSpPr>
-          <p:cNvPr id="24" name="Rounded Rectangle 23"/>
+          <p:cNvPr id="28" name="Rounded Rectangle 27"/>
           <p:cNvSpPr/>
           <p:nvPr/>
         </p:nvSpPr>
@@ -13844,7 +15170,7 @@
       </p:sp>
       <p:sp>
         <p:nvSpPr>
-          <p:cNvPr id="25" name="TextBox 24"/>
+          <p:cNvPr id="29" name="TextBox 28"/>
           <p:cNvSpPr txBox="1"/>
           <p:nvPr/>
         </p:nvSpPr>
@@ -13883,7 +15209,7 @@
       </p:sp>
       <p:sp>
         <p:nvSpPr>
-          <p:cNvPr id="26" name="TextBox 25"/>
+          <p:cNvPr id="30" name="TextBox 29"/>
           <p:cNvSpPr txBox="1"/>
           <p:nvPr/>
         </p:nvSpPr>
@@ -13922,7 +15248,7 @@
       </p:sp>
       <p:sp>
         <p:nvSpPr>
-          <p:cNvPr id="27" name="TextBox 26"/>
+          <p:cNvPr id="31" name="TextBox 30"/>
           <p:cNvSpPr txBox="1"/>
           <p:nvPr/>
         </p:nvSpPr>
@@ -13961,7 +15287,7 @@
       </p:sp>
       <p:sp>
         <p:nvSpPr>
-          <p:cNvPr id="28" name="TextBox 27"/>
+          <p:cNvPr id="32" name="TextBox 31"/>
           <p:cNvSpPr txBox="1"/>
           <p:nvPr/>
         </p:nvSpPr>
@@ -14025,7 +15351,7 @@
         <p:spPr>
           <a:xfrm>
             <a:off x="137160" y="91440"/>
-            <a:ext cx="11795760" cy="566928"/>
+            <a:ext cx="10058400" cy="566928"/>
           </a:xfrm>
           <a:prstGeom prst="rect">
             <a:avLst/>
@@ -14057,7 +15383,130 @@
       </p:sp>
       <p:sp>
         <p:nvSpPr>
-          <p:cNvPr id="3" name="TextBox 2"/>
+          <p:cNvPr id="3" name="Oval 2"/>
+          <p:cNvSpPr/>
+          <p:nvPr/>
+        </p:nvSpPr>
+        <p:spPr>
+          <a:xfrm>
+            <a:off x="10594238" y="188366"/>
+            <a:ext cx="285292" cy="285292"/>
+          </a:xfrm>
+          <a:prstGeom prst="ellipse">
+            <a:avLst/>
+          </a:prstGeom>
+          <a:noFill/>
+          <a:ln w="13868">
+            <a:solidFill>
+              <a:srgbClr val="E10514"/>
+            </a:solidFill>
+          </a:ln>
+          <a:effectLst/>
+        </p:spPr>
+        <p:txBody>
+          <a:bodyPr rtlCol="0" anchor="ctr"/>
+          <a:lstStyle/>
+          <a:p/>
+        </p:txBody>
+      </p:sp>
+      <p:sp>
+        <p:nvSpPr>
+          <p:cNvPr id="4" name="Oval 3"/>
+          <p:cNvSpPr/>
+          <p:nvPr/>
+        </p:nvSpPr>
+        <p:spPr>
+          <a:xfrm>
+            <a:off x="10648444" y="242572"/>
+            <a:ext cx="176881" cy="176881"/>
+          </a:xfrm>
+          <a:prstGeom prst="ellipse">
+            <a:avLst/>
+          </a:prstGeom>
+          <a:noFill/>
+          <a:ln w="6934">
+            <a:solidFill>
+              <a:srgbClr val="B4BEC3"/>
+            </a:solidFill>
+          </a:ln>
+          <a:effectLst/>
+        </p:spPr>
+        <p:txBody>
+          <a:bodyPr rtlCol="0" anchor="ctr"/>
+          <a:lstStyle/>
+          <a:p/>
+        </p:txBody>
+      </p:sp>
+      <p:sp>
+        <p:nvSpPr>
+          <p:cNvPr id="5" name="Oval 4"/>
+          <p:cNvSpPr/>
+          <p:nvPr/>
+        </p:nvSpPr>
+        <p:spPr>
+          <a:xfrm>
+            <a:off x="10705502" y="299630"/>
+            <a:ext cx="62764" cy="62764"/>
+          </a:xfrm>
+          <a:prstGeom prst="ellipse">
+            <a:avLst/>
+          </a:prstGeom>
+          <a:solidFill>
+            <a:srgbClr val="E10514"/>
+          </a:solidFill>
+          <a:ln>
+            <a:noFill/>
+          </a:ln>
+          <a:effectLst/>
+        </p:spPr>
+        <p:txBody>
+          <a:bodyPr rtlCol="0" anchor="ctr"/>
+          <a:lstStyle/>
+          <a:p/>
+        </p:txBody>
+      </p:sp>
+      <p:sp>
+        <p:nvSpPr>
+          <p:cNvPr id="6" name="TextBox 5"/>
+          <p:cNvSpPr txBox="1"/>
+          <p:nvPr/>
+        </p:nvSpPr>
+        <p:spPr>
+          <a:xfrm>
+            <a:off x="10972800" y="155448"/>
+            <a:ext cx="1645919" cy="351129"/>
+          </a:xfrm>
+          <a:prstGeom prst="rect">
+            <a:avLst/>
+          </a:prstGeom>
+          <a:noFill/>
+        </p:spPr>
+        <p:txBody>
+          <a:bodyPr wrap="square" anchor="ctr" lIns="0" rIns="0" tIns="0" bIns="0">
+            <a:spAutoFit/>
+          </a:bodyPr>
+          <a:lstStyle/>
+          <a:p>
+            <a:pPr algn="l">
+              <a:spcAft>
+                <a:spcPts val="400"/>
+              </a:spcAft>
+            </a:pPr>
+            <a:r>
+              <a:rPr sz="1500" b="1" i="0">
+                <a:solidFill>
+                  <a:srgbClr val="1E1E1E"/>
+                </a:solidFill>
+                <a:latin typeface="Calibri"/>
+              </a:rPr>
+              <a:t>MERCEK</a:t>
+            </a:r>
+          </a:p>
+        </p:txBody>
+      </p:sp>
+      <p:sp>
+        <p:nvSpPr>
+          <p:cNvPr id="7" name="TextBox 6"/>
           <p:cNvSpPr txBox="1"/>
           <p:nvPr/>
         </p:nvSpPr>
@@ -14096,7 +15545,7 @@
       </p:sp>
       <p:sp>
         <p:nvSpPr>
-          <p:cNvPr id="4" name="Rounded Rectangle 3"/>
+          <p:cNvPr id="8" name="Rounded Rectangle 7"/>
           <p:cNvSpPr/>
           <p:nvPr/>
         </p:nvSpPr>
@@ -14126,7 +15575,7 @@
       </p:sp>
       <p:sp>
         <p:nvSpPr>
-          <p:cNvPr id="5" name="TextBox 4"/>
+          <p:cNvPr id="9" name="TextBox 8"/>
           <p:cNvSpPr txBox="1"/>
           <p:nvPr/>
         </p:nvSpPr>
@@ -14181,7 +15630,7 @@
       </p:sp>
       <p:sp>
         <p:nvSpPr>
-          <p:cNvPr id="6" name="Rounded Rectangle 5"/>
+          <p:cNvPr id="10" name="Rounded Rectangle 9"/>
           <p:cNvSpPr/>
           <p:nvPr/>
         </p:nvSpPr>
@@ -14211,7 +15660,7 @@
       </p:sp>
       <p:sp>
         <p:nvSpPr>
-          <p:cNvPr id="7" name="TextBox 6"/>
+          <p:cNvPr id="11" name="TextBox 10"/>
           <p:cNvSpPr txBox="1"/>
           <p:nvPr/>
         </p:nvSpPr>
@@ -14266,7 +15715,7 @@
       </p:sp>
       <p:sp>
         <p:nvSpPr>
-          <p:cNvPr id="8" name="Rounded Rectangle 7"/>
+          <p:cNvPr id="12" name="Rounded Rectangle 11"/>
           <p:cNvSpPr/>
           <p:nvPr/>
         </p:nvSpPr>
@@ -14296,7 +15745,7 @@
       </p:sp>
       <p:sp>
         <p:nvSpPr>
-          <p:cNvPr id="9" name="TextBox 8"/>
+          <p:cNvPr id="13" name="TextBox 12"/>
           <p:cNvSpPr txBox="1"/>
           <p:nvPr/>
         </p:nvSpPr>
@@ -14351,7 +15800,7 @@
       </p:sp>
       <p:graphicFrame>
         <p:nvGraphicFramePr>
-          <p:cNvPr id="10" name="Table 9"/>
+          <p:cNvPr id="14" name="Table 13"/>
           <p:cNvGraphicFramePr>
             <a:graphicFrameLocks noGrp="1"/>
           </p:cNvGraphicFramePr>
@@ -14784,7 +16233,7 @@
       </p:graphicFrame>
       <p:sp>
         <p:nvSpPr>
-          <p:cNvPr id="11" name="TextBox 10"/>
+          <p:cNvPr id="15" name="TextBox 14"/>
           <p:cNvSpPr txBox="1"/>
           <p:nvPr/>
         </p:nvSpPr>

</xml_diff>

<commit_message>
Sunum: mimari slaytı hibrit RAG çerçevesine göre güncellendi
Co-Authored-By: Claude Opus 5.5 <noreply@anthropic.com>
Claude-Session: https://claude.ai/code/session_01DTiHxbPkixs9Jadunw7PB9
</commit_message>
<xml_diff>
--- a/presentation/Mercek_AI_Overflow_Sunum.pptx
+++ b/presentation/Mercek_AI_Overflow_Sunum.pptx
@@ -1029,7 +1029,7 @@
           <a:lstStyle/>
           <a:p>
             <a:r>
-              <a:t>0:58–1:05 · İki App Service (web ve api), Foundry'de sohbet ve embedding modeli, SQL yapısal veri, AI Search hibrit arama. CI/CD her PR'da test ve güvenlik taraması yapıyor. Sağda AI'ın ve kuralların işi. (Yalnızca gerçekten çalışan servisler bu slaytta kalmalı.)</a:t>
+              <a:t>0:58–1:05 · Mercek hibrit RAG kullanır: AI Search geçmiş çözümleri, talepleri ve duyuruları anlam benzerliğiyle bulur (vektör + kelime, Türkçe analizör, Foundry embedding); Azure SQL o anki gerçek rakamları parametreli sorgularla getirir. Foundry ikisini bağlam olarak alıp cevabı yazar; rakam uydurmaz çünkü her sayı SQL'den gelir. Model SQL yazmaz (text-to-SQL yok). CI/CD her PR'da test ve güvenlik taraması yapıyor. Sağda AI'ın ve kuralların işi. (Yalnızca gerçekten çalışan servisler bu slaytta kalmalı.)</a:t>
             </a:r>
           </a:p>
         </p:txBody>
@@ -5139,7 +5139,7 @@
                 </a:solidFill>
                 <a:latin typeface="Calibri"/>
               </a:rPr>
-              <a:t>Azure: 2 App Service, Foundry, SQL, AI Search</a:t>
+              <a:t>Azure: 2 App Service, Foundry, hibrit RAG (AI Search + SQL)</a:t>
             </a:r>
           </a:p>
           <a:p>
@@ -10418,7 +10418,7 @@
                 </a:solidFill>
                 <a:latin typeface="Calibri"/>
               </a:rPr>
-              <a:t>Mimari: Azure Üzerinde Uçtan Uca</a:t>
+              <a:t>Mimari: Azure Üzerinde Hibrit RAG</a:t>
             </a:r>
           </a:p>
         </p:txBody>
@@ -10534,7 +10534,7 @@
         <p:spPr>
           <a:xfrm>
             <a:off x="411480" y="2148840"/>
-            <a:ext cx="1783080" cy="2377440"/>
+            <a:ext cx="1463040" cy="2377440"/>
           </a:xfrm>
           <a:prstGeom prst="roundRect">
             <a:avLst>
@@ -10563,8 +10563,8 @@
         </p:nvSpPr>
         <p:spPr>
           <a:xfrm>
-            <a:off x="502920" y="2194560"/>
-            <a:ext cx="1600200" cy="2286000"/>
+            <a:off x="484632" y="2194560"/>
+            <a:ext cx="1316736" cy="2286000"/>
           </a:xfrm>
           <a:prstGeom prst="rect">
             <a:avLst/>
@@ -10605,9 +10605,11 @@
                 </a:solidFill>
                 <a:latin typeface="Calibri"/>
               </a:rPr>
-              <a:t>Şube, çağrı merkezi
+              <a:t>Şube, çağrı
+merkezi
 L2 destek
-İş birimi, analist</a:t>
+İş birimi,
+analist</a:t>
             </a:r>
           </a:p>
         </p:txBody>
@@ -10620,8 +10622,8 @@
         </p:nvSpPr>
         <p:spPr>
           <a:xfrm>
-            <a:off x="2697480" y="1234440"/>
-            <a:ext cx="2377440" cy="1600200"/>
+            <a:off x="2103120" y="1234440"/>
+            <a:ext cx="2103120" cy="1600200"/>
           </a:xfrm>
           <a:prstGeom prst="roundRect">
             <a:avLst>
@@ -10650,8 +10652,8 @@
         </p:nvSpPr>
         <p:spPr>
           <a:xfrm>
-            <a:off x="2788920" y="1280160"/>
-            <a:ext cx="2194560" cy="1508760"/>
+            <a:off x="2176272" y="1280160"/>
+            <a:ext cx="1956815" cy="1508760"/>
           </a:xfrm>
           <a:prstGeom prst="rect">
             <a:avLst/>
@@ -10694,7 +10696,7 @@
               </a:rPr>
               <a:t>Next.js 16
 Bankacılık ekranları,
-Mercek, Talep Yönlendirme</a:t>
+Mercek, Talep</a:t>
             </a:r>
           </a:p>
         </p:txBody>
@@ -10707,8 +10709,8 @@
         </p:nvSpPr>
         <p:spPr>
           <a:xfrm>
-            <a:off x="2697480" y="3794760"/>
-            <a:ext cx="2377440" cy="1600200"/>
+            <a:off x="2103120" y="3794760"/>
+            <a:ext cx="2103120" cy="1600200"/>
           </a:xfrm>
           <a:prstGeom prst="roundRect">
             <a:avLst>
@@ -10737,8 +10739,8 @@
         </p:nvSpPr>
         <p:spPr>
           <a:xfrm>
-            <a:off x="2788920" y="3840480"/>
-            <a:ext cx="2194560" cy="1508760"/>
+            <a:off x="2176272" y="3840480"/>
+            <a:ext cx="1956815" cy="1508760"/>
           </a:xfrm>
           <a:prstGeom prst="rect">
             <a:avLst/>
@@ -10794,8 +10796,8 @@
         </p:nvSpPr>
         <p:spPr>
           <a:xfrm>
-            <a:off x="5532120" y="1234440"/>
-            <a:ext cx="2514600" cy="1234440"/>
+            <a:off x="4434840" y="1097280"/>
+            <a:ext cx="3749039" cy="4343400"/>
           </a:xfrm>
           <a:prstGeom prst="roundRect">
             <a:avLst>
@@ -10804,6 +10806,175 @@
           </a:prstGeom>
           <a:solidFill>
             <a:srgbClr val="FFFFFF"/>
+          </a:solidFill>
+          <a:ln w="15875">
+            <a:solidFill>
+              <a:srgbClr val="E10514"/>
+            </a:solidFill>
+          </a:ln>
+          <a:effectLst/>
+        </p:spPr>
+        <p:txBody>
+          <a:bodyPr rtlCol="0" anchor="ctr"/>
+          <a:lstStyle/>
+          <a:p/>
+        </p:txBody>
+      </p:sp>
+      <p:sp>
+        <p:nvSpPr>
+          <p:cNvPr id="13" name="TextBox 12"/>
+          <p:cNvSpPr txBox="1"/>
+          <p:nvPr/>
+        </p:nvSpPr>
+        <p:spPr>
+          <a:xfrm>
+            <a:off x="4572000" y="1133856"/>
+            <a:ext cx="3474720" cy="365760"/>
+          </a:xfrm>
+          <a:prstGeom prst="rect">
+            <a:avLst/>
+          </a:prstGeom>
+          <a:noFill/>
+        </p:spPr>
+        <p:txBody>
+          <a:bodyPr wrap="square" anchor="ctr" lIns="0" rIns="0" tIns="0" bIns="0">
+            <a:spAutoFit/>
+          </a:bodyPr>
+          <a:lstStyle/>
+          <a:p>
+            <a:pPr algn="l">
+              <a:spcAft>
+                <a:spcPts val="400"/>
+              </a:spcAft>
+            </a:pPr>
+            <a:r>
+              <a:rPr sz="1300" b="1" i="0">
+                <a:solidFill>
+                  <a:srgbClr val="E10514"/>
+                </a:solidFill>
+                <a:latin typeface="Calibri"/>
+              </a:rPr>
+              <a:t>HİBRİT RAG  </a:t>
+            </a:r>
+            <a:r>
+              <a:rPr sz="1100" b="0" i="0">
+                <a:solidFill>
+                  <a:srgbClr val="91969B"/>
+                </a:solidFill>
+                <a:latin typeface="Calibri"/>
+              </a:rPr>
+              <a:t>1 getir · 2 bağlam · 3 üret</a:t>
+            </a:r>
+          </a:p>
+        </p:txBody>
+      </p:sp>
+      <p:sp>
+        <p:nvSpPr>
+          <p:cNvPr id="14" name="Rounded Rectangle 13"/>
+          <p:cNvSpPr/>
+          <p:nvPr/>
+        </p:nvSpPr>
+        <p:spPr>
+          <a:xfrm>
+            <a:off x="4572000" y="1554480"/>
+            <a:ext cx="2103120" cy="1463040"/>
+          </a:xfrm>
+          <a:prstGeom prst="roundRect">
+            <a:avLst>
+              <a:gd name="adj" fmla="val 6000"/>
+            </a:avLst>
+          </a:prstGeom>
+          <a:solidFill>
+            <a:srgbClr val="F2F5F6"/>
+          </a:solidFill>
+          <a:ln w="15875">
+            <a:solidFill>
+              <a:srgbClr val="E10514"/>
+            </a:solidFill>
+          </a:ln>
+          <a:effectLst/>
+        </p:spPr>
+        <p:txBody>
+          <a:bodyPr rtlCol="0" anchor="ctr"/>
+          <a:lstStyle/>
+          <a:p/>
+        </p:txBody>
+      </p:sp>
+      <p:sp>
+        <p:nvSpPr>
+          <p:cNvPr id="15" name="TextBox 14"/>
+          <p:cNvSpPr txBox="1"/>
+          <p:nvPr/>
+        </p:nvSpPr>
+        <p:spPr>
+          <a:xfrm>
+            <a:off x="4645152" y="1600200"/>
+            <a:ext cx="1956815" cy="1371600"/>
+          </a:xfrm>
+          <a:prstGeom prst="rect">
+            <a:avLst/>
+          </a:prstGeom>
+          <a:noFill/>
+        </p:spPr>
+        <p:txBody>
+          <a:bodyPr wrap="square" anchor="ctr" lIns="0" rIns="0" tIns="0" bIns="0">
+            <a:spAutoFit/>
+          </a:bodyPr>
+          <a:lstStyle/>
+          <a:p>
+            <a:pPr algn="ctr">
+              <a:spcAft>
+                <a:spcPts val="200"/>
+              </a:spcAft>
+            </a:pPr>
+            <a:r>
+              <a:rPr sz="1400" b="1" i="0">
+                <a:solidFill>
+                  <a:srgbClr val="1E1E1E"/>
+                </a:solidFill>
+                <a:latin typeface="Calibri"/>
+              </a:rPr>
+              <a:t>Azure AI Search</a:t>
+            </a:r>
+          </a:p>
+          <a:p>
+            <a:pPr algn="ctr">
+              <a:spcAft>
+                <a:spcPts val="200"/>
+              </a:spcAft>
+            </a:pPr>
+            <a:r>
+              <a:rPr sz="1100" b="0" i="0">
+                <a:solidFill>
+                  <a:srgbClr val="1E1E1E"/>
+                </a:solidFill>
+                <a:latin typeface="Calibri"/>
+              </a:rPr>
+              <a:t>1 · anlamca getir
+çözüm · talep · duyuru
+vektör + kelime, Türkçe</a:t>
+            </a:r>
+          </a:p>
+        </p:txBody>
+      </p:sp>
+      <p:sp>
+        <p:nvSpPr>
+          <p:cNvPr id="16" name="Rounded Rectangle 15"/>
+          <p:cNvSpPr/>
+          <p:nvPr/>
+        </p:nvSpPr>
+        <p:spPr>
+          <a:xfrm>
+            <a:off x="4572000" y="3154680"/>
+            <a:ext cx="2103120" cy="1325880"/>
+          </a:xfrm>
+          <a:prstGeom prst="roundRect">
+            <a:avLst>
+              <a:gd name="adj" fmla="val 6000"/>
+            </a:avLst>
+          </a:prstGeom>
+          <a:solidFill>
+            <a:srgbClr val="F2F5F6"/>
           </a:solidFill>
           <a:ln w="15875">
             <a:solidFill>
@@ -10820,14 +10991,14 @@
       </p:sp>
       <p:sp>
         <p:nvSpPr>
-          <p:cNvPr id="13" name="TextBox 12"/>
+          <p:cNvPr id="17" name="TextBox 16"/>
           <p:cNvSpPr txBox="1"/>
           <p:nvPr/>
         </p:nvSpPr>
         <p:spPr>
           <a:xfrm>
-            <a:off x="5623559" y="1280160"/>
-            <a:ext cx="2331720" cy="1143000"/>
+            <a:off x="4645152" y="3200400"/>
+            <a:ext cx="1956815" cy="1234439"/>
           </a:xfrm>
           <a:prstGeom prst="rect">
             <a:avLst/>
@@ -10846,13 +11017,13 @@
               </a:spcAft>
             </a:pPr>
             <a:r>
-              <a:rPr sz="1500" b="1" i="0">
+              <a:rPr sz="1400" b="1" i="0">
                 <a:solidFill>
                   <a:srgbClr val="1E1E1E"/>
                 </a:solidFill>
                 <a:latin typeface="Calibri"/>
               </a:rPr>
-              <a:t>Azure AI Foundry</a:t>
+              <a:t>Azure SQL</a:t>
             </a:r>
           </a:p>
           <a:p>
@@ -10862,27 +11033,29 @@
               </a:spcAft>
             </a:pPr>
             <a:r>
-              <a:rPr sz="1200" b="0" i="0">
+              <a:rPr sz="1100" b="0" i="0">
                 <a:solidFill>
                   <a:srgbClr val="1E1E1E"/>
                 </a:solidFill>
                 <a:latin typeface="Calibri"/>
               </a:rPr>
-              <a:t>chat + embedding modeli</a:t>
-            </a:r>
-          </a:p>
-        </p:txBody>
-      </p:sp>
-      <p:sp>
-        <p:nvSpPr>
-          <p:cNvPr id="14" name="Rounded Rectangle 13"/>
+              <a:t>1 · rakamı getir
+log · çağrı · portföy · takvim
+parametreli sorgu</a:t>
+            </a:r>
+          </a:p>
+        </p:txBody>
+      </p:sp>
+      <p:sp>
+        <p:nvSpPr>
+          <p:cNvPr id="18" name="Rounded Rectangle 17"/>
           <p:cNvSpPr/>
           <p:nvPr/>
         </p:nvSpPr>
         <p:spPr>
           <a:xfrm>
-            <a:off x="5532120" y="2697480"/>
-            <a:ext cx="2514600" cy="1234440"/>
+            <a:off x="6903720" y="1554480"/>
+            <a:ext cx="1143000" cy="2926080"/>
           </a:xfrm>
           <a:prstGeom prst="roundRect">
             <a:avLst>
@@ -10890,12 +11063,10 @@
             </a:avLst>
           </a:prstGeom>
           <a:solidFill>
-            <a:srgbClr val="FFFFFF"/>
+            <a:srgbClr val="E10514"/>
           </a:solidFill>
-          <a:ln w="15875">
-            <a:solidFill>
-              <a:srgbClr val="B4BEC3"/>
-            </a:solidFill>
+          <a:ln>
+            <a:noFill/>
           </a:ln>
           <a:effectLst/>
         </p:spPr>
@@ -10907,14 +11078,14 @@
       </p:sp>
       <p:sp>
         <p:nvSpPr>
-          <p:cNvPr id="15" name="TextBox 14"/>
+          <p:cNvPr id="19" name="TextBox 18"/>
           <p:cNvSpPr txBox="1"/>
           <p:nvPr/>
         </p:nvSpPr>
         <p:spPr>
           <a:xfrm>
-            <a:off x="5623559" y="2743200"/>
-            <a:ext cx="2331720" cy="1143000"/>
+            <a:off x="6976872" y="1600200"/>
+            <a:ext cx="996696" cy="2834640"/>
           </a:xfrm>
           <a:prstGeom prst="rect">
             <a:avLst/>
@@ -10933,13 +11104,13 @@
               </a:spcAft>
             </a:pPr>
             <a:r>
-              <a:rPr sz="1500" b="1" i="0">
-                <a:solidFill>
-                  <a:srgbClr val="1E1E1E"/>
-                </a:solidFill>
-                <a:latin typeface="Calibri"/>
-              </a:rPr>
-              <a:t>Azure SQL</a:t>
+              <a:rPr sz="1300" b="1" i="0">
+                <a:solidFill>
+                  <a:srgbClr val="FFFFFF"/>
+                </a:solidFill>
+                <a:latin typeface="Calibri"/>
+              </a:rPr>
+              <a:t>Azure AI Foundry</a:t>
             </a:r>
           </a:p>
           <a:p>
@@ -10949,60 +11120,29 @@
               </a:spcAft>
             </a:pPr>
             <a:r>
-              <a:rPr sz="1200" b="0" i="0">
-                <a:solidFill>
-                  <a:srgbClr val="1E1E1E"/>
-                </a:solidFill>
-                <a:latin typeface="Calibri"/>
-              </a:rPr>
-              <a:t>Log, katalog, portföy,
-çağrı, talep, takvim</a:t>
-            </a:r>
-          </a:p>
-        </p:txBody>
-      </p:sp>
-      <p:sp>
-        <p:nvSpPr>
-          <p:cNvPr id="16" name="Rounded Rectangle 15"/>
-          <p:cNvSpPr/>
-          <p:nvPr/>
-        </p:nvSpPr>
-        <p:spPr>
-          <a:xfrm>
-            <a:off x="5532120" y="4160520"/>
-            <a:ext cx="2514600" cy="1234440"/>
-          </a:xfrm>
-          <a:prstGeom prst="roundRect">
-            <a:avLst>
-              <a:gd name="adj" fmla="val 6000"/>
-            </a:avLst>
-          </a:prstGeom>
-          <a:solidFill>
-            <a:srgbClr val="FFFFFF"/>
-          </a:solidFill>
-          <a:ln w="15875">
-            <a:solidFill>
-              <a:srgbClr val="B4BEC3"/>
-            </a:solidFill>
-          </a:ln>
-          <a:effectLst/>
-        </p:spPr>
-        <p:txBody>
-          <a:bodyPr rtlCol="0" anchor="ctr"/>
-          <a:lstStyle/>
-          <a:p/>
-        </p:txBody>
-      </p:sp>
-      <p:sp>
-        <p:nvSpPr>
-          <p:cNvPr id="17" name="TextBox 16"/>
+              <a:rPr sz="1100" b="0" i="0">
+                <a:solidFill>
+                  <a:srgbClr val="FFFFFF"/>
+                </a:solidFill>
+                <a:latin typeface="Calibri"/>
+              </a:rPr>
+              <a:t>2 · bağlam
+3 · chat ile üret
+embedding → indeks</a:t>
+            </a:r>
+          </a:p>
+        </p:txBody>
+      </p:sp>
+      <p:sp>
+        <p:nvSpPr>
+          <p:cNvPr id="20" name="TextBox 19"/>
           <p:cNvSpPr txBox="1"/>
           <p:nvPr/>
         </p:nvSpPr>
         <p:spPr>
           <a:xfrm>
-            <a:off x="5623559" y="4206240"/>
-            <a:ext cx="2331720" cy="1143000"/>
+            <a:off x="4572000" y="4572000"/>
+            <a:ext cx="3474720" cy="822960"/>
           </a:xfrm>
           <a:prstGeom prst="rect">
             <a:avLst/>
@@ -11015,148 +11155,23 @@
           </a:bodyPr>
           <a:lstStyle/>
           <a:p>
-            <a:pPr algn="ctr">
-              <a:spcAft>
-                <a:spcPts val="200"/>
-              </a:spcAft>
-            </a:pPr>
-            <a:r>
-              <a:rPr sz="1500" b="1" i="0">
+            <a:pPr algn="l">
+              <a:spcAft>
+                <a:spcPts val="400"/>
+              </a:spcAft>
+            </a:pPr>
+            <a:r>
+              <a:rPr sz="1100" b="0" i="0">
                 <a:solidFill>
                   <a:srgbClr val="1E1E1E"/>
                 </a:solidFill>
                 <a:latin typeface="Calibri"/>
               </a:rPr>
-              <a:t>Azure AI Search</a:t>
-            </a:r>
-          </a:p>
-          <a:p>
-            <a:pPr algn="ctr">
-              <a:spcAft>
-                <a:spcPts val="200"/>
-              </a:spcAft>
-            </a:pPr>
-            <a:r>
-              <a:rPr sz="1200" b="0" i="0">
-                <a:solidFill>
-                  <a:srgbClr val="1E1E1E"/>
-                </a:solidFill>
-                <a:latin typeface="Calibri"/>
-              </a:rPr>
-              <a:t>Çözüm, talep, duyuru
-hibrit arama</a:t>
-            </a:r>
-          </a:p>
-        </p:txBody>
-      </p:sp>
-      <p:cxnSp>
-        <p:nvCxnSpPr>
-          <p:cNvPr id="18" name="Connector 17"/>
-          <p:cNvCxnSpPr/>
-          <p:nvPr/>
-        </p:nvCxnSpPr>
-        <p:spPr>
-          <a:xfrm flipV="1">
-            <a:off x="2194560" y="2057400"/>
-            <a:ext cx="502920" cy="685800"/>
-          </a:xfrm>
-          <a:prstGeom prst="line">
-            <a:avLst/>
-          </a:prstGeom>
-          <a:ln w="22225">
-            <a:solidFill>
-              <a:srgbClr val="91969B"/>
-            </a:solidFill>
-            <a:tailEnd type="triangle"/>
-          </a:ln>
-        </p:spPr>
-        <p:style>
-          <a:lnRef idx="2">
-            <a:schemeClr val="accent1"/>
-          </a:lnRef>
-          <a:fillRef idx="0">
-            <a:schemeClr val="accent1"/>
-          </a:fillRef>
-          <a:effectRef idx="1">
-            <a:schemeClr val="accent1"/>
-          </a:effectRef>
-          <a:fontRef idx="minor">
-            <a:schemeClr val="tx1"/>
-          </a:fontRef>
-        </p:style>
-      </p:cxnSp>
-      <p:cxnSp>
-        <p:nvCxnSpPr>
-          <p:cNvPr id="19" name="Connector 18"/>
-          <p:cNvCxnSpPr/>
-          <p:nvPr/>
-        </p:nvCxnSpPr>
-        <p:spPr>
-          <a:xfrm>
-            <a:off x="3886200" y="2834640"/>
-            <a:ext cx="0" cy="960120"/>
-          </a:xfrm>
-          <a:prstGeom prst="line">
-            <a:avLst/>
-          </a:prstGeom>
-          <a:ln w="22225">
-            <a:solidFill>
-              <a:srgbClr val="91969B"/>
-            </a:solidFill>
-            <a:tailEnd type="triangle"/>
-          </a:ln>
-        </p:spPr>
-        <p:style>
-          <a:lnRef idx="2">
-            <a:schemeClr val="accent1"/>
-          </a:lnRef>
-          <a:fillRef idx="0">
-            <a:schemeClr val="accent1"/>
-          </a:fillRef>
-          <a:effectRef idx="1">
-            <a:schemeClr val="accent1"/>
-          </a:effectRef>
-          <a:fontRef idx="minor">
-            <a:schemeClr val="tx1"/>
-          </a:fontRef>
-        </p:style>
-      </p:cxnSp>
-      <p:cxnSp>
-        <p:nvCxnSpPr>
-          <p:cNvPr id="20" name="Connector 19"/>
-          <p:cNvCxnSpPr/>
-          <p:nvPr/>
-        </p:nvCxnSpPr>
-        <p:spPr>
-          <a:xfrm flipV="1">
-            <a:off x="5074920" y="1847088"/>
-            <a:ext cx="457200" cy="2359152"/>
-          </a:xfrm>
-          <a:prstGeom prst="line">
-            <a:avLst/>
-          </a:prstGeom>
-          <a:ln w="22225">
-            <a:solidFill>
-              <a:srgbClr val="91969B"/>
-            </a:solidFill>
-            <a:tailEnd type="triangle"/>
-          </a:ln>
-        </p:spPr>
-        <p:style>
-          <a:lnRef idx="2">
-            <a:schemeClr val="accent1"/>
-          </a:lnRef>
-          <a:fillRef idx="0">
-            <a:schemeClr val="accent1"/>
-          </a:fillRef>
-          <a:effectRef idx="1">
-            <a:schemeClr val="accent1"/>
-          </a:effectRef>
-          <a:fontRef idx="minor">
-            <a:schemeClr val="tx1"/>
-          </a:fontRef>
-        </p:style>
-      </p:cxnSp>
+              <a:t>Benzeri AI Search bulur, rakamı SQL verir; model yalnızca bu kaynaklı bağlamla yazar ve her cevapta kaynak no'su gösterir.</a:t>
+            </a:r>
+          </a:p>
+        </p:txBody>
+      </p:sp>
       <p:cxnSp>
         <p:nvCxnSpPr>
           <p:cNvPr id="21" name="Connector 20"/>
@@ -11165,8 +11180,8 @@
         </p:nvCxnSpPr>
         <p:spPr>
           <a:xfrm flipV="1">
-            <a:off x="5074920" y="3310128"/>
-            <a:ext cx="457200" cy="1261872"/>
+            <a:off x="1874519" y="2057400"/>
+            <a:ext cx="228601" cy="685800"/>
           </a:xfrm>
           <a:prstGeom prst="line">
             <a:avLst/>
@@ -11200,9 +11215,9 @@
           <p:nvPr/>
         </p:nvCxnSpPr>
         <p:spPr>
-          <a:xfrm flipV="1">
-            <a:off x="5074920" y="4773168"/>
-            <a:ext cx="457200" cy="73152"/>
+          <a:xfrm>
+            <a:off x="3154680" y="2834640"/>
+            <a:ext cx="0" cy="960120"/>
           </a:xfrm>
           <a:prstGeom prst="line">
             <a:avLst/>
@@ -11229,9 +11244,153 @@
           </a:fontRef>
         </p:style>
       </p:cxnSp>
-      <p:sp>
-        <p:nvSpPr>
-          <p:cNvPr id="23" name="Rounded Rectangle 22"/>
+      <p:cxnSp>
+        <p:nvCxnSpPr>
+          <p:cNvPr id="23" name="Connector 22"/>
+          <p:cNvCxnSpPr/>
+          <p:nvPr/>
+        </p:nvCxnSpPr>
+        <p:spPr>
+          <a:xfrm flipV="1">
+            <a:off x="4206240" y="2286000"/>
+            <a:ext cx="365760" cy="2011680"/>
+          </a:xfrm>
+          <a:prstGeom prst="line">
+            <a:avLst/>
+          </a:prstGeom>
+          <a:ln w="22225">
+            <a:solidFill>
+              <a:srgbClr val="91969B"/>
+            </a:solidFill>
+            <a:tailEnd type="triangle"/>
+          </a:ln>
+        </p:spPr>
+        <p:style>
+          <a:lnRef idx="2">
+            <a:schemeClr val="accent1"/>
+          </a:lnRef>
+          <a:fillRef idx="0">
+            <a:schemeClr val="accent1"/>
+          </a:fillRef>
+          <a:effectRef idx="1">
+            <a:schemeClr val="accent1"/>
+          </a:effectRef>
+          <a:fontRef idx="minor">
+            <a:schemeClr val="tx1"/>
+          </a:fontRef>
+        </p:style>
+      </p:cxnSp>
+      <p:cxnSp>
+        <p:nvCxnSpPr>
+          <p:cNvPr id="24" name="Connector 23"/>
+          <p:cNvCxnSpPr/>
+          <p:nvPr/>
+        </p:nvCxnSpPr>
+        <p:spPr>
+          <a:xfrm flipV="1">
+            <a:off x="4206240" y="3813048"/>
+            <a:ext cx="365760" cy="758952"/>
+          </a:xfrm>
+          <a:prstGeom prst="line">
+            <a:avLst/>
+          </a:prstGeom>
+          <a:ln w="22225">
+            <a:solidFill>
+              <a:srgbClr val="91969B"/>
+            </a:solidFill>
+            <a:tailEnd type="triangle"/>
+          </a:ln>
+        </p:spPr>
+        <p:style>
+          <a:lnRef idx="2">
+            <a:schemeClr val="accent1"/>
+          </a:lnRef>
+          <a:fillRef idx="0">
+            <a:schemeClr val="accent1"/>
+          </a:fillRef>
+          <a:effectRef idx="1">
+            <a:schemeClr val="accent1"/>
+          </a:effectRef>
+          <a:fontRef idx="minor">
+            <a:schemeClr val="tx1"/>
+          </a:fontRef>
+        </p:style>
+      </p:cxnSp>
+      <p:cxnSp>
+        <p:nvCxnSpPr>
+          <p:cNvPr id="25" name="Connector 24"/>
+          <p:cNvCxnSpPr/>
+          <p:nvPr/>
+        </p:nvCxnSpPr>
+        <p:spPr>
+          <a:xfrm>
+            <a:off x="6675120" y="2286000"/>
+            <a:ext cx="228600" cy="365760"/>
+          </a:xfrm>
+          <a:prstGeom prst="line">
+            <a:avLst/>
+          </a:prstGeom>
+          <a:ln w="22225">
+            <a:solidFill>
+              <a:srgbClr val="E10514"/>
+            </a:solidFill>
+            <a:tailEnd type="triangle"/>
+          </a:ln>
+        </p:spPr>
+        <p:style>
+          <a:lnRef idx="2">
+            <a:schemeClr val="accent1"/>
+          </a:lnRef>
+          <a:fillRef idx="0">
+            <a:schemeClr val="accent1"/>
+          </a:fillRef>
+          <a:effectRef idx="1">
+            <a:schemeClr val="accent1"/>
+          </a:effectRef>
+          <a:fontRef idx="minor">
+            <a:schemeClr val="tx1"/>
+          </a:fontRef>
+        </p:style>
+      </p:cxnSp>
+      <p:cxnSp>
+        <p:nvCxnSpPr>
+          <p:cNvPr id="26" name="Connector 25"/>
+          <p:cNvCxnSpPr/>
+          <p:nvPr/>
+        </p:nvCxnSpPr>
+        <p:spPr>
+          <a:xfrm flipV="1">
+            <a:off x="6675120" y="3383280"/>
+            <a:ext cx="228600" cy="429768"/>
+          </a:xfrm>
+          <a:prstGeom prst="line">
+            <a:avLst/>
+          </a:prstGeom>
+          <a:ln w="22225">
+            <a:solidFill>
+              <a:srgbClr val="E10514"/>
+            </a:solidFill>
+            <a:tailEnd type="triangle"/>
+          </a:ln>
+        </p:spPr>
+        <p:style>
+          <a:lnRef idx="2">
+            <a:schemeClr val="accent1"/>
+          </a:lnRef>
+          <a:fillRef idx="0">
+            <a:schemeClr val="accent1"/>
+          </a:fillRef>
+          <a:effectRef idx="1">
+            <a:schemeClr val="accent1"/>
+          </a:effectRef>
+          <a:fontRef idx="minor">
+            <a:schemeClr val="tx1"/>
+          </a:fontRef>
+        </p:style>
+      </p:cxnSp>
+      <p:sp>
+        <p:nvSpPr>
+          <p:cNvPr id="27" name="Rounded Rectangle 26"/>
           <p:cNvSpPr/>
           <p:nvPr/>
         </p:nvSpPr>
@@ -11261,7 +11420,7 @@
       </p:sp>
       <p:pic>
         <p:nvPicPr>
-          <p:cNvPr id="24" name="Picture 23" descr="github-g.png"/>
+          <p:cNvPr id="28" name="Picture 27" descr="github-g.png"/>
           <p:cNvPicPr>
             <a:picLocks noChangeAspect="1"/>
           </p:cNvPicPr>
@@ -11285,7 +11444,7 @@
       </p:pic>
       <p:sp>
         <p:nvSpPr>
-          <p:cNvPr id="25" name="TextBox 24"/>
+          <p:cNvPr id="29" name="TextBox 28"/>
           <p:cNvSpPr txBox="1"/>
           <p:nvPr/>
         </p:nvSpPr>
@@ -11351,7 +11510,7 @@
       </p:sp>
       <p:sp>
         <p:nvSpPr>
-          <p:cNvPr id="26" name="Rounded Rectangle 25"/>
+          <p:cNvPr id="30" name="Rounded Rectangle 29"/>
           <p:cNvSpPr/>
           <p:nvPr/>
         </p:nvSpPr>
@@ -11381,7 +11540,7 @@
       </p:sp>
       <p:sp>
         <p:nvSpPr>
-          <p:cNvPr id="27" name="TextBox 26"/>
+          <p:cNvPr id="31" name="TextBox 30"/>
           <p:cNvSpPr txBox="1"/>
           <p:nvPr/>
         </p:nvSpPr>
@@ -11500,7 +11659,7 @@
       </p:sp>
       <p:sp>
         <p:nvSpPr>
-          <p:cNvPr id="28" name="Rounded Rectangle 27"/>
+          <p:cNvPr id="32" name="Rounded Rectangle 31"/>
           <p:cNvSpPr/>
           <p:nvPr/>
         </p:nvSpPr>
@@ -11530,7 +11689,7 @@
       </p:sp>
       <p:sp>
         <p:nvSpPr>
-          <p:cNvPr id="29" name="TextBox 28"/>
+          <p:cNvPr id="33" name="TextBox 32"/>
           <p:cNvSpPr txBox="1"/>
           <p:nvPr/>
         </p:nvSpPr>

</xml_diff>

<commit_message>
Sunum: mimari slaytına SQL → AI Search otomatik eşitleme (indexer) eklendi
Co-Authored-By: Claude Opus 5.5 <noreply@anthropic.com>
Claude-Session: https://claude.ai/code/session_01DTiHxbPkixs9Jadunw7PB9
</commit_message>
<xml_diff>
--- a/presentation/Mercek_AI_Overflow_Sunum.pptx
+++ b/presentation/Mercek_AI_Overflow_Sunum.pptx
@@ -1029,7 +1029,7 @@
           <a:lstStyle/>
           <a:p>
             <a:r>
-              <a:t>0:58–1:05 · Mercek hibrit RAG kullanır: AI Search geçmiş çözümleri, talepleri ve duyuruları anlam benzerliğiyle bulur (vektör + kelime, Türkçe analizör, Foundry embedding); Azure SQL o anki gerçek rakamları parametreli sorgularla getirir. Foundry ikisini bağlam olarak alıp cevabı yazar; rakam uydurmaz çünkü her sayı SQL'den gelir. Model SQL yazmaz (text-to-SQL yok). CI/CD her PR'da test ve güvenlik taraması yapıyor. Sağda AI'ın ve kuralların işi. (Yalnızca gerçekten çalışan servisler bu slaytta kalmalı.)</a:t>
+              <a:t>0:58–1:05 · Mercek hibrit RAG kullanır: AI Search geçmiş çözümleri, talepleri ve duyuruları anlam benzerliğiyle bulur (vektör + kelime, Türkçe analizör, Foundry embedding); Azure SQL o anki gerçek rakamları parametreli sorgularla getirir. SQL'e yazılan çözüm ve talepler AI Search indexer'ıyla birkaç dakikada kendiliğinden indekse girer; embedding'i Search, Foundry ile kendisi üretir. Foundry ikisini bağlam olarak alıp cevabı yazar; rakam uydurmaz çünkü her sayı SQL'den gelir. Model SQL yazmaz (text-to-SQL yok). CI/CD her PR'da test ve güvenlik taraması yapıyor. Sağda AI'ın ve kuralların işi. (Yalnızca gerçekten çalışan servisler bu slaytta kalmalı.)</a:t>
             </a:r>
           </a:p>
         </p:txBody>
@@ -11316,9 +11316,78 @@
           </a:fontRef>
         </p:style>
       </p:cxnSp>
+      <p:sp>
+        <p:nvSpPr>
+          <p:cNvPr id="25" name="Rounded Rectangle 24"/>
+          <p:cNvSpPr/>
+          <p:nvPr/>
+        </p:nvSpPr>
+        <p:spPr>
+          <a:xfrm>
+            <a:off x="4892040" y="2944368"/>
+            <a:ext cx="1463040" cy="274320"/>
+          </a:xfrm>
+          <a:prstGeom prst="roundRect">
+            <a:avLst>
+              <a:gd name="adj" fmla="val 50000"/>
+            </a:avLst>
+          </a:prstGeom>
+          <a:solidFill>
+            <a:srgbClr val="870F00"/>
+          </a:solidFill>
+          <a:ln>
+            <a:noFill/>
+          </a:ln>
+          <a:effectLst/>
+        </p:spPr>
+        <p:txBody>
+          <a:bodyPr rtlCol="0" anchor="ctr"/>
+          <a:lstStyle/>
+          <a:p/>
+        </p:txBody>
+      </p:sp>
+      <p:sp>
+        <p:nvSpPr>
+          <p:cNvPr id="26" name="TextBox 25"/>
+          <p:cNvSpPr txBox="1"/>
+          <p:nvPr/>
+        </p:nvSpPr>
+        <p:spPr>
+          <a:xfrm>
+            <a:off x="4892040" y="2944368"/>
+            <a:ext cx="1463040" cy="274320"/>
+          </a:xfrm>
+          <a:prstGeom prst="rect">
+            <a:avLst/>
+          </a:prstGeom>
+          <a:noFill/>
+        </p:spPr>
+        <p:txBody>
+          <a:bodyPr wrap="square" anchor="ctr" lIns="0" rIns="0" tIns="0" bIns="0">
+            <a:spAutoFit/>
+          </a:bodyPr>
+          <a:lstStyle/>
+          <a:p>
+            <a:pPr algn="ctr">
+              <a:spcAft>
+                <a:spcPts val="400"/>
+              </a:spcAft>
+            </a:pPr>
+            <a:r>
+              <a:rPr sz="1000" b="1" i="0">
+                <a:solidFill>
+                  <a:srgbClr val="FFFFFF"/>
+                </a:solidFill>
+                <a:latin typeface="Calibri"/>
+              </a:rPr>
+              <a:t>▲ indexer · otomatik</a:t>
+            </a:r>
+          </a:p>
+        </p:txBody>
+      </p:sp>
       <p:cxnSp>
         <p:nvCxnSpPr>
-          <p:cNvPr id="25" name="Connector 24"/>
+          <p:cNvPr id="27" name="Connector 26"/>
           <p:cNvCxnSpPr/>
           <p:nvPr/>
         </p:nvCxnSpPr>
@@ -11354,7 +11423,7 @@
       </p:cxnSp>
       <p:cxnSp>
         <p:nvCxnSpPr>
-          <p:cNvPr id="26" name="Connector 25"/>
+          <p:cNvPr id="28" name="Connector 27"/>
           <p:cNvCxnSpPr/>
           <p:nvPr/>
         </p:nvCxnSpPr>
@@ -11390,7 +11459,7 @@
       </p:cxnSp>
       <p:sp>
         <p:nvSpPr>
-          <p:cNvPr id="27" name="Rounded Rectangle 26"/>
+          <p:cNvPr id="29" name="Rounded Rectangle 28"/>
           <p:cNvSpPr/>
           <p:nvPr/>
         </p:nvSpPr>
@@ -11420,7 +11489,7 @@
       </p:sp>
       <p:pic>
         <p:nvPicPr>
-          <p:cNvPr id="28" name="Picture 27" descr="github-g.png"/>
+          <p:cNvPr id="30" name="Picture 29" descr="github-g.png"/>
           <p:cNvPicPr>
             <a:picLocks noChangeAspect="1"/>
           </p:cNvPicPr>
@@ -11444,7 +11513,7 @@
       </p:pic>
       <p:sp>
         <p:nvSpPr>
-          <p:cNvPr id="29" name="TextBox 28"/>
+          <p:cNvPr id="31" name="TextBox 30"/>
           <p:cNvSpPr txBox="1"/>
           <p:nvPr/>
         </p:nvSpPr>
@@ -11510,7 +11579,7 @@
       </p:sp>
       <p:sp>
         <p:nvSpPr>
-          <p:cNvPr id="30" name="Rounded Rectangle 29"/>
+          <p:cNvPr id="32" name="Rounded Rectangle 31"/>
           <p:cNvSpPr/>
           <p:nvPr/>
         </p:nvSpPr>
@@ -11540,7 +11609,7 @@
       </p:sp>
       <p:sp>
         <p:nvSpPr>
-          <p:cNvPr id="31" name="TextBox 30"/>
+          <p:cNvPr id="33" name="TextBox 32"/>
           <p:cNvSpPr txBox="1"/>
           <p:nvPr/>
         </p:nvSpPr>
@@ -11659,7 +11728,7 @@
       </p:sp>
       <p:sp>
         <p:nvSpPr>
-          <p:cNvPr id="32" name="Rounded Rectangle 31"/>
+          <p:cNvPr id="34" name="Rounded Rectangle 33"/>
           <p:cNvSpPr/>
           <p:nvPr/>
         </p:nvSpPr>
@@ -11689,7 +11758,7 @@
       </p:sp>
       <p:sp>
         <p:nvSpPr>
-          <p:cNvPr id="33" name="TextBox 32"/>
+          <p:cNvPr id="35" name="TextBox 34"/>
           <p:cNvSpPr txBox="1"/>
           <p:nvPr/>
         </p:nvSpPr>

</xml_diff>